<commit_message>
Add cover and Q&A closing slides to the Board pitch (5-slide deck)
</commit_message>
<xml_diff>
--- a/Hennecke/pitch/HenneckeOMS_Board_Pitch_EN.pptx
+++ b/Hennecke/pitch/HenneckeOMS_Board_Pitch_EN.pptx
@@ -8,6 +8,8 @@
     <p:sldId id="256" r:id="rId7"/>
     <p:sldId id="257" r:id="rId8"/>
     <p:sldId id="258" r:id="rId9"/>
+    <p:sldId id="259" r:id="rId10"/>
+    <p:sldId id="260" r:id="rId11"/>
   </p:sldIdLst>
   <p:sldSz cx="12191695" cy="6858000" type="screen4x3"/>
   <p:notesSz cx="6858000" cy="9144000"/>
@@ -3092,7 +3094,7 @@
       <p:grpSpPr/>
       <p:pic>
         <p:nvPicPr>
-          <p:cNvPr id="2" name="Picture 1" descr="slide-1-opportunity.png"/>
+          <p:cNvPr id="2" name="Picture 1" descr="slide-0-cover.png"/>
           <p:cNvPicPr>
             <a:picLocks noChangeAspect="1"/>
           </p:cNvPicPr>
@@ -3134,7 +3136,7 @@
       <p:grpSpPr/>
       <p:pic>
         <p:nvPicPr>
-          <p:cNvPr id="2" name="Picture 1" descr="slide-2-financials.png"/>
+          <p:cNvPr id="2" name="Picture 1" descr="slide-1-opportunity.png"/>
           <p:cNvPicPr>
             <a:picLocks noChangeAspect="1"/>
           </p:cNvPicPr>
@@ -3176,7 +3178,91 @@
       <p:grpSpPr/>
       <p:pic>
         <p:nvPicPr>
+          <p:cNvPr id="2" name="Picture 1" descr="slide-2-financials.png"/>
+          <p:cNvPicPr>
+            <a:picLocks noChangeAspect="1"/>
+          </p:cNvPicPr>
+          <p:nvPr/>
+        </p:nvPicPr>
+        <p:blipFill>
+          <a:blip r:embed="rId2"/>
+          <a:stretch>
+            <a:fillRect/>
+          </a:stretch>
+        </p:blipFill>
+        <p:spPr>
+          <a:xfrm>
+            <a:off x="0" y="0"/>
+            <a:ext cx="12191695" cy="6858000"/>
+          </a:xfrm>
+          <a:prstGeom prst="rect">
+            <a:avLst/>
+          </a:prstGeom>
+        </p:spPr>
+      </p:pic>
+    </p:spTree>
+  </p:cSld>
+  <p:clrMapOvr>
+    <a:masterClrMapping/>
+  </p:clrMapOvr>
+</p:sld>
+</file>
+
+<file path=ppt/slides/slide4.xml><?xml version="1.0" encoding="utf-8"?>
+<p:sld xmlns:a="http://schemas.openxmlformats.org/drawingml/2006/main" xmlns:p="http://schemas.openxmlformats.org/presentationml/2006/main" xmlns:r="http://schemas.openxmlformats.org/officeDocument/2006/relationships">
+  <p:cSld>
+    <p:spTree>
+      <p:nvGrpSpPr>
+        <p:cNvPr id="1" name=""/>
+        <p:cNvGrpSpPr/>
+        <p:nvPr/>
+      </p:nvGrpSpPr>
+      <p:grpSpPr/>
+      <p:pic>
+        <p:nvPicPr>
           <p:cNvPr id="2" name="Picture 1" descr="slide-3-thesis.png"/>
+          <p:cNvPicPr>
+            <a:picLocks noChangeAspect="1"/>
+          </p:cNvPicPr>
+          <p:nvPr/>
+        </p:nvPicPr>
+        <p:blipFill>
+          <a:blip r:embed="rId2"/>
+          <a:stretch>
+            <a:fillRect/>
+          </a:stretch>
+        </p:blipFill>
+        <p:spPr>
+          <a:xfrm>
+            <a:off x="0" y="0"/>
+            <a:ext cx="12191695" cy="6858000"/>
+          </a:xfrm>
+          <a:prstGeom prst="rect">
+            <a:avLst/>
+          </a:prstGeom>
+        </p:spPr>
+      </p:pic>
+    </p:spTree>
+  </p:cSld>
+  <p:clrMapOvr>
+    <a:masterClrMapping/>
+  </p:clrMapOvr>
+</p:sld>
+</file>
+
+<file path=ppt/slides/slide5.xml><?xml version="1.0" encoding="utf-8"?>
+<p:sld xmlns:a="http://schemas.openxmlformats.org/drawingml/2006/main" xmlns:p="http://schemas.openxmlformats.org/presentationml/2006/main" xmlns:r="http://schemas.openxmlformats.org/officeDocument/2006/relationships">
+  <p:cSld>
+    <p:spTree>
+      <p:nvGrpSpPr>
+        <p:cNvPr id="1" name=""/>
+        <p:cNvGrpSpPr/>
+        <p:nvPr/>
+      </p:nvGrpSpPr>
+      <p:grpSpPr/>
+      <p:pic>
+        <p:nvPicPr>
+          <p:cNvPr id="2" name="Picture 1" descr="slide-4-closing.png"/>
           <p:cNvPicPr>
             <a:picLocks noChangeAspect="1"/>
           </p:cNvPicPr>

</xml_diff>

<commit_message>
Add B2B customer-map slide to the Board pitch (6 slides)
</commit_message>
<xml_diff>
--- a/Hennecke/pitch/HenneckeOMS_Board_Pitch_EN.pptx
+++ b/Hennecke/pitch/HenneckeOMS_Board_Pitch_EN.pptx
@@ -10,6 +10,7 @@
     <p:sldId id="258" r:id="rId9"/>
     <p:sldId id="259" r:id="rId10"/>
     <p:sldId id="260" r:id="rId11"/>
+    <p:sldId id="261" r:id="rId12"/>
   </p:sldIdLst>
   <p:sldSz cx="12191695" cy="6858000" type="screen4x3"/>
   <p:notesSz cx="6858000" cy="9144000"/>
@@ -4231,7 +4232,7 @@
                 </a:solidFill>
                 <a:latin typeface="Arial"/>
               </a:rPr>
-              <a:t>1 / 3</a:t>
+              <a:t>1 / 4</a:t>
             </a:r>
           </a:p>
         </p:txBody>
@@ -5991,7 +5992,7 @@
                 </a:solidFill>
                 <a:latin typeface="Arial"/>
               </a:rPr>
-              <a:t>2 / 3</a:t>
+              <a:t>2 / 4</a:t>
             </a:r>
           </a:p>
         </p:txBody>
@@ -7072,7 +7073,7 @@
                 </a:solidFill>
                 <a:latin typeface="Arial"/>
               </a:rPr>
-              <a:t>Investment thesis — value, risks &amp; recommendation</a:t>
+              <a:t>Who buys from Hennecke — B2B customer map</a:t>
             </a:r>
           </a:p>
         </p:txBody>
@@ -7117,7 +7118,7 @@
                 </a:solidFill>
                 <a:latin typeface="Arial"/>
               </a:rPr>
-              <a:t>Margin-recovery &amp; aftermarket story on a structurally-supported PU platform</a:t>
+              <a:t>Customers are industrial manufacturers that process polyurethane · by application</a:t>
             </a:r>
           </a:p>
         </p:txBody>
@@ -7251,7 +7252,7 @@
                 </a:solidFill>
                 <a:latin typeface="Arial"/>
               </a:rPr>
-              <a:t>3 / 3</a:t>
+              <a:t>3 / 4</a:t>
             </a:r>
           </a:p>
         </p:txBody>
@@ -7264,8 +7265,8 @@
         </p:nvSpPr>
         <p:spPr>
           <a:xfrm>
-            <a:off x="381000" y="952500"/>
-            <a:ext cx="3657600" cy="4267200"/>
+            <a:off x="381000" y="1280160"/>
+            <a:ext cx="2743200" cy="1920240"/>
           </a:xfrm>
           <a:prstGeom prst="rect">
             <a:avLst/>
@@ -7310,6 +7311,2143 @@
         </p:nvSpPr>
         <p:spPr>
           <a:xfrm>
+            <a:off x="381000" y="1280160"/>
+            <a:ext cx="2743200" cy="320040"/>
+          </a:xfrm>
+          <a:prstGeom prst="rect">
+            <a:avLst/>
+          </a:prstGeom>
+          <a:solidFill>
+            <a:srgbClr val="1F3A5F"/>
+          </a:solidFill>
+          <a:ln>
+            <a:noFill/>
+          </a:ln>
+          <a:effectLst/>
+        </p:spPr>
+        <p:style>
+          <a:lnRef idx="1">
+            <a:schemeClr val="accent1"/>
+          </a:lnRef>
+          <a:fillRef idx="3">
+            <a:schemeClr val="accent1"/>
+          </a:fillRef>
+          <a:effectRef idx="2">
+            <a:schemeClr val="accent1"/>
+          </a:effectRef>
+          <a:fontRef idx="minor">
+            <a:schemeClr val="lt1"/>
+          </a:fontRef>
+        </p:style>
+        <p:txBody>
+          <a:bodyPr rtlCol="0" anchor="ctr"/>
+          <a:lstStyle/>
+          <a:p>
+            <a:pPr algn="ctr"/>
+          </a:p>
+        </p:txBody>
+      </p:sp>
+      <p:sp>
+        <p:nvSpPr>
+          <p:cNvPr id="10" name="TextBox 9"/>
+          <p:cNvSpPr txBox="1"/>
+          <p:nvPr/>
+        </p:nvSpPr>
+        <p:spPr>
+          <a:xfrm>
+            <a:off x="502920" y="1280160"/>
+            <a:ext cx="2575560" cy="320040"/>
+          </a:xfrm>
+          <a:prstGeom prst="rect">
+            <a:avLst/>
+          </a:prstGeom>
+          <a:noFill/>
+        </p:spPr>
+        <p:txBody>
+          <a:bodyPr wrap="square" anchor="ctr" lIns="25400" rIns="25400" tIns="12700" bIns="12700">
+            <a:spAutoFit/>
+          </a:bodyPr>
+          <a:lstStyle/>
+          <a:p>
+            <a:pPr algn="l">
+              <a:lnSpc>
+                <a:spcPct val="100000"/>
+              </a:lnSpc>
+              <a:spcBef>
+                <a:spcPts val="0"/>
+              </a:spcBef>
+              <a:spcAft>
+                <a:spcPts val="400"/>
+              </a:spcAft>
+            </a:pPr>
+            <a:r>
+              <a:rPr sz="1300" b="1" i="0">
+                <a:solidFill>
+                  <a:srgbClr val="FFFFFF"/>
+                </a:solidFill>
+                <a:latin typeface="Arial"/>
+              </a:rPr>
+              <a:t>1 · Building insulation — sandwich panels</a:t>
+            </a:r>
+          </a:p>
+        </p:txBody>
+      </p:sp>
+      <p:sp>
+        <p:nvSpPr>
+          <p:cNvPr id="11" name="TextBox 10"/>
+          <p:cNvSpPr txBox="1"/>
+          <p:nvPr/>
+        </p:nvSpPr>
+        <p:spPr>
+          <a:xfrm>
+            <a:off x="502920" y="1676400"/>
+            <a:ext cx="2514600" cy="1447800"/>
+          </a:xfrm>
+          <a:prstGeom prst="rect">
+            <a:avLst/>
+          </a:prstGeom>
+          <a:noFill/>
+        </p:spPr>
+        <p:txBody>
+          <a:bodyPr wrap="square" anchor="t" lIns="25400" rIns="25400" tIns="12700" bIns="12700">
+            <a:spAutoFit/>
+          </a:bodyPr>
+          <a:lstStyle/>
+          <a:p>
+            <a:pPr algn="l">
+              <a:lnSpc>
+                <a:spcPct val="100000"/>
+              </a:lnSpc>
+              <a:spcBef>
+                <a:spcPts val="0"/>
+              </a:spcBef>
+              <a:spcAft>
+                <a:spcPts val="600"/>
+              </a:spcAft>
+            </a:pPr>
+            <a:r>
+              <a:rPr sz="1150" b="0" i="1">
+                <a:solidFill>
+                  <a:srgbClr val="666666"/>
+                </a:solidFill>
+                <a:latin typeface="Arial"/>
+              </a:rPr>
+              <a:t>Continuous &amp; discontinuous panel makers (roofing, façades, cold rooms).</a:t>
+            </a:r>
+          </a:p>
+          <a:p>
+            <a:pPr algn="l">
+              <a:lnSpc>
+                <a:spcPct val="100000"/>
+              </a:lnSpc>
+              <a:spcBef>
+                <a:spcPts val="0"/>
+              </a:spcBef>
+              <a:spcAft>
+                <a:spcPts val="0"/>
+              </a:spcAft>
+            </a:pPr>
+            <a:r>
+              <a:rPr sz="1150" b="1" i="0">
+                <a:solidFill>
+                  <a:srgbClr val="222222"/>
+                </a:solidFill>
+                <a:latin typeface="Arial"/>
+              </a:rPr>
+              <a:t>e.g. </a:t>
+            </a:r>
+            <a:r>
+              <a:rPr sz="1150" b="0" i="0">
+                <a:solidFill>
+                  <a:srgbClr val="222222"/>
+                </a:solidFill>
+                <a:latin typeface="Arial"/>
+              </a:rPr>
+              <a:t>Kingspan, Isopan / Manni, Metecno, Brucha, Trimo, Tata Steel</a:t>
+            </a:r>
+          </a:p>
+        </p:txBody>
+      </p:sp>
+      <p:sp>
+        <p:nvSpPr>
+          <p:cNvPr id="12" name="Rectangle 11"/>
+          <p:cNvSpPr/>
+          <p:nvPr/>
+        </p:nvSpPr>
+        <p:spPr>
+          <a:xfrm>
+            <a:off x="3276600" y="1280160"/>
+            <a:ext cx="2743200" cy="1920240"/>
+          </a:xfrm>
+          <a:prstGeom prst="rect">
+            <a:avLst/>
+          </a:prstGeom>
+          <a:solidFill>
+            <a:srgbClr val="FFFFFF"/>
+          </a:solidFill>
+          <a:ln w="12700">
+            <a:solidFill>
+              <a:srgbClr val="DFE4EA"/>
+            </a:solidFill>
+          </a:ln>
+          <a:effectLst/>
+        </p:spPr>
+        <p:style>
+          <a:lnRef idx="1">
+            <a:schemeClr val="accent1"/>
+          </a:lnRef>
+          <a:fillRef idx="3">
+            <a:schemeClr val="accent1"/>
+          </a:fillRef>
+          <a:effectRef idx="2">
+            <a:schemeClr val="accent1"/>
+          </a:effectRef>
+          <a:fontRef idx="minor">
+            <a:schemeClr val="lt1"/>
+          </a:fontRef>
+        </p:style>
+        <p:txBody>
+          <a:bodyPr rtlCol="0" anchor="ctr"/>
+          <a:lstStyle/>
+          <a:p>
+            <a:pPr algn="ctr"/>
+          </a:p>
+        </p:txBody>
+      </p:sp>
+      <p:sp>
+        <p:nvSpPr>
+          <p:cNvPr id="13" name="Rectangle 12"/>
+          <p:cNvSpPr/>
+          <p:nvPr/>
+        </p:nvSpPr>
+        <p:spPr>
+          <a:xfrm>
+            <a:off x="3276600" y="1280160"/>
+            <a:ext cx="2743200" cy="320040"/>
+          </a:xfrm>
+          <a:prstGeom prst="rect">
+            <a:avLst/>
+          </a:prstGeom>
+          <a:solidFill>
+            <a:srgbClr val="1F3A5F"/>
+          </a:solidFill>
+          <a:ln>
+            <a:noFill/>
+          </a:ln>
+          <a:effectLst/>
+        </p:spPr>
+        <p:style>
+          <a:lnRef idx="1">
+            <a:schemeClr val="accent1"/>
+          </a:lnRef>
+          <a:fillRef idx="3">
+            <a:schemeClr val="accent1"/>
+          </a:fillRef>
+          <a:effectRef idx="2">
+            <a:schemeClr val="accent1"/>
+          </a:effectRef>
+          <a:fontRef idx="minor">
+            <a:schemeClr val="lt1"/>
+          </a:fontRef>
+        </p:style>
+        <p:txBody>
+          <a:bodyPr rtlCol="0" anchor="ctr"/>
+          <a:lstStyle/>
+          <a:p>
+            <a:pPr algn="ctr"/>
+          </a:p>
+        </p:txBody>
+      </p:sp>
+      <p:sp>
+        <p:nvSpPr>
+          <p:cNvPr id="14" name="TextBox 13"/>
+          <p:cNvSpPr txBox="1"/>
+          <p:nvPr/>
+        </p:nvSpPr>
+        <p:spPr>
+          <a:xfrm>
+            <a:off x="3398520" y="1280160"/>
+            <a:ext cx="2575560" cy="320040"/>
+          </a:xfrm>
+          <a:prstGeom prst="rect">
+            <a:avLst/>
+          </a:prstGeom>
+          <a:noFill/>
+        </p:spPr>
+        <p:txBody>
+          <a:bodyPr wrap="square" anchor="ctr" lIns="25400" rIns="25400" tIns="12700" bIns="12700">
+            <a:spAutoFit/>
+          </a:bodyPr>
+          <a:lstStyle/>
+          <a:p>
+            <a:pPr algn="l">
+              <a:lnSpc>
+                <a:spcPct val="100000"/>
+              </a:lnSpc>
+              <a:spcBef>
+                <a:spcPts val="0"/>
+              </a:spcBef>
+              <a:spcAft>
+                <a:spcPts val="400"/>
+              </a:spcAft>
+            </a:pPr>
+            <a:r>
+              <a:rPr sz="1300" b="1" i="0">
+                <a:solidFill>
+                  <a:srgbClr val="FFFFFF"/>
+                </a:solidFill>
+                <a:latin typeface="Arial"/>
+              </a:rPr>
+              <a:t>2 · Refrigeration &amp; cold chain</a:t>
+            </a:r>
+          </a:p>
+        </p:txBody>
+      </p:sp>
+      <p:sp>
+        <p:nvSpPr>
+          <p:cNvPr id="15" name="TextBox 14"/>
+          <p:cNvSpPr txBox="1"/>
+          <p:nvPr/>
+        </p:nvSpPr>
+        <p:spPr>
+          <a:xfrm>
+            <a:off x="3398520" y="1676400"/>
+            <a:ext cx="2514600" cy="1447800"/>
+          </a:xfrm>
+          <a:prstGeom prst="rect">
+            <a:avLst/>
+          </a:prstGeom>
+          <a:noFill/>
+        </p:spPr>
+        <p:txBody>
+          <a:bodyPr wrap="square" anchor="t" lIns="25400" rIns="25400" tIns="12700" bIns="12700">
+            <a:spAutoFit/>
+          </a:bodyPr>
+          <a:lstStyle/>
+          <a:p>
+            <a:pPr algn="l">
+              <a:lnSpc>
+                <a:spcPct val="100000"/>
+              </a:lnSpc>
+              <a:spcBef>
+                <a:spcPts val="0"/>
+              </a:spcBef>
+              <a:spcAft>
+                <a:spcPts val="600"/>
+              </a:spcAft>
+            </a:pPr>
+            <a:r>
+              <a:rPr sz="1150" b="0" i="1">
+                <a:solidFill>
+                  <a:srgbClr val="666666"/>
+                </a:solidFill>
+                <a:latin typeface="Arial"/>
+              </a:rPr>
+              <a:t>Fridge / freezer &amp; cold-room manufacturers (PU injection insulation).</a:t>
+            </a:r>
+          </a:p>
+          <a:p>
+            <a:pPr algn="l">
+              <a:lnSpc>
+                <a:spcPct val="100000"/>
+              </a:lnSpc>
+              <a:spcBef>
+                <a:spcPts val="0"/>
+              </a:spcBef>
+              <a:spcAft>
+                <a:spcPts val="0"/>
+              </a:spcAft>
+            </a:pPr>
+            <a:r>
+              <a:rPr sz="1150" b="1" i="0">
+                <a:solidFill>
+                  <a:srgbClr val="222222"/>
+                </a:solidFill>
+                <a:latin typeface="Arial"/>
+              </a:rPr>
+              <a:t>e.g. </a:t>
+            </a:r>
+            <a:r>
+              <a:rPr sz="1150" b="0" i="0">
+                <a:solidFill>
+                  <a:srgbClr val="222222"/>
+                </a:solidFill>
+                <a:latin typeface="Arial"/>
+              </a:rPr>
+              <a:t>Whirlpool, Electrolux, BSH, Liebherr, Haier, Arçelik; Epta, Arneg</a:t>
+            </a:r>
+          </a:p>
+        </p:txBody>
+      </p:sp>
+      <p:sp>
+        <p:nvSpPr>
+          <p:cNvPr id="16" name="Rectangle 15"/>
+          <p:cNvSpPr/>
+          <p:nvPr/>
+        </p:nvSpPr>
+        <p:spPr>
+          <a:xfrm>
+            <a:off x="6172200" y="1280160"/>
+            <a:ext cx="2743200" cy="1920240"/>
+          </a:xfrm>
+          <a:prstGeom prst="rect">
+            <a:avLst/>
+          </a:prstGeom>
+          <a:solidFill>
+            <a:srgbClr val="FFFFFF"/>
+          </a:solidFill>
+          <a:ln w="12700">
+            <a:solidFill>
+              <a:srgbClr val="DFE4EA"/>
+            </a:solidFill>
+          </a:ln>
+          <a:effectLst/>
+        </p:spPr>
+        <p:style>
+          <a:lnRef idx="1">
+            <a:schemeClr val="accent1"/>
+          </a:lnRef>
+          <a:fillRef idx="3">
+            <a:schemeClr val="accent1"/>
+          </a:fillRef>
+          <a:effectRef idx="2">
+            <a:schemeClr val="accent1"/>
+          </a:effectRef>
+          <a:fontRef idx="minor">
+            <a:schemeClr val="lt1"/>
+          </a:fontRef>
+        </p:style>
+        <p:txBody>
+          <a:bodyPr rtlCol="0" anchor="ctr"/>
+          <a:lstStyle/>
+          <a:p>
+            <a:pPr algn="ctr"/>
+          </a:p>
+        </p:txBody>
+      </p:sp>
+      <p:sp>
+        <p:nvSpPr>
+          <p:cNvPr id="17" name="Rectangle 16"/>
+          <p:cNvSpPr/>
+          <p:nvPr/>
+        </p:nvSpPr>
+        <p:spPr>
+          <a:xfrm>
+            <a:off x="6172200" y="1280160"/>
+            <a:ext cx="2743200" cy="320040"/>
+          </a:xfrm>
+          <a:prstGeom prst="rect">
+            <a:avLst/>
+          </a:prstGeom>
+          <a:solidFill>
+            <a:srgbClr val="1F3A5F"/>
+          </a:solidFill>
+          <a:ln>
+            <a:noFill/>
+          </a:ln>
+          <a:effectLst/>
+        </p:spPr>
+        <p:style>
+          <a:lnRef idx="1">
+            <a:schemeClr val="accent1"/>
+          </a:lnRef>
+          <a:fillRef idx="3">
+            <a:schemeClr val="accent1"/>
+          </a:fillRef>
+          <a:effectRef idx="2">
+            <a:schemeClr val="accent1"/>
+          </a:effectRef>
+          <a:fontRef idx="minor">
+            <a:schemeClr val="lt1"/>
+          </a:fontRef>
+        </p:style>
+        <p:txBody>
+          <a:bodyPr rtlCol="0" anchor="ctr"/>
+          <a:lstStyle/>
+          <a:p>
+            <a:pPr algn="ctr"/>
+          </a:p>
+        </p:txBody>
+      </p:sp>
+      <p:sp>
+        <p:nvSpPr>
+          <p:cNvPr id="18" name="TextBox 17"/>
+          <p:cNvSpPr txBox="1"/>
+          <p:nvPr/>
+        </p:nvSpPr>
+        <p:spPr>
+          <a:xfrm>
+            <a:off x="6294120" y="1280160"/>
+            <a:ext cx="2575560" cy="320040"/>
+          </a:xfrm>
+          <a:prstGeom prst="rect">
+            <a:avLst/>
+          </a:prstGeom>
+          <a:noFill/>
+        </p:spPr>
+        <p:txBody>
+          <a:bodyPr wrap="square" anchor="ctr" lIns="25400" rIns="25400" tIns="12700" bIns="12700">
+            <a:spAutoFit/>
+          </a:bodyPr>
+          <a:lstStyle/>
+          <a:p>
+            <a:pPr algn="l">
+              <a:lnSpc>
+                <a:spcPct val="100000"/>
+              </a:lnSpc>
+              <a:spcBef>
+                <a:spcPts val="0"/>
+              </a:spcBef>
+              <a:spcAft>
+                <a:spcPts val="400"/>
+              </a:spcAft>
+            </a:pPr>
+            <a:r>
+              <a:rPr sz="1300" b="1" i="0">
+                <a:solidFill>
+                  <a:srgbClr val="FFFFFF"/>
+                </a:solidFill>
+                <a:latin typeface="Arial"/>
+              </a:rPr>
+              <a:t>3 · Flexible foam (slabstock)</a:t>
+            </a:r>
+          </a:p>
+        </p:txBody>
+      </p:sp>
+      <p:sp>
+        <p:nvSpPr>
+          <p:cNvPr id="19" name="TextBox 18"/>
+          <p:cNvSpPr txBox="1"/>
+          <p:nvPr/>
+        </p:nvSpPr>
+        <p:spPr>
+          <a:xfrm>
+            <a:off x="6294120" y="1676400"/>
+            <a:ext cx="2514600" cy="1447800"/>
+          </a:xfrm>
+          <a:prstGeom prst="rect">
+            <a:avLst/>
+          </a:prstGeom>
+          <a:noFill/>
+        </p:spPr>
+        <p:txBody>
+          <a:bodyPr wrap="square" anchor="t" lIns="25400" rIns="25400" tIns="12700" bIns="12700">
+            <a:spAutoFit/>
+          </a:bodyPr>
+          <a:lstStyle/>
+          <a:p>
+            <a:pPr algn="l">
+              <a:lnSpc>
+                <a:spcPct val="100000"/>
+              </a:lnSpc>
+              <a:spcBef>
+                <a:spcPts val="0"/>
+              </a:spcBef>
+              <a:spcAft>
+                <a:spcPts val="600"/>
+              </a:spcAft>
+            </a:pPr>
+            <a:r>
+              <a:rPr sz="1150" b="0" i="1">
+                <a:solidFill>
+                  <a:srgbClr val="666666"/>
+                </a:solidFill>
+                <a:latin typeface="Arial"/>
+              </a:rPr>
+              <a:t>Foam producers supplying bedding &amp; upholstered furniture.</a:t>
+            </a:r>
+          </a:p>
+          <a:p>
+            <a:pPr algn="l">
+              <a:lnSpc>
+                <a:spcPct val="100000"/>
+              </a:lnSpc>
+              <a:spcBef>
+                <a:spcPts val="0"/>
+              </a:spcBef>
+              <a:spcAft>
+                <a:spcPts val="0"/>
+              </a:spcAft>
+            </a:pPr>
+            <a:r>
+              <a:rPr sz="1150" b="1" i="0">
+                <a:solidFill>
+                  <a:srgbClr val="222222"/>
+                </a:solidFill>
+                <a:latin typeface="Arial"/>
+              </a:rPr>
+              <a:t>e.g. </a:t>
+            </a:r>
+            <a:r>
+              <a:rPr sz="1150" b="0" i="0">
+                <a:solidFill>
+                  <a:srgbClr val="222222"/>
+                </a:solidFill>
+                <a:latin typeface="Arial"/>
+              </a:rPr>
+              <a:t>Recticel, The Vita Group, Eurofoam, Carpenter, Orsa Foam</a:t>
+            </a:r>
+          </a:p>
+        </p:txBody>
+      </p:sp>
+      <p:sp>
+        <p:nvSpPr>
+          <p:cNvPr id="20" name="Rectangle 19"/>
+          <p:cNvSpPr/>
+          <p:nvPr/>
+        </p:nvSpPr>
+        <p:spPr>
+          <a:xfrm>
+            <a:off x="9067800" y="1280160"/>
+            <a:ext cx="2743200" cy="1920240"/>
+          </a:xfrm>
+          <a:prstGeom prst="rect">
+            <a:avLst/>
+          </a:prstGeom>
+          <a:solidFill>
+            <a:srgbClr val="FFFFFF"/>
+          </a:solidFill>
+          <a:ln w="12700">
+            <a:solidFill>
+              <a:srgbClr val="DFE4EA"/>
+            </a:solidFill>
+          </a:ln>
+          <a:effectLst/>
+        </p:spPr>
+        <p:style>
+          <a:lnRef idx="1">
+            <a:schemeClr val="accent1"/>
+          </a:lnRef>
+          <a:fillRef idx="3">
+            <a:schemeClr val="accent1"/>
+          </a:fillRef>
+          <a:effectRef idx="2">
+            <a:schemeClr val="accent1"/>
+          </a:effectRef>
+          <a:fontRef idx="minor">
+            <a:schemeClr val="lt1"/>
+          </a:fontRef>
+        </p:style>
+        <p:txBody>
+          <a:bodyPr rtlCol="0" anchor="ctr"/>
+          <a:lstStyle/>
+          <a:p>
+            <a:pPr algn="ctr"/>
+          </a:p>
+        </p:txBody>
+      </p:sp>
+      <p:sp>
+        <p:nvSpPr>
+          <p:cNvPr id="21" name="Rectangle 20"/>
+          <p:cNvSpPr/>
+          <p:nvPr/>
+        </p:nvSpPr>
+        <p:spPr>
+          <a:xfrm>
+            <a:off x="9067800" y="1280160"/>
+            <a:ext cx="2743200" cy="320040"/>
+          </a:xfrm>
+          <a:prstGeom prst="rect">
+            <a:avLst/>
+          </a:prstGeom>
+          <a:solidFill>
+            <a:srgbClr val="1F3A5F"/>
+          </a:solidFill>
+          <a:ln>
+            <a:noFill/>
+          </a:ln>
+          <a:effectLst/>
+        </p:spPr>
+        <p:style>
+          <a:lnRef idx="1">
+            <a:schemeClr val="accent1"/>
+          </a:lnRef>
+          <a:fillRef idx="3">
+            <a:schemeClr val="accent1"/>
+          </a:fillRef>
+          <a:effectRef idx="2">
+            <a:schemeClr val="accent1"/>
+          </a:effectRef>
+          <a:fontRef idx="minor">
+            <a:schemeClr val="lt1"/>
+          </a:fontRef>
+        </p:style>
+        <p:txBody>
+          <a:bodyPr rtlCol="0" anchor="ctr"/>
+          <a:lstStyle/>
+          <a:p>
+            <a:pPr algn="ctr"/>
+          </a:p>
+        </p:txBody>
+      </p:sp>
+      <p:sp>
+        <p:nvSpPr>
+          <p:cNvPr id="22" name="TextBox 21"/>
+          <p:cNvSpPr txBox="1"/>
+          <p:nvPr/>
+        </p:nvSpPr>
+        <p:spPr>
+          <a:xfrm>
+            <a:off x="9189720" y="1280160"/>
+            <a:ext cx="2575560" cy="320040"/>
+          </a:xfrm>
+          <a:prstGeom prst="rect">
+            <a:avLst/>
+          </a:prstGeom>
+          <a:noFill/>
+        </p:spPr>
+        <p:txBody>
+          <a:bodyPr wrap="square" anchor="ctr" lIns="25400" rIns="25400" tIns="12700" bIns="12700">
+            <a:spAutoFit/>
+          </a:bodyPr>
+          <a:lstStyle/>
+          <a:p>
+            <a:pPr algn="l">
+              <a:lnSpc>
+                <a:spcPct val="100000"/>
+              </a:lnSpc>
+              <a:spcBef>
+                <a:spcPts val="0"/>
+              </a:spcBef>
+              <a:spcAft>
+                <a:spcPts val="400"/>
+              </a:spcAft>
+            </a:pPr>
+            <a:r>
+              <a:rPr sz="1300" b="1" i="0">
+                <a:solidFill>
+                  <a:srgbClr val="FFFFFF"/>
+                </a:solidFill>
+                <a:latin typeface="Arial"/>
+              </a:rPr>
+              <a:t>4 · Automotive</a:t>
+            </a:r>
+          </a:p>
+        </p:txBody>
+      </p:sp>
+      <p:sp>
+        <p:nvSpPr>
+          <p:cNvPr id="23" name="TextBox 22"/>
+          <p:cNvSpPr txBox="1"/>
+          <p:nvPr/>
+        </p:nvSpPr>
+        <p:spPr>
+          <a:xfrm>
+            <a:off x="9189720" y="1676400"/>
+            <a:ext cx="2514600" cy="1447800"/>
+          </a:xfrm>
+          <a:prstGeom prst="rect">
+            <a:avLst/>
+          </a:prstGeom>
+          <a:noFill/>
+        </p:spPr>
+        <p:txBody>
+          <a:bodyPr wrap="square" anchor="t" lIns="25400" rIns="25400" tIns="12700" bIns="12700">
+            <a:spAutoFit/>
+          </a:bodyPr>
+          <a:lstStyle/>
+          <a:p>
+            <a:pPr algn="l">
+              <a:lnSpc>
+                <a:spcPct val="100000"/>
+              </a:lnSpc>
+              <a:spcBef>
+                <a:spcPts val="0"/>
+              </a:spcBef>
+              <a:spcAft>
+                <a:spcPts val="600"/>
+              </a:spcAft>
+            </a:pPr>
+            <a:r>
+              <a:rPr sz="1150" b="0" i="1">
+                <a:solidFill>
+                  <a:srgbClr val="666666"/>
+                </a:solidFill>
+                <a:latin typeface="Arial"/>
+              </a:rPr>
+              <a:t>Tier-1 makers of seating, interiors, NVH, RIM &amp; composite parts.</a:t>
+            </a:r>
+          </a:p>
+          <a:p>
+            <a:pPr algn="l">
+              <a:lnSpc>
+                <a:spcPct val="100000"/>
+              </a:lnSpc>
+              <a:spcBef>
+                <a:spcPts val="0"/>
+              </a:spcBef>
+              <a:spcAft>
+                <a:spcPts val="0"/>
+              </a:spcAft>
+            </a:pPr>
+            <a:r>
+              <a:rPr sz="1150" b="1" i="0">
+                <a:solidFill>
+                  <a:srgbClr val="222222"/>
+                </a:solidFill>
+                <a:latin typeface="Arial"/>
+              </a:rPr>
+              <a:t>e.g. </a:t>
+            </a:r>
+            <a:r>
+              <a:rPr sz="1150" b="0" i="0">
+                <a:solidFill>
+                  <a:srgbClr val="222222"/>
+                </a:solidFill>
+                <a:latin typeface="Arial"/>
+              </a:rPr>
+              <a:t>Adient, Lear, Forvia, Magna, Grupo Antolin</a:t>
+            </a:r>
+          </a:p>
+        </p:txBody>
+      </p:sp>
+      <p:sp>
+        <p:nvSpPr>
+          <p:cNvPr id="24" name="Rectangle 23"/>
+          <p:cNvSpPr/>
+          <p:nvPr/>
+        </p:nvSpPr>
+        <p:spPr>
+          <a:xfrm>
+            <a:off x="381000" y="3444240"/>
+            <a:ext cx="2743200" cy="1920240"/>
+          </a:xfrm>
+          <a:prstGeom prst="rect">
+            <a:avLst/>
+          </a:prstGeom>
+          <a:solidFill>
+            <a:srgbClr val="FFFFFF"/>
+          </a:solidFill>
+          <a:ln w="12700">
+            <a:solidFill>
+              <a:srgbClr val="DFE4EA"/>
+            </a:solidFill>
+          </a:ln>
+          <a:effectLst/>
+        </p:spPr>
+        <p:style>
+          <a:lnRef idx="1">
+            <a:schemeClr val="accent1"/>
+          </a:lnRef>
+          <a:fillRef idx="3">
+            <a:schemeClr val="accent1"/>
+          </a:fillRef>
+          <a:effectRef idx="2">
+            <a:schemeClr val="accent1"/>
+          </a:effectRef>
+          <a:fontRef idx="minor">
+            <a:schemeClr val="lt1"/>
+          </a:fontRef>
+        </p:style>
+        <p:txBody>
+          <a:bodyPr rtlCol="0" anchor="ctr"/>
+          <a:lstStyle/>
+          <a:p>
+            <a:pPr algn="ctr"/>
+          </a:p>
+        </p:txBody>
+      </p:sp>
+      <p:sp>
+        <p:nvSpPr>
+          <p:cNvPr id="25" name="Rectangle 24"/>
+          <p:cNvSpPr/>
+          <p:nvPr/>
+        </p:nvSpPr>
+        <p:spPr>
+          <a:xfrm>
+            <a:off x="381000" y="3444240"/>
+            <a:ext cx="2743200" cy="320040"/>
+          </a:xfrm>
+          <a:prstGeom prst="rect">
+            <a:avLst/>
+          </a:prstGeom>
+          <a:solidFill>
+            <a:srgbClr val="1F3A5F"/>
+          </a:solidFill>
+          <a:ln>
+            <a:noFill/>
+          </a:ln>
+          <a:effectLst/>
+        </p:spPr>
+        <p:style>
+          <a:lnRef idx="1">
+            <a:schemeClr val="accent1"/>
+          </a:lnRef>
+          <a:fillRef idx="3">
+            <a:schemeClr val="accent1"/>
+          </a:fillRef>
+          <a:effectRef idx="2">
+            <a:schemeClr val="accent1"/>
+          </a:effectRef>
+          <a:fontRef idx="minor">
+            <a:schemeClr val="lt1"/>
+          </a:fontRef>
+        </p:style>
+        <p:txBody>
+          <a:bodyPr rtlCol="0" anchor="ctr"/>
+          <a:lstStyle/>
+          <a:p>
+            <a:pPr algn="ctr"/>
+          </a:p>
+        </p:txBody>
+      </p:sp>
+      <p:sp>
+        <p:nvSpPr>
+          <p:cNvPr id="26" name="TextBox 25"/>
+          <p:cNvSpPr txBox="1"/>
+          <p:nvPr/>
+        </p:nvSpPr>
+        <p:spPr>
+          <a:xfrm>
+            <a:off x="502920" y="3444240"/>
+            <a:ext cx="2575560" cy="320040"/>
+          </a:xfrm>
+          <a:prstGeom prst="rect">
+            <a:avLst/>
+          </a:prstGeom>
+          <a:noFill/>
+        </p:spPr>
+        <p:txBody>
+          <a:bodyPr wrap="square" anchor="ctr" lIns="25400" rIns="25400" tIns="12700" bIns="12700">
+            <a:spAutoFit/>
+          </a:bodyPr>
+          <a:lstStyle/>
+          <a:p>
+            <a:pPr algn="l">
+              <a:lnSpc>
+                <a:spcPct val="100000"/>
+              </a:lnSpc>
+              <a:spcBef>
+                <a:spcPts val="0"/>
+              </a:spcBef>
+              <a:spcAft>
+                <a:spcPts val="400"/>
+              </a:spcAft>
+            </a:pPr>
+            <a:r>
+              <a:rPr sz="1300" b="1" i="0">
+                <a:solidFill>
+                  <a:srgbClr val="FFFFFF"/>
+                </a:solidFill>
+                <a:latin typeface="Arial"/>
+              </a:rPr>
+              <a:t>5 · Footwear</a:t>
+            </a:r>
+          </a:p>
+        </p:txBody>
+      </p:sp>
+      <p:sp>
+        <p:nvSpPr>
+          <p:cNvPr id="27" name="TextBox 26"/>
+          <p:cNvSpPr txBox="1"/>
+          <p:nvPr/>
+        </p:nvSpPr>
+        <p:spPr>
+          <a:xfrm>
+            <a:off x="502920" y="3840480"/>
+            <a:ext cx="2514600" cy="1447800"/>
+          </a:xfrm>
+          <a:prstGeom prst="rect">
+            <a:avLst/>
+          </a:prstGeom>
+          <a:noFill/>
+        </p:spPr>
+        <p:txBody>
+          <a:bodyPr wrap="square" anchor="t" lIns="25400" rIns="25400" tIns="12700" bIns="12700">
+            <a:spAutoFit/>
+          </a:bodyPr>
+          <a:lstStyle/>
+          <a:p>
+            <a:pPr algn="l">
+              <a:lnSpc>
+                <a:spcPct val="100000"/>
+              </a:lnSpc>
+              <a:spcBef>
+                <a:spcPts val="0"/>
+              </a:spcBef>
+              <a:spcAft>
+                <a:spcPts val="600"/>
+              </a:spcAft>
+            </a:pPr>
+            <a:r>
+              <a:rPr sz="1150" b="0" i="1">
+                <a:solidFill>
+                  <a:srgbClr val="666666"/>
+                </a:solidFill>
+                <a:latin typeface="Arial"/>
+              </a:rPr>
+              <a:t>PU sole producers &amp; footwear makers (direct injection); strong Italian districts.</a:t>
+            </a:r>
+          </a:p>
+          <a:p>
+            <a:pPr algn="l">
+              <a:lnSpc>
+                <a:spcPct val="100000"/>
+              </a:lnSpc>
+              <a:spcBef>
+                <a:spcPts val="0"/>
+              </a:spcBef>
+              <a:spcAft>
+                <a:spcPts val="0"/>
+              </a:spcAft>
+            </a:pPr>
+            <a:r>
+              <a:rPr sz="1150" b="1" i="0">
+                <a:solidFill>
+                  <a:srgbClr val="222222"/>
+                </a:solidFill>
+                <a:latin typeface="Arial"/>
+              </a:rPr>
+              <a:t>e.g. </a:t>
+            </a:r>
+            <a:r>
+              <a:rPr sz="1150" b="0" i="0">
+                <a:solidFill>
+                  <a:srgbClr val="222222"/>
+                </a:solidFill>
+                <a:latin typeface="Arial"/>
+              </a:rPr>
+              <a:t>Sole manufacturers &amp; footwear brands' suppliers</a:t>
+            </a:r>
+          </a:p>
+        </p:txBody>
+      </p:sp>
+      <p:sp>
+        <p:nvSpPr>
+          <p:cNvPr id="28" name="Rectangle 27"/>
+          <p:cNvSpPr/>
+          <p:nvPr/>
+        </p:nvSpPr>
+        <p:spPr>
+          <a:xfrm>
+            <a:off x="3276600" y="3444240"/>
+            <a:ext cx="2743200" cy="1920240"/>
+          </a:xfrm>
+          <a:prstGeom prst="rect">
+            <a:avLst/>
+          </a:prstGeom>
+          <a:solidFill>
+            <a:srgbClr val="FFFFFF"/>
+          </a:solidFill>
+          <a:ln w="12700">
+            <a:solidFill>
+              <a:srgbClr val="DFE4EA"/>
+            </a:solidFill>
+          </a:ln>
+          <a:effectLst/>
+        </p:spPr>
+        <p:style>
+          <a:lnRef idx="1">
+            <a:schemeClr val="accent1"/>
+          </a:lnRef>
+          <a:fillRef idx="3">
+            <a:schemeClr val="accent1"/>
+          </a:fillRef>
+          <a:effectRef idx="2">
+            <a:schemeClr val="accent1"/>
+          </a:effectRef>
+          <a:fontRef idx="minor">
+            <a:schemeClr val="lt1"/>
+          </a:fontRef>
+        </p:style>
+        <p:txBody>
+          <a:bodyPr rtlCol="0" anchor="ctr"/>
+          <a:lstStyle/>
+          <a:p>
+            <a:pPr algn="ctr"/>
+          </a:p>
+        </p:txBody>
+      </p:sp>
+      <p:sp>
+        <p:nvSpPr>
+          <p:cNvPr id="29" name="Rectangle 28"/>
+          <p:cNvSpPr/>
+          <p:nvPr/>
+        </p:nvSpPr>
+        <p:spPr>
+          <a:xfrm>
+            <a:off x="3276600" y="3444240"/>
+            <a:ext cx="2743200" cy="320040"/>
+          </a:xfrm>
+          <a:prstGeom prst="rect">
+            <a:avLst/>
+          </a:prstGeom>
+          <a:solidFill>
+            <a:srgbClr val="1F3A5F"/>
+          </a:solidFill>
+          <a:ln>
+            <a:noFill/>
+          </a:ln>
+          <a:effectLst/>
+        </p:spPr>
+        <p:style>
+          <a:lnRef idx="1">
+            <a:schemeClr val="accent1"/>
+          </a:lnRef>
+          <a:fillRef idx="3">
+            <a:schemeClr val="accent1"/>
+          </a:fillRef>
+          <a:effectRef idx="2">
+            <a:schemeClr val="accent1"/>
+          </a:effectRef>
+          <a:fontRef idx="minor">
+            <a:schemeClr val="lt1"/>
+          </a:fontRef>
+        </p:style>
+        <p:txBody>
+          <a:bodyPr rtlCol="0" anchor="ctr"/>
+          <a:lstStyle/>
+          <a:p>
+            <a:pPr algn="ctr"/>
+          </a:p>
+        </p:txBody>
+      </p:sp>
+      <p:sp>
+        <p:nvSpPr>
+          <p:cNvPr id="30" name="TextBox 29"/>
+          <p:cNvSpPr txBox="1"/>
+          <p:nvPr/>
+        </p:nvSpPr>
+        <p:spPr>
+          <a:xfrm>
+            <a:off x="3398520" y="3444240"/>
+            <a:ext cx="2575560" cy="320040"/>
+          </a:xfrm>
+          <a:prstGeom prst="rect">
+            <a:avLst/>
+          </a:prstGeom>
+          <a:noFill/>
+        </p:spPr>
+        <p:txBody>
+          <a:bodyPr wrap="square" anchor="ctr" lIns="25400" rIns="25400" tIns="12700" bIns="12700">
+            <a:spAutoFit/>
+          </a:bodyPr>
+          <a:lstStyle/>
+          <a:p>
+            <a:pPr algn="l">
+              <a:lnSpc>
+                <a:spcPct val="100000"/>
+              </a:lnSpc>
+              <a:spcBef>
+                <a:spcPts val="0"/>
+              </a:spcBef>
+              <a:spcAft>
+                <a:spcPts val="400"/>
+              </a:spcAft>
+            </a:pPr>
+            <a:r>
+              <a:rPr sz="1300" b="1" i="0">
+                <a:solidFill>
+                  <a:srgbClr val="FFFFFF"/>
+                </a:solidFill>
+                <a:latin typeface="Arial"/>
+              </a:rPr>
+              <a:t>6 · Elastomers &amp; composites</a:t>
+            </a:r>
+          </a:p>
+        </p:txBody>
+      </p:sp>
+      <p:sp>
+        <p:nvSpPr>
+          <p:cNvPr id="31" name="TextBox 30"/>
+          <p:cNvSpPr txBox="1"/>
+          <p:nvPr/>
+        </p:nvSpPr>
+        <p:spPr>
+          <a:xfrm>
+            <a:off x="3398520" y="3840480"/>
+            <a:ext cx="2514600" cy="1447800"/>
+          </a:xfrm>
+          <a:prstGeom prst="rect">
+            <a:avLst/>
+          </a:prstGeom>
+          <a:noFill/>
+        </p:spPr>
+        <p:txBody>
+          <a:bodyPr wrap="square" anchor="t" lIns="25400" rIns="25400" tIns="12700" bIns="12700">
+            <a:spAutoFit/>
+          </a:bodyPr>
+          <a:lstStyle/>
+          <a:p>
+            <a:pPr algn="l">
+              <a:lnSpc>
+                <a:spcPct val="100000"/>
+              </a:lnSpc>
+              <a:spcBef>
+                <a:spcPts val="0"/>
+              </a:spcBef>
+              <a:spcAft>
+                <a:spcPts val="600"/>
+              </a:spcAft>
+            </a:pPr>
+            <a:r>
+              <a:rPr sz="1150" b="0" i="1">
+                <a:solidFill>
+                  <a:srgbClr val="666666"/>
+                </a:solidFill>
+                <a:latin typeface="Arial"/>
+              </a:rPr>
+              <a:t>Technical PU parts: rollers, coatings, RIM and composite components.</a:t>
+            </a:r>
+          </a:p>
+          <a:p>
+            <a:pPr algn="l">
+              <a:lnSpc>
+                <a:spcPct val="100000"/>
+              </a:lnSpc>
+              <a:spcBef>
+                <a:spcPts val="0"/>
+              </a:spcBef>
+              <a:spcAft>
+                <a:spcPts val="0"/>
+              </a:spcAft>
+            </a:pPr>
+            <a:r>
+              <a:rPr sz="1150" b="1" i="0">
+                <a:solidFill>
+                  <a:srgbClr val="222222"/>
+                </a:solidFill>
+                <a:latin typeface="Arial"/>
+              </a:rPr>
+              <a:t>e.g. </a:t>
+            </a:r>
+            <a:r>
+              <a:rPr sz="1150" b="0" i="0">
+                <a:solidFill>
+                  <a:srgbClr val="222222"/>
+                </a:solidFill>
+                <a:latin typeface="Arial"/>
+              </a:rPr>
+              <a:t>Industrial manufacturers of technical PU parts</a:t>
+            </a:r>
+          </a:p>
+        </p:txBody>
+      </p:sp>
+      <p:sp>
+        <p:nvSpPr>
+          <p:cNvPr id="32" name="Rectangle 31"/>
+          <p:cNvSpPr/>
+          <p:nvPr/>
+        </p:nvSpPr>
+        <p:spPr>
+          <a:xfrm>
+            <a:off x="6172200" y="3444240"/>
+            <a:ext cx="2743200" cy="1920240"/>
+          </a:xfrm>
+          <a:prstGeom prst="rect">
+            <a:avLst/>
+          </a:prstGeom>
+          <a:solidFill>
+            <a:srgbClr val="FFFFFF"/>
+          </a:solidFill>
+          <a:ln w="12700">
+            <a:solidFill>
+              <a:srgbClr val="DFE4EA"/>
+            </a:solidFill>
+          </a:ln>
+          <a:effectLst/>
+        </p:spPr>
+        <p:style>
+          <a:lnRef idx="1">
+            <a:schemeClr val="accent1"/>
+          </a:lnRef>
+          <a:fillRef idx="3">
+            <a:schemeClr val="accent1"/>
+          </a:fillRef>
+          <a:effectRef idx="2">
+            <a:schemeClr val="accent1"/>
+          </a:effectRef>
+          <a:fontRef idx="minor">
+            <a:schemeClr val="lt1"/>
+          </a:fontRef>
+        </p:style>
+        <p:txBody>
+          <a:bodyPr rtlCol="0" anchor="ctr"/>
+          <a:lstStyle/>
+          <a:p>
+            <a:pPr algn="ctr"/>
+          </a:p>
+        </p:txBody>
+      </p:sp>
+      <p:sp>
+        <p:nvSpPr>
+          <p:cNvPr id="33" name="Rectangle 32"/>
+          <p:cNvSpPr/>
+          <p:nvPr/>
+        </p:nvSpPr>
+        <p:spPr>
+          <a:xfrm>
+            <a:off x="6172200" y="3444240"/>
+            <a:ext cx="2743200" cy="320040"/>
+          </a:xfrm>
+          <a:prstGeom prst="rect">
+            <a:avLst/>
+          </a:prstGeom>
+          <a:solidFill>
+            <a:srgbClr val="1F3A5F"/>
+          </a:solidFill>
+          <a:ln>
+            <a:noFill/>
+          </a:ln>
+          <a:effectLst/>
+        </p:spPr>
+        <p:style>
+          <a:lnRef idx="1">
+            <a:schemeClr val="accent1"/>
+          </a:lnRef>
+          <a:fillRef idx="3">
+            <a:schemeClr val="accent1"/>
+          </a:fillRef>
+          <a:effectRef idx="2">
+            <a:schemeClr val="accent1"/>
+          </a:effectRef>
+          <a:fontRef idx="minor">
+            <a:schemeClr val="lt1"/>
+          </a:fontRef>
+        </p:style>
+        <p:txBody>
+          <a:bodyPr rtlCol="0" anchor="ctr"/>
+          <a:lstStyle/>
+          <a:p>
+            <a:pPr algn="ctr"/>
+          </a:p>
+        </p:txBody>
+      </p:sp>
+      <p:sp>
+        <p:nvSpPr>
+          <p:cNvPr id="34" name="TextBox 33"/>
+          <p:cNvSpPr txBox="1"/>
+          <p:nvPr/>
+        </p:nvSpPr>
+        <p:spPr>
+          <a:xfrm>
+            <a:off x="6294120" y="3444240"/>
+            <a:ext cx="2575560" cy="320040"/>
+          </a:xfrm>
+          <a:prstGeom prst="rect">
+            <a:avLst/>
+          </a:prstGeom>
+          <a:noFill/>
+        </p:spPr>
+        <p:txBody>
+          <a:bodyPr wrap="square" anchor="ctr" lIns="25400" rIns="25400" tIns="12700" bIns="12700">
+            <a:spAutoFit/>
+          </a:bodyPr>
+          <a:lstStyle/>
+          <a:p>
+            <a:pPr algn="l">
+              <a:lnSpc>
+                <a:spcPct val="100000"/>
+              </a:lnSpc>
+              <a:spcBef>
+                <a:spcPts val="0"/>
+              </a:spcBef>
+              <a:spcAft>
+                <a:spcPts val="400"/>
+              </a:spcAft>
+            </a:pPr>
+            <a:r>
+              <a:rPr sz="1300" b="1" i="0">
+                <a:solidFill>
+                  <a:srgbClr val="FFFFFF"/>
+                </a:solidFill>
+                <a:latin typeface="Arial"/>
+              </a:rPr>
+              <a:t>7 · Pipe insulation &amp; water heaters</a:t>
+            </a:r>
+          </a:p>
+        </p:txBody>
+      </p:sp>
+      <p:sp>
+        <p:nvSpPr>
+          <p:cNvPr id="35" name="TextBox 34"/>
+          <p:cNvSpPr txBox="1"/>
+          <p:nvPr/>
+        </p:nvSpPr>
+        <p:spPr>
+          <a:xfrm>
+            <a:off x="6294120" y="3840480"/>
+            <a:ext cx="2514600" cy="1447800"/>
+          </a:xfrm>
+          <a:prstGeom prst="rect">
+            <a:avLst/>
+          </a:prstGeom>
+          <a:noFill/>
+        </p:spPr>
+        <p:txBody>
+          <a:bodyPr wrap="square" anchor="t" lIns="25400" rIns="25400" tIns="12700" bIns="12700">
+            <a:spAutoFit/>
+          </a:bodyPr>
+          <a:lstStyle/>
+          <a:p>
+            <a:pPr algn="l">
+              <a:lnSpc>
+                <a:spcPct val="100000"/>
+              </a:lnSpc>
+              <a:spcBef>
+                <a:spcPts val="0"/>
+              </a:spcBef>
+              <a:spcAft>
+                <a:spcPts val="600"/>
+              </a:spcAft>
+            </a:pPr>
+            <a:r>
+              <a:rPr sz="1150" b="0" i="1">
+                <a:solidFill>
+                  <a:srgbClr val="666666"/>
+                </a:solidFill>
+                <a:latin typeface="Arial"/>
+              </a:rPr>
+              <a:t>District-heating pre-insulated pipes; boiler / water-heater makers.</a:t>
+            </a:r>
+          </a:p>
+          <a:p>
+            <a:pPr algn="l">
+              <a:lnSpc>
+                <a:spcPct val="100000"/>
+              </a:lnSpc>
+              <a:spcBef>
+                <a:spcPts val="0"/>
+              </a:spcBef>
+              <a:spcAft>
+                <a:spcPts val="0"/>
+              </a:spcAft>
+            </a:pPr>
+            <a:r>
+              <a:rPr sz="1150" b="1" i="0">
+                <a:solidFill>
+                  <a:srgbClr val="222222"/>
+                </a:solidFill>
+                <a:latin typeface="Arial"/>
+              </a:rPr>
+              <a:t>e.g. </a:t>
+            </a:r>
+            <a:r>
+              <a:rPr sz="1150" b="0" i="0">
+                <a:solidFill>
+                  <a:srgbClr val="222222"/>
+                </a:solidFill>
+                <a:latin typeface="Arial"/>
+              </a:rPr>
+              <a:t>Logstor (Kingspan), Brugg, Isoplus; Ariston, A.O. Smith</a:t>
+            </a:r>
+          </a:p>
+        </p:txBody>
+      </p:sp>
+      <p:sp>
+        <p:nvSpPr>
+          <p:cNvPr id="36" name="Rectangle 35"/>
+          <p:cNvSpPr/>
+          <p:nvPr/>
+        </p:nvSpPr>
+        <p:spPr>
+          <a:xfrm>
+            <a:off x="9067800" y="3444240"/>
+            <a:ext cx="2743200" cy="1920240"/>
+          </a:xfrm>
+          <a:prstGeom prst="rect">
+            <a:avLst/>
+          </a:prstGeom>
+          <a:solidFill>
+            <a:srgbClr val="FFFFFF"/>
+          </a:solidFill>
+          <a:ln w="12700">
+            <a:solidFill>
+              <a:srgbClr val="DFE4EA"/>
+            </a:solidFill>
+          </a:ln>
+          <a:effectLst/>
+        </p:spPr>
+        <p:style>
+          <a:lnRef idx="1">
+            <a:schemeClr val="accent1"/>
+          </a:lnRef>
+          <a:fillRef idx="3">
+            <a:schemeClr val="accent1"/>
+          </a:fillRef>
+          <a:effectRef idx="2">
+            <a:schemeClr val="accent1"/>
+          </a:effectRef>
+          <a:fontRef idx="minor">
+            <a:schemeClr val="lt1"/>
+          </a:fontRef>
+        </p:style>
+        <p:txBody>
+          <a:bodyPr rtlCol="0" anchor="ctr"/>
+          <a:lstStyle/>
+          <a:p>
+            <a:pPr algn="ctr"/>
+          </a:p>
+        </p:txBody>
+      </p:sp>
+      <p:sp>
+        <p:nvSpPr>
+          <p:cNvPr id="37" name="Rectangle 36"/>
+          <p:cNvSpPr/>
+          <p:nvPr/>
+        </p:nvSpPr>
+        <p:spPr>
+          <a:xfrm>
+            <a:off x="9067800" y="3444240"/>
+            <a:ext cx="2743200" cy="320040"/>
+          </a:xfrm>
+          <a:prstGeom prst="rect">
+            <a:avLst/>
+          </a:prstGeom>
+          <a:solidFill>
+            <a:srgbClr val="1F3A5F"/>
+          </a:solidFill>
+          <a:ln>
+            <a:noFill/>
+          </a:ln>
+          <a:effectLst/>
+        </p:spPr>
+        <p:style>
+          <a:lnRef idx="1">
+            <a:schemeClr val="accent1"/>
+          </a:lnRef>
+          <a:fillRef idx="3">
+            <a:schemeClr val="accent1"/>
+          </a:fillRef>
+          <a:effectRef idx="2">
+            <a:schemeClr val="accent1"/>
+          </a:effectRef>
+          <a:fontRef idx="minor">
+            <a:schemeClr val="lt1"/>
+          </a:fontRef>
+        </p:style>
+        <p:txBody>
+          <a:bodyPr rtlCol="0" anchor="ctr"/>
+          <a:lstStyle/>
+          <a:p>
+            <a:pPr algn="ctr"/>
+          </a:p>
+        </p:txBody>
+      </p:sp>
+      <p:sp>
+        <p:nvSpPr>
+          <p:cNvPr id="38" name="TextBox 37"/>
+          <p:cNvSpPr txBox="1"/>
+          <p:nvPr/>
+        </p:nvSpPr>
+        <p:spPr>
+          <a:xfrm>
+            <a:off x="9189720" y="3444240"/>
+            <a:ext cx="2575560" cy="320040"/>
+          </a:xfrm>
+          <a:prstGeom prst="rect">
+            <a:avLst/>
+          </a:prstGeom>
+          <a:noFill/>
+        </p:spPr>
+        <p:txBody>
+          <a:bodyPr wrap="square" anchor="ctr" lIns="25400" rIns="25400" tIns="12700" bIns="12700">
+            <a:spAutoFit/>
+          </a:bodyPr>
+          <a:lstStyle/>
+          <a:p>
+            <a:pPr algn="l">
+              <a:lnSpc>
+                <a:spcPct val="100000"/>
+              </a:lnSpc>
+              <a:spcBef>
+                <a:spcPts val="0"/>
+              </a:spcBef>
+              <a:spcAft>
+                <a:spcPts val="400"/>
+              </a:spcAft>
+            </a:pPr>
+            <a:r>
+              <a:rPr sz="1300" b="1" i="0">
+                <a:solidFill>
+                  <a:srgbClr val="FFFFFF"/>
+                </a:solidFill>
+                <a:latin typeface="Arial"/>
+              </a:rPr>
+              <a:t>8 · PU system houses (partners)</a:t>
+            </a:r>
+          </a:p>
+        </p:txBody>
+      </p:sp>
+      <p:sp>
+        <p:nvSpPr>
+          <p:cNvPr id="39" name="TextBox 38"/>
+          <p:cNvSpPr txBox="1"/>
+          <p:nvPr/>
+        </p:nvSpPr>
+        <p:spPr>
+          <a:xfrm>
+            <a:off x="9189720" y="3840480"/>
+            <a:ext cx="2514600" cy="1447800"/>
+          </a:xfrm>
+          <a:prstGeom prst="rect">
+            <a:avLst/>
+          </a:prstGeom>
+          <a:noFill/>
+        </p:spPr>
+        <p:txBody>
+          <a:bodyPr wrap="square" anchor="t" lIns="25400" rIns="25400" tIns="12700" bIns="12700">
+            <a:spAutoFit/>
+          </a:bodyPr>
+          <a:lstStyle/>
+          <a:p>
+            <a:pPr algn="l">
+              <a:lnSpc>
+                <a:spcPct val="100000"/>
+              </a:lnSpc>
+              <a:spcBef>
+                <a:spcPts val="0"/>
+              </a:spcBef>
+              <a:spcAft>
+                <a:spcPts val="600"/>
+              </a:spcAft>
+            </a:pPr>
+            <a:r>
+              <a:rPr sz="1150" b="0" i="1">
+                <a:solidFill>
+                  <a:srgbClr val="666666"/>
+                </a:solidFill>
+                <a:latin typeface="Arial"/>
+              </a:rPr>
+              <a:t>Chemical groups integrating process technology with raw-material systems.</a:t>
+            </a:r>
+          </a:p>
+          <a:p>
+            <a:pPr algn="l">
+              <a:lnSpc>
+                <a:spcPct val="100000"/>
+              </a:lnSpc>
+              <a:spcBef>
+                <a:spcPts val="0"/>
+              </a:spcBef>
+              <a:spcAft>
+                <a:spcPts val="0"/>
+              </a:spcAft>
+            </a:pPr>
+            <a:r>
+              <a:rPr sz="1150" b="1" i="0">
+                <a:solidFill>
+                  <a:srgbClr val="222222"/>
+                </a:solidFill>
+                <a:latin typeface="Arial"/>
+              </a:rPr>
+              <a:t>e.g. </a:t>
+            </a:r>
+            <a:r>
+              <a:rPr sz="1150" b="0" i="0">
+                <a:solidFill>
+                  <a:srgbClr val="222222"/>
+                </a:solidFill>
+                <a:latin typeface="Arial"/>
+              </a:rPr>
+              <a:t>Covestro, BASF, Dow, Huntsman</a:t>
+            </a:r>
+          </a:p>
+        </p:txBody>
+      </p:sp>
+      <p:sp>
+        <p:nvSpPr>
+          <p:cNvPr id="40" name="Rectangle 39"/>
+          <p:cNvSpPr/>
+          <p:nvPr/>
+        </p:nvSpPr>
+        <p:spPr>
+          <a:xfrm>
+            <a:off x="381000" y="5471160"/>
+            <a:ext cx="11430000" cy="731520"/>
+          </a:xfrm>
+          <a:prstGeom prst="rect">
+            <a:avLst/>
+          </a:prstGeom>
+          <a:solidFill>
+            <a:srgbClr val="EEF2F7"/>
+          </a:solidFill>
+          <a:ln w="12700">
+            <a:solidFill>
+              <a:srgbClr val="CDD8E6"/>
+            </a:solidFill>
+          </a:ln>
+          <a:effectLst/>
+        </p:spPr>
+        <p:style>
+          <a:lnRef idx="1">
+            <a:schemeClr val="accent1"/>
+          </a:lnRef>
+          <a:fillRef idx="3">
+            <a:schemeClr val="accent1"/>
+          </a:fillRef>
+          <a:effectRef idx="2">
+            <a:schemeClr val="accent1"/>
+          </a:effectRef>
+          <a:fontRef idx="minor">
+            <a:schemeClr val="lt1"/>
+          </a:fontRef>
+        </p:style>
+        <p:txBody>
+          <a:bodyPr rtlCol="0" anchor="ctr"/>
+          <a:lstStyle/>
+          <a:p>
+            <a:pPr algn="ctr"/>
+          </a:p>
+        </p:txBody>
+      </p:sp>
+      <p:sp>
+        <p:nvSpPr>
+          <p:cNvPr id="41" name="TextBox 40"/>
+          <p:cNvSpPr txBox="1"/>
+          <p:nvPr/>
+        </p:nvSpPr>
+        <p:spPr>
+          <a:xfrm>
+            <a:off x="563880" y="5547360"/>
+            <a:ext cx="11064240" cy="609600"/>
+          </a:xfrm>
+          <a:prstGeom prst="rect">
+            <a:avLst/>
+          </a:prstGeom>
+          <a:noFill/>
+        </p:spPr>
+        <p:txBody>
+          <a:bodyPr wrap="square" anchor="ctr" lIns="25400" rIns="25400" tIns="12700" bIns="12700">
+            <a:spAutoFit/>
+          </a:bodyPr>
+          <a:lstStyle/>
+          <a:p>
+            <a:pPr algn="l">
+              <a:lnSpc>
+                <a:spcPct val="100000"/>
+              </a:lnSpc>
+              <a:spcBef>
+                <a:spcPts val="0"/>
+              </a:spcBef>
+              <a:spcAft>
+                <a:spcPts val="400"/>
+              </a:spcAft>
+            </a:pPr>
+            <a:r>
+              <a:rPr sz="1400" b="1" i="0">
+                <a:solidFill>
+                  <a:srgbClr val="1F3A5F"/>
+                </a:solidFill>
+                <a:latin typeface="Arial"/>
+              </a:rPr>
+              <a:t>Read-across: </a:t>
+            </a:r>
+            <a:r>
+              <a:rPr sz="1400" b="0" i="0">
+                <a:solidFill>
+                  <a:srgbClr val="333333"/>
+                </a:solidFill>
+                <a:latin typeface="Arial"/>
+              </a:rPr>
+              <a:t>capex-driven, cyclical buyers → the installed base drives recurring </a:t>
+            </a:r>
+            <a:r>
+              <a:rPr sz="1400" b="1" i="0">
+                <a:solidFill>
+                  <a:srgbClr val="333333"/>
+                </a:solidFill>
+                <a:latin typeface="Arial"/>
+              </a:rPr>
+              <a:t>aftermarket</a:t>
+            </a:r>
+            <a:r>
+              <a:rPr sz="1400" b="0" i="0">
+                <a:solidFill>
+                  <a:srgbClr val="333333"/>
+                </a:solidFill>
+                <a:latin typeface="Arial"/>
+              </a:rPr>
+              <a:t> (spares, retrofit, service). Reach is Italy/Europe-centric, global via the Hennecke network (US, Asia).</a:t>
+            </a:r>
+          </a:p>
+        </p:txBody>
+      </p:sp>
+      <p:sp>
+        <p:nvSpPr>
+          <p:cNvPr id="42" name="TextBox 41"/>
+          <p:cNvSpPr txBox="1"/>
+          <p:nvPr/>
+        </p:nvSpPr>
+        <p:spPr>
+          <a:xfrm>
+            <a:off x="381000" y="6598920"/>
+            <a:ext cx="9906000" cy="152400"/>
+          </a:xfrm>
+          <a:prstGeom prst="rect">
+            <a:avLst/>
+          </a:prstGeom>
+          <a:noFill/>
+        </p:spPr>
+        <p:txBody>
+          <a:bodyPr wrap="square" anchor="t" lIns="25400" rIns="25400" tIns="12700" bIns="12700">
+            <a:spAutoFit/>
+          </a:bodyPr>
+          <a:lstStyle/>
+          <a:p>
+            <a:pPr algn="l">
+              <a:lnSpc>
+                <a:spcPct val="100000"/>
+              </a:lnSpc>
+              <a:spcBef>
+                <a:spcPts val="0"/>
+              </a:spcBef>
+              <a:spcAft>
+                <a:spcPts val="400"/>
+              </a:spcAft>
+            </a:pPr>
+            <a:r>
+              <a:rPr sz="950" b="0" i="0">
+                <a:solidFill>
+                  <a:srgbClr val="999999"/>
+                </a:solidFill>
+                <a:latin typeface="Arial"/>
+              </a:rPr>
+              <a:t>Illustrative customer profiles by application — not a confirmed client list (customer breakdown not disclosed in the analysed documents). Company names are sector examples.</a:t>
+            </a:r>
+          </a:p>
+        </p:txBody>
+      </p:sp>
+    </p:spTree>
+  </p:cSld>
+  <p:clrMapOvr>
+    <a:masterClrMapping/>
+  </p:clrMapOvr>
+</p:sld>
+</file>
+
+<file path=ppt/slides/slide5.xml><?xml version="1.0" encoding="utf-8"?>
+<p:sld xmlns:a="http://schemas.openxmlformats.org/drawingml/2006/main" xmlns:p="http://schemas.openxmlformats.org/presentationml/2006/main" xmlns:r="http://schemas.openxmlformats.org/officeDocument/2006/relationships">
+  <p:cSld>
+    <p:spTree>
+      <p:nvGrpSpPr>
+        <p:cNvPr id="1" name=""/>
+        <p:cNvGrpSpPr/>
+        <p:nvPr/>
+      </p:nvGrpSpPr>
+      <p:grpSpPr/>
+      <p:sp>
+        <p:nvSpPr>
+          <p:cNvPr id="2" name="Rectangle 1"/>
+          <p:cNvSpPr/>
+          <p:nvPr/>
+        </p:nvSpPr>
+        <p:spPr>
+          <a:xfrm>
+            <a:off x="0" y="0"/>
+            <a:ext cx="12192000" cy="60960"/>
+          </a:xfrm>
+          <a:prstGeom prst="rect">
+            <a:avLst/>
+          </a:prstGeom>
+          <a:solidFill>
+            <a:srgbClr val="C8102E"/>
+          </a:solidFill>
+          <a:ln>
+            <a:noFill/>
+          </a:ln>
+          <a:effectLst/>
+        </p:spPr>
+        <p:style>
+          <a:lnRef idx="1">
+            <a:schemeClr val="accent1"/>
+          </a:lnRef>
+          <a:fillRef idx="3">
+            <a:schemeClr val="accent1"/>
+          </a:fillRef>
+          <a:effectRef idx="2">
+            <a:schemeClr val="accent1"/>
+          </a:effectRef>
+          <a:fontRef idx="minor">
+            <a:schemeClr val="lt1"/>
+          </a:fontRef>
+        </p:style>
+        <p:txBody>
+          <a:bodyPr rtlCol="0" anchor="ctr"/>
+          <a:lstStyle/>
+          <a:p>
+            <a:pPr algn="ctr"/>
+          </a:p>
+        </p:txBody>
+      </p:sp>
+      <p:sp>
+        <p:nvSpPr>
+          <p:cNvPr id="3" name="TextBox 2"/>
+          <p:cNvSpPr txBox="1"/>
+          <p:nvPr/>
+        </p:nvSpPr>
+        <p:spPr>
+          <a:xfrm>
+            <a:off x="381000" y="228600"/>
+            <a:ext cx="8382000" cy="381000"/>
+          </a:xfrm>
+          <a:prstGeom prst="rect">
+            <a:avLst/>
+          </a:prstGeom>
+          <a:noFill/>
+        </p:spPr>
+        <p:txBody>
+          <a:bodyPr wrap="square" anchor="t" lIns="25400" rIns="25400" tIns="12700" bIns="12700">
+            <a:spAutoFit/>
+          </a:bodyPr>
+          <a:lstStyle/>
+          <a:p>
+            <a:pPr algn="l">
+              <a:lnSpc>
+                <a:spcPct val="100000"/>
+              </a:lnSpc>
+              <a:spcBef>
+                <a:spcPts val="0"/>
+              </a:spcBef>
+              <a:spcAft>
+                <a:spcPts val="400"/>
+              </a:spcAft>
+            </a:pPr>
+            <a:r>
+              <a:rPr sz="2600" b="1" i="0">
+                <a:solidFill>
+                  <a:srgbClr val="1F3A5F"/>
+                </a:solidFill>
+                <a:latin typeface="Arial"/>
+              </a:rPr>
+              <a:t>Investment thesis — value, risks &amp; recommendation</a:t>
+            </a:r>
+          </a:p>
+        </p:txBody>
+      </p:sp>
+      <p:sp>
+        <p:nvSpPr>
+          <p:cNvPr id="4" name="TextBox 3"/>
+          <p:cNvSpPr txBox="1"/>
+          <p:nvPr/>
+        </p:nvSpPr>
+        <p:spPr>
+          <a:xfrm>
+            <a:off x="381000" y="594360"/>
+            <a:ext cx="9144000" cy="228600"/>
+          </a:xfrm>
+          <a:prstGeom prst="rect">
+            <a:avLst/>
+          </a:prstGeom>
+          <a:noFill/>
+        </p:spPr>
+        <p:txBody>
+          <a:bodyPr wrap="square" anchor="t" lIns="25400" rIns="25400" tIns="12700" bIns="12700">
+            <a:spAutoFit/>
+          </a:bodyPr>
+          <a:lstStyle/>
+          <a:p>
+            <a:pPr algn="l">
+              <a:lnSpc>
+                <a:spcPct val="100000"/>
+              </a:lnSpc>
+              <a:spcBef>
+                <a:spcPts val="0"/>
+              </a:spcBef>
+              <a:spcAft>
+                <a:spcPts val="400"/>
+              </a:spcAft>
+            </a:pPr>
+            <a:r>
+              <a:rPr sz="1300" b="0" i="0">
+                <a:solidFill>
+                  <a:srgbClr val="666666"/>
+                </a:solidFill>
+                <a:latin typeface="Arial"/>
+              </a:rPr>
+              <a:t>Margin-recovery &amp; aftermarket story on a structurally-supported PU platform</a:t>
+            </a:r>
+          </a:p>
+        </p:txBody>
+      </p:sp>
+      <p:sp>
+        <p:nvSpPr>
+          <p:cNvPr id="5" name="TextBox 4"/>
+          <p:cNvSpPr txBox="1"/>
+          <p:nvPr/>
+        </p:nvSpPr>
+        <p:spPr>
+          <a:xfrm>
+            <a:off x="8763000" y="198120"/>
+            <a:ext cx="3048000" cy="167640"/>
+          </a:xfrm>
+          <a:prstGeom prst="rect">
+            <a:avLst/>
+          </a:prstGeom>
+          <a:noFill/>
+        </p:spPr>
+        <p:txBody>
+          <a:bodyPr wrap="square" anchor="t" lIns="25400" rIns="25400" tIns="12700" bIns="12700">
+            <a:spAutoFit/>
+          </a:bodyPr>
+          <a:lstStyle/>
+          <a:p>
+            <a:pPr algn="r">
+              <a:lnSpc>
+                <a:spcPct val="100000"/>
+              </a:lnSpc>
+              <a:spcBef>
+                <a:spcPts val="0"/>
+              </a:spcBef>
+              <a:spcAft>
+                <a:spcPts val="400"/>
+              </a:spcAft>
+            </a:pPr>
+            <a:r>
+              <a:rPr sz="950" b="0" i="0">
+                <a:solidFill>
+                  <a:srgbClr val="999999"/>
+                </a:solidFill>
+                <a:latin typeface="Arial"/>
+              </a:rPr>
+              <a:t>CONFIDENTIAL · For Board discussion</a:t>
+            </a:r>
+          </a:p>
+        </p:txBody>
+      </p:sp>
+      <p:sp>
+        <p:nvSpPr>
+          <p:cNvPr id="6" name="Rectangle 5"/>
+          <p:cNvSpPr/>
+          <p:nvPr/>
+        </p:nvSpPr>
+        <p:spPr>
+          <a:xfrm>
+            <a:off x="381000" y="6537960"/>
+            <a:ext cx="11430000" cy="7620"/>
+          </a:xfrm>
+          <a:prstGeom prst="rect">
+            <a:avLst/>
+          </a:prstGeom>
+          <a:solidFill>
+            <a:srgbClr val="DFE4EA"/>
+          </a:solidFill>
+          <a:ln>
+            <a:noFill/>
+          </a:ln>
+          <a:effectLst/>
+        </p:spPr>
+        <p:style>
+          <a:lnRef idx="1">
+            <a:schemeClr val="accent1"/>
+          </a:lnRef>
+          <a:fillRef idx="3">
+            <a:schemeClr val="accent1"/>
+          </a:fillRef>
+          <a:effectRef idx="2">
+            <a:schemeClr val="accent1"/>
+          </a:effectRef>
+          <a:fontRef idx="minor">
+            <a:schemeClr val="lt1"/>
+          </a:fontRef>
+        </p:style>
+        <p:txBody>
+          <a:bodyPr rtlCol="0" anchor="ctr"/>
+          <a:lstStyle/>
+          <a:p>
+            <a:pPr algn="ctr"/>
+          </a:p>
+        </p:txBody>
+      </p:sp>
+      <p:sp>
+        <p:nvSpPr>
+          <p:cNvPr id="7" name="TextBox 6"/>
+          <p:cNvSpPr txBox="1"/>
+          <p:nvPr/>
+        </p:nvSpPr>
+        <p:spPr>
+          <a:xfrm>
+            <a:off x="10668000" y="6598920"/>
+            <a:ext cx="1143000" cy="152400"/>
+          </a:xfrm>
+          <a:prstGeom prst="rect">
+            <a:avLst/>
+          </a:prstGeom>
+          <a:noFill/>
+        </p:spPr>
+        <p:txBody>
+          <a:bodyPr wrap="square" anchor="t" lIns="25400" rIns="25400" tIns="12700" bIns="12700">
+            <a:spAutoFit/>
+          </a:bodyPr>
+          <a:lstStyle/>
+          <a:p>
+            <a:pPr algn="r">
+              <a:lnSpc>
+                <a:spcPct val="100000"/>
+              </a:lnSpc>
+              <a:spcBef>
+                <a:spcPts val="0"/>
+              </a:spcBef>
+              <a:spcAft>
+                <a:spcPts val="400"/>
+              </a:spcAft>
+            </a:pPr>
+            <a:r>
+              <a:rPr sz="950" b="1" i="0">
+                <a:solidFill>
+                  <a:srgbClr val="1F3A5F"/>
+                </a:solidFill>
+                <a:latin typeface="Arial"/>
+              </a:rPr>
+              <a:t>4 / 4</a:t>
+            </a:r>
+          </a:p>
+        </p:txBody>
+      </p:sp>
+      <p:sp>
+        <p:nvSpPr>
+          <p:cNvPr id="8" name="Rectangle 7"/>
+          <p:cNvSpPr/>
+          <p:nvPr/>
+        </p:nvSpPr>
+        <p:spPr>
+          <a:xfrm>
+            <a:off x="381000" y="952500"/>
+            <a:ext cx="3657600" cy="4267200"/>
+          </a:xfrm>
+          <a:prstGeom prst="rect">
+            <a:avLst/>
+          </a:prstGeom>
+          <a:solidFill>
+            <a:srgbClr val="FFFFFF"/>
+          </a:solidFill>
+          <a:ln w="12700">
+            <a:solidFill>
+              <a:srgbClr val="DFE4EA"/>
+            </a:solidFill>
+          </a:ln>
+          <a:effectLst/>
+        </p:spPr>
+        <p:style>
+          <a:lnRef idx="1">
+            <a:schemeClr val="accent1"/>
+          </a:lnRef>
+          <a:fillRef idx="3">
+            <a:schemeClr val="accent1"/>
+          </a:fillRef>
+          <a:effectRef idx="2">
+            <a:schemeClr val="accent1"/>
+          </a:effectRef>
+          <a:fontRef idx="minor">
+            <a:schemeClr val="lt1"/>
+          </a:fontRef>
+        </p:style>
+        <p:txBody>
+          <a:bodyPr rtlCol="0" anchor="ctr"/>
+          <a:lstStyle/>
+          <a:p>
+            <a:pPr algn="ctr"/>
+          </a:p>
+        </p:txBody>
+      </p:sp>
+      <p:sp>
+        <p:nvSpPr>
+          <p:cNvPr id="9" name="Rectangle 8"/>
+          <p:cNvSpPr/>
+          <p:nvPr/>
+        </p:nvSpPr>
+        <p:spPr>
+          <a:xfrm>
             <a:off x="381000" y="952500"/>
             <a:ext cx="3657600" cy="350520"/>
           </a:xfrm>
@@ -9045,7 +11183,7 @@
 </p:sld>
 </file>
 
-<file path=ppt/slides/slide5.xml><?xml version="1.0" encoding="utf-8"?>
+<file path=ppt/slides/slide6.xml><?xml version="1.0" encoding="utf-8"?>
 <p:sld xmlns:a="http://schemas.openxmlformats.org/drawingml/2006/main" xmlns:p="http://schemas.openxmlformats.org/presentationml/2006/main" xmlns:r="http://schemas.openxmlformats.org/officeDocument/2006/relationships">
   <p:cSld>
     <p:spTree>

</xml_diff>

<commit_message>
Add Tailwinds vs Headwinds slide to the Board pitch (7 slides)
</commit_message>
<xml_diff>
--- a/Hennecke/pitch/HenneckeOMS_Board_Pitch_EN.pptx
+++ b/Hennecke/pitch/HenneckeOMS_Board_Pitch_EN.pptx
@@ -11,6 +11,7 @@
     <p:sldId id="259" r:id="rId10"/>
     <p:sldId id="260" r:id="rId11"/>
     <p:sldId id="261" r:id="rId12"/>
+    <p:sldId id="262" r:id="rId13"/>
   </p:sldIdLst>
   <p:sldSz cx="12191695" cy="6858000" type="screen4x3"/>
   <p:notesSz cx="6858000" cy="9144000"/>
@@ -4232,7 +4233,7 @@
                 </a:solidFill>
                 <a:latin typeface="Arial"/>
               </a:rPr>
-              <a:t>1 / 4</a:t>
+              <a:t>1 / 5</a:t>
             </a:r>
           </a:p>
         </p:txBody>
@@ -5992,7 +5993,7 @@
                 </a:solidFill>
                 <a:latin typeface="Arial"/>
               </a:rPr>
-              <a:t>2 / 4</a:t>
+              <a:t>2 / 5</a:t>
             </a:r>
           </a:p>
         </p:txBody>
@@ -7252,7 +7253,7 @@
                 </a:solidFill>
                 <a:latin typeface="Arial"/>
               </a:rPr>
-              <a:t>3 / 4</a:t>
+              <a:t>3 / 5</a:t>
             </a:r>
           </a:p>
         </p:txBody>
@@ -9210,7 +9211,7 @@
                 </a:solidFill>
                 <a:latin typeface="Arial"/>
               </a:rPr>
-              <a:t>Investment thesis — value, risks &amp; recommendation</a:t>
+              <a:t>Tailwinds vs headwinds — what drives this business</a:t>
             </a:r>
           </a:p>
         </p:txBody>
@@ -9255,7 +9256,7 @@
                 </a:solidFill>
                 <a:latin typeface="Arial"/>
               </a:rPr>
-              <a:t>Margin-recovery &amp; aftermarket story on a structurally-supported PU platform</a:t>
+              <a:t>Two silos: structural supports vs structural pressures, specific to a PU capital-goods model</a:t>
             </a:r>
           </a:p>
         </p:txBody>
@@ -9389,7 +9390,7 @@
                 </a:solidFill>
                 <a:latin typeface="Arial"/>
               </a:rPr>
-              <a:t>4 / 4</a:t>
+              <a:t>4 / 5</a:t>
             </a:r>
           </a:p>
         </p:txBody>
@@ -9403,7 +9404,7 @@
         <p:spPr>
           <a:xfrm>
             <a:off x="381000" y="952500"/>
-            <a:ext cx="3657600" cy="4267200"/>
+            <a:ext cx="5638800" cy="4381500"/>
           </a:xfrm>
           <a:prstGeom prst="rect">
             <a:avLst/>
@@ -9449,6 +9450,1349 @@
         <p:spPr>
           <a:xfrm>
             <a:off x="381000" y="952500"/>
+            <a:ext cx="5638800" cy="350520"/>
+          </a:xfrm>
+          <a:prstGeom prst="rect">
+            <a:avLst/>
+          </a:prstGeom>
+          <a:solidFill>
+            <a:srgbClr val="2E7D4F"/>
+          </a:solidFill>
+          <a:ln>
+            <a:noFill/>
+          </a:ln>
+          <a:effectLst/>
+        </p:spPr>
+        <p:style>
+          <a:lnRef idx="1">
+            <a:schemeClr val="accent1"/>
+          </a:lnRef>
+          <a:fillRef idx="3">
+            <a:schemeClr val="accent1"/>
+          </a:fillRef>
+          <a:effectRef idx="2">
+            <a:schemeClr val="accent1"/>
+          </a:effectRef>
+          <a:fontRef idx="minor">
+            <a:schemeClr val="lt1"/>
+          </a:fontRef>
+        </p:style>
+        <p:txBody>
+          <a:bodyPr rtlCol="0" anchor="ctr"/>
+          <a:lstStyle/>
+          <a:p>
+            <a:pPr algn="ctr"/>
+          </a:p>
+        </p:txBody>
+      </p:sp>
+      <p:sp>
+        <p:nvSpPr>
+          <p:cNvPr id="10" name="TextBox 9"/>
+          <p:cNvSpPr txBox="1"/>
+          <p:nvPr/>
+        </p:nvSpPr>
+        <p:spPr>
+          <a:xfrm>
+            <a:off x="548640" y="952500"/>
+            <a:ext cx="5410200" cy="350520"/>
+          </a:xfrm>
+          <a:prstGeom prst="rect">
+            <a:avLst/>
+          </a:prstGeom>
+          <a:noFill/>
+        </p:spPr>
+        <p:txBody>
+          <a:bodyPr wrap="square" anchor="ctr" lIns="25400" rIns="25400" tIns="12700" bIns="12700">
+            <a:spAutoFit/>
+          </a:bodyPr>
+          <a:lstStyle/>
+          <a:p>
+            <a:pPr algn="l">
+              <a:lnSpc>
+                <a:spcPct val="100000"/>
+              </a:lnSpc>
+              <a:spcBef>
+                <a:spcPts val="0"/>
+              </a:spcBef>
+              <a:spcAft>
+                <a:spcPts val="400"/>
+              </a:spcAft>
+            </a:pPr>
+            <a:r>
+              <a:rPr sz="1500" b="1" i="0">
+                <a:solidFill>
+                  <a:srgbClr val="FFFFFF"/>
+                </a:solidFill>
+                <a:latin typeface="Arial"/>
+              </a:rPr>
+              <a:t>TAILWINDS  ·  structural supports</a:t>
+            </a:r>
+          </a:p>
+        </p:txBody>
+      </p:sp>
+      <p:sp>
+        <p:nvSpPr>
+          <p:cNvPr id="11" name="TextBox 10"/>
+          <p:cNvSpPr txBox="1"/>
+          <p:nvPr/>
+        </p:nvSpPr>
+        <p:spPr>
+          <a:xfrm>
+            <a:off x="563880" y="1432560"/>
+            <a:ext cx="5273040" cy="3810000"/>
+          </a:xfrm>
+          <a:prstGeom prst="rect">
+            <a:avLst/>
+          </a:prstGeom>
+          <a:noFill/>
+        </p:spPr>
+        <p:txBody>
+          <a:bodyPr wrap="square" anchor="t" lIns="25400" rIns="25400" tIns="12700" bIns="12700">
+            <a:spAutoFit/>
+          </a:bodyPr>
+          <a:lstStyle/>
+          <a:p>
+            <a:pPr algn="l">
+              <a:lnSpc>
+                <a:spcPct val="100000"/>
+              </a:lnSpc>
+              <a:spcBef>
+                <a:spcPts val="0"/>
+              </a:spcBef>
+              <a:spcAft>
+                <a:spcPts val="1000"/>
+              </a:spcAft>
+            </a:pPr>
+            <a:r>
+              <a:rPr sz="1450" b="0" i="0">
+                <a:solidFill>
+                  <a:srgbClr val="2E7D4F"/>
+                </a:solidFill>
+                <a:latin typeface="Arial"/>
+              </a:rPr>
+              <a:t>•  </a:t>
+            </a:r>
+            <a:r>
+              <a:rPr sz="1450" b="1" i="0">
+                <a:solidFill>
+                  <a:srgbClr val="222222"/>
+                </a:solidFill>
+                <a:latin typeface="Arial"/>
+              </a:rPr>
+              <a:t>Building energy-efficiency regulation</a:t>
+            </a:r>
+            <a:r>
+              <a:rPr sz="1450" b="0" i="0">
+                <a:solidFill>
+                  <a:srgbClr val="222222"/>
+                </a:solidFill>
+                <a:latin typeface="Arial"/>
+              </a:rPr>
+              <a:t> (EU EPBD, Green Deal, renovations) → demand for insulating sandwich panels &amp; rigid foam.</a:t>
+            </a:r>
+          </a:p>
+          <a:p>
+            <a:pPr algn="l">
+              <a:lnSpc>
+                <a:spcPct val="100000"/>
+              </a:lnSpc>
+              <a:spcBef>
+                <a:spcPts val="0"/>
+              </a:spcBef>
+              <a:spcAft>
+                <a:spcPts val="1000"/>
+              </a:spcAft>
+            </a:pPr>
+            <a:r>
+              <a:rPr sz="1450" b="0" i="0">
+                <a:solidFill>
+                  <a:srgbClr val="2E7D4F"/>
+                </a:solidFill>
+                <a:latin typeface="Arial"/>
+              </a:rPr>
+              <a:t>•  </a:t>
+            </a:r>
+            <a:r>
+              <a:rPr sz="1450" b="1" i="0">
+                <a:solidFill>
+                  <a:srgbClr val="222222"/>
+                </a:solidFill>
+                <a:latin typeface="Arial"/>
+              </a:rPr>
+              <a:t>Cold-chain &amp; refrigeration</a:t>
+            </a:r>
+            <a:r>
+              <a:rPr sz="1450" b="0" i="0">
+                <a:solidFill>
+                  <a:srgbClr val="222222"/>
+                </a:solidFill>
+                <a:latin typeface="Arial"/>
+              </a:rPr>
+              <a:t> expansion (food, pharma) → PU-injection lines; Hennecke already equips much of global fridge output.</a:t>
+            </a:r>
+          </a:p>
+          <a:p>
+            <a:pPr algn="l">
+              <a:lnSpc>
+                <a:spcPct val="100000"/>
+              </a:lnSpc>
+              <a:spcBef>
+                <a:spcPts val="0"/>
+              </a:spcBef>
+              <a:spcAft>
+                <a:spcPts val="1000"/>
+              </a:spcAft>
+            </a:pPr>
+            <a:r>
+              <a:rPr sz="1450" b="0" i="0">
+                <a:solidFill>
+                  <a:srgbClr val="2E7D4F"/>
+                </a:solidFill>
+                <a:latin typeface="Arial"/>
+              </a:rPr>
+              <a:t>•  </a:t>
+            </a:r>
+            <a:r>
+              <a:rPr sz="1450" b="1" i="0">
+                <a:solidFill>
+                  <a:srgbClr val="222222"/>
+                </a:solidFill>
+                <a:latin typeface="Arial"/>
+              </a:rPr>
+              <a:t>Blowing-agent transition</a:t>
+            </a:r>
+            <a:r>
+              <a:rPr sz="1450" b="0" i="0">
+                <a:solidFill>
+                  <a:srgbClr val="222222"/>
+                </a:solidFill>
+                <a:latin typeface="Arial"/>
+              </a:rPr>
+              <a:t> (HFC → HFO/pentane) forces a customer machine-fleet renewal cycle.</a:t>
+            </a:r>
+          </a:p>
+          <a:p>
+            <a:pPr algn="l">
+              <a:lnSpc>
+                <a:spcPct val="100000"/>
+              </a:lnSpc>
+              <a:spcBef>
+                <a:spcPts val="0"/>
+              </a:spcBef>
+              <a:spcAft>
+                <a:spcPts val="1000"/>
+              </a:spcAft>
+            </a:pPr>
+            <a:r>
+              <a:rPr sz="1450" b="0" i="0">
+                <a:solidFill>
+                  <a:srgbClr val="2E7D4F"/>
+                </a:solidFill>
+                <a:latin typeface="Arial"/>
+              </a:rPr>
+              <a:t>•  </a:t>
+            </a:r>
+            <a:r>
+              <a:rPr sz="1450" b="1" i="0">
+                <a:solidFill>
+                  <a:srgbClr val="222222"/>
+                </a:solidFill>
+                <a:latin typeface="Arial"/>
+              </a:rPr>
+              <a:t>e-mobility &amp; lightweighting</a:t>
+            </a:r>
+            <a:r>
+              <a:rPr sz="1450" b="0" i="0">
+                <a:solidFill>
+                  <a:srgbClr val="222222"/>
+                </a:solidFill>
+                <a:latin typeface="Arial"/>
+              </a:rPr>
+              <a:t> → automotive PU seating, NVH and composite parts.</a:t>
+            </a:r>
+          </a:p>
+          <a:p>
+            <a:pPr algn="l">
+              <a:lnSpc>
+                <a:spcPct val="100000"/>
+              </a:lnSpc>
+              <a:spcBef>
+                <a:spcPts val="0"/>
+              </a:spcBef>
+              <a:spcAft>
+                <a:spcPts val="1000"/>
+              </a:spcAft>
+            </a:pPr>
+            <a:r>
+              <a:rPr sz="1450" b="0" i="0">
+                <a:solidFill>
+                  <a:srgbClr val="2E7D4F"/>
+                </a:solidFill>
+                <a:latin typeface="Arial"/>
+              </a:rPr>
+              <a:t>•  </a:t>
+            </a:r>
+            <a:r>
+              <a:rPr sz="1450" b="1" i="0">
+                <a:solidFill>
+                  <a:srgbClr val="222222"/>
+                </a:solidFill>
+                <a:latin typeface="Arial"/>
+              </a:rPr>
+              <a:t>Large global installed base</a:t>
+            </a:r>
+            <a:r>
+              <a:rPr sz="1450" b="0" i="0">
+                <a:solidFill>
+                  <a:srgbClr val="222222"/>
+                </a:solidFill>
+                <a:latin typeface="Arial"/>
+              </a:rPr>
+              <a:t> → recurring, high-margin aftermarket (spares, retrofit, service).</a:t>
+            </a:r>
+          </a:p>
+          <a:p>
+            <a:pPr algn="l">
+              <a:lnSpc>
+                <a:spcPct val="100000"/>
+              </a:lnSpc>
+              <a:spcBef>
+                <a:spcPts val="0"/>
+              </a:spcBef>
+              <a:spcAft>
+                <a:spcPts val="1000"/>
+              </a:spcAft>
+            </a:pPr>
+            <a:r>
+              <a:rPr sz="1450" b="0" i="0">
+                <a:solidFill>
+                  <a:srgbClr val="2E7D4F"/>
+                </a:solidFill>
+                <a:latin typeface="Arial"/>
+              </a:rPr>
+              <a:t>•  </a:t>
+            </a:r>
+            <a:r>
+              <a:rPr sz="1450" b="1" i="0">
+                <a:solidFill>
+                  <a:srgbClr val="222222"/>
+                </a:solidFill>
+                <a:latin typeface="Arial"/>
+              </a:rPr>
+              <a:t>Brückner Group backing</a:t>
+            </a:r>
+            <a:r>
+              <a:rPr sz="1450" b="0" i="0">
+                <a:solidFill>
+                  <a:srgbClr val="222222"/>
+                </a:solidFill>
+                <a:latin typeface="Arial"/>
+              </a:rPr>
+              <a:t> → R&amp;D, cross-selling, global reach and financial strength.</a:t>
+            </a:r>
+          </a:p>
+          <a:p>
+            <a:pPr algn="l">
+              <a:lnSpc>
+                <a:spcPct val="100000"/>
+              </a:lnSpc>
+              <a:spcBef>
+                <a:spcPts val="0"/>
+              </a:spcBef>
+              <a:spcAft>
+                <a:spcPts val="1000"/>
+              </a:spcAft>
+            </a:pPr>
+            <a:r>
+              <a:rPr sz="1450" b="0" i="0">
+                <a:solidFill>
+                  <a:srgbClr val="2E7D4F"/>
+                </a:solidFill>
+                <a:latin typeface="Arial"/>
+              </a:rPr>
+              <a:t>•  </a:t>
+            </a:r>
+            <a:r>
+              <a:rPr sz="1450" b="1" i="0">
+                <a:solidFill>
+                  <a:srgbClr val="222222"/>
+                </a:solidFill>
+                <a:latin typeface="Arial"/>
+              </a:rPr>
+              <a:t>Historic OMS know-how</a:t>
+            </a:r>
+            <a:r>
+              <a:rPr sz="1450" b="0" i="0">
+                <a:solidFill>
+                  <a:srgbClr val="222222"/>
+                </a:solidFill>
+                <a:latin typeface="Arial"/>
+              </a:rPr>
+              <a:t> in continuous sandwich-panel &amp; flexible-foam lines (differentiation).</a:t>
+            </a:r>
+          </a:p>
+        </p:txBody>
+      </p:sp>
+      <p:sp>
+        <p:nvSpPr>
+          <p:cNvPr id="12" name="Rectangle 11"/>
+          <p:cNvSpPr/>
+          <p:nvPr/>
+        </p:nvSpPr>
+        <p:spPr>
+          <a:xfrm>
+            <a:off x="6172200" y="952500"/>
+            <a:ext cx="5638800" cy="4381500"/>
+          </a:xfrm>
+          <a:prstGeom prst="rect">
+            <a:avLst/>
+          </a:prstGeom>
+          <a:solidFill>
+            <a:srgbClr val="FFFFFF"/>
+          </a:solidFill>
+          <a:ln w="12700">
+            <a:solidFill>
+              <a:srgbClr val="DFE4EA"/>
+            </a:solidFill>
+          </a:ln>
+          <a:effectLst/>
+        </p:spPr>
+        <p:style>
+          <a:lnRef idx="1">
+            <a:schemeClr val="accent1"/>
+          </a:lnRef>
+          <a:fillRef idx="3">
+            <a:schemeClr val="accent1"/>
+          </a:fillRef>
+          <a:effectRef idx="2">
+            <a:schemeClr val="accent1"/>
+          </a:effectRef>
+          <a:fontRef idx="minor">
+            <a:schemeClr val="lt1"/>
+          </a:fontRef>
+        </p:style>
+        <p:txBody>
+          <a:bodyPr rtlCol="0" anchor="ctr"/>
+          <a:lstStyle/>
+          <a:p>
+            <a:pPr algn="ctr"/>
+          </a:p>
+        </p:txBody>
+      </p:sp>
+      <p:sp>
+        <p:nvSpPr>
+          <p:cNvPr id="13" name="Rectangle 12"/>
+          <p:cNvSpPr/>
+          <p:nvPr/>
+        </p:nvSpPr>
+        <p:spPr>
+          <a:xfrm>
+            <a:off x="6172200" y="952500"/>
+            <a:ext cx="5638800" cy="350520"/>
+          </a:xfrm>
+          <a:prstGeom prst="rect">
+            <a:avLst/>
+          </a:prstGeom>
+          <a:solidFill>
+            <a:srgbClr val="C8102E"/>
+          </a:solidFill>
+          <a:ln>
+            <a:noFill/>
+          </a:ln>
+          <a:effectLst/>
+        </p:spPr>
+        <p:style>
+          <a:lnRef idx="1">
+            <a:schemeClr val="accent1"/>
+          </a:lnRef>
+          <a:fillRef idx="3">
+            <a:schemeClr val="accent1"/>
+          </a:fillRef>
+          <a:effectRef idx="2">
+            <a:schemeClr val="accent1"/>
+          </a:effectRef>
+          <a:fontRef idx="minor">
+            <a:schemeClr val="lt1"/>
+          </a:fontRef>
+        </p:style>
+        <p:txBody>
+          <a:bodyPr rtlCol="0" anchor="ctr"/>
+          <a:lstStyle/>
+          <a:p>
+            <a:pPr algn="ctr"/>
+          </a:p>
+        </p:txBody>
+      </p:sp>
+      <p:sp>
+        <p:nvSpPr>
+          <p:cNvPr id="14" name="TextBox 13"/>
+          <p:cNvSpPr txBox="1"/>
+          <p:nvPr/>
+        </p:nvSpPr>
+        <p:spPr>
+          <a:xfrm>
+            <a:off x="6339840" y="952500"/>
+            <a:ext cx="5410200" cy="350520"/>
+          </a:xfrm>
+          <a:prstGeom prst="rect">
+            <a:avLst/>
+          </a:prstGeom>
+          <a:noFill/>
+        </p:spPr>
+        <p:txBody>
+          <a:bodyPr wrap="square" anchor="ctr" lIns="25400" rIns="25400" tIns="12700" bIns="12700">
+            <a:spAutoFit/>
+          </a:bodyPr>
+          <a:lstStyle/>
+          <a:p>
+            <a:pPr algn="l">
+              <a:lnSpc>
+                <a:spcPct val="100000"/>
+              </a:lnSpc>
+              <a:spcBef>
+                <a:spcPts val="0"/>
+              </a:spcBef>
+              <a:spcAft>
+                <a:spcPts val="400"/>
+              </a:spcAft>
+            </a:pPr>
+            <a:r>
+              <a:rPr sz="1500" b="1" i="0">
+                <a:solidFill>
+                  <a:srgbClr val="FFFFFF"/>
+                </a:solidFill>
+                <a:latin typeface="Arial"/>
+              </a:rPr>
+              <a:t>HEADWINDS  ·  structural pressures</a:t>
+            </a:r>
+          </a:p>
+        </p:txBody>
+      </p:sp>
+      <p:sp>
+        <p:nvSpPr>
+          <p:cNvPr id="15" name="TextBox 14"/>
+          <p:cNvSpPr txBox="1"/>
+          <p:nvPr/>
+        </p:nvSpPr>
+        <p:spPr>
+          <a:xfrm>
+            <a:off x="6355080" y="1432560"/>
+            <a:ext cx="5273040" cy="3810000"/>
+          </a:xfrm>
+          <a:prstGeom prst="rect">
+            <a:avLst/>
+          </a:prstGeom>
+          <a:noFill/>
+        </p:spPr>
+        <p:txBody>
+          <a:bodyPr wrap="square" anchor="t" lIns="25400" rIns="25400" tIns="12700" bIns="12700">
+            <a:spAutoFit/>
+          </a:bodyPr>
+          <a:lstStyle/>
+          <a:p>
+            <a:pPr algn="l">
+              <a:lnSpc>
+                <a:spcPct val="100000"/>
+              </a:lnSpc>
+              <a:spcBef>
+                <a:spcPts val="0"/>
+              </a:spcBef>
+              <a:spcAft>
+                <a:spcPts val="1000"/>
+              </a:spcAft>
+            </a:pPr>
+            <a:r>
+              <a:rPr sz="1450" b="0" i="0">
+                <a:solidFill>
+                  <a:srgbClr val="C8102E"/>
+                </a:solidFill>
+                <a:latin typeface="Arial"/>
+              </a:rPr>
+              <a:t>•  </a:t>
+            </a:r>
+            <a:r>
+              <a:rPr sz="1450" b="1" i="0">
+                <a:solidFill>
+                  <a:srgbClr val="222222"/>
+                </a:solidFill>
+                <a:latin typeface="Arial"/>
+              </a:rPr>
+              <a:t>Capex-driven cyclicality</a:t>
+            </a:r>
+            <a:r>
+              <a:rPr sz="1450" b="0" i="0">
+                <a:solidFill>
+                  <a:srgbClr val="222222"/>
+                </a:solidFill>
+                <a:latin typeface="Arial"/>
+              </a:rPr>
+              <a:t> → lumpy, volatile order intake tied to customers' investment cycle.</a:t>
+            </a:r>
+          </a:p>
+          <a:p>
+            <a:pPr algn="l">
+              <a:lnSpc>
+                <a:spcPct val="100000"/>
+              </a:lnSpc>
+              <a:spcBef>
+                <a:spcPts val="0"/>
+              </a:spcBef>
+              <a:spcAft>
+                <a:spcPts val="1000"/>
+              </a:spcAft>
+            </a:pPr>
+            <a:r>
+              <a:rPr sz="1450" b="0" i="0">
+                <a:solidFill>
+                  <a:srgbClr val="C8102E"/>
+                </a:solidFill>
+                <a:latin typeface="Arial"/>
+              </a:rPr>
+              <a:t>•  </a:t>
+            </a:r>
+            <a:r>
+              <a:rPr sz="1450" b="1" i="0">
+                <a:solidFill>
+                  <a:srgbClr val="222222"/>
+                </a:solidFill>
+                <a:latin typeface="Arial"/>
+              </a:rPr>
+              <a:t>Long project cycles</a:t>
+            </a:r>
+            <a:r>
+              <a:rPr sz="1450" b="0" i="0">
+                <a:solidFill>
+                  <a:srgbClr val="222222"/>
+                </a:solidFill>
+                <a:latin typeface="Arial"/>
+              </a:rPr>
+              <a:t> → work-in-progress swings distort reported earnings (the 2024 margin effect).</a:t>
+            </a:r>
+          </a:p>
+          <a:p>
+            <a:pPr algn="l">
+              <a:lnSpc>
+                <a:spcPct val="100000"/>
+              </a:lnSpc>
+              <a:spcBef>
+                <a:spcPts val="0"/>
+              </a:spcBef>
+              <a:spcAft>
+                <a:spcPts val="1000"/>
+              </a:spcAft>
+            </a:pPr>
+            <a:r>
+              <a:rPr sz="1450" b="0" i="0">
+                <a:solidFill>
+                  <a:srgbClr val="C8102E"/>
+                </a:solidFill>
+                <a:latin typeface="Arial"/>
+              </a:rPr>
+              <a:t>•  </a:t>
+            </a:r>
+            <a:r>
+              <a:rPr sz="1450" b="1" i="0">
+                <a:solidFill>
+                  <a:srgbClr val="222222"/>
+                </a:solidFill>
+                <a:latin typeface="Arial"/>
+              </a:rPr>
+              <a:t>Thin, volatile margins</a:t>
+            </a:r>
+            <a:r>
+              <a:rPr sz="1450" b="0" i="0">
+                <a:solidFill>
+                  <a:srgbClr val="222222"/>
+                </a:solidFill>
+                <a:latin typeface="Arial"/>
+              </a:rPr>
+              <a:t> &amp; execution risk on complex turnkey orders.</a:t>
+            </a:r>
+          </a:p>
+          <a:p>
+            <a:pPr algn="l">
+              <a:lnSpc>
+                <a:spcPct val="100000"/>
+              </a:lnSpc>
+              <a:spcBef>
+                <a:spcPts val="0"/>
+              </a:spcBef>
+              <a:spcAft>
+                <a:spcPts val="1000"/>
+              </a:spcAft>
+            </a:pPr>
+            <a:r>
+              <a:rPr sz="1450" b="0" i="0">
+                <a:solidFill>
+                  <a:srgbClr val="C8102E"/>
+                </a:solidFill>
+                <a:latin typeface="Arial"/>
+              </a:rPr>
+              <a:t>•  </a:t>
+            </a:r>
+            <a:r>
+              <a:rPr sz="1450" b="1" i="0">
+                <a:solidFill>
+                  <a:srgbClr val="222222"/>
+                </a:solidFill>
+                <a:latin typeface="Arial"/>
+              </a:rPr>
+              <a:t>Captive nature</a:t>
+            </a:r>
+            <a:r>
+              <a:rPr sz="1450" b="0" i="0">
+                <a:solidFill>
+                  <a:srgbClr val="222222"/>
+                </a:solidFill>
+                <a:latin typeface="Arial"/>
+              </a:rPr>
+              <a:t> → limited autonomy, intercompany dependence, carve-out complexity.</a:t>
+            </a:r>
+          </a:p>
+          <a:p>
+            <a:pPr algn="l">
+              <a:lnSpc>
+                <a:spcPct val="100000"/>
+              </a:lnSpc>
+              <a:spcBef>
+                <a:spcPts val="0"/>
+              </a:spcBef>
+              <a:spcAft>
+                <a:spcPts val="1000"/>
+              </a:spcAft>
+            </a:pPr>
+            <a:r>
+              <a:rPr sz="1450" b="0" i="0">
+                <a:solidFill>
+                  <a:srgbClr val="C8102E"/>
+                </a:solidFill>
+                <a:latin typeface="Arial"/>
+              </a:rPr>
+              <a:t>•  </a:t>
+            </a:r>
+            <a:r>
+              <a:rPr sz="1450" b="1" i="0">
+                <a:solidFill>
+                  <a:srgbClr val="222222"/>
+                </a:solidFill>
+                <a:latin typeface="Arial"/>
+              </a:rPr>
+              <a:t>Input-cost volatility</a:t>
+            </a:r>
+            <a:r>
+              <a:rPr sz="1450" b="0" i="0">
+                <a:solidFill>
+                  <a:srgbClr val="222222"/>
+                </a:solidFill>
+                <a:latin typeface="Arial"/>
+              </a:rPr>
+              <a:t> (steel, energy, components) and supply-chain tensions.</a:t>
+            </a:r>
+          </a:p>
+          <a:p>
+            <a:pPr algn="l">
+              <a:lnSpc>
+                <a:spcPct val="100000"/>
+              </a:lnSpc>
+              <a:spcBef>
+                <a:spcPts val="0"/>
+              </a:spcBef>
+              <a:spcAft>
+                <a:spcPts val="1000"/>
+              </a:spcAft>
+            </a:pPr>
+            <a:r>
+              <a:rPr sz="1450" b="0" i="0">
+                <a:solidFill>
+                  <a:srgbClr val="C8102E"/>
+                </a:solidFill>
+                <a:latin typeface="Arial"/>
+              </a:rPr>
+              <a:t>•  </a:t>
+            </a:r>
+            <a:r>
+              <a:rPr sz="1450" b="1" i="0">
+                <a:solidFill>
+                  <a:srgbClr val="222222"/>
+                </a:solidFill>
+                <a:latin typeface="Arial"/>
+              </a:rPr>
+              <a:t>FX &amp; country risk</a:t>
+            </a:r>
+            <a:r>
+              <a:rPr sz="1450" b="0" i="0">
+                <a:solidFill>
+                  <a:srgbClr val="222222"/>
+                </a:solidFill>
+                <a:latin typeface="Arial"/>
+              </a:rPr>
+              <a:t> on export projects; qualified competition (Cannon/Afros, KraussMaffei) → price pressure.</a:t>
+            </a:r>
+          </a:p>
+          <a:p>
+            <a:pPr algn="l">
+              <a:lnSpc>
+                <a:spcPct val="100000"/>
+              </a:lnSpc>
+              <a:spcBef>
+                <a:spcPts val="0"/>
+              </a:spcBef>
+              <a:spcAft>
+                <a:spcPts val="1000"/>
+              </a:spcAft>
+            </a:pPr>
+            <a:r>
+              <a:rPr sz="1450" b="0" i="0">
+                <a:solidFill>
+                  <a:srgbClr val="C8102E"/>
+                </a:solidFill>
+                <a:latin typeface="Arial"/>
+              </a:rPr>
+              <a:t>•  </a:t>
+            </a:r>
+            <a:r>
+              <a:rPr sz="1450" b="1" i="0">
+                <a:solidFill>
+                  <a:srgbClr val="222222"/>
+                </a:solidFill>
+                <a:latin typeface="Arial"/>
+              </a:rPr>
+              <a:t>Order concentration</a:t>
+            </a:r>
+            <a:r>
+              <a:rPr sz="1450" b="0" i="0">
+                <a:solidFill>
+                  <a:srgbClr val="222222"/>
+                </a:solidFill>
+                <a:latin typeface="Arial"/>
+              </a:rPr>
+              <a:t> on single large projects; warranty / performance-bond exposure.</a:t>
+            </a:r>
+          </a:p>
+        </p:txBody>
+      </p:sp>
+      <p:sp>
+        <p:nvSpPr>
+          <p:cNvPr id="16" name="Rectangle 15"/>
+          <p:cNvSpPr/>
+          <p:nvPr/>
+        </p:nvSpPr>
+        <p:spPr>
+          <a:xfrm>
+            <a:off x="381000" y="5471160"/>
+            <a:ext cx="11430000" cy="731520"/>
+          </a:xfrm>
+          <a:prstGeom prst="rect">
+            <a:avLst/>
+          </a:prstGeom>
+          <a:solidFill>
+            <a:srgbClr val="EEF2F7"/>
+          </a:solidFill>
+          <a:ln w="12700">
+            <a:solidFill>
+              <a:srgbClr val="CDD8E6"/>
+            </a:solidFill>
+          </a:ln>
+          <a:effectLst/>
+        </p:spPr>
+        <p:style>
+          <a:lnRef idx="1">
+            <a:schemeClr val="accent1"/>
+          </a:lnRef>
+          <a:fillRef idx="3">
+            <a:schemeClr val="accent1"/>
+          </a:fillRef>
+          <a:effectRef idx="2">
+            <a:schemeClr val="accent1"/>
+          </a:effectRef>
+          <a:fontRef idx="minor">
+            <a:schemeClr val="lt1"/>
+          </a:fontRef>
+        </p:style>
+        <p:txBody>
+          <a:bodyPr rtlCol="0" anchor="ctr"/>
+          <a:lstStyle/>
+          <a:p>
+            <a:pPr algn="ctr"/>
+          </a:p>
+        </p:txBody>
+      </p:sp>
+      <p:sp>
+        <p:nvSpPr>
+          <p:cNvPr id="17" name="TextBox 16"/>
+          <p:cNvSpPr txBox="1"/>
+          <p:nvPr/>
+        </p:nvSpPr>
+        <p:spPr>
+          <a:xfrm>
+            <a:off x="563880" y="5547360"/>
+            <a:ext cx="11064240" cy="609600"/>
+          </a:xfrm>
+          <a:prstGeom prst="rect">
+            <a:avLst/>
+          </a:prstGeom>
+          <a:noFill/>
+        </p:spPr>
+        <p:txBody>
+          <a:bodyPr wrap="square" anchor="ctr" lIns="25400" rIns="25400" tIns="12700" bIns="12700">
+            <a:spAutoFit/>
+          </a:bodyPr>
+          <a:lstStyle/>
+          <a:p>
+            <a:pPr algn="l">
+              <a:lnSpc>
+                <a:spcPct val="100000"/>
+              </a:lnSpc>
+              <a:spcBef>
+                <a:spcPts val="0"/>
+              </a:spcBef>
+              <a:spcAft>
+                <a:spcPts val="400"/>
+              </a:spcAft>
+            </a:pPr>
+            <a:r>
+              <a:rPr sz="1400" b="1" i="0">
+                <a:solidFill>
+                  <a:srgbClr val="1F3A5F"/>
+                </a:solidFill>
+                <a:latin typeface="Arial"/>
+              </a:rPr>
+              <a:t>Net read:  </a:t>
+            </a:r>
+            <a:r>
+              <a:rPr sz="1400" b="0" i="0">
+                <a:solidFill>
+                  <a:srgbClr val="333333"/>
+                </a:solidFill>
+                <a:latin typeface="Arial"/>
+              </a:rPr>
+              <a:t>structurally-supported demand on a cyclical, execution-heavy model. The thesis hinges on </a:t>
+            </a:r>
+            <a:r>
+              <a:rPr sz="1400" b="1" i="0">
+                <a:solidFill>
+                  <a:srgbClr val="333333"/>
+                </a:solidFill>
+                <a:latin typeface="Arial"/>
+              </a:rPr>
+              <a:t>smoothing the cycle</a:t>
+            </a:r>
+            <a:r>
+              <a:rPr sz="1400" b="0" i="0">
+                <a:solidFill>
+                  <a:srgbClr val="333333"/>
+                </a:solidFill>
+                <a:latin typeface="Arial"/>
+              </a:rPr>
+              <a:t> (backlog &amp; pricing discipline) and </a:t>
+            </a:r>
+            <a:r>
+              <a:rPr sz="1400" b="1" i="0">
+                <a:solidFill>
+                  <a:srgbClr val="333333"/>
+                </a:solidFill>
+                <a:latin typeface="Arial"/>
+              </a:rPr>
+              <a:t>scaling the recurring aftermarket</a:t>
+            </a:r>
+            <a:r>
+              <a:rPr sz="1400" b="0" i="0">
+                <a:solidFill>
+                  <a:srgbClr val="333333"/>
+                </a:solidFill>
+                <a:latin typeface="Arial"/>
+              </a:rPr>
+              <a:t> to lift and stabilise margins.</a:t>
+            </a:r>
+          </a:p>
+        </p:txBody>
+      </p:sp>
+      <p:sp>
+        <p:nvSpPr>
+          <p:cNvPr id="18" name="TextBox 17"/>
+          <p:cNvSpPr txBox="1"/>
+          <p:nvPr/>
+        </p:nvSpPr>
+        <p:spPr>
+          <a:xfrm>
+            <a:off x="381000" y="6598920"/>
+            <a:ext cx="9906000" cy="152400"/>
+          </a:xfrm>
+          <a:prstGeom prst="rect">
+            <a:avLst/>
+          </a:prstGeom>
+          <a:noFill/>
+        </p:spPr>
+        <p:txBody>
+          <a:bodyPr wrap="square" anchor="t" lIns="25400" rIns="25400" tIns="12700" bIns="12700">
+            <a:spAutoFit/>
+          </a:bodyPr>
+          <a:lstStyle/>
+          <a:p>
+            <a:pPr algn="l">
+              <a:lnSpc>
+                <a:spcPct val="100000"/>
+              </a:lnSpc>
+              <a:spcBef>
+                <a:spcPts val="0"/>
+              </a:spcBef>
+              <a:spcAft>
+                <a:spcPts val="400"/>
+              </a:spcAft>
+            </a:pPr>
+            <a:r>
+              <a:rPr sz="950" b="0" i="0">
+                <a:solidFill>
+                  <a:srgbClr val="999999"/>
+                </a:solidFill>
+                <a:latin typeface="Arial"/>
+              </a:rPr>
+              <a:t>Drivers synthesised from the dossier (sections 3, 5, 9, 11) and public industry sources.</a:t>
+            </a:r>
+          </a:p>
+        </p:txBody>
+      </p:sp>
+    </p:spTree>
+  </p:cSld>
+  <p:clrMapOvr>
+    <a:masterClrMapping/>
+  </p:clrMapOvr>
+</p:sld>
+</file>
+
+<file path=ppt/slides/slide6.xml><?xml version="1.0" encoding="utf-8"?>
+<p:sld xmlns:a="http://schemas.openxmlformats.org/drawingml/2006/main" xmlns:p="http://schemas.openxmlformats.org/presentationml/2006/main" xmlns:r="http://schemas.openxmlformats.org/officeDocument/2006/relationships">
+  <p:cSld>
+    <p:spTree>
+      <p:nvGrpSpPr>
+        <p:cNvPr id="1" name=""/>
+        <p:cNvGrpSpPr/>
+        <p:nvPr/>
+      </p:nvGrpSpPr>
+      <p:grpSpPr/>
+      <p:sp>
+        <p:nvSpPr>
+          <p:cNvPr id="2" name="Rectangle 1"/>
+          <p:cNvSpPr/>
+          <p:nvPr/>
+        </p:nvSpPr>
+        <p:spPr>
+          <a:xfrm>
+            <a:off x="0" y="0"/>
+            <a:ext cx="12192000" cy="60960"/>
+          </a:xfrm>
+          <a:prstGeom prst="rect">
+            <a:avLst/>
+          </a:prstGeom>
+          <a:solidFill>
+            <a:srgbClr val="C8102E"/>
+          </a:solidFill>
+          <a:ln>
+            <a:noFill/>
+          </a:ln>
+          <a:effectLst/>
+        </p:spPr>
+        <p:style>
+          <a:lnRef idx="1">
+            <a:schemeClr val="accent1"/>
+          </a:lnRef>
+          <a:fillRef idx="3">
+            <a:schemeClr val="accent1"/>
+          </a:fillRef>
+          <a:effectRef idx="2">
+            <a:schemeClr val="accent1"/>
+          </a:effectRef>
+          <a:fontRef idx="minor">
+            <a:schemeClr val="lt1"/>
+          </a:fontRef>
+        </p:style>
+        <p:txBody>
+          <a:bodyPr rtlCol="0" anchor="ctr"/>
+          <a:lstStyle/>
+          <a:p>
+            <a:pPr algn="ctr"/>
+          </a:p>
+        </p:txBody>
+      </p:sp>
+      <p:sp>
+        <p:nvSpPr>
+          <p:cNvPr id="3" name="TextBox 2"/>
+          <p:cNvSpPr txBox="1"/>
+          <p:nvPr/>
+        </p:nvSpPr>
+        <p:spPr>
+          <a:xfrm>
+            <a:off x="381000" y="228600"/>
+            <a:ext cx="8382000" cy="381000"/>
+          </a:xfrm>
+          <a:prstGeom prst="rect">
+            <a:avLst/>
+          </a:prstGeom>
+          <a:noFill/>
+        </p:spPr>
+        <p:txBody>
+          <a:bodyPr wrap="square" anchor="t" lIns="25400" rIns="25400" tIns="12700" bIns="12700">
+            <a:spAutoFit/>
+          </a:bodyPr>
+          <a:lstStyle/>
+          <a:p>
+            <a:pPr algn="l">
+              <a:lnSpc>
+                <a:spcPct val="100000"/>
+              </a:lnSpc>
+              <a:spcBef>
+                <a:spcPts val="0"/>
+              </a:spcBef>
+              <a:spcAft>
+                <a:spcPts val="400"/>
+              </a:spcAft>
+            </a:pPr>
+            <a:r>
+              <a:rPr sz="2600" b="1" i="0">
+                <a:solidFill>
+                  <a:srgbClr val="1F3A5F"/>
+                </a:solidFill>
+                <a:latin typeface="Arial"/>
+              </a:rPr>
+              <a:t>Investment thesis — value, risks &amp; recommendation</a:t>
+            </a:r>
+          </a:p>
+        </p:txBody>
+      </p:sp>
+      <p:sp>
+        <p:nvSpPr>
+          <p:cNvPr id="4" name="TextBox 3"/>
+          <p:cNvSpPr txBox="1"/>
+          <p:nvPr/>
+        </p:nvSpPr>
+        <p:spPr>
+          <a:xfrm>
+            <a:off x="381000" y="594360"/>
+            <a:ext cx="9144000" cy="228600"/>
+          </a:xfrm>
+          <a:prstGeom prst="rect">
+            <a:avLst/>
+          </a:prstGeom>
+          <a:noFill/>
+        </p:spPr>
+        <p:txBody>
+          <a:bodyPr wrap="square" anchor="t" lIns="25400" rIns="25400" tIns="12700" bIns="12700">
+            <a:spAutoFit/>
+          </a:bodyPr>
+          <a:lstStyle/>
+          <a:p>
+            <a:pPr algn="l">
+              <a:lnSpc>
+                <a:spcPct val="100000"/>
+              </a:lnSpc>
+              <a:spcBef>
+                <a:spcPts val="0"/>
+              </a:spcBef>
+              <a:spcAft>
+                <a:spcPts val="400"/>
+              </a:spcAft>
+            </a:pPr>
+            <a:r>
+              <a:rPr sz="1300" b="0" i="0">
+                <a:solidFill>
+                  <a:srgbClr val="666666"/>
+                </a:solidFill>
+                <a:latin typeface="Arial"/>
+              </a:rPr>
+              <a:t>Margin-recovery &amp; aftermarket story on a structurally-supported PU platform</a:t>
+            </a:r>
+          </a:p>
+        </p:txBody>
+      </p:sp>
+      <p:sp>
+        <p:nvSpPr>
+          <p:cNvPr id="5" name="TextBox 4"/>
+          <p:cNvSpPr txBox="1"/>
+          <p:nvPr/>
+        </p:nvSpPr>
+        <p:spPr>
+          <a:xfrm>
+            <a:off x="8763000" y="198120"/>
+            <a:ext cx="3048000" cy="167640"/>
+          </a:xfrm>
+          <a:prstGeom prst="rect">
+            <a:avLst/>
+          </a:prstGeom>
+          <a:noFill/>
+        </p:spPr>
+        <p:txBody>
+          <a:bodyPr wrap="square" anchor="t" lIns="25400" rIns="25400" tIns="12700" bIns="12700">
+            <a:spAutoFit/>
+          </a:bodyPr>
+          <a:lstStyle/>
+          <a:p>
+            <a:pPr algn="r">
+              <a:lnSpc>
+                <a:spcPct val="100000"/>
+              </a:lnSpc>
+              <a:spcBef>
+                <a:spcPts val="0"/>
+              </a:spcBef>
+              <a:spcAft>
+                <a:spcPts val="400"/>
+              </a:spcAft>
+            </a:pPr>
+            <a:r>
+              <a:rPr sz="950" b="0" i="0">
+                <a:solidFill>
+                  <a:srgbClr val="999999"/>
+                </a:solidFill>
+                <a:latin typeface="Arial"/>
+              </a:rPr>
+              <a:t>CONFIDENTIAL · For Board discussion</a:t>
+            </a:r>
+          </a:p>
+        </p:txBody>
+      </p:sp>
+      <p:sp>
+        <p:nvSpPr>
+          <p:cNvPr id="6" name="Rectangle 5"/>
+          <p:cNvSpPr/>
+          <p:nvPr/>
+        </p:nvSpPr>
+        <p:spPr>
+          <a:xfrm>
+            <a:off x="381000" y="6537960"/>
+            <a:ext cx="11430000" cy="7620"/>
+          </a:xfrm>
+          <a:prstGeom prst="rect">
+            <a:avLst/>
+          </a:prstGeom>
+          <a:solidFill>
+            <a:srgbClr val="DFE4EA"/>
+          </a:solidFill>
+          <a:ln>
+            <a:noFill/>
+          </a:ln>
+          <a:effectLst/>
+        </p:spPr>
+        <p:style>
+          <a:lnRef idx="1">
+            <a:schemeClr val="accent1"/>
+          </a:lnRef>
+          <a:fillRef idx="3">
+            <a:schemeClr val="accent1"/>
+          </a:fillRef>
+          <a:effectRef idx="2">
+            <a:schemeClr val="accent1"/>
+          </a:effectRef>
+          <a:fontRef idx="minor">
+            <a:schemeClr val="lt1"/>
+          </a:fontRef>
+        </p:style>
+        <p:txBody>
+          <a:bodyPr rtlCol="0" anchor="ctr"/>
+          <a:lstStyle/>
+          <a:p>
+            <a:pPr algn="ctr"/>
+          </a:p>
+        </p:txBody>
+      </p:sp>
+      <p:sp>
+        <p:nvSpPr>
+          <p:cNvPr id="7" name="TextBox 6"/>
+          <p:cNvSpPr txBox="1"/>
+          <p:nvPr/>
+        </p:nvSpPr>
+        <p:spPr>
+          <a:xfrm>
+            <a:off x="10668000" y="6598920"/>
+            <a:ext cx="1143000" cy="152400"/>
+          </a:xfrm>
+          <a:prstGeom prst="rect">
+            <a:avLst/>
+          </a:prstGeom>
+          <a:noFill/>
+        </p:spPr>
+        <p:txBody>
+          <a:bodyPr wrap="square" anchor="t" lIns="25400" rIns="25400" tIns="12700" bIns="12700">
+            <a:spAutoFit/>
+          </a:bodyPr>
+          <a:lstStyle/>
+          <a:p>
+            <a:pPr algn="r">
+              <a:lnSpc>
+                <a:spcPct val="100000"/>
+              </a:lnSpc>
+              <a:spcBef>
+                <a:spcPts val="0"/>
+              </a:spcBef>
+              <a:spcAft>
+                <a:spcPts val="400"/>
+              </a:spcAft>
+            </a:pPr>
+            <a:r>
+              <a:rPr sz="950" b="1" i="0">
+                <a:solidFill>
+                  <a:srgbClr val="1F3A5F"/>
+                </a:solidFill>
+                <a:latin typeface="Arial"/>
+              </a:rPr>
+              <a:t>5 / 5</a:t>
+            </a:r>
+          </a:p>
+        </p:txBody>
+      </p:sp>
+      <p:sp>
+        <p:nvSpPr>
+          <p:cNvPr id="8" name="Rectangle 7"/>
+          <p:cNvSpPr/>
+          <p:nvPr/>
+        </p:nvSpPr>
+        <p:spPr>
+          <a:xfrm>
+            <a:off x="381000" y="952500"/>
+            <a:ext cx="3657600" cy="4267200"/>
+          </a:xfrm>
+          <a:prstGeom prst="rect">
+            <a:avLst/>
+          </a:prstGeom>
+          <a:solidFill>
+            <a:srgbClr val="FFFFFF"/>
+          </a:solidFill>
+          <a:ln w="12700">
+            <a:solidFill>
+              <a:srgbClr val="DFE4EA"/>
+            </a:solidFill>
+          </a:ln>
+          <a:effectLst/>
+        </p:spPr>
+        <p:style>
+          <a:lnRef idx="1">
+            <a:schemeClr val="accent1"/>
+          </a:lnRef>
+          <a:fillRef idx="3">
+            <a:schemeClr val="accent1"/>
+          </a:fillRef>
+          <a:effectRef idx="2">
+            <a:schemeClr val="accent1"/>
+          </a:effectRef>
+          <a:fontRef idx="minor">
+            <a:schemeClr val="lt1"/>
+          </a:fontRef>
+        </p:style>
+        <p:txBody>
+          <a:bodyPr rtlCol="0" anchor="ctr"/>
+          <a:lstStyle/>
+          <a:p>
+            <a:pPr algn="ctr"/>
+          </a:p>
+        </p:txBody>
+      </p:sp>
+      <p:sp>
+        <p:nvSpPr>
+          <p:cNvPr id="9" name="Rectangle 8"/>
+          <p:cNvSpPr/>
+          <p:nvPr/>
+        </p:nvSpPr>
+        <p:spPr>
+          <a:xfrm>
+            <a:off x="381000" y="952500"/>
             <a:ext cx="3657600" cy="350520"/>
           </a:xfrm>
           <a:prstGeom prst="rect">
@@ -11183,7 +12527,7 @@
 </p:sld>
 </file>
 
-<file path=ppt/slides/slide6.xml><?xml version="1.0" encoding="utf-8"?>
+<file path=ppt/slides/slide7.xml><?xml version="1.0" encoding="utf-8"?>
 <p:sld xmlns:a="http://schemas.openxmlformats.org/drawingml/2006/main" xmlns:p="http://schemas.openxmlformats.org/presentationml/2006/main" xmlns:r="http://schemas.openxmlformats.org/officeDocument/2006/relationships">
   <p:cSld>
     <p:spTree>

</xml_diff>

<commit_message>
Add competitor map slide to the Board pitch (8 slides)
</commit_message>
<xml_diff>
--- a/Hennecke/pitch/HenneckeOMS_Board_Pitch_EN.pptx
+++ b/Hennecke/pitch/HenneckeOMS_Board_Pitch_EN.pptx
@@ -12,6 +12,7 @@
     <p:sldId id="260" r:id="rId11"/>
     <p:sldId id="261" r:id="rId12"/>
     <p:sldId id="262" r:id="rId13"/>
+    <p:sldId id="263" r:id="rId14"/>
   </p:sldIdLst>
   <p:sldSz cx="12191695" cy="6858000" type="screen4x3"/>
   <p:notesSz cx="6858000" cy="9144000"/>
@@ -4233,7 +4234,7 @@
                 </a:solidFill>
                 <a:latin typeface="Arial"/>
               </a:rPr>
-              <a:t>1 / 5</a:t>
+              <a:t>1 / 6</a:t>
             </a:r>
           </a:p>
         </p:txBody>
@@ -5993,7 +5994,7 @@
                 </a:solidFill>
                 <a:latin typeface="Arial"/>
               </a:rPr>
-              <a:t>2 / 5</a:t>
+              <a:t>2 / 6</a:t>
             </a:r>
           </a:p>
         </p:txBody>
@@ -7253,7 +7254,7 @@
                 </a:solidFill>
                 <a:latin typeface="Arial"/>
               </a:rPr>
-              <a:t>3 / 5</a:t>
+              <a:t>3 / 6</a:t>
             </a:r>
           </a:p>
         </p:txBody>
@@ -9211,7 +9212,7 @@
                 </a:solidFill>
                 <a:latin typeface="Arial"/>
               </a:rPr>
-              <a:t>Tailwinds vs headwinds — what drives this business</a:t>
+              <a:t>Competitor map — PU machinery landscape</a:t>
             </a:r>
           </a:p>
         </p:txBody>
@@ -9256,7 +9257,7 @@
                 </a:solidFill>
                 <a:latin typeface="Arial"/>
               </a:rPr>
-              <a:t>Two silos: structural supports vs structural pressures, specific to a PU capital-goods model</a:t>
+              <a:t>Qualitative positioning of the main players in the reference sector</a:t>
             </a:r>
           </a:p>
         </p:txBody>
@@ -9390,7 +9391,7 @@
                 </a:solidFill>
                 <a:latin typeface="Arial"/>
               </a:rPr>
-              <a:t>4 / 5</a:t>
+              <a:t>4 / 6</a:t>
             </a:r>
           </a:p>
         </p:txBody>
@@ -9403,8 +9404,1025 @@
         </p:nvSpPr>
         <p:spPr>
           <a:xfrm>
-            <a:off x="381000" y="952500"/>
-            <a:ext cx="5638800" cy="4381500"/>
+            <a:off x="914400" y="1203960"/>
+            <a:ext cx="6705600" cy="4038600"/>
+          </a:xfrm>
+          <a:prstGeom prst="rect">
+            <a:avLst/>
+          </a:prstGeom>
+          <a:solidFill>
+            <a:srgbClr val="FBFCFD"/>
+          </a:solidFill>
+          <a:ln w="12700">
+            <a:solidFill>
+              <a:srgbClr val="DFE4EA"/>
+            </a:solidFill>
+          </a:ln>
+          <a:effectLst/>
+        </p:spPr>
+        <p:style>
+          <a:lnRef idx="1">
+            <a:schemeClr val="accent1"/>
+          </a:lnRef>
+          <a:fillRef idx="3">
+            <a:schemeClr val="accent1"/>
+          </a:fillRef>
+          <a:effectRef idx="2">
+            <a:schemeClr val="accent1"/>
+          </a:effectRef>
+          <a:fontRef idx="minor">
+            <a:schemeClr val="lt1"/>
+          </a:fontRef>
+        </p:style>
+        <p:txBody>
+          <a:bodyPr rtlCol="0" anchor="ctr"/>
+          <a:lstStyle/>
+          <a:p>
+            <a:pPr algn="ctr"/>
+          </a:p>
+        </p:txBody>
+      </p:sp>
+      <p:sp>
+        <p:nvSpPr>
+          <p:cNvPr id="9" name="Rectangle 8"/>
+          <p:cNvSpPr/>
+          <p:nvPr/>
+        </p:nvSpPr>
+        <p:spPr>
+          <a:xfrm>
+            <a:off x="1143000" y="3238500"/>
+            <a:ext cx="6248400" cy="10668"/>
+          </a:xfrm>
+          <a:prstGeom prst="rect">
+            <a:avLst/>
+          </a:prstGeom>
+          <a:solidFill>
+            <a:srgbClr val="C9D2DD"/>
+          </a:solidFill>
+          <a:ln>
+            <a:noFill/>
+          </a:ln>
+          <a:effectLst/>
+        </p:spPr>
+        <p:style>
+          <a:lnRef idx="1">
+            <a:schemeClr val="accent1"/>
+          </a:lnRef>
+          <a:fillRef idx="3">
+            <a:schemeClr val="accent1"/>
+          </a:fillRef>
+          <a:effectRef idx="2">
+            <a:schemeClr val="accent1"/>
+          </a:effectRef>
+          <a:fontRef idx="minor">
+            <a:schemeClr val="lt1"/>
+          </a:fontRef>
+        </p:style>
+        <p:txBody>
+          <a:bodyPr rtlCol="0" anchor="ctr"/>
+          <a:lstStyle/>
+          <a:p>
+            <a:pPr algn="ctr"/>
+          </a:p>
+        </p:txBody>
+      </p:sp>
+      <p:sp>
+        <p:nvSpPr>
+          <p:cNvPr id="10" name="Rectangle 9"/>
+          <p:cNvSpPr/>
+          <p:nvPr/>
+        </p:nvSpPr>
+        <p:spPr>
+          <a:xfrm>
+            <a:off x="4267200" y="1447800"/>
+            <a:ext cx="10668" cy="3581400"/>
+          </a:xfrm>
+          <a:prstGeom prst="rect">
+            <a:avLst/>
+          </a:prstGeom>
+          <a:solidFill>
+            <a:srgbClr val="C9D2DD"/>
+          </a:solidFill>
+          <a:ln>
+            <a:noFill/>
+          </a:ln>
+          <a:effectLst/>
+        </p:spPr>
+        <p:style>
+          <a:lnRef idx="1">
+            <a:schemeClr val="accent1"/>
+          </a:lnRef>
+          <a:fillRef idx="3">
+            <a:schemeClr val="accent1"/>
+          </a:fillRef>
+          <a:effectRef idx="2">
+            <a:schemeClr val="accent1"/>
+          </a:effectRef>
+          <a:fontRef idx="minor">
+            <a:schemeClr val="lt1"/>
+          </a:fontRef>
+        </p:style>
+        <p:txBody>
+          <a:bodyPr rtlCol="0" anchor="ctr"/>
+          <a:lstStyle/>
+          <a:p>
+            <a:pPr algn="ctr"/>
+          </a:p>
+        </p:txBody>
+      </p:sp>
+      <p:sp>
+        <p:nvSpPr>
+          <p:cNvPr id="11" name="TextBox 10"/>
+          <p:cNvSpPr txBox="1"/>
+          <p:nvPr/>
+        </p:nvSpPr>
+        <p:spPr>
+          <a:xfrm>
+            <a:off x="1143000" y="1257300"/>
+            <a:ext cx="6248400" cy="152400"/>
+          </a:xfrm>
+          <a:prstGeom prst="rect">
+            <a:avLst/>
+          </a:prstGeom>
+          <a:noFill/>
+        </p:spPr>
+        <p:txBody>
+          <a:bodyPr wrap="square" anchor="t" lIns="25400" rIns="25400" tIns="12700" bIns="12700">
+            <a:spAutoFit/>
+          </a:bodyPr>
+          <a:lstStyle/>
+          <a:p>
+            <a:pPr algn="ctr">
+              <a:lnSpc>
+                <a:spcPct val="100000"/>
+              </a:lnSpc>
+              <a:spcBef>
+                <a:spcPts val="0"/>
+              </a:spcBef>
+              <a:spcAft>
+                <a:spcPts val="400"/>
+              </a:spcAft>
+            </a:pPr>
+            <a:r>
+              <a:rPr sz="1150" b="1" i="0">
+                <a:solidFill>
+                  <a:srgbClr val="666666"/>
+                </a:solidFill>
+                <a:latin typeface="Arial"/>
+              </a:rPr>
+              <a:t>▲ Global scale &amp; installed base</a:t>
+            </a:r>
+          </a:p>
+        </p:txBody>
+      </p:sp>
+      <p:sp>
+        <p:nvSpPr>
+          <p:cNvPr id="12" name="TextBox 11"/>
+          <p:cNvSpPr txBox="1"/>
+          <p:nvPr/>
+        </p:nvSpPr>
+        <p:spPr>
+          <a:xfrm>
+            <a:off x="1143000" y="5067300"/>
+            <a:ext cx="6248400" cy="152400"/>
+          </a:xfrm>
+          <a:prstGeom prst="rect">
+            <a:avLst/>
+          </a:prstGeom>
+          <a:noFill/>
+        </p:spPr>
+        <p:txBody>
+          <a:bodyPr wrap="square" anchor="t" lIns="25400" rIns="25400" tIns="12700" bIns="12700">
+            <a:spAutoFit/>
+          </a:bodyPr>
+          <a:lstStyle/>
+          <a:p>
+            <a:pPr algn="ctr">
+              <a:lnSpc>
+                <a:spcPct val="100000"/>
+              </a:lnSpc>
+              <a:spcBef>
+                <a:spcPts val="0"/>
+              </a:spcBef>
+              <a:spcAft>
+                <a:spcPts val="400"/>
+              </a:spcAft>
+            </a:pPr>
+            <a:r>
+              <a:rPr sz="1150" b="1" i="0">
+                <a:solidFill>
+                  <a:srgbClr val="666666"/>
+                </a:solidFill>
+                <a:latin typeface="Arial"/>
+              </a:rPr>
+              <a:t>▼ Regional / niche reach</a:t>
+            </a:r>
+          </a:p>
+        </p:txBody>
+      </p:sp>
+      <p:sp>
+        <p:nvSpPr>
+          <p:cNvPr id="13" name="TextBox 12"/>
+          <p:cNvSpPr txBox="1"/>
+          <p:nvPr/>
+        </p:nvSpPr>
+        <p:spPr>
+          <a:xfrm>
+            <a:off x="975360" y="3284220"/>
+            <a:ext cx="1752600" cy="137160"/>
+          </a:xfrm>
+          <a:prstGeom prst="rect">
+            <a:avLst/>
+          </a:prstGeom>
+          <a:noFill/>
+        </p:spPr>
+        <p:txBody>
+          <a:bodyPr wrap="square" anchor="t" lIns="25400" rIns="25400" tIns="12700" bIns="12700">
+            <a:spAutoFit/>
+          </a:bodyPr>
+          <a:lstStyle/>
+          <a:p>
+            <a:pPr algn="l">
+              <a:lnSpc>
+                <a:spcPct val="100000"/>
+              </a:lnSpc>
+              <a:spcBef>
+                <a:spcPts val="0"/>
+              </a:spcBef>
+              <a:spcAft>
+                <a:spcPts val="400"/>
+              </a:spcAft>
+            </a:pPr>
+            <a:r>
+              <a:rPr sz="1100" b="0" i="0">
+                <a:solidFill>
+                  <a:srgbClr val="999999"/>
+                </a:solidFill>
+                <a:latin typeface="Arial"/>
+              </a:rPr>
+              <a:t>◄ Specialised PU pure-play</a:t>
+            </a:r>
+          </a:p>
+        </p:txBody>
+      </p:sp>
+      <p:sp>
+        <p:nvSpPr>
+          <p:cNvPr id="14" name="TextBox 13"/>
+          <p:cNvSpPr txBox="1"/>
+          <p:nvPr/>
+        </p:nvSpPr>
+        <p:spPr>
+          <a:xfrm>
+            <a:off x="5562600" y="3284220"/>
+            <a:ext cx="1752600" cy="137160"/>
+          </a:xfrm>
+          <a:prstGeom prst="rect">
+            <a:avLst/>
+          </a:prstGeom>
+          <a:noFill/>
+        </p:spPr>
+        <p:txBody>
+          <a:bodyPr wrap="square" anchor="t" lIns="25400" rIns="25400" tIns="12700" bIns="12700">
+            <a:spAutoFit/>
+          </a:bodyPr>
+          <a:lstStyle/>
+          <a:p>
+            <a:pPr algn="r">
+              <a:lnSpc>
+                <a:spcPct val="100000"/>
+              </a:lnSpc>
+              <a:spcBef>
+                <a:spcPts val="0"/>
+              </a:spcBef>
+              <a:spcAft>
+                <a:spcPts val="400"/>
+              </a:spcAft>
+            </a:pPr>
+            <a:r>
+              <a:rPr sz="1100" b="0" i="0">
+                <a:solidFill>
+                  <a:srgbClr val="999999"/>
+                </a:solidFill>
+                <a:latin typeface="Arial"/>
+              </a:rPr>
+              <a:t>Diversified machinery group ►</a:t>
+            </a:r>
+          </a:p>
+        </p:txBody>
+      </p:sp>
+      <p:sp>
+        <p:nvSpPr>
+          <p:cNvPr id="15" name="Oval 14"/>
+          <p:cNvSpPr/>
+          <p:nvPr/>
+        </p:nvSpPr>
+        <p:spPr>
+          <a:xfrm>
+            <a:off x="2999232" y="1743456"/>
+            <a:ext cx="411480" cy="411480"/>
+          </a:xfrm>
+          <a:prstGeom prst="ellipse">
+            <a:avLst/>
+          </a:prstGeom>
+          <a:solidFill>
+            <a:srgbClr val="1F3A5F"/>
+          </a:solidFill>
+          <a:ln w="19050">
+            <a:solidFill>
+              <a:srgbClr val="FFFFFF"/>
+            </a:solidFill>
+          </a:ln>
+          <a:effectLst/>
+        </p:spPr>
+        <p:style>
+          <a:lnRef idx="1">
+            <a:schemeClr val="accent1"/>
+          </a:lnRef>
+          <a:fillRef idx="3">
+            <a:schemeClr val="accent1"/>
+          </a:fillRef>
+          <a:effectRef idx="2">
+            <a:schemeClr val="accent1"/>
+          </a:effectRef>
+          <a:fontRef idx="minor">
+            <a:schemeClr val="lt1"/>
+          </a:fontRef>
+        </p:style>
+        <p:txBody>
+          <a:bodyPr rtlCol="0" anchor="ctr"/>
+          <a:lstStyle/>
+          <a:p>
+            <a:pPr algn="ctr"/>
+          </a:p>
+        </p:txBody>
+      </p:sp>
+      <p:sp>
+        <p:nvSpPr>
+          <p:cNvPr id="16" name="TextBox 15"/>
+          <p:cNvSpPr txBox="1"/>
+          <p:nvPr/>
+        </p:nvSpPr>
+        <p:spPr>
+          <a:xfrm>
+            <a:off x="2519172" y="2162556"/>
+            <a:ext cx="1371600" cy="259080"/>
+          </a:xfrm>
+          <a:prstGeom prst="rect">
+            <a:avLst/>
+          </a:prstGeom>
+          <a:noFill/>
+        </p:spPr>
+        <p:txBody>
+          <a:bodyPr wrap="square" anchor="t" lIns="25400" rIns="25400" tIns="12700" bIns="12700">
+            <a:spAutoFit/>
+          </a:bodyPr>
+          <a:lstStyle/>
+          <a:p>
+            <a:pPr algn="ctr">
+              <a:lnSpc>
+                <a:spcPct val="95000"/>
+              </a:lnSpc>
+              <a:spcBef>
+                <a:spcPts val="0"/>
+              </a:spcBef>
+              <a:spcAft>
+                <a:spcPts val="0"/>
+              </a:spcAft>
+            </a:pPr>
+            <a:r>
+              <a:rPr sz="1150" b="1" i="0">
+                <a:solidFill>
+                  <a:srgbClr val="222222"/>
+                </a:solidFill>
+                <a:latin typeface="Arial"/>
+              </a:rPr>
+              <a:t>Hennecke Group</a:t>
+            </a:r>
+          </a:p>
+          <a:p>
+            <a:pPr algn="ctr">
+              <a:lnSpc>
+                <a:spcPct val="100000"/>
+              </a:lnSpc>
+              <a:spcBef>
+                <a:spcPts val="0"/>
+              </a:spcBef>
+              <a:spcAft>
+                <a:spcPts val="0"/>
+              </a:spcAft>
+            </a:pPr>
+            <a:r>
+              <a:rPr sz="950" b="0" i="1">
+                <a:solidFill>
+                  <a:srgbClr val="1F3A5F"/>
+                </a:solidFill>
+                <a:latin typeface="Arial"/>
+              </a:rPr>
+              <a:t>PU world leader (incl. OMS)</a:t>
+            </a:r>
+          </a:p>
+        </p:txBody>
+      </p:sp>
+      <p:sp>
+        <p:nvSpPr>
+          <p:cNvPr id="17" name="Oval 16"/>
+          <p:cNvSpPr/>
+          <p:nvPr/>
+        </p:nvSpPr>
+        <p:spPr>
+          <a:xfrm>
+            <a:off x="2287524" y="2497836"/>
+            <a:ext cx="335280" cy="335280"/>
+          </a:xfrm>
+          <a:prstGeom prst="ellipse">
+            <a:avLst/>
+          </a:prstGeom>
+          <a:solidFill>
+            <a:srgbClr val="C8102E"/>
+          </a:solidFill>
+          <a:ln w="19050">
+            <a:solidFill>
+              <a:srgbClr val="FFFFFF"/>
+            </a:solidFill>
+          </a:ln>
+          <a:effectLst/>
+        </p:spPr>
+        <p:style>
+          <a:lnRef idx="1">
+            <a:schemeClr val="accent1"/>
+          </a:lnRef>
+          <a:fillRef idx="3">
+            <a:schemeClr val="accent1"/>
+          </a:fillRef>
+          <a:effectRef idx="2">
+            <a:schemeClr val="accent1"/>
+          </a:effectRef>
+          <a:fontRef idx="minor">
+            <a:schemeClr val="lt1"/>
+          </a:fontRef>
+        </p:style>
+        <p:txBody>
+          <a:bodyPr rtlCol="0" anchor="ctr"/>
+          <a:lstStyle/>
+          <a:p>
+            <a:pPr algn="ctr"/>
+          </a:p>
+        </p:txBody>
+      </p:sp>
+      <p:sp>
+        <p:nvSpPr>
+          <p:cNvPr id="18" name="TextBox 17"/>
+          <p:cNvSpPr txBox="1"/>
+          <p:nvPr/>
+        </p:nvSpPr>
+        <p:spPr>
+          <a:xfrm>
+            <a:off x="1769364" y="2840736"/>
+            <a:ext cx="1371600" cy="259080"/>
+          </a:xfrm>
+          <a:prstGeom prst="rect">
+            <a:avLst/>
+          </a:prstGeom>
+          <a:noFill/>
+        </p:spPr>
+        <p:txBody>
+          <a:bodyPr wrap="square" anchor="t" lIns="25400" rIns="25400" tIns="12700" bIns="12700">
+            <a:spAutoFit/>
+          </a:bodyPr>
+          <a:lstStyle/>
+          <a:p>
+            <a:pPr algn="ctr">
+              <a:lnSpc>
+                <a:spcPct val="95000"/>
+              </a:lnSpc>
+              <a:spcBef>
+                <a:spcPts val="0"/>
+              </a:spcBef>
+              <a:spcAft>
+                <a:spcPts val="0"/>
+              </a:spcAft>
+            </a:pPr>
+            <a:r>
+              <a:rPr sz="1150" b="1" i="0">
+                <a:solidFill>
+                  <a:srgbClr val="222222"/>
+                </a:solidFill>
+                <a:latin typeface="Arial"/>
+              </a:rPr>
+              <a:t>Hennecke-OMS</a:t>
+            </a:r>
+          </a:p>
+          <a:p>
+            <a:pPr algn="ctr">
+              <a:lnSpc>
+                <a:spcPct val="100000"/>
+              </a:lnSpc>
+              <a:spcBef>
+                <a:spcPts val="0"/>
+              </a:spcBef>
+              <a:spcAft>
+                <a:spcPts val="0"/>
+              </a:spcAft>
+            </a:pPr>
+            <a:r>
+              <a:rPr sz="950" b="0" i="1">
+                <a:solidFill>
+                  <a:srgbClr val="C8102E"/>
+                </a:solidFill>
+                <a:latin typeface="Arial"/>
+              </a:rPr>
+              <a:t>TARGET</a:t>
+            </a:r>
+          </a:p>
+        </p:txBody>
+      </p:sp>
+      <p:sp>
+        <p:nvSpPr>
+          <p:cNvPr id="19" name="Oval 18"/>
+          <p:cNvSpPr/>
+          <p:nvPr/>
+        </p:nvSpPr>
+        <p:spPr>
+          <a:xfrm>
+            <a:off x="2942844" y="3101340"/>
+            <a:ext cx="274320" cy="274320"/>
+          </a:xfrm>
+          <a:prstGeom prst="ellipse">
+            <a:avLst/>
+          </a:prstGeom>
+          <a:solidFill>
+            <a:srgbClr val="5B7A9E"/>
+          </a:solidFill>
+          <a:ln w="19050">
+            <a:solidFill>
+              <a:srgbClr val="FFFFFF"/>
+            </a:solidFill>
+          </a:ln>
+          <a:effectLst/>
+        </p:spPr>
+        <p:style>
+          <a:lnRef idx="1">
+            <a:schemeClr val="accent1"/>
+          </a:lnRef>
+          <a:fillRef idx="3">
+            <a:schemeClr val="accent1"/>
+          </a:fillRef>
+          <a:effectRef idx="2">
+            <a:schemeClr val="accent1"/>
+          </a:effectRef>
+          <a:fontRef idx="minor">
+            <a:schemeClr val="lt1"/>
+          </a:fontRef>
+        </p:style>
+        <p:txBody>
+          <a:bodyPr rtlCol="0" anchor="ctr"/>
+          <a:lstStyle/>
+          <a:p>
+            <a:pPr algn="ctr"/>
+          </a:p>
+        </p:txBody>
+      </p:sp>
+      <p:sp>
+        <p:nvSpPr>
+          <p:cNvPr id="20" name="TextBox 19"/>
+          <p:cNvSpPr txBox="1"/>
+          <p:nvPr/>
+        </p:nvSpPr>
+        <p:spPr>
+          <a:xfrm>
+            <a:off x="2394204" y="3383280"/>
+            <a:ext cx="1371600" cy="259080"/>
+          </a:xfrm>
+          <a:prstGeom prst="rect">
+            <a:avLst/>
+          </a:prstGeom>
+          <a:noFill/>
+        </p:spPr>
+        <p:txBody>
+          <a:bodyPr wrap="square" anchor="t" lIns="25400" rIns="25400" tIns="12700" bIns="12700">
+            <a:spAutoFit/>
+          </a:bodyPr>
+          <a:lstStyle/>
+          <a:p>
+            <a:pPr algn="ctr">
+              <a:lnSpc>
+                <a:spcPct val="95000"/>
+              </a:lnSpc>
+              <a:spcBef>
+                <a:spcPts val="0"/>
+              </a:spcBef>
+              <a:spcAft>
+                <a:spcPts val="0"/>
+              </a:spcAft>
+            </a:pPr>
+            <a:r>
+              <a:rPr sz="1150" b="1" i="0">
+                <a:solidFill>
+                  <a:srgbClr val="222222"/>
+                </a:solidFill>
+                <a:latin typeface="Arial"/>
+              </a:rPr>
+              <a:t>Cannon / Afros</a:t>
+            </a:r>
+          </a:p>
+        </p:txBody>
+      </p:sp>
+      <p:sp>
+        <p:nvSpPr>
+          <p:cNvPr id="21" name="Oval 20"/>
+          <p:cNvSpPr/>
+          <p:nvPr/>
+        </p:nvSpPr>
+        <p:spPr>
+          <a:xfrm>
+            <a:off x="6216396" y="1917192"/>
+            <a:ext cx="350520" cy="350520"/>
+          </a:xfrm>
+          <a:prstGeom prst="ellipse">
+            <a:avLst/>
+          </a:prstGeom>
+          <a:solidFill>
+            <a:srgbClr val="5B7A9E"/>
+          </a:solidFill>
+          <a:ln w="19050">
+            <a:solidFill>
+              <a:srgbClr val="FFFFFF"/>
+            </a:solidFill>
+          </a:ln>
+          <a:effectLst/>
+        </p:spPr>
+        <p:style>
+          <a:lnRef idx="1">
+            <a:schemeClr val="accent1"/>
+          </a:lnRef>
+          <a:fillRef idx="3">
+            <a:schemeClr val="accent1"/>
+          </a:fillRef>
+          <a:effectRef idx="2">
+            <a:schemeClr val="accent1"/>
+          </a:effectRef>
+          <a:fontRef idx="minor">
+            <a:schemeClr val="lt1"/>
+          </a:fontRef>
+        </p:style>
+        <p:txBody>
+          <a:bodyPr rtlCol="0" anchor="ctr"/>
+          <a:lstStyle/>
+          <a:p>
+            <a:pPr algn="ctr"/>
+          </a:p>
+        </p:txBody>
+      </p:sp>
+      <p:sp>
+        <p:nvSpPr>
+          <p:cNvPr id="22" name="TextBox 21"/>
+          <p:cNvSpPr txBox="1"/>
+          <p:nvPr/>
+        </p:nvSpPr>
+        <p:spPr>
+          <a:xfrm>
+            <a:off x="5705856" y="2275332"/>
+            <a:ext cx="1371600" cy="259080"/>
+          </a:xfrm>
+          <a:prstGeom prst="rect">
+            <a:avLst/>
+          </a:prstGeom>
+          <a:noFill/>
+        </p:spPr>
+        <p:txBody>
+          <a:bodyPr wrap="square" anchor="t" lIns="25400" rIns="25400" tIns="12700" bIns="12700">
+            <a:spAutoFit/>
+          </a:bodyPr>
+          <a:lstStyle/>
+          <a:p>
+            <a:pPr algn="ctr">
+              <a:lnSpc>
+                <a:spcPct val="95000"/>
+              </a:lnSpc>
+              <a:spcBef>
+                <a:spcPts val="0"/>
+              </a:spcBef>
+              <a:spcAft>
+                <a:spcPts val="0"/>
+              </a:spcAft>
+            </a:pPr>
+            <a:r>
+              <a:rPr sz="1150" b="1" i="0">
+                <a:solidFill>
+                  <a:srgbClr val="222222"/>
+                </a:solidFill>
+                <a:latin typeface="Arial"/>
+              </a:rPr>
+              <a:t>KraussMaffei</a:t>
+            </a:r>
+          </a:p>
+          <a:p>
+            <a:pPr algn="ctr">
+              <a:lnSpc>
+                <a:spcPct val="100000"/>
+              </a:lnSpc>
+              <a:spcBef>
+                <a:spcPts val="0"/>
+              </a:spcBef>
+              <a:spcAft>
+                <a:spcPts val="0"/>
+              </a:spcAft>
+            </a:pPr>
+            <a:r>
+              <a:rPr sz="950" b="0" i="1">
+                <a:solidFill>
+                  <a:srgbClr val="999999"/>
+                </a:solidFill>
+                <a:latin typeface="Arial"/>
+              </a:rPr>
+              <a:t>RPM unit · ChemChina</a:t>
+            </a:r>
+          </a:p>
+        </p:txBody>
+      </p:sp>
+      <p:sp>
+        <p:nvSpPr>
+          <p:cNvPr id="23" name="Oval 22"/>
+          <p:cNvSpPr/>
+          <p:nvPr/>
+        </p:nvSpPr>
+        <p:spPr>
+          <a:xfrm>
+            <a:off x="5644896" y="2973324"/>
+            <a:ext cx="243840" cy="243840"/>
+          </a:xfrm>
+          <a:prstGeom prst="ellipse">
+            <a:avLst/>
+          </a:prstGeom>
+          <a:solidFill>
+            <a:srgbClr val="5B7A9E"/>
+          </a:solidFill>
+          <a:ln w="19050">
+            <a:solidFill>
+              <a:srgbClr val="FFFFFF"/>
+            </a:solidFill>
+          </a:ln>
+          <a:effectLst/>
+        </p:spPr>
+        <p:style>
+          <a:lnRef idx="1">
+            <a:schemeClr val="accent1"/>
+          </a:lnRef>
+          <a:fillRef idx="3">
+            <a:schemeClr val="accent1"/>
+          </a:fillRef>
+          <a:effectRef idx="2">
+            <a:schemeClr val="accent1"/>
+          </a:effectRef>
+          <a:fontRef idx="minor">
+            <a:schemeClr val="lt1"/>
+          </a:fontRef>
+        </p:style>
+        <p:txBody>
+          <a:bodyPr rtlCol="0" anchor="ctr"/>
+          <a:lstStyle/>
+          <a:p>
+            <a:pPr algn="ctr"/>
+          </a:p>
+        </p:txBody>
+      </p:sp>
+      <p:sp>
+        <p:nvSpPr>
+          <p:cNvPr id="24" name="TextBox 23"/>
+          <p:cNvSpPr txBox="1"/>
+          <p:nvPr/>
+        </p:nvSpPr>
+        <p:spPr>
+          <a:xfrm>
+            <a:off x="5081016" y="3224784"/>
+            <a:ext cx="1371600" cy="259080"/>
+          </a:xfrm>
+          <a:prstGeom prst="rect">
+            <a:avLst/>
+          </a:prstGeom>
+          <a:noFill/>
+        </p:spPr>
+        <p:txBody>
+          <a:bodyPr wrap="square" anchor="t" lIns="25400" rIns="25400" tIns="12700" bIns="12700">
+            <a:spAutoFit/>
+          </a:bodyPr>
+          <a:lstStyle/>
+          <a:p>
+            <a:pPr algn="ctr">
+              <a:lnSpc>
+                <a:spcPct val="95000"/>
+              </a:lnSpc>
+              <a:spcBef>
+                <a:spcPts val="0"/>
+              </a:spcBef>
+              <a:spcAft>
+                <a:spcPts val="0"/>
+              </a:spcAft>
+            </a:pPr>
+            <a:r>
+              <a:rPr sz="1150" b="1" i="0">
+                <a:solidFill>
+                  <a:srgbClr val="222222"/>
+                </a:solidFill>
+                <a:latin typeface="Arial"/>
+              </a:rPr>
+              <a:t>Kurtz Ersa</a:t>
+            </a:r>
+          </a:p>
+        </p:txBody>
+      </p:sp>
+      <p:sp>
+        <p:nvSpPr>
+          <p:cNvPr id="25" name="Oval 24"/>
+          <p:cNvSpPr/>
+          <p:nvPr/>
+        </p:nvSpPr>
+        <p:spPr>
+          <a:xfrm>
+            <a:off x="4770120" y="3403092"/>
+            <a:ext cx="243840" cy="243840"/>
+          </a:xfrm>
+          <a:prstGeom prst="ellipse">
+            <a:avLst/>
+          </a:prstGeom>
+          <a:solidFill>
+            <a:srgbClr val="5B7A9E"/>
+          </a:solidFill>
+          <a:ln w="19050">
+            <a:solidFill>
+              <a:srgbClr val="FFFFFF"/>
+            </a:solidFill>
+          </a:ln>
+          <a:effectLst/>
+        </p:spPr>
+        <p:style>
+          <a:lnRef idx="1">
+            <a:schemeClr val="accent1"/>
+          </a:lnRef>
+          <a:fillRef idx="3">
+            <a:schemeClr val="accent1"/>
+          </a:fillRef>
+          <a:effectRef idx="2">
+            <a:schemeClr val="accent1"/>
+          </a:effectRef>
+          <a:fontRef idx="minor">
+            <a:schemeClr val="lt1"/>
+          </a:fontRef>
+        </p:style>
+        <p:txBody>
+          <a:bodyPr rtlCol="0" anchor="ctr"/>
+          <a:lstStyle/>
+          <a:p>
+            <a:pPr algn="ctr"/>
+          </a:p>
+        </p:txBody>
+      </p:sp>
+      <p:sp>
+        <p:nvSpPr>
+          <p:cNvPr id="26" name="TextBox 25"/>
+          <p:cNvSpPr txBox="1"/>
+          <p:nvPr/>
+        </p:nvSpPr>
+        <p:spPr>
+          <a:xfrm>
+            <a:off x="4206240" y="3654552"/>
+            <a:ext cx="1371600" cy="259080"/>
+          </a:xfrm>
+          <a:prstGeom prst="rect">
+            <a:avLst/>
+          </a:prstGeom>
+          <a:noFill/>
+        </p:spPr>
+        <p:txBody>
+          <a:bodyPr wrap="square" anchor="t" lIns="25400" rIns="25400" tIns="12700" bIns="12700">
+            <a:spAutoFit/>
+          </a:bodyPr>
+          <a:lstStyle/>
+          <a:p>
+            <a:pPr algn="ctr">
+              <a:lnSpc>
+                <a:spcPct val="95000"/>
+              </a:lnSpc>
+              <a:spcBef>
+                <a:spcPts val="0"/>
+              </a:spcBef>
+              <a:spcAft>
+                <a:spcPts val="0"/>
+              </a:spcAft>
+            </a:pPr>
+            <a:r>
+              <a:rPr sz="1150" b="1" i="0">
+                <a:solidFill>
+                  <a:srgbClr val="222222"/>
+                </a:solidFill>
+                <a:latin typeface="Arial"/>
+              </a:rPr>
+              <a:t>Frimo</a:t>
+            </a:r>
+          </a:p>
+        </p:txBody>
+      </p:sp>
+      <p:sp>
+        <p:nvSpPr>
+          <p:cNvPr id="27" name="Oval 26"/>
+          <p:cNvSpPr/>
+          <p:nvPr/>
+        </p:nvSpPr>
+        <p:spPr>
+          <a:xfrm>
+            <a:off x="2286000" y="3991356"/>
+            <a:ext cx="213360" cy="213360"/>
+          </a:xfrm>
+          <a:prstGeom prst="ellipse">
+            <a:avLst/>
+          </a:prstGeom>
+          <a:solidFill>
+            <a:srgbClr val="5B7A9E"/>
+          </a:solidFill>
+          <a:ln w="19050">
+            <a:solidFill>
+              <a:srgbClr val="FFFFFF"/>
+            </a:solidFill>
+          </a:ln>
+          <a:effectLst/>
+        </p:spPr>
+        <p:style>
+          <a:lnRef idx="1">
+            <a:schemeClr val="accent1"/>
+          </a:lnRef>
+          <a:fillRef idx="3">
+            <a:schemeClr val="accent1"/>
+          </a:fillRef>
+          <a:effectRef idx="2">
+            <a:schemeClr val="accent1"/>
+          </a:effectRef>
+          <a:fontRef idx="minor">
+            <a:schemeClr val="lt1"/>
+          </a:fontRef>
+        </p:style>
+        <p:txBody>
+          <a:bodyPr rtlCol="0" anchor="ctr"/>
+          <a:lstStyle/>
+          <a:p>
+            <a:pPr algn="ctr"/>
+          </a:p>
+        </p:txBody>
+      </p:sp>
+      <p:sp>
+        <p:nvSpPr>
+          <p:cNvPr id="28" name="TextBox 27"/>
+          <p:cNvSpPr txBox="1"/>
+          <p:nvPr/>
+        </p:nvSpPr>
+        <p:spPr>
+          <a:xfrm>
+            <a:off x="1706880" y="4212336"/>
+            <a:ext cx="1371600" cy="259080"/>
+          </a:xfrm>
+          <a:prstGeom prst="rect">
+            <a:avLst/>
+          </a:prstGeom>
+          <a:noFill/>
+        </p:spPr>
+        <p:txBody>
+          <a:bodyPr wrap="square" anchor="t" lIns="25400" rIns="25400" tIns="12700" bIns="12700">
+            <a:spAutoFit/>
+          </a:bodyPr>
+          <a:lstStyle/>
+          <a:p>
+            <a:pPr algn="ctr">
+              <a:lnSpc>
+                <a:spcPct val="95000"/>
+              </a:lnSpc>
+              <a:spcBef>
+                <a:spcPts val="0"/>
+              </a:spcBef>
+              <a:spcAft>
+                <a:spcPts val="0"/>
+              </a:spcAft>
+            </a:pPr>
+            <a:r>
+              <a:rPr sz="1150" b="1" i="0">
+                <a:solidFill>
+                  <a:srgbClr val="222222"/>
+                </a:solidFill>
+                <a:latin typeface="Arial"/>
+              </a:rPr>
+              <a:t>Saip</a:t>
+            </a:r>
+          </a:p>
+        </p:txBody>
+      </p:sp>
+      <p:sp>
+        <p:nvSpPr>
+          <p:cNvPr id="29" name="Rectangle 28"/>
+          <p:cNvSpPr/>
+          <p:nvPr/>
+        </p:nvSpPr>
+        <p:spPr>
+          <a:xfrm>
+            <a:off x="7772400" y="1203960"/>
+            <a:ext cx="4038600" cy="4038600"/>
           </a:xfrm>
           <a:prstGeom prst="rect">
             <a:avLst/>
@@ -9443,20 +10461,65 @@
       </p:sp>
       <p:sp>
         <p:nvSpPr>
-          <p:cNvPr id="9" name="Rectangle 8"/>
+          <p:cNvPr id="30" name="TextBox 29"/>
+          <p:cNvSpPr txBox="1"/>
+          <p:nvPr/>
+        </p:nvSpPr>
+        <p:spPr>
+          <a:xfrm>
+            <a:off x="7955280" y="1295400"/>
+            <a:ext cx="3657600" cy="198120"/>
+          </a:xfrm>
+          <a:prstGeom prst="rect">
+            <a:avLst/>
+          </a:prstGeom>
+          <a:noFill/>
+        </p:spPr>
+        <p:txBody>
+          <a:bodyPr wrap="square" anchor="t" lIns="25400" rIns="25400" tIns="12700" bIns="12700">
+            <a:spAutoFit/>
+          </a:bodyPr>
+          <a:lstStyle/>
+          <a:p>
+            <a:pPr algn="l">
+              <a:lnSpc>
+                <a:spcPct val="100000"/>
+              </a:lnSpc>
+              <a:spcBef>
+                <a:spcPts val="0"/>
+              </a:spcBef>
+              <a:spcAft>
+                <a:spcPts val="400"/>
+              </a:spcAft>
+            </a:pPr>
+            <a:r>
+              <a:rPr sz="1600" b="1" i="0">
+                <a:solidFill>
+                  <a:srgbClr val="1F3A5F"/>
+                </a:solidFill>
+                <a:latin typeface="Arial"/>
+              </a:rPr>
+              <a:t>Key players</a:t>
+            </a:r>
+          </a:p>
+        </p:txBody>
+      </p:sp>
+      <p:sp>
+        <p:nvSpPr>
+          <p:cNvPr id="31" name="Rectangle 30"/>
           <p:cNvSpPr/>
           <p:nvPr/>
         </p:nvSpPr>
         <p:spPr>
           <a:xfrm>
-            <a:off x="381000" y="952500"/>
-            <a:ext cx="5638800" cy="350520"/>
+            <a:off x="7955280" y="1524000"/>
+            <a:ext cx="3672840" cy="7620"/>
           </a:xfrm>
           <a:prstGeom prst="rect">
             <a:avLst/>
           </a:prstGeom>
           <a:solidFill>
-            <a:srgbClr val="2E7D4F"/>
+            <a:srgbClr val="DFE4EA"/>
           </a:solidFill>
           <a:ln>
             <a:noFill/>
@@ -9487,59 +10550,14 @@
       </p:sp>
       <p:sp>
         <p:nvSpPr>
-          <p:cNvPr id="10" name="TextBox 9"/>
+          <p:cNvPr id="32" name="TextBox 31"/>
           <p:cNvSpPr txBox="1"/>
           <p:nvPr/>
         </p:nvSpPr>
         <p:spPr>
           <a:xfrm>
-            <a:off x="548640" y="952500"/>
-            <a:ext cx="5410200" cy="350520"/>
-          </a:xfrm>
-          <a:prstGeom prst="rect">
-            <a:avLst/>
-          </a:prstGeom>
-          <a:noFill/>
-        </p:spPr>
-        <p:txBody>
-          <a:bodyPr wrap="square" anchor="ctr" lIns="25400" rIns="25400" tIns="12700" bIns="12700">
-            <a:spAutoFit/>
-          </a:bodyPr>
-          <a:lstStyle/>
-          <a:p>
-            <a:pPr algn="l">
-              <a:lnSpc>
-                <a:spcPct val="100000"/>
-              </a:lnSpc>
-              <a:spcBef>
-                <a:spcPts val="0"/>
-              </a:spcBef>
-              <a:spcAft>
-                <a:spcPts val="400"/>
-              </a:spcAft>
-            </a:pPr>
-            <a:r>
-              <a:rPr sz="1500" b="1" i="0">
-                <a:solidFill>
-                  <a:srgbClr val="FFFFFF"/>
-                </a:solidFill>
-                <a:latin typeface="Arial"/>
-              </a:rPr>
-              <a:t>TAILWINDS  ·  structural supports</a:t>
-            </a:r>
-          </a:p>
-        </p:txBody>
-      </p:sp>
-      <p:sp>
-        <p:nvSpPr>
-          <p:cNvPr id="11" name="TextBox 10"/>
-          <p:cNvSpPr txBox="1"/>
-          <p:nvPr/>
-        </p:nvSpPr>
-        <p:spPr>
-          <a:xfrm>
-            <a:off x="563880" y="1432560"/>
-            <a:ext cx="5273040" cy="3810000"/>
+            <a:off x="7955280" y="1615440"/>
+            <a:ext cx="3688080" cy="3505200"/>
           </a:xfrm>
           <a:prstGeom prst="rect">
             <a:avLst/>
@@ -9560,424 +10578,249 @@
                 <a:spcPts val="0"/>
               </a:spcBef>
               <a:spcAft>
-                <a:spcPts val="1000"/>
-              </a:spcAft>
-            </a:pPr>
-            <a:r>
-              <a:rPr sz="1450" b="0" i="0">
-                <a:solidFill>
-                  <a:srgbClr val="2E7D4F"/>
+                <a:spcPts val="1300"/>
+              </a:spcAft>
+            </a:pPr>
+            <a:r>
+              <a:rPr sz="1300" b="0" i="0">
+                <a:solidFill>
+                  <a:srgbClr val="5B7A9E"/>
                 </a:solidFill>
                 <a:latin typeface="Arial"/>
               </a:rPr>
               <a:t>•  </a:t>
             </a:r>
             <a:r>
-              <a:rPr sz="1450" b="1" i="0">
+              <a:rPr sz="1300" b="1" i="0">
+                <a:solidFill>
+                  <a:srgbClr val="1F3A5F"/>
+                </a:solidFill>
+                <a:latin typeface="Arial"/>
+              </a:rPr>
+              <a:t>Hennecke Group </a:t>
+            </a:r>
+            <a:r>
+              <a:rPr sz="1300" b="0" i="0">
                 <a:solidFill>
                   <a:srgbClr val="222222"/>
                 </a:solidFill>
                 <a:latin typeface="Arial"/>
               </a:rPr>
-              <a:t>Building energy-efficiency regulation</a:t>
-            </a:r>
-            <a:r>
-              <a:rPr sz="1450" b="0" i="0">
+              <a:t>(DE/IT) — world leader in PU process tech; includes the target Hennecke-OMS.</a:t>
+            </a:r>
+          </a:p>
+          <a:p>
+            <a:pPr algn="l">
+              <a:lnSpc>
+                <a:spcPct val="100000"/>
+              </a:lnSpc>
+              <a:spcBef>
+                <a:spcPts val="0"/>
+              </a:spcBef>
+              <a:spcAft>
+                <a:spcPts val="1300"/>
+              </a:spcAft>
+            </a:pPr>
+            <a:r>
+              <a:rPr sz="1300" b="0" i="0">
+                <a:solidFill>
+                  <a:srgbClr val="5B7A9E"/>
+                </a:solidFill>
+                <a:latin typeface="Arial"/>
+              </a:rPr>
+              <a:t>•  </a:t>
+            </a:r>
+            <a:r>
+              <a:rPr sz="1300" b="1" i="0">
                 <a:solidFill>
                   <a:srgbClr val="222222"/>
                 </a:solidFill>
                 <a:latin typeface="Arial"/>
               </a:rPr>
-              <a:t> (EU EPBD, Green Deal, renovations) → demand for insulating sandwich panels &amp; rigid foam.</a:t>
-            </a:r>
-          </a:p>
-          <a:p>
-            <a:pPr algn="l">
-              <a:lnSpc>
-                <a:spcPct val="100000"/>
-              </a:lnSpc>
-              <a:spcBef>
-                <a:spcPts val="0"/>
-              </a:spcBef>
-              <a:spcAft>
-                <a:spcPts val="1000"/>
-              </a:spcAft>
-            </a:pPr>
-            <a:r>
-              <a:rPr sz="1450" b="0" i="0">
-                <a:solidFill>
-                  <a:srgbClr val="2E7D4F"/>
+              <a:t>Cannon / Afros </a:t>
+            </a:r>
+            <a:r>
+              <a:rPr sz="1300" b="0" i="0">
+                <a:solidFill>
+                  <a:srgbClr val="222222"/>
+                </a:solidFill>
+                <a:latin typeface="Arial"/>
+              </a:rPr>
+              <a:t>(Peschiera Borromeo, IT) — PU metering, foam &amp; composites; main Italian rival.</a:t>
+            </a:r>
+          </a:p>
+          <a:p>
+            <a:pPr algn="l">
+              <a:lnSpc>
+                <a:spcPct val="100000"/>
+              </a:lnSpc>
+              <a:spcBef>
+                <a:spcPts val="0"/>
+              </a:spcBef>
+              <a:spcAft>
+                <a:spcPts val="1300"/>
+              </a:spcAft>
+            </a:pPr>
+            <a:r>
+              <a:rPr sz="1300" b="0" i="0">
+                <a:solidFill>
+                  <a:srgbClr val="5B7A9E"/>
                 </a:solidFill>
                 <a:latin typeface="Arial"/>
               </a:rPr>
               <a:t>•  </a:t>
             </a:r>
             <a:r>
-              <a:rPr sz="1450" b="1" i="0">
+              <a:rPr sz="1300" b="1" i="0">
                 <a:solidFill>
                   <a:srgbClr val="222222"/>
                 </a:solidFill>
                 <a:latin typeface="Arial"/>
               </a:rPr>
-              <a:t>Cold-chain &amp; refrigeration</a:t>
-            </a:r>
-            <a:r>
-              <a:rPr sz="1450" b="0" i="0">
+              <a:t>KraussMaffei </a:t>
+            </a:r>
+            <a:r>
+              <a:rPr sz="1300" b="0" i="0">
                 <a:solidFill>
                   <a:srgbClr val="222222"/>
                 </a:solidFill>
                 <a:latin typeface="Arial"/>
               </a:rPr>
-              <a:t> expansion (food, pharma) → PU-injection lines; Hennecke already equips much of global fridge output.</a:t>
-            </a:r>
-          </a:p>
-          <a:p>
-            <a:pPr algn="l">
-              <a:lnSpc>
-                <a:spcPct val="100000"/>
-              </a:lnSpc>
-              <a:spcBef>
-                <a:spcPts val="0"/>
-              </a:spcBef>
-              <a:spcAft>
-                <a:spcPts val="1000"/>
-              </a:spcAft>
-            </a:pPr>
-            <a:r>
-              <a:rPr sz="1450" b="0" i="0">
-                <a:solidFill>
-                  <a:srgbClr val="2E7D4F"/>
+              <a:t>(Munich, DE) — Reaction Process Machinery unit; diversified, ChemChina-owned.</a:t>
+            </a:r>
+          </a:p>
+          <a:p>
+            <a:pPr algn="l">
+              <a:lnSpc>
+                <a:spcPct val="100000"/>
+              </a:lnSpc>
+              <a:spcBef>
+                <a:spcPts val="0"/>
+              </a:spcBef>
+              <a:spcAft>
+                <a:spcPts val="1300"/>
+              </a:spcAft>
+            </a:pPr>
+            <a:r>
+              <a:rPr sz="1300" b="0" i="0">
+                <a:solidFill>
+                  <a:srgbClr val="5B7A9E"/>
                 </a:solidFill>
                 <a:latin typeface="Arial"/>
               </a:rPr>
               <a:t>•  </a:t>
             </a:r>
             <a:r>
-              <a:rPr sz="1450" b="1" i="0">
+              <a:rPr sz="1300" b="1" i="0">
                 <a:solidFill>
                   <a:srgbClr val="222222"/>
                 </a:solidFill>
                 <a:latin typeface="Arial"/>
               </a:rPr>
-              <a:t>Blowing-agent transition</a:t>
-            </a:r>
-            <a:r>
-              <a:rPr sz="1450" b="0" i="0">
+              <a:t>Frimo Group </a:t>
+            </a:r>
+            <a:r>
+              <a:rPr sz="1300" b="0" i="0">
                 <a:solidFill>
                   <a:srgbClr val="222222"/>
                 </a:solidFill>
                 <a:latin typeface="Arial"/>
               </a:rPr>
-              <a:t> (HFC → HFO/pentane) forces a customer machine-fleet renewal cycle.</a:t>
-            </a:r>
-          </a:p>
-          <a:p>
-            <a:pPr algn="l">
-              <a:lnSpc>
-                <a:spcPct val="100000"/>
-              </a:lnSpc>
-              <a:spcBef>
-                <a:spcPts val="0"/>
-              </a:spcBef>
-              <a:spcAft>
-                <a:spcPts val="1000"/>
-              </a:spcAft>
-            </a:pPr>
-            <a:r>
-              <a:rPr sz="1450" b="0" i="0">
-                <a:solidFill>
-                  <a:srgbClr val="2E7D4F"/>
+              <a:t>(Lotte, DE) — PU tooling &amp; systems, automotive-focused.</a:t>
+            </a:r>
+          </a:p>
+          <a:p>
+            <a:pPr algn="l">
+              <a:lnSpc>
+                <a:spcPct val="100000"/>
+              </a:lnSpc>
+              <a:spcBef>
+                <a:spcPts val="0"/>
+              </a:spcBef>
+              <a:spcAft>
+                <a:spcPts val="1300"/>
+              </a:spcAft>
+            </a:pPr>
+            <a:r>
+              <a:rPr sz="1300" b="0" i="0">
+                <a:solidFill>
+                  <a:srgbClr val="5B7A9E"/>
                 </a:solidFill>
                 <a:latin typeface="Arial"/>
               </a:rPr>
               <a:t>•  </a:t>
             </a:r>
             <a:r>
-              <a:rPr sz="1450" b="1" i="0">
+              <a:rPr sz="1300" b="1" i="0">
                 <a:solidFill>
                   <a:srgbClr val="222222"/>
                 </a:solidFill>
                 <a:latin typeface="Arial"/>
               </a:rPr>
-              <a:t>e-mobility &amp; lightweighting</a:t>
-            </a:r>
-            <a:r>
-              <a:rPr sz="1450" b="0" i="0">
+              <a:t>Kurtz Ersa </a:t>
+            </a:r>
+            <a:r>
+              <a:rPr sz="1300" b="0" i="0">
                 <a:solidFill>
                   <a:srgbClr val="222222"/>
                 </a:solidFill>
                 <a:latin typeface="Arial"/>
               </a:rPr>
-              <a:t> → automotive PU seating, NVH and composite parts.</a:t>
-            </a:r>
-          </a:p>
-          <a:p>
-            <a:pPr algn="l">
-              <a:lnSpc>
-                <a:spcPct val="100000"/>
-              </a:lnSpc>
-              <a:spcBef>
-                <a:spcPts val="0"/>
-              </a:spcBef>
-              <a:spcAft>
-                <a:spcPts val="1000"/>
-              </a:spcAft>
-            </a:pPr>
-            <a:r>
-              <a:rPr sz="1450" b="0" i="0">
-                <a:solidFill>
-                  <a:srgbClr val="2E7D4F"/>
+              <a:t>(Kreuzwertheim, DE) — EPS/PU foaming machinery.</a:t>
+            </a:r>
+          </a:p>
+          <a:p>
+            <a:pPr algn="l">
+              <a:lnSpc>
+                <a:spcPct val="100000"/>
+              </a:lnSpc>
+              <a:spcBef>
+                <a:spcPts val="0"/>
+              </a:spcBef>
+              <a:spcAft>
+                <a:spcPts val="1300"/>
+              </a:spcAft>
+            </a:pPr>
+            <a:r>
+              <a:rPr sz="1300" b="0" i="0">
+                <a:solidFill>
+                  <a:srgbClr val="5B7A9E"/>
                 </a:solidFill>
                 <a:latin typeface="Arial"/>
               </a:rPr>
               <a:t>•  </a:t>
             </a:r>
             <a:r>
-              <a:rPr sz="1450" b="1" i="0">
+              <a:rPr sz="1300" b="1" i="0">
                 <a:solidFill>
                   <a:srgbClr val="222222"/>
                 </a:solidFill>
                 <a:latin typeface="Arial"/>
               </a:rPr>
-              <a:t>Large global installed base</a:t>
-            </a:r>
-            <a:r>
-              <a:rPr sz="1450" b="0" i="0">
+              <a:t>Saip </a:t>
+            </a:r>
+            <a:r>
+              <a:rPr sz="1300" b="0" i="0">
                 <a:solidFill>
                   <a:srgbClr val="222222"/>
                 </a:solidFill>
                 <a:latin typeface="Arial"/>
               </a:rPr>
-              <a:t> → recurring, high-margin aftermarket (spares, retrofit, service).</a:t>
-            </a:r>
-          </a:p>
-          <a:p>
-            <a:pPr algn="l">
-              <a:lnSpc>
-                <a:spcPct val="100000"/>
-              </a:lnSpc>
-              <a:spcBef>
-                <a:spcPts val="0"/>
-              </a:spcBef>
-              <a:spcAft>
-                <a:spcPts val="1000"/>
-              </a:spcAft>
-            </a:pPr>
-            <a:r>
-              <a:rPr sz="1450" b="0" i="0">
-                <a:solidFill>
-                  <a:srgbClr val="2E7D4F"/>
-                </a:solidFill>
-                <a:latin typeface="Arial"/>
-              </a:rPr>
-              <a:t>•  </a:t>
-            </a:r>
-            <a:r>
-              <a:rPr sz="1450" b="1" i="0">
-                <a:solidFill>
-                  <a:srgbClr val="222222"/>
-                </a:solidFill>
-                <a:latin typeface="Arial"/>
-              </a:rPr>
-              <a:t>Brückner Group backing</a:t>
-            </a:r>
-            <a:r>
-              <a:rPr sz="1450" b="0" i="0">
-                <a:solidFill>
-                  <a:srgbClr val="222222"/>
-                </a:solidFill>
-                <a:latin typeface="Arial"/>
-              </a:rPr>
-              <a:t> → R&amp;D, cross-selling, global reach and financial strength.</a:t>
-            </a:r>
-          </a:p>
-          <a:p>
-            <a:pPr algn="l">
-              <a:lnSpc>
-                <a:spcPct val="100000"/>
-              </a:lnSpc>
-              <a:spcBef>
-                <a:spcPts val="0"/>
-              </a:spcBef>
-              <a:spcAft>
-                <a:spcPts val="1000"/>
-              </a:spcAft>
-            </a:pPr>
-            <a:r>
-              <a:rPr sz="1450" b="0" i="0">
-                <a:solidFill>
-                  <a:srgbClr val="2E7D4F"/>
-                </a:solidFill>
-                <a:latin typeface="Arial"/>
-              </a:rPr>
-              <a:t>•  </a:t>
-            </a:r>
-            <a:r>
-              <a:rPr sz="1450" b="1" i="0">
-                <a:solidFill>
-                  <a:srgbClr val="222222"/>
-                </a:solidFill>
-                <a:latin typeface="Arial"/>
-              </a:rPr>
-              <a:t>Historic OMS know-how</a:t>
-            </a:r>
-            <a:r>
-              <a:rPr sz="1450" b="0" i="0">
-                <a:solidFill>
-                  <a:srgbClr val="222222"/>
-                </a:solidFill>
-                <a:latin typeface="Arial"/>
-              </a:rPr>
-              <a:t> in continuous sandwich-panel &amp; flexible-foam lines (differentiation).</a:t>
-            </a:r>
-          </a:p>
-        </p:txBody>
-      </p:sp>
-      <p:sp>
-        <p:nvSpPr>
-          <p:cNvPr id="12" name="Rectangle 11"/>
-          <p:cNvSpPr/>
-          <p:nvPr/>
-        </p:nvSpPr>
-        <p:spPr>
-          <a:xfrm>
-            <a:off x="6172200" y="952500"/>
-            <a:ext cx="5638800" cy="4381500"/>
-          </a:xfrm>
-          <a:prstGeom prst="rect">
-            <a:avLst/>
-          </a:prstGeom>
-          <a:solidFill>
-            <a:srgbClr val="FFFFFF"/>
-          </a:solidFill>
-          <a:ln w="12700">
-            <a:solidFill>
-              <a:srgbClr val="DFE4EA"/>
-            </a:solidFill>
-          </a:ln>
-          <a:effectLst/>
-        </p:spPr>
-        <p:style>
-          <a:lnRef idx="1">
-            <a:schemeClr val="accent1"/>
-          </a:lnRef>
-          <a:fillRef idx="3">
-            <a:schemeClr val="accent1"/>
-          </a:fillRef>
-          <a:effectRef idx="2">
-            <a:schemeClr val="accent1"/>
-          </a:effectRef>
-          <a:fontRef idx="minor">
-            <a:schemeClr val="lt1"/>
-          </a:fontRef>
-        </p:style>
-        <p:txBody>
-          <a:bodyPr rtlCol="0" anchor="ctr"/>
-          <a:lstStyle/>
-          <a:p>
-            <a:pPr algn="ctr"/>
-          </a:p>
-        </p:txBody>
-      </p:sp>
-      <p:sp>
-        <p:nvSpPr>
-          <p:cNvPr id="13" name="Rectangle 12"/>
-          <p:cNvSpPr/>
-          <p:nvPr/>
-        </p:nvSpPr>
-        <p:spPr>
-          <a:xfrm>
-            <a:off x="6172200" y="952500"/>
-            <a:ext cx="5638800" cy="350520"/>
-          </a:xfrm>
-          <a:prstGeom prst="rect">
-            <a:avLst/>
-          </a:prstGeom>
-          <a:solidFill>
-            <a:srgbClr val="C8102E"/>
-          </a:solidFill>
-          <a:ln>
-            <a:noFill/>
-          </a:ln>
-          <a:effectLst/>
-        </p:spPr>
-        <p:style>
-          <a:lnRef idx="1">
-            <a:schemeClr val="accent1"/>
-          </a:lnRef>
-          <a:fillRef idx="3">
-            <a:schemeClr val="accent1"/>
-          </a:fillRef>
-          <a:effectRef idx="2">
-            <a:schemeClr val="accent1"/>
-          </a:effectRef>
-          <a:fontRef idx="minor">
-            <a:schemeClr val="lt1"/>
-          </a:fontRef>
-        </p:style>
-        <p:txBody>
-          <a:bodyPr rtlCol="0" anchor="ctr"/>
-          <a:lstStyle/>
-          <a:p>
-            <a:pPr algn="ctr"/>
-          </a:p>
-        </p:txBody>
-      </p:sp>
-      <p:sp>
-        <p:nvSpPr>
-          <p:cNvPr id="14" name="TextBox 13"/>
+              <a:t>(Offanengo, IT) — PU plants / refrigeration insulation.</a:t>
+            </a:r>
+          </a:p>
+        </p:txBody>
+      </p:sp>
+      <p:sp>
+        <p:nvSpPr>
+          <p:cNvPr id="33" name="TextBox 32"/>
           <p:cNvSpPr txBox="1"/>
           <p:nvPr/>
         </p:nvSpPr>
         <p:spPr>
           <a:xfrm>
-            <a:off x="6339840" y="952500"/>
-            <a:ext cx="5410200" cy="350520"/>
-          </a:xfrm>
-          <a:prstGeom prst="rect">
-            <a:avLst/>
-          </a:prstGeom>
-          <a:noFill/>
-        </p:spPr>
-        <p:txBody>
-          <a:bodyPr wrap="square" anchor="ctr" lIns="25400" rIns="25400" tIns="12700" bIns="12700">
-            <a:spAutoFit/>
-          </a:bodyPr>
-          <a:lstStyle/>
-          <a:p>
-            <a:pPr algn="l">
-              <a:lnSpc>
-                <a:spcPct val="100000"/>
-              </a:lnSpc>
-              <a:spcBef>
-                <a:spcPts val="0"/>
-              </a:spcBef>
-              <a:spcAft>
-                <a:spcPts val="400"/>
-              </a:spcAft>
-            </a:pPr>
-            <a:r>
-              <a:rPr sz="1500" b="1" i="0">
-                <a:solidFill>
-                  <a:srgbClr val="FFFFFF"/>
-                </a:solidFill>
-                <a:latin typeface="Arial"/>
-              </a:rPr>
-              <a:t>HEADWINDS  ·  structural pressures</a:t>
-            </a:r>
-          </a:p>
-        </p:txBody>
-      </p:sp>
-      <p:sp>
-        <p:nvSpPr>
-          <p:cNvPr id="15" name="TextBox 14"/>
-          <p:cNvSpPr txBox="1"/>
-          <p:nvPr/>
-        </p:nvSpPr>
-        <p:spPr>
-          <a:xfrm>
-            <a:off x="6355080" y="1432560"/>
-            <a:ext cx="5273040" cy="3810000"/>
+            <a:off x="381000" y="5334000"/>
+            <a:ext cx="7620000" cy="182880"/>
           </a:xfrm>
           <a:prstGeom prst="rect">
             <a:avLst/>
@@ -9998,418 +10841,24 @@
                 <a:spcPts val="0"/>
               </a:spcBef>
               <a:spcAft>
-                <a:spcPts val="1000"/>
-              </a:spcAft>
-            </a:pPr>
-            <a:r>
-              <a:rPr sz="1450" b="0" i="0">
-                <a:solidFill>
-                  <a:srgbClr val="C8102E"/>
-                </a:solidFill>
-                <a:latin typeface="Arial"/>
-              </a:rPr>
-              <a:t>•  </a:t>
-            </a:r>
-            <a:r>
-              <a:rPr sz="1450" b="1" i="0">
-                <a:solidFill>
-                  <a:srgbClr val="222222"/>
-                </a:solidFill>
-                <a:latin typeface="Arial"/>
-              </a:rPr>
-              <a:t>Capex-driven cyclicality</a:t>
-            </a:r>
-            <a:r>
-              <a:rPr sz="1450" b="0" i="0">
-                <a:solidFill>
-                  <a:srgbClr val="222222"/>
-                </a:solidFill>
-                <a:latin typeface="Arial"/>
-              </a:rPr>
-              <a:t> → lumpy, volatile order intake tied to customers' investment cycle.</a:t>
-            </a:r>
-          </a:p>
-          <a:p>
-            <a:pPr algn="l">
-              <a:lnSpc>
-                <a:spcPct val="100000"/>
-              </a:lnSpc>
-              <a:spcBef>
-                <a:spcPts val="0"/>
-              </a:spcBef>
-              <a:spcAft>
-                <a:spcPts val="1000"/>
-              </a:spcAft>
-            </a:pPr>
-            <a:r>
-              <a:rPr sz="1450" b="0" i="0">
-                <a:solidFill>
-                  <a:srgbClr val="C8102E"/>
-                </a:solidFill>
-                <a:latin typeface="Arial"/>
-              </a:rPr>
-              <a:t>•  </a:t>
-            </a:r>
-            <a:r>
-              <a:rPr sz="1450" b="1" i="0">
-                <a:solidFill>
-                  <a:srgbClr val="222222"/>
-                </a:solidFill>
-                <a:latin typeface="Arial"/>
-              </a:rPr>
-              <a:t>Long project cycles</a:t>
-            </a:r>
-            <a:r>
-              <a:rPr sz="1450" b="0" i="0">
-                <a:solidFill>
-                  <a:srgbClr val="222222"/>
-                </a:solidFill>
-                <a:latin typeface="Arial"/>
-              </a:rPr>
-              <a:t> → work-in-progress swings distort reported earnings (the 2024 margin effect).</a:t>
-            </a:r>
-          </a:p>
-          <a:p>
-            <a:pPr algn="l">
-              <a:lnSpc>
-                <a:spcPct val="100000"/>
-              </a:lnSpc>
-              <a:spcBef>
-                <a:spcPts val="0"/>
-              </a:spcBef>
-              <a:spcAft>
-                <a:spcPts val="1000"/>
-              </a:spcAft>
-            </a:pPr>
-            <a:r>
-              <a:rPr sz="1450" b="0" i="0">
-                <a:solidFill>
-                  <a:srgbClr val="C8102E"/>
-                </a:solidFill>
-                <a:latin typeface="Arial"/>
-              </a:rPr>
-              <a:t>•  </a:t>
-            </a:r>
-            <a:r>
-              <a:rPr sz="1450" b="1" i="0">
-                <a:solidFill>
-                  <a:srgbClr val="222222"/>
-                </a:solidFill>
-                <a:latin typeface="Arial"/>
-              </a:rPr>
-              <a:t>Thin, volatile margins</a:t>
-            </a:r>
-            <a:r>
-              <a:rPr sz="1450" b="0" i="0">
-                <a:solidFill>
-                  <a:srgbClr val="222222"/>
-                </a:solidFill>
-                <a:latin typeface="Arial"/>
-              </a:rPr>
-              <a:t> &amp; execution risk on complex turnkey orders.</a:t>
-            </a:r>
-          </a:p>
-          <a:p>
-            <a:pPr algn="l">
-              <a:lnSpc>
-                <a:spcPct val="100000"/>
-              </a:lnSpc>
-              <a:spcBef>
-                <a:spcPts val="0"/>
-              </a:spcBef>
-              <a:spcAft>
-                <a:spcPts val="1000"/>
-              </a:spcAft>
-            </a:pPr>
-            <a:r>
-              <a:rPr sz="1450" b="0" i="0">
-                <a:solidFill>
-                  <a:srgbClr val="C8102E"/>
-                </a:solidFill>
-                <a:latin typeface="Arial"/>
-              </a:rPr>
-              <a:t>•  </a:t>
-            </a:r>
-            <a:r>
-              <a:rPr sz="1450" b="1" i="0">
-                <a:solidFill>
-                  <a:srgbClr val="222222"/>
-                </a:solidFill>
-                <a:latin typeface="Arial"/>
-              </a:rPr>
-              <a:t>Captive nature</a:t>
-            </a:r>
-            <a:r>
-              <a:rPr sz="1450" b="0" i="0">
-                <a:solidFill>
-                  <a:srgbClr val="222222"/>
-                </a:solidFill>
-                <a:latin typeface="Arial"/>
-              </a:rPr>
-              <a:t> → limited autonomy, intercompany dependence, carve-out complexity.</a:t>
-            </a:r>
-          </a:p>
-          <a:p>
-            <a:pPr algn="l">
-              <a:lnSpc>
-                <a:spcPct val="100000"/>
-              </a:lnSpc>
-              <a:spcBef>
-                <a:spcPts val="0"/>
-              </a:spcBef>
-              <a:spcAft>
-                <a:spcPts val="1000"/>
-              </a:spcAft>
-            </a:pPr>
-            <a:r>
-              <a:rPr sz="1450" b="0" i="0">
-                <a:solidFill>
-                  <a:srgbClr val="C8102E"/>
-                </a:solidFill>
-                <a:latin typeface="Arial"/>
-              </a:rPr>
-              <a:t>•  </a:t>
-            </a:r>
-            <a:r>
-              <a:rPr sz="1450" b="1" i="0">
-                <a:solidFill>
-                  <a:srgbClr val="222222"/>
-                </a:solidFill>
-                <a:latin typeface="Arial"/>
-              </a:rPr>
-              <a:t>Input-cost volatility</a:t>
-            </a:r>
-            <a:r>
-              <a:rPr sz="1450" b="0" i="0">
-                <a:solidFill>
-                  <a:srgbClr val="222222"/>
-                </a:solidFill>
-                <a:latin typeface="Arial"/>
-              </a:rPr>
-              <a:t> (steel, energy, components) and supply-chain tensions.</a:t>
-            </a:r>
-          </a:p>
-          <a:p>
-            <a:pPr algn="l">
-              <a:lnSpc>
-                <a:spcPct val="100000"/>
-              </a:lnSpc>
-              <a:spcBef>
-                <a:spcPts val="0"/>
-              </a:spcBef>
-              <a:spcAft>
-                <a:spcPts val="1000"/>
-              </a:spcAft>
-            </a:pPr>
-            <a:r>
-              <a:rPr sz="1450" b="0" i="0">
-                <a:solidFill>
-                  <a:srgbClr val="C8102E"/>
-                </a:solidFill>
-                <a:latin typeface="Arial"/>
-              </a:rPr>
-              <a:t>•  </a:t>
-            </a:r>
-            <a:r>
-              <a:rPr sz="1450" b="1" i="0">
-                <a:solidFill>
-                  <a:srgbClr val="222222"/>
-                </a:solidFill>
-                <a:latin typeface="Arial"/>
-              </a:rPr>
-              <a:t>FX &amp; country risk</a:t>
-            </a:r>
-            <a:r>
-              <a:rPr sz="1450" b="0" i="0">
-                <a:solidFill>
-                  <a:srgbClr val="222222"/>
-                </a:solidFill>
-                <a:latin typeface="Arial"/>
-              </a:rPr>
-              <a:t> on export projects; qualified competition (Cannon/Afros, KraussMaffei) → price pressure.</a:t>
-            </a:r>
-          </a:p>
-          <a:p>
-            <a:pPr algn="l">
-              <a:lnSpc>
-                <a:spcPct val="100000"/>
-              </a:lnSpc>
-              <a:spcBef>
-                <a:spcPts val="0"/>
-              </a:spcBef>
-              <a:spcAft>
-                <a:spcPts val="1000"/>
-              </a:spcAft>
-            </a:pPr>
-            <a:r>
-              <a:rPr sz="1450" b="0" i="0">
-                <a:solidFill>
-                  <a:srgbClr val="C8102E"/>
-                </a:solidFill>
-                <a:latin typeface="Arial"/>
-              </a:rPr>
-              <a:t>•  </a:t>
-            </a:r>
-            <a:r>
-              <a:rPr sz="1450" b="1" i="0">
-                <a:solidFill>
-                  <a:srgbClr val="222222"/>
-                </a:solidFill>
-                <a:latin typeface="Arial"/>
-              </a:rPr>
-              <a:t>Order concentration</a:t>
-            </a:r>
-            <a:r>
-              <a:rPr sz="1450" b="0" i="0">
-                <a:solidFill>
-                  <a:srgbClr val="222222"/>
-                </a:solidFill>
-                <a:latin typeface="Arial"/>
-              </a:rPr>
-              <a:t> on single large projects; warranty / performance-bond exposure.</a:t>
-            </a:r>
-          </a:p>
-        </p:txBody>
-      </p:sp>
-      <p:sp>
-        <p:nvSpPr>
-          <p:cNvPr id="16" name="Rectangle 15"/>
-          <p:cNvSpPr/>
-          <p:nvPr/>
-        </p:nvSpPr>
-        <p:spPr>
-          <a:xfrm>
-            <a:off x="381000" y="5471160"/>
-            <a:ext cx="11430000" cy="731520"/>
-          </a:xfrm>
-          <a:prstGeom prst="rect">
-            <a:avLst/>
-          </a:prstGeom>
-          <a:solidFill>
-            <a:srgbClr val="EEF2F7"/>
-          </a:solidFill>
-          <a:ln w="12700">
-            <a:solidFill>
-              <a:srgbClr val="CDD8E6"/>
-            </a:solidFill>
-          </a:ln>
-          <a:effectLst/>
-        </p:spPr>
-        <p:style>
-          <a:lnRef idx="1">
-            <a:schemeClr val="accent1"/>
-          </a:lnRef>
-          <a:fillRef idx="3">
-            <a:schemeClr val="accent1"/>
-          </a:fillRef>
-          <a:effectRef idx="2">
-            <a:schemeClr val="accent1"/>
-          </a:effectRef>
-          <a:fontRef idx="minor">
-            <a:schemeClr val="lt1"/>
-          </a:fontRef>
-        </p:style>
-        <p:txBody>
-          <a:bodyPr rtlCol="0" anchor="ctr"/>
-          <a:lstStyle/>
-          <a:p>
-            <a:pPr algn="ctr"/>
-          </a:p>
-        </p:txBody>
-      </p:sp>
-      <p:sp>
-        <p:nvSpPr>
-          <p:cNvPr id="17" name="TextBox 16"/>
-          <p:cNvSpPr txBox="1"/>
-          <p:nvPr/>
-        </p:nvSpPr>
-        <p:spPr>
-          <a:xfrm>
-            <a:off x="563880" y="5547360"/>
-            <a:ext cx="11064240" cy="609600"/>
-          </a:xfrm>
-          <a:prstGeom prst="rect">
-            <a:avLst/>
-          </a:prstGeom>
-          <a:noFill/>
-        </p:spPr>
-        <p:txBody>
-          <a:bodyPr wrap="square" anchor="ctr" lIns="25400" rIns="25400" tIns="12700" bIns="12700">
-            <a:spAutoFit/>
-          </a:bodyPr>
-          <a:lstStyle/>
-          <a:p>
-            <a:pPr algn="l">
-              <a:lnSpc>
-                <a:spcPct val="100000"/>
-              </a:lnSpc>
-              <a:spcBef>
-                <a:spcPts val="0"/>
-              </a:spcBef>
-              <a:spcAft>
                 <a:spcPts val="400"/>
               </a:spcAft>
             </a:pPr>
             <a:r>
-              <a:rPr sz="1400" b="1" i="0">
+              <a:rPr sz="1250" b="1" i="0">
                 <a:solidFill>
                   <a:srgbClr val="1F3A5F"/>
                 </a:solidFill>
                 <a:latin typeface="Arial"/>
               </a:rPr>
-              <a:t>Net read:  </a:t>
-            </a:r>
-            <a:r>
-              <a:rPr sz="1400" b="0" i="0">
-                <a:solidFill>
-                  <a:srgbClr val="333333"/>
-                </a:solidFill>
-                <a:latin typeface="Arial"/>
-              </a:rPr>
-              <a:t>structurally-supported demand on a cyclical, execution-heavy model. The thesis hinges on </a:t>
-            </a:r>
-            <a:r>
-              <a:rPr sz="1400" b="1" i="0">
-                <a:solidFill>
-                  <a:srgbClr val="333333"/>
-                </a:solidFill>
-                <a:latin typeface="Arial"/>
-              </a:rPr>
-              <a:t>smoothing the cycle</a:t>
-            </a:r>
-            <a:r>
-              <a:rPr sz="1400" b="0" i="0">
-                <a:solidFill>
-                  <a:srgbClr val="333333"/>
-                </a:solidFill>
-                <a:latin typeface="Arial"/>
-              </a:rPr>
-              <a:t> (backlog &amp; pricing discipline) and </a:t>
-            </a:r>
-            <a:r>
-              <a:rPr sz="1400" b="1" i="0">
-                <a:solidFill>
-                  <a:srgbClr val="333333"/>
-                </a:solidFill>
-                <a:latin typeface="Arial"/>
-              </a:rPr>
-              <a:t>scaling the recurring aftermarket</a:t>
-            </a:r>
-            <a:r>
-              <a:rPr sz="1400" b="0" i="0">
-                <a:solidFill>
-                  <a:srgbClr val="333333"/>
-                </a:solidFill>
-                <a:latin typeface="Arial"/>
-              </a:rPr>
-              <a:t> to lift and stabilise margins.</a:t>
-            </a:r>
-          </a:p>
-        </p:txBody>
-      </p:sp>
-      <p:sp>
-        <p:nvSpPr>
-          <p:cNvPr id="18" name="TextBox 17"/>
+              <a:t>Net read: the target sits among specialised PU pure-plays with global, group-backed reach — differentiated in sandwich-panel &amp; flexible-foam lines.</a:t>
+            </a:r>
+          </a:p>
+        </p:txBody>
+      </p:sp>
+      <p:sp>
+        <p:nvSpPr>
+          <p:cNvPr id="34" name="TextBox 33"/>
           <p:cNvSpPr txBox="1"/>
           <p:nvPr/>
         </p:nvSpPr>
@@ -10447,7 +10896,7 @@
                 </a:solidFill>
                 <a:latin typeface="Arial"/>
               </a:rPr>
-              <a:t>Drivers synthesised from the dossier (sections 3, 5, 9, 11) and public industry sources.</a:t>
+              <a:t>Qualitative positioning — illustrative, not to scale; consolidated competitor revenues not disclosed in the analysed documents.</a:t>
             </a:r>
           </a:p>
         </p:txBody>
@@ -10554,7 +11003,7 @@
                 </a:solidFill>
                 <a:latin typeface="Arial"/>
               </a:rPr>
-              <a:t>Investment thesis — value, risks &amp; recommendation</a:t>
+              <a:t>Tailwinds vs headwinds — what drives this business</a:t>
             </a:r>
           </a:p>
         </p:txBody>
@@ -10599,7 +11048,7 @@
                 </a:solidFill>
                 <a:latin typeface="Arial"/>
               </a:rPr>
-              <a:t>Margin-recovery &amp; aftermarket story on a structurally-supported PU platform</a:t>
+              <a:t>Two silos: structural supports vs structural pressures, specific to a PU capital-goods model</a:t>
             </a:r>
           </a:p>
         </p:txBody>
@@ -10733,7 +11182,7 @@
                 </a:solidFill>
                 <a:latin typeface="Arial"/>
               </a:rPr>
-              <a:t>5 / 5</a:t>
+              <a:t>5 / 6</a:t>
             </a:r>
           </a:p>
         </p:txBody>
@@ -10747,7 +11196,7 @@
         <p:spPr>
           <a:xfrm>
             <a:off x="381000" y="952500"/>
-            <a:ext cx="3657600" cy="4267200"/>
+            <a:ext cx="5638800" cy="4381500"/>
           </a:xfrm>
           <a:prstGeom prst="rect">
             <a:avLst/>
@@ -10793,6 +11242,1349 @@
         <p:spPr>
           <a:xfrm>
             <a:off x="381000" y="952500"/>
+            <a:ext cx="5638800" cy="350520"/>
+          </a:xfrm>
+          <a:prstGeom prst="rect">
+            <a:avLst/>
+          </a:prstGeom>
+          <a:solidFill>
+            <a:srgbClr val="2E7D4F"/>
+          </a:solidFill>
+          <a:ln>
+            <a:noFill/>
+          </a:ln>
+          <a:effectLst/>
+        </p:spPr>
+        <p:style>
+          <a:lnRef idx="1">
+            <a:schemeClr val="accent1"/>
+          </a:lnRef>
+          <a:fillRef idx="3">
+            <a:schemeClr val="accent1"/>
+          </a:fillRef>
+          <a:effectRef idx="2">
+            <a:schemeClr val="accent1"/>
+          </a:effectRef>
+          <a:fontRef idx="minor">
+            <a:schemeClr val="lt1"/>
+          </a:fontRef>
+        </p:style>
+        <p:txBody>
+          <a:bodyPr rtlCol="0" anchor="ctr"/>
+          <a:lstStyle/>
+          <a:p>
+            <a:pPr algn="ctr"/>
+          </a:p>
+        </p:txBody>
+      </p:sp>
+      <p:sp>
+        <p:nvSpPr>
+          <p:cNvPr id="10" name="TextBox 9"/>
+          <p:cNvSpPr txBox="1"/>
+          <p:nvPr/>
+        </p:nvSpPr>
+        <p:spPr>
+          <a:xfrm>
+            <a:off x="548640" y="952500"/>
+            <a:ext cx="5410200" cy="350520"/>
+          </a:xfrm>
+          <a:prstGeom prst="rect">
+            <a:avLst/>
+          </a:prstGeom>
+          <a:noFill/>
+        </p:spPr>
+        <p:txBody>
+          <a:bodyPr wrap="square" anchor="ctr" lIns="25400" rIns="25400" tIns="12700" bIns="12700">
+            <a:spAutoFit/>
+          </a:bodyPr>
+          <a:lstStyle/>
+          <a:p>
+            <a:pPr algn="l">
+              <a:lnSpc>
+                <a:spcPct val="100000"/>
+              </a:lnSpc>
+              <a:spcBef>
+                <a:spcPts val="0"/>
+              </a:spcBef>
+              <a:spcAft>
+                <a:spcPts val="400"/>
+              </a:spcAft>
+            </a:pPr>
+            <a:r>
+              <a:rPr sz="1500" b="1" i="0">
+                <a:solidFill>
+                  <a:srgbClr val="FFFFFF"/>
+                </a:solidFill>
+                <a:latin typeface="Arial"/>
+              </a:rPr>
+              <a:t>TAILWINDS  ·  structural supports</a:t>
+            </a:r>
+          </a:p>
+        </p:txBody>
+      </p:sp>
+      <p:sp>
+        <p:nvSpPr>
+          <p:cNvPr id="11" name="TextBox 10"/>
+          <p:cNvSpPr txBox="1"/>
+          <p:nvPr/>
+        </p:nvSpPr>
+        <p:spPr>
+          <a:xfrm>
+            <a:off x="563880" y="1432560"/>
+            <a:ext cx="5273040" cy="3810000"/>
+          </a:xfrm>
+          <a:prstGeom prst="rect">
+            <a:avLst/>
+          </a:prstGeom>
+          <a:noFill/>
+        </p:spPr>
+        <p:txBody>
+          <a:bodyPr wrap="square" anchor="t" lIns="25400" rIns="25400" tIns="12700" bIns="12700">
+            <a:spAutoFit/>
+          </a:bodyPr>
+          <a:lstStyle/>
+          <a:p>
+            <a:pPr algn="l">
+              <a:lnSpc>
+                <a:spcPct val="100000"/>
+              </a:lnSpc>
+              <a:spcBef>
+                <a:spcPts val="0"/>
+              </a:spcBef>
+              <a:spcAft>
+                <a:spcPts val="1000"/>
+              </a:spcAft>
+            </a:pPr>
+            <a:r>
+              <a:rPr sz="1450" b="0" i="0">
+                <a:solidFill>
+                  <a:srgbClr val="2E7D4F"/>
+                </a:solidFill>
+                <a:latin typeface="Arial"/>
+              </a:rPr>
+              <a:t>•  </a:t>
+            </a:r>
+            <a:r>
+              <a:rPr sz="1450" b="1" i="0">
+                <a:solidFill>
+                  <a:srgbClr val="222222"/>
+                </a:solidFill>
+                <a:latin typeface="Arial"/>
+              </a:rPr>
+              <a:t>Building energy-efficiency regulation</a:t>
+            </a:r>
+            <a:r>
+              <a:rPr sz="1450" b="0" i="0">
+                <a:solidFill>
+                  <a:srgbClr val="222222"/>
+                </a:solidFill>
+                <a:latin typeface="Arial"/>
+              </a:rPr>
+              <a:t> (EU EPBD, Green Deal, renovations) → demand for insulating sandwich panels &amp; rigid foam.</a:t>
+            </a:r>
+          </a:p>
+          <a:p>
+            <a:pPr algn="l">
+              <a:lnSpc>
+                <a:spcPct val="100000"/>
+              </a:lnSpc>
+              <a:spcBef>
+                <a:spcPts val="0"/>
+              </a:spcBef>
+              <a:spcAft>
+                <a:spcPts val="1000"/>
+              </a:spcAft>
+            </a:pPr>
+            <a:r>
+              <a:rPr sz="1450" b="0" i="0">
+                <a:solidFill>
+                  <a:srgbClr val="2E7D4F"/>
+                </a:solidFill>
+                <a:latin typeface="Arial"/>
+              </a:rPr>
+              <a:t>•  </a:t>
+            </a:r>
+            <a:r>
+              <a:rPr sz="1450" b="1" i="0">
+                <a:solidFill>
+                  <a:srgbClr val="222222"/>
+                </a:solidFill>
+                <a:latin typeface="Arial"/>
+              </a:rPr>
+              <a:t>Cold-chain &amp; refrigeration</a:t>
+            </a:r>
+            <a:r>
+              <a:rPr sz="1450" b="0" i="0">
+                <a:solidFill>
+                  <a:srgbClr val="222222"/>
+                </a:solidFill>
+                <a:latin typeface="Arial"/>
+              </a:rPr>
+              <a:t> expansion (food, pharma) → PU-injection lines; Hennecke already equips much of global fridge output.</a:t>
+            </a:r>
+          </a:p>
+          <a:p>
+            <a:pPr algn="l">
+              <a:lnSpc>
+                <a:spcPct val="100000"/>
+              </a:lnSpc>
+              <a:spcBef>
+                <a:spcPts val="0"/>
+              </a:spcBef>
+              <a:spcAft>
+                <a:spcPts val="1000"/>
+              </a:spcAft>
+            </a:pPr>
+            <a:r>
+              <a:rPr sz="1450" b="0" i="0">
+                <a:solidFill>
+                  <a:srgbClr val="2E7D4F"/>
+                </a:solidFill>
+                <a:latin typeface="Arial"/>
+              </a:rPr>
+              <a:t>•  </a:t>
+            </a:r>
+            <a:r>
+              <a:rPr sz="1450" b="1" i="0">
+                <a:solidFill>
+                  <a:srgbClr val="222222"/>
+                </a:solidFill>
+                <a:latin typeface="Arial"/>
+              </a:rPr>
+              <a:t>Blowing-agent transition</a:t>
+            </a:r>
+            <a:r>
+              <a:rPr sz="1450" b="0" i="0">
+                <a:solidFill>
+                  <a:srgbClr val="222222"/>
+                </a:solidFill>
+                <a:latin typeface="Arial"/>
+              </a:rPr>
+              <a:t> (HFC → HFO/pentane) forces a customer machine-fleet renewal cycle.</a:t>
+            </a:r>
+          </a:p>
+          <a:p>
+            <a:pPr algn="l">
+              <a:lnSpc>
+                <a:spcPct val="100000"/>
+              </a:lnSpc>
+              <a:spcBef>
+                <a:spcPts val="0"/>
+              </a:spcBef>
+              <a:spcAft>
+                <a:spcPts val="1000"/>
+              </a:spcAft>
+            </a:pPr>
+            <a:r>
+              <a:rPr sz="1450" b="0" i="0">
+                <a:solidFill>
+                  <a:srgbClr val="2E7D4F"/>
+                </a:solidFill>
+                <a:latin typeface="Arial"/>
+              </a:rPr>
+              <a:t>•  </a:t>
+            </a:r>
+            <a:r>
+              <a:rPr sz="1450" b="1" i="0">
+                <a:solidFill>
+                  <a:srgbClr val="222222"/>
+                </a:solidFill>
+                <a:latin typeface="Arial"/>
+              </a:rPr>
+              <a:t>e-mobility &amp; lightweighting</a:t>
+            </a:r>
+            <a:r>
+              <a:rPr sz="1450" b="0" i="0">
+                <a:solidFill>
+                  <a:srgbClr val="222222"/>
+                </a:solidFill>
+                <a:latin typeface="Arial"/>
+              </a:rPr>
+              <a:t> → automotive PU seating, NVH and composite parts.</a:t>
+            </a:r>
+          </a:p>
+          <a:p>
+            <a:pPr algn="l">
+              <a:lnSpc>
+                <a:spcPct val="100000"/>
+              </a:lnSpc>
+              <a:spcBef>
+                <a:spcPts val="0"/>
+              </a:spcBef>
+              <a:spcAft>
+                <a:spcPts val="1000"/>
+              </a:spcAft>
+            </a:pPr>
+            <a:r>
+              <a:rPr sz="1450" b="0" i="0">
+                <a:solidFill>
+                  <a:srgbClr val="2E7D4F"/>
+                </a:solidFill>
+                <a:latin typeface="Arial"/>
+              </a:rPr>
+              <a:t>•  </a:t>
+            </a:r>
+            <a:r>
+              <a:rPr sz="1450" b="1" i="0">
+                <a:solidFill>
+                  <a:srgbClr val="222222"/>
+                </a:solidFill>
+                <a:latin typeface="Arial"/>
+              </a:rPr>
+              <a:t>Large global installed base</a:t>
+            </a:r>
+            <a:r>
+              <a:rPr sz="1450" b="0" i="0">
+                <a:solidFill>
+                  <a:srgbClr val="222222"/>
+                </a:solidFill>
+                <a:latin typeface="Arial"/>
+              </a:rPr>
+              <a:t> → recurring, high-margin aftermarket (spares, retrofit, service).</a:t>
+            </a:r>
+          </a:p>
+          <a:p>
+            <a:pPr algn="l">
+              <a:lnSpc>
+                <a:spcPct val="100000"/>
+              </a:lnSpc>
+              <a:spcBef>
+                <a:spcPts val="0"/>
+              </a:spcBef>
+              <a:spcAft>
+                <a:spcPts val="1000"/>
+              </a:spcAft>
+            </a:pPr>
+            <a:r>
+              <a:rPr sz="1450" b="0" i="0">
+                <a:solidFill>
+                  <a:srgbClr val="2E7D4F"/>
+                </a:solidFill>
+                <a:latin typeface="Arial"/>
+              </a:rPr>
+              <a:t>•  </a:t>
+            </a:r>
+            <a:r>
+              <a:rPr sz="1450" b="1" i="0">
+                <a:solidFill>
+                  <a:srgbClr val="222222"/>
+                </a:solidFill>
+                <a:latin typeface="Arial"/>
+              </a:rPr>
+              <a:t>Brückner Group backing</a:t>
+            </a:r>
+            <a:r>
+              <a:rPr sz="1450" b="0" i="0">
+                <a:solidFill>
+                  <a:srgbClr val="222222"/>
+                </a:solidFill>
+                <a:latin typeface="Arial"/>
+              </a:rPr>
+              <a:t> → R&amp;D, cross-selling, global reach and financial strength.</a:t>
+            </a:r>
+          </a:p>
+          <a:p>
+            <a:pPr algn="l">
+              <a:lnSpc>
+                <a:spcPct val="100000"/>
+              </a:lnSpc>
+              <a:spcBef>
+                <a:spcPts val="0"/>
+              </a:spcBef>
+              <a:spcAft>
+                <a:spcPts val="1000"/>
+              </a:spcAft>
+            </a:pPr>
+            <a:r>
+              <a:rPr sz="1450" b="0" i="0">
+                <a:solidFill>
+                  <a:srgbClr val="2E7D4F"/>
+                </a:solidFill>
+                <a:latin typeface="Arial"/>
+              </a:rPr>
+              <a:t>•  </a:t>
+            </a:r>
+            <a:r>
+              <a:rPr sz="1450" b="1" i="0">
+                <a:solidFill>
+                  <a:srgbClr val="222222"/>
+                </a:solidFill>
+                <a:latin typeface="Arial"/>
+              </a:rPr>
+              <a:t>Historic OMS know-how</a:t>
+            </a:r>
+            <a:r>
+              <a:rPr sz="1450" b="0" i="0">
+                <a:solidFill>
+                  <a:srgbClr val="222222"/>
+                </a:solidFill>
+                <a:latin typeface="Arial"/>
+              </a:rPr>
+              <a:t> in continuous sandwich-panel &amp; flexible-foam lines (differentiation).</a:t>
+            </a:r>
+          </a:p>
+        </p:txBody>
+      </p:sp>
+      <p:sp>
+        <p:nvSpPr>
+          <p:cNvPr id="12" name="Rectangle 11"/>
+          <p:cNvSpPr/>
+          <p:nvPr/>
+        </p:nvSpPr>
+        <p:spPr>
+          <a:xfrm>
+            <a:off x="6172200" y="952500"/>
+            <a:ext cx="5638800" cy="4381500"/>
+          </a:xfrm>
+          <a:prstGeom prst="rect">
+            <a:avLst/>
+          </a:prstGeom>
+          <a:solidFill>
+            <a:srgbClr val="FFFFFF"/>
+          </a:solidFill>
+          <a:ln w="12700">
+            <a:solidFill>
+              <a:srgbClr val="DFE4EA"/>
+            </a:solidFill>
+          </a:ln>
+          <a:effectLst/>
+        </p:spPr>
+        <p:style>
+          <a:lnRef idx="1">
+            <a:schemeClr val="accent1"/>
+          </a:lnRef>
+          <a:fillRef idx="3">
+            <a:schemeClr val="accent1"/>
+          </a:fillRef>
+          <a:effectRef idx="2">
+            <a:schemeClr val="accent1"/>
+          </a:effectRef>
+          <a:fontRef idx="minor">
+            <a:schemeClr val="lt1"/>
+          </a:fontRef>
+        </p:style>
+        <p:txBody>
+          <a:bodyPr rtlCol="0" anchor="ctr"/>
+          <a:lstStyle/>
+          <a:p>
+            <a:pPr algn="ctr"/>
+          </a:p>
+        </p:txBody>
+      </p:sp>
+      <p:sp>
+        <p:nvSpPr>
+          <p:cNvPr id="13" name="Rectangle 12"/>
+          <p:cNvSpPr/>
+          <p:nvPr/>
+        </p:nvSpPr>
+        <p:spPr>
+          <a:xfrm>
+            <a:off x="6172200" y="952500"/>
+            <a:ext cx="5638800" cy="350520"/>
+          </a:xfrm>
+          <a:prstGeom prst="rect">
+            <a:avLst/>
+          </a:prstGeom>
+          <a:solidFill>
+            <a:srgbClr val="C8102E"/>
+          </a:solidFill>
+          <a:ln>
+            <a:noFill/>
+          </a:ln>
+          <a:effectLst/>
+        </p:spPr>
+        <p:style>
+          <a:lnRef idx="1">
+            <a:schemeClr val="accent1"/>
+          </a:lnRef>
+          <a:fillRef idx="3">
+            <a:schemeClr val="accent1"/>
+          </a:fillRef>
+          <a:effectRef idx="2">
+            <a:schemeClr val="accent1"/>
+          </a:effectRef>
+          <a:fontRef idx="minor">
+            <a:schemeClr val="lt1"/>
+          </a:fontRef>
+        </p:style>
+        <p:txBody>
+          <a:bodyPr rtlCol="0" anchor="ctr"/>
+          <a:lstStyle/>
+          <a:p>
+            <a:pPr algn="ctr"/>
+          </a:p>
+        </p:txBody>
+      </p:sp>
+      <p:sp>
+        <p:nvSpPr>
+          <p:cNvPr id="14" name="TextBox 13"/>
+          <p:cNvSpPr txBox="1"/>
+          <p:nvPr/>
+        </p:nvSpPr>
+        <p:spPr>
+          <a:xfrm>
+            <a:off x="6339840" y="952500"/>
+            <a:ext cx="5410200" cy="350520"/>
+          </a:xfrm>
+          <a:prstGeom prst="rect">
+            <a:avLst/>
+          </a:prstGeom>
+          <a:noFill/>
+        </p:spPr>
+        <p:txBody>
+          <a:bodyPr wrap="square" anchor="ctr" lIns="25400" rIns="25400" tIns="12700" bIns="12700">
+            <a:spAutoFit/>
+          </a:bodyPr>
+          <a:lstStyle/>
+          <a:p>
+            <a:pPr algn="l">
+              <a:lnSpc>
+                <a:spcPct val="100000"/>
+              </a:lnSpc>
+              <a:spcBef>
+                <a:spcPts val="0"/>
+              </a:spcBef>
+              <a:spcAft>
+                <a:spcPts val="400"/>
+              </a:spcAft>
+            </a:pPr>
+            <a:r>
+              <a:rPr sz="1500" b="1" i="0">
+                <a:solidFill>
+                  <a:srgbClr val="FFFFFF"/>
+                </a:solidFill>
+                <a:latin typeface="Arial"/>
+              </a:rPr>
+              <a:t>HEADWINDS  ·  structural pressures</a:t>
+            </a:r>
+          </a:p>
+        </p:txBody>
+      </p:sp>
+      <p:sp>
+        <p:nvSpPr>
+          <p:cNvPr id="15" name="TextBox 14"/>
+          <p:cNvSpPr txBox="1"/>
+          <p:nvPr/>
+        </p:nvSpPr>
+        <p:spPr>
+          <a:xfrm>
+            <a:off x="6355080" y="1432560"/>
+            <a:ext cx="5273040" cy="3810000"/>
+          </a:xfrm>
+          <a:prstGeom prst="rect">
+            <a:avLst/>
+          </a:prstGeom>
+          <a:noFill/>
+        </p:spPr>
+        <p:txBody>
+          <a:bodyPr wrap="square" anchor="t" lIns="25400" rIns="25400" tIns="12700" bIns="12700">
+            <a:spAutoFit/>
+          </a:bodyPr>
+          <a:lstStyle/>
+          <a:p>
+            <a:pPr algn="l">
+              <a:lnSpc>
+                <a:spcPct val="100000"/>
+              </a:lnSpc>
+              <a:spcBef>
+                <a:spcPts val="0"/>
+              </a:spcBef>
+              <a:spcAft>
+                <a:spcPts val="1000"/>
+              </a:spcAft>
+            </a:pPr>
+            <a:r>
+              <a:rPr sz="1450" b="0" i="0">
+                <a:solidFill>
+                  <a:srgbClr val="C8102E"/>
+                </a:solidFill>
+                <a:latin typeface="Arial"/>
+              </a:rPr>
+              <a:t>•  </a:t>
+            </a:r>
+            <a:r>
+              <a:rPr sz="1450" b="1" i="0">
+                <a:solidFill>
+                  <a:srgbClr val="222222"/>
+                </a:solidFill>
+                <a:latin typeface="Arial"/>
+              </a:rPr>
+              <a:t>Capex-driven cyclicality</a:t>
+            </a:r>
+            <a:r>
+              <a:rPr sz="1450" b="0" i="0">
+                <a:solidFill>
+                  <a:srgbClr val="222222"/>
+                </a:solidFill>
+                <a:latin typeface="Arial"/>
+              </a:rPr>
+              <a:t> → lumpy, volatile order intake tied to customers' investment cycle.</a:t>
+            </a:r>
+          </a:p>
+          <a:p>
+            <a:pPr algn="l">
+              <a:lnSpc>
+                <a:spcPct val="100000"/>
+              </a:lnSpc>
+              <a:spcBef>
+                <a:spcPts val="0"/>
+              </a:spcBef>
+              <a:spcAft>
+                <a:spcPts val="1000"/>
+              </a:spcAft>
+            </a:pPr>
+            <a:r>
+              <a:rPr sz="1450" b="0" i="0">
+                <a:solidFill>
+                  <a:srgbClr val="C8102E"/>
+                </a:solidFill>
+                <a:latin typeface="Arial"/>
+              </a:rPr>
+              <a:t>•  </a:t>
+            </a:r>
+            <a:r>
+              <a:rPr sz="1450" b="1" i="0">
+                <a:solidFill>
+                  <a:srgbClr val="222222"/>
+                </a:solidFill>
+                <a:latin typeface="Arial"/>
+              </a:rPr>
+              <a:t>Long project cycles</a:t>
+            </a:r>
+            <a:r>
+              <a:rPr sz="1450" b="0" i="0">
+                <a:solidFill>
+                  <a:srgbClr val="222222"/>
+                </a:solidFill>
+                <a:latin typeface="Arial"/>
+              </a:rPr>
+              <a:t> → work-in-progress swings distort reported earnings (the 2024 margin effect).</a:t>
+            </a:r>
+          </a:p>
+          <a:p>
+            <a:pPr algn="l">
+              <a:lnSpc>
+                <a:spcPct val="100000"/>
+              </a:lnSpc>
+              <a:spcBef>
+                <a:spcPts val="0"/>
+              </a:spcBef>
+              <a:spcAft>
+                <a:spcPts val="1000"/>
+              </a:spcAft>
+            </a:pPr>
+            <a:r>
+              <a:rPr sz="1450" b="0" i="0">
+                <a:solidFill>
+                  <a:srgbClr val="C8102E"/>
+                </a:solidFill>
+                <a:latin typeface="Arial"/>
+              </a:rPr>
+              <a:t>•  </a:t>
+            </a:r>
+            <a:r>
+              <a:rPr sz="1450" b="1" i="0">
+                <a:solidFill>
+                  <a:srgbClr val="222222"/>
+                </a:solidFill>
+                <a:latin typeface="Arial"/>
+              </a:rPr>
+              <a:t>Thin, volatile margins</a:t>
+            </a:r>
+            <a:r>
+              <a:rPr sz="1450" b="0" i="0">
+                <a:solidFill>
+                  <a:srgbClr val="222222"/>
+                </a:solidFill>
+                <a:latin typeface="Arial"/>
+              </a:rPr>
+              <a:t> &amp; execution risk on complex turnkey orders.</a:t>
+            </a:r>
+          </a:p>
+          <a:p>
+            <a:pPr algn="l">
+              <a:lnSpc>
+                <a:spcPct val="100000"/>
+              </a:lnSpc>
+              <a:spcBef>
+                <a:spcPts val="0"/>
+              </a:spcBef>
+              <a:spcAft>
+                <a:spcPts val="1000"/>
+              </a:spcAft>
+            </a:pPr>
+            <a:r>
+              <a:rPr sz="1450" b="0" i="0">
+                <a:solidFill>
+                  <a:srgbClr val="C8102E"/>
+                </a:solidFill>
+                <a:latin typeface="Arial"/>
+              </a:rPr>
+              <a:t>•  </a:t>
+            </a:r>
+            <a:r>
+              <a:rPr sz="1450" b="1" i="0">
+                <a:solidFill>
+                  <a:srgbClr val="222222"/>
+                </a:solidFill>
+                <a:latin typeface="Arial"/>
+              </a:rPr>
+              <a:t>Captive nature</a:t>
+            </a:r>
+            <a:r>
+              <a:rPr sz="1450" b="0" i="0">
+                <a:solidFill>
+                  <a:srgbClr val="222222"/>
+                </a:solidFill>
+                <a:latin typeface="Arial"/>
+              </a:rPr>
+              <a:t> → limited autonomy, intercompany dependence, carve-out complexity.</a:t>
+            </a:r>
+          </a:p>
+          <a:p>
+            <a:pPr algn="l">
+              <a:lnSpc>
+                <a:spcPct val="100000"/>
+              </a:lnSpc>
+              <a:spcBef>
+                <a:spcPts val="0"/>
+              </a:spcBef>
+              <a:spcAft>
+                <a:spcPts val="1000"/>
+              </a:spcAft>
+            </a:pPr>
+            <a:r>
+              <a:rPr sz="1450" b="0" i="0">
+                <a:solidFill>
+                  <a:srgbClr val="C8102E"/>
+                </a:solidFill>
+                <a:latin typeface="Arial"/>
+              </a:rPr>
+              <a:t>•  </a:t>
+            </a:r>
+            <a:r>
+              <a:rPr sz="1450" b="1" i="0">
+                <a:solidFill>
+                  <a:srgbClr val="222222"/>
+                </a:solidFill>
+                <a:latin typeface="Arial"/>
+              </a:rPr>
+              <a:t>Input-cost volatility</a:t>
+            </a:r>
+            <a:r>
+              <a:rPr sz="1450" b="0" i="0">
+                <a:solidFill>
+                  <a:srgbClr val="222222"/>
+                </a:solidFill>
+                <a:latin typeface="Arial"/>
+              </a:rPr>
+              <a:t> (steel, energy, components) and supply-chain tensions.</a:t>
+            </a:r>
+          </a:p>
+          <a:p>
+            <a:pPr algn="l">
+              <a:lnSpc>
+                <a:spcPct val="100000"/>
+              </a:lnSpc>
+              <a:spcBef>
+                <a:spcPts val="0"/>
+              </a:spcBef>
+              <a:spcAft>
+                <a:spcPts val="1000"/>
+              </a:spcAft>
+            </a:pPr>
+            <a:r>
+              <a:rPr sz="1450" b="0" i="0">
+                <a:solidFill>
+                  <a:srgbClr val="C8102E"/>
+                </a:solidFill>
+                <a:latin typeface="Arial"/>
+              </a:rPr>
+              <a:t>•  </a:t>
+            </a:r>
+            <a:r>
+              <a:rPr sz="1450" b="1" i="0">
+                <a:solidFill>
+                  <a:srgbClr val="222222"/>
+                </a:solidFill>
+                <a:latin typeface="Arial"/>
+              </a:rPr>
+              <a:t>FX &amp; country risk</a:t>
+            </a:r>
+            <a:r>
+              <a:rPr sz="1450" b="0" i="0">
+                <a:solidFill>
+                  <a:srgbClr val="222222"/>
+                </a:solidFill>
+                <a:latin typeface="Arial"/>
+              </a:rPr>
+              <a:t> on export projects; qualified competition (Cannon/Afros, KraussMaffei) → price pressure.</a:t>
+            </a:r>
+          </a:p>
+          <a:p>
+            <a:pPr algn="l">
+              <a:lnSpc>
+                <a:spcPct val="100000"/>
+              </a:lnSpc>
+              <a:spcBef>
+                <a:spcPts val="0"/>
+              </a:spcBef>
+              <a:spcAft>
+                <a:spcPts val="1000"/>
+              </a:spcAft>
+            </a:pPr>
+            <a:r>
+              <a:rPr sz="1450" b="0" i="0">
+                <a:solidFill>
+                  <a:srgbClr val="C8102E"/>
+                </a:solidFill>
+                <a:latin typeface="Arial"/>
+              </a:rPr>
+              <a:t>•  </a:t>
+            </a:r>
+            <a:r>
+              <a:rPr sz="1450" b="1" i="0">
+                <a:solidFill>
+                  <a:srgbClr val="222222"/>
+                </a:solidFill>
+                <a:latin typeface="Arial"/>
+              </a:rPr>
+              <a:t>Order concentration</a:t>
+            </a:r>
+            <a:r>
+              <a:rPr sz="1450" b="0" i="0">
+                <a:solidFill>
+                  <a:srgbClr val="222222"/>
+                </a:solidFill>
+                <a:latin typeface="Arial"/>
+              </a:rPr>
+              <a:t> on single large projects; warranty / performance-bond exposure.</a:t>
+            </a:r>
+          </a:p>
+        </p:txBody>
+      </p:sp>
+      <p:sp>
+        <p:nvSpPr>
+          <p:cNvPr id="16" name="Rectangle 15"/>
+          <p:cNvSpPr/>
+          <p:nvPr/>
+        </p:nvSpPr>
+        <p:spPr>
+          <a:xfrm>
+            <a:off x="381000" y="5471160"/>
+            <a:ext cx="11430000" cy="731520"/>
+          </a:xfrm>
+          <a:prstGeom prst="rect">
+            <a:avLst/>
+          </a:prstGeom>
+          <a:solidFill>
+            <a:srgbClr val="EEF2F7"/>
+          </a:solidFill>
+          <a:ln w="12700">
+            <a:solidFill>
+              <a:srgbClr val="CDD8E6"/>
+            </a:solidFill>
+          </a:ln>
+          <a:effectLst/>
+        </p:spPr>
+        <p:style>
+          <a:lnRef idx="1">
+            <a:schemeClr val="accent1"/>
+          </a:lnRef>
+          <a:fillRef idx="3">
+            <a:schemeClr val="accent1"/>
+          </a:fillRef>
+          <a:effectRef idx="2">
+            <a:schemeClr val="accent1"/>
+          </a:effectRef>
+          <a:fontRef idx="minor">
+            <a:schemeClr val="lt1"/>
+          </a:fontRef>
+        </p:style>
+        <p:txBody>
+          <a:bodyPr rtlCol="0" anchor="ctr"/>
+          <a:lstStyle/>
+          <a:p>
+            <a:pPr algn="ctr"/>
+          </a:p>
+        </p:txBody>
+      </p:sp>
+      <p:sp>
+        <p:nvSpPr>
+          <p:cNvPr id="17" name="TextBox 16"/>
+          <p:cNvSpPr txBox="1"/>
+          <p:nvPr/>
+        </p:nvSpPr>
+        <p:spPr>
+          <a:xfrm>
+            <a:off x="563880" y="5547360"/>
+            <a:ext cx="11064240" cy="609600"/>
+          </a:xfrm>
+          <a:prstGeom prst="rect">
+            <a:avLst/>
+          </a:prstGeom>
+          <a:noFill/>
+        </p:spPr>
+        <p:txBody>
+          <a:bodyPr wrap="square" anchor="ctr" lIns="25400" rIns="25400" tIns="12700" bIns="12700">
+            <a:spAutoFit/>
+          </a:bodyPr>
+          <a:lstStyle/>
+          <a:p>
+            <a:pPr algn="l">
+              <a:lnSpc>
+                <a:spcPct val="100000"/>
+              </a:lnSpc>
+              <a:spcBef>
+                <a:spcPts val="0"/>
+              </a:spcBef>
+              <a:spcAft>
+                <a:spcPts val="400"/>
+              </a:spcAft>
+            </a:pPr>
+            <a:r>
+              <a:rPr sz="1400" b="1" i="0">
+                <a:solidFill>
+                  <a:srgbClr val="1F3A5F"/>
+                </a:solidFill>
+                <a:latin typeface="Arial"/>
+              </a:rPr>
+              <a:t>Net read:  </a:t>
+            </a:r>
+            <a:r>
+              <a:rPr sz="1400" b="0" i="0">
+                <a:solidFill>
+                  <a:srgbClr val="333333"/>
+                </a:solidFill>
+                <a:latin typeface="Arial"/>
+              </a:rPr>
+              <a:t>structurally-supported demand on a cyclical, execution-heavy model. The thesis hinges on </a:t>
+            </a:r>
+            <a:r>
+              <a:rPr sz="1400" b="1" i="0">
+                <a:solidFill>
+                  <a:srgbClr val="333333"/>
+                </a:solidFill>
+                <a:latin typeface="Arial"/>
+              </a:rPr>
+              <a:t>smoothing the cycle</a:t>
+            </a:r>
+            <a:r>
+              <a:rPr sz="1400" b="0" i="0">
+                <a:solidFill>
+                  <a:srgbClr val="333333"/>
+                </a:solidFill>
+                <a:latin typeface="Arial"/>
+              </a:rPr>
+              <a:t> (backlog &amp; pricing discipline) and </a:t>
+            </a:r>
+            <a:r>
+              <a:rPr sz="1400" b="1" i="0">
+                <a:solidFill>
+                  <a:srgbClr val="333333"/>
+                </a:solidFill>
+                <a:latin typeface="Arial"/>
+              </a:rPr>
+              <a:t>scaling the recurring aftermarket</a:t>
+            </a:r>
+            <a:r>
+              <a:rPr sz="1400" b="0" i="0">
+                <a:solidFill>
+                  <a:srgbClr val="333333"/>
+                </a:solidFill>
+                <a:latin typeface="Arial"/>
+              </a:rPr>
+              <a:t> to lift and stabilise margins.</a:t>
+            </a:r>
+          </a:p>
+        </p:txBody>
+      </p:sp>
+      <p:sp>
+        <p:nvSpPr>
+          <p:cNvPr id="18" name="TextBox 17"/>
+          <p:cNvSpPr txBox="1"/>
+          <p:nvPr/>
+        </p:nvSpPr>
+        <p:spPr>
+          <a:xfrm>
+            <a:off x="381000" y="6598920"/>
+            <a:ext cx="9906000" cy="152400"/>
+          </a:xfrm>
+          <a:prstGeom prst="rect">
+            <a:avLst/>
+          </a:prstGeom>
+          <a:noFill/>
+        </p:spPr>
+        <p:txBody>
+          <a:bodyPr wrap="square" anchor="t" lIns="25400" rIns="25400" tIns="12700" bIns="12700">
+            <a:spAutoFit/>
+          </a:bodyPr>
+          <a:lstStyle/>
+          <a:p>
+            <a:pPr algn="l">
+              <a:lnSpc>
+                <a:spcPct val="100000"/>
+              </a:lnSpc>
+              <a:spcBef>
+                <a:spcPts val="0"/>
+              </a:spcBef>
+              <a:spcAft>
+                <a:spcPts val="400"/>
+              </a:spcAft>
+            </a:pPr>
+            <a:r>
+              <a:rPr sz="950" b="0" i="0">
+                <a:solidFill>
+                  <a:srgbClr val="999999"/>
+                </a:solidFill>
+                <a:latin typeface="Arial"/>
+              </a:rPr>
+              <a:t>Drivers synthesised from the dossier (sections 3, 5, 9, 11) and public industry sources.</a:t>
+            </a:r>
+          </a:p>
+        </p:txBody>
+      </p:sp>
+    </p:spTree>
+  </p:cSld>
+  <p:clrMapOvr>
+    <a:masterClrMapping/>
+  </p:clrMapOvr>
+</p:sld>
+</file>
+
+<file path=ppt/slides/slide7.xml><?xml version="1.0" encoding="utf-8"?>
+<p:sld xmlns:a="http://schemas.openxmlformats.org/drawingml/2006/main" xmlns:p="http://schemas.openxmlformats.org/presentationml/2006/main" xmlns:r="http://schemas.openxmlformats.org/officeDocument/2006/relationships">
+  <p:cSld>
+    <p:spTree>
+      <p:nvGrpSpPr>
+        <p:cNvPr id="1" name=""/>
+        <p:cNvGrpSpPr/>
+        <p:nvPr/>
+      </p:nvGrpSpPr>
+      <p:grpSpPr/>
+      <p:sp>
+        <p:nvSpPr>
+          <p:cNvPr id="2" name="Rectangle 1"/>
+          <p:cNvSpPr/>
+          <p:nvPr/>
+        </p:nvSpPr>
+        <p:spPr>
+          <a:xfrm>
+            <a:off x="0" y="0"/>
+            <a:ext cx="12192000" cy="60960"/>
+          </a:xfrm>
+          <a:prstGeom prst="rect">
+            <a:avLst/>
+          </a:prstGeom>
+          <a:solidFill>
+            <a:srgbClr val="C8102E"/>
+          </a:solidFill>
+          <a:ln>
+            <a:noFill/>
+          </a:ln>
+          <a:effectLst/>
+        </p:spPr>
+        <p:style>
+          <a:lnRef idx="1">
+            <a:schemeClr val="accent1"/>
+          </a:lnRef>
+          <a:fillRef idx="3">
+            <a:schemeClr val="accent1"/>
+          </a:fillRef>
+          <a:effectRef idx="2">
+            <a:schemeClr val="accent1"/>
+          </a:effectRef>
+          <a:fontRef idx="minor">
+            <a:schemeClr val="lt1"/>
+          </a:fontRef>
+        </p:style>
+        <p:txBody>
+          <a:bodyPr rtlCol="0" anchor="ctr"/>
+          <a:lstStyle/>
+          <a:p>
+            <a:pPr algn="ctr"/>
+          </a:p>
+        </p:txBody>
+      </p:sp>
+      <p:sp>
+        <p:nvSpPr>
+          <p:cNvPr id="3" name="TextBox 2"/>
+          <p:cNvSpPr txBox="1"/>
+          <p:nvPr/>
+        </p:nvSpPr>
+        <p:spPr>
+          <a:xfrm>
+            <a:off x="381000" y="228600"/>
+            <a:ext cx="8382000" cy="381000"/>
+          </a:xfrm>
+          <a:prstGeom prst="rect">
+            <a:avLst/>
+          </a:prstGeom>
+          <a:noFill/>
+        </p:spPr>
+        <p:txBody>
+          <a:bodyPr wrap="square" anchor="t" lIns="25400" rIns="25400" tIns="12700" bIns="12700">
+            <a:spAutoFit/>
+          </a:bodyPr>
+          <a:lstStyle/>
+          <a:p>
+            <a:pPr algn="l">
+              <a:lnSpc>
+                <a:spcPct val="100000"/>
+              </a:lnSpc>
+              <a:spcBef>
+                <a:spcPts val="0"/>
+              </a:spcBef>
+              <a:spcAft>
+                <a:spcPts val="400"/>
+              </a:spcAft>
+            </a:pPr>
+            <a:r>
+              <a:rPr sz="2600" b="1" i="0">
+                <a:solidFill>
+                  <a:srgbClr val="1F3A5F"/>
+                </a:solidFill>
+                <a:latin typeface="Arial"/>
+              </a:rPr>
+              <a:t>Investment thesis — value, risks &amp; recommendation</a:t>
+            </a:r>
+          </a:p>
+        </p:txBody>
+      </p:sp>
+      <p:sp>
+        <p:nvSpPr>
+          <p:cNvPr id="4" name="TextBox 3"/>
+          <p:cNvSpPr txBox="1"/>
+          <p:nvPr/>
+        </p:nvSpPr>
+        <p:spPr>
+          <a:xfrm>
+            <a:off x="381000" y="594360"/>
+            <a:ext cx="9144000" cy="228600"/>
+          </a:xfrm>
+          <a:prstGeom prst="rect">
+            <a:avLst/>
+          </a:prstGeom>
+          <a:noFill/>
+        </p:spPr>
+        <p:txBody>
+          <a:bodyPr wrap="square" anchor="t" lIns="25400" rIns="25400" tIns="12700" bIns="12700">
+            <a:spAutoFit/>
+          </a:bodyPr>
+          <a:lstStyle/>
+          <a:p>
+            <a:pPr algn="l">
+              <a:lnSpc>
+                <a:spcPct val="100000"/>
+              </a:lnSpc>
+              <a:spcBef>
+                <a:spcPts val="0"/>
+              </a:spcBef>
+              <a:spcAft>
+                <a:spcPts val="400"/>
+              </a:spcAft>
+            </a:pPr>
+            <a:r>
+              <a:rPr sz="1300" b="0" i="0">
+                <a:solidFill>
+                  <a:srgbClr val="666666"/>
+                </a:solidFill>
+                <a:latin typeface="Arial"/>
+              </a:rPr>
+              <a:t>Margin-recovery &amp; aftermarket story on a structurally-supported PU platform</a:t>
+            </a:r>
+          </a:p>
+        </p:txBody>
+      </p:sp>
+      <p:sp>
+        <p:nvSpPr>
+          <p:cNvPr id="5" name="TextBox 4"/>
+          <p:cNvSpPr txBox="1"/>
+          <p:nvPr/>
+        </p:nvSpPr>
+        <p:spPr>
+          <a:xfrm>
+            <a:off x="8763000" y="198120"/>
+            <a:ext cx="3048000" cy="167640"/>
+          </a:xfrm>
+          <a:prstGeom prst="rect">
+            <a:avLst/>
+          </a:prstGeom>
+          <a:noFill/>
+        </p:spPr>
+        <p:txBody>
+          <a:bodyPr wrap="square" anchor="t" lIns="25400" rIns="25400" tIns="12700" bIns="12700">
+            <a:spAutoFit/>
+          </a:bodyPr>
+          <a:lstStyle/>
+          <a:p>
+            <a:pPr algn="r">
+              <a:lnSpc>
+                <a:spcPct val="100000"/>
+              </a:lnSpc>
+              <a:spcBef>
+                <a:spcPts val="0"/>
+              </a:spcBef>
+              <a:spcAft>
+                <a:spcPts val="400"/>
+              </a:spcAft>
+            </a:pPr>
+            <a:r>
+              <a:rPr sz="950" b="0" i="0">
+                <a:solidFill>
+                  <a:srgbClr val="999999"/>
+                </a:solidFill>
+                <a:latin typeface="Arial"/>
+              </a:rPr>
+              <a:t>CONFIDENTIAL · For Board discussion</a:t>
+            </a:r>
+          </a:p>
+        </p:txBody>
+      </p:sp>
+      <p:sp>
+        <p:nvSpPr>
+          <p:cNvPr id="6" name="Rectangle 5"/>
+          <p:cNvSpPr/>
+          <p:nvPr/>
+        </p:nvSpPr>
+        <p:spPr>
+          <a:xfrm>
+            <a:off x="381000" y="6537960"/>
+            <a:ext cx="11430000" cy="7620"/>
+          </a:xfrm>
+          <a:prstGeom prst="rect">
+            <a:avLst/>
+          </a:prstGeom>
+          <a:solidFill>
+            <a:srgbClr val="DFE4EA"/>
+          </a:solidFill>
+          <a:ln>
+            <a:noFill/>
+          </a:ln>
+          <a:effectLst/>
+        </p:spPr>
+        <p:style>
+          <a:lnRef idx="1">
+            <a:schemeClr val="accent1"/>
+          </a:lnRef>
+          <a:fillRef idx="3">
+            <a:schemeClr val="accent1"/>
+          </a:fillRef>
+          <a:effectRef idx="2">
+            <a:schemeClr val="accent1"/>
+          </a:effectRef>
+          <a:fontRef idx="minor">
+            <a:schemeClr val="lt1"/>
+          </a:fontRef>
+        </p:style>
+        <p:txBody>
+          <a:bodyPr rtlCol="0" anchor="ctr"/>
+          <a:lstStyle/>
+          <a:p>
+            <a:pPr algn="ctr"/>
+          </a:p>
+        </p:txBody>
+      </p:sp>
+      <p:sp>
+        <p:nvSpPr>
+          <p:cNvPr id="7" name="TextBox 6"/>
+          <p:cNvSpPr txBox="1"/>
+          <p:nvPr/>
+        </p:nvSpPr>
+        <p:spPr>
+          <a:xfrm>
+            <a:off x="10668000" y="6598920"/>
+            <a:ext cx="1143000" cy="152400"/>
+          </a:xfrm>
+          <a:prstGeom prst="rect">
+            <a:avLst/>
+          </a:prstGeom>
+          <a:noFill/>
+        </p:spPr>
+        <p:txBody>
+          <a:bodyPr wrap="square" anchor="t" lIns="25400" rIns="25400" tIns="12700" bIns="12700">
+            <a:spAutoFit/>
+          </a:bodyPr>
+          <a:lstStyle/>
+          <a:p>
+            <a:pPr algn="r">
+              <a:lnSpc>
+                <a:spcPct val="100000"/>
+              </a:lnSpc>
+              <a:spcBef>
+                <a:spcPts val="0"/>
+              </a:spcBef>
+              <a:spcAft>
+                <a:spcPts val="400"/>
+              </a:spcAft>
+            </a:pPr>
+            <a:r>
+              <a:rPr sz="950" b="1" i="0">
+                <a:solidFill>
+                  <a:srgbClr val="1F3A5F"/>
+                </a:solidFill>
+                <a:latin typeface="Arial"/>
+              </a:rPr>
+              <a:t>6 / 6</a:t>
+            </a:r>
+          </a:p>
+        </p:txBody>
+      </p:sp>
+      <p:sp>
+        <p:nvSpPr>
+          <p:cNvPr id="8" name="Rectangle 7"/>
+          <p:cNvSpPr/>
+          <p:nvPr/>
+        </p:nvSpPr>
+        <p:spPr>
+          <a:xfrm>
+            <a:off x="381000" y="952500"/>
+            <a:ext cx="3657600" cy="4267200"/>
+          </a:xfrm>
+          <a:prstGeom prst="rect">
+            <a:avLst/>
+          </a:prstGeom>
+          <a:solidFill>
+            <a:srgbClr val="FFFFFF"/>
+          </a:solidFill>
+          <a:ln w="12700">
+            <a:solidFill>
+              <a:srgbClr val="DFE4EA"/>
+            </a:solidFill>
+          </a:ln>
+          <a:effectLst/>
+        </p:spPr>
+        <p:style>
+          <a:lnRef idx="1">
+            <a:schemeClr val="accent1"/>
+          </a:lnRef>
+          <a:fillRef idx="3">
+            <a:schemeClr val="accent1"/>
+          </a:fillRef>
+          <a:effectRef idx="2">
+            <a:schemeClr val="accent1"/>
+          </a:effectRef>
+          <a:fontRef idx="minor">
+            <a:schemeClr val="lt1"/>
+          </a:fontRef>
+        </p:style>
+        <p:txBody>
+          <a:bodyPr rtlCol="0" anchor="ctr"/>
+          <a:lstStyle/>
+          <a:p>
+            <a:pPr algn="ctr"/>
+          </a:p>
+        </p:txBody>
+      </p:sp>
+      <p:sp>
+        <p:nvSpPr>
+          <p:cNvPr id="9" name="Rectangle 8"/>
+          <p:cNvSpPr/>
+          <p:nvPr/>
+        </p:nvSpPr>
+        <p:spPr>
+          <a:xfrm>
+            <a:off x="381000" y="952500"/>
             <a:ext cx="3657600" cy="350520"/>
           </a:xfrm>
           <a:prstGeom prst="rect">
@@ -12527,7 +14319,7 @@
 </p:sld>
 </file>
 
-<file path=ppt/slides/slide7.xml><?xml version="1.0" encoding="utf-8"?>
+<file path=ppt/slides/slide8.xml><?xml version="1.0" encoding="utf-8"?>
 <p:sld xmlns:a="http://schemas.openxmlformats.org/drawingml/2006/main" xmlns:p="http://schemas.openxmlformats.org/presentationml/2006/main" xmlns:r="http://schemas.openxmlformats.org/officeDocument/2006/relationships">
   <p:cSld>
     <p:spTree>

</xml_diff>

<commit_message>
Rework P&L slide with real Hennecke data and 2023-vs-2024 YoY comparison
</commit_message>
<xml_diff>
--- a/Hennecke/pitch/HenneckeOMS_Board_Pitch_EN.pptx
+++ b/Hennecke/pitch/HenneckeOMS_Board_Pitch_EN.pptx
@@ -7076,7 +7076,7 @@
                 </a:solidFill>
                 <a:latin typeface="Arial"/>
               </a:rPr>
-              <a:t>P&amp;L recap — cost structure</a:t>
+              <a:t>P&amp;L recap — cost structure (2023 vs 2024)</a:t>
             </a:r>
           </a:p>
         </p:txBody>
@@ -7121,7 +7121,7 @@
                 </a:solidFill>
                 <a:latin typeface="Arial"/>
               </a:rPr>
-              <a:t>Revenue split into EBITDA and cost categories (cost bar)</a:t>
+              <a:t>Value of production split into EBITDA and cost categories · year-on-year</a:t>
             </a:r>
           </a:p>
         </p:txBody>
@@ -7268,8 +7268,8 @@
         </p:nvSpPr>
         <p:spPr>
           <a:xfrm>
-            <a:off x="4572000" y="1280160"/>
-            <a:ext cx="1143000" cy="457200"/>
+            <a:off x="3657600" y="1257300"/>
+            <a:ext cx="990600" cy="320040"/>
           </a:xfrm>
           <a:prstGeom prst="rect">
             <a:avLst/>
@@ -7312,8 +7312,8 @@
         </p:nvSpPr>
         <p:spPr>
           <a:xfrm>
-            <a:off x="4572000" y="1280160"/>
-            <a:ext cx="1143000" cy="457200"/>
+            <a:off x="3657600" y="1257300"/>
+            <a:ext cx="990600" cy="320040"/>
           </a:xfrm>
           <a:prstGeom prst="rect">
             <a:avLst/>
@@ -7338,116 +7338,27 @@
               </a:spcAft>
             </a:pPr>
             <a:r>
-              <a:rPr sz="1500" b="1" i="0">
+              <a:rPr sz="1300" b="1" i="0">
                 <a:solidFill>
                   <a:srgbClr val="222222"/>
                 </a:solidFill>
                 <a:latin typeface="Arial"/>
               </a:rPr>
-              <a:t>10%</a:t>
-            </a:r>
-          </a:p>
-        </p:txBody>
-      </p:sp>
-      <p:sp>
-        <p:nvSpPr>
-          <p:cNvPr id="10" name="TextBox 9"/>
-          <p:cNvSpPr txBox="1"/>
-          <p:nvPr/>
-        </p:nvSpPr>
-        <p:spPr>
-          <a:xfrm>
-            <a:off x="2286000" y="1280160"/>
-            <a:ext cx="1905000" cy="457200"/>
-          </a:xfrm>
-          <a:prstGeom prst="rect">
-            <a:avLst/>
-          </a:prstGeom>
-          <a:noFill/>
-        </p:spPr>
-        <p:txBody>
-          <a:bodyPr wrap="square" anchor="ctr" lIns="25400" rIns="25400" tIns="12700" bIns="12700">
-            <a:spAutoFit/>
-          </a:bodyPr>
-          <a:lstStyle/>
-          <a:p>
-            <a:pPr algn="r">
-              <a:lnSpc>
-                <a:spcPct val="100000"/>
-              </a:lnSpc>
-              <a:spcBef>
-                <a:spcPts val="0"/>
-              </a:spcBef>
-              <a:spcAft>
-                <a:spcPts val="400"/>
-              </a:spcAft>
-            </a:pPr>
-            <a:r>
-              <a:rPr sz="1500" b="0" i="0">
-                <a:solidFill>
-                  <a:srgbClr val="222222"/>
-                </a:solidFill>
-                <a:latin typeface="Arial"/>
-              </a:rPr>
-              <a:t>EBITDA</a:t>
-            </a:r>
-          </a:p>
-        </p:txBody>
-      </p:sp>
-      <p:sp>
-        <p:nvSpPr>
-          <p:cNvPr id="11" name="Rectangle 10"/>
+              <a:t>7.0%</a:t>
+            </a:r>
+          </a:p>
+        </p:txBody>
+      </p:sp>
+      <p:sp>
+        <p:nvSpPr>
+          <p:cNvPr id="10" name="Rectangle 9"/>
           <p:cNvSpPr/>
           <p:nvPr/>
         </p:nvSpPr>
         <p:spPr>
           <a:xfrm>
-            <a:off x="4229100" y="1508760"/>
-            <a:ext cx="342900" cy="7620"/>
-          </a:xfrm>
-          <a:prstGeom prst="rect">
-            <a:avLst/>
-          </a:prstGeom>
-          <a:solidFill>
-            <a:srgbClr val="C9D2DD"/>
-          </a:solidFill>
-          <a:ln>
-            <a:noFill/>
-          </a:ln>
-          <a:effectLst/>
-        </p:spPr>
-        <p:style>
-          <a:lnRef idx="1">
-            <a:schemeClr val="accent1"/>
-          </a:lnRef>
-          <a:fillRef idx="3">
-            <a:schemeClr val="accent1"/>
-          </a:fillRef>
-          <a:effectRef idx="2">
-            <a:schemeClr val="accent1"/>
-          </a:effectRef>
-          <a:fontRef idx="minor">
-            <a:schemeClr val="lt1"/>
-          </a:fontRef>
-        </p:style>
-        <p:txBody>
-          <a:bodyPr rtlCol="0" anchor="ctr"/>
-          <a:lstStyle/>
-          <a:p>
-            <a:pPr algn="ctr"/>
-          </a:p>
-        </p:txBody>
-      </p:sp>
-      <p:sp>
-        <p:nvSpPr>
-          <p:cNvPr id="12" name="Rectangle 11"/>
-          <p:cNvSpPr/>
-          <p:nvPr/>
-        </p:nvSpPr>
-        <p:spPr>
-          <a:xfrm>
-            <a:off x="4572000" y="1737360"/>
-            <a:ext cx="1143000" cy="2331720"/>
+            <a:off x="3657600" y="1577340"/>
+            <a:ext cx="990600" cy="2103120"/>
           </a:xfrm>
           <a:prstGeom prst="rect">
             <a:avLst/>
@@ -7484,14 +7395,14 @@
       </p:sp>
       <p:sp>
         <p:nvSpPr>
-          <p:cNvPr id="13" name="TextBox 12"/>
+          <p:cNvPr id="11" name="TextBox 10"/>
           <p:cNvSpPr txBox="1"/>
           <p:nvPr/>
         </p:nvSpPr>
         <p:spPr>
           <a:xfrm>
-            <a:off x="4572000" y="1737360"/>
-            <a:ext cx="1143000" cy="2331720"/>
+            <a:off x="3657600" y="1577340"/>
+            <a:ext cx="990600" cy="2103120"/>
           </a:xfrm>
           <a:prstGeom prst="rect">
             <a:avLst/>
@@ -7516,116 +7427,27 @@
               </a:spcAft>
             </a:pPr>
             <a:r>
-              <a:rPr sz="1500" b="1" i="0">
+              <a:rPr sz="1300" b="1" i="0">
                 <a:solidFill>
                   <a:srgbClr val="222222"/>
                 </a:solidFill>
                 <a:latin typeface="Arial"/>
               </a:rPr>
-              <a:t>51%</a:t>
-            </a:r>
-          </a:p>
-        </p:txBody>
-      </p:sp>
-      <p:sp>
-        <p:nvSpPr>
-          <p:cNvPr id="14" name="TextBox 13"/>
-          <p:cNvSpPr txBox="1"/>
-          <p:nvPr/>
-        </p:nvSpPr>
-        <p:spPr>
-          <a:xfrm>
-            <a:off x="2286000" y="1737360"/>
-            <a:ext cx="1905000" cy="2331720"/>
-          </a:xfrm>
-          <a:prstGeom prst="rect">
-            <a:avLst/>
-          </a:prstGeom>
-          <a:noFill/>
-        </p:spPr>
-        <p:txBody>
-          <a:bodyPr wrap="square" anchor="ctr" lIns="25400" rIns="25400" tIns="12700" bIns="12700">
-            <a:spAutoFit/>
-          </a:bodyPr>
-          <a:lstStyle/>
-          <a:p>
-            <a:pPr algn="r">
-              <a:lnSpc>
-                <a:spcPct val="100000"/>
-              </a:lnSpc>
-              <a:spcBef>
-                <a:spcPts val="0"/>
-              </a:spcBef>
-              <a:spcAft>
-                <a:spcPts val="400"/>
-              </a:spcAft>
-            </a:pPr>
-            <a:r>
-              <a:rPr sz="1500" b="0" i="0">
-                <a:solidFill>
-                  <a:srgbClr val="222222"/>
-                </a:solidFill>
-                <a:latin typeface="Arial"/>
-              </a:rPr>
-              <a:t>Materials</a:t>
-            </a:r>
-          </a:p>
-        </p:txBody>
-      </p:sp>
-      <p:sp>
-        <p:nvSpPr>
-          <p:cNvPr id="15" name="Rectangle 14"/>
+              <a:t>46.0%</a:t>
+            </a:r>
+          </a:p>
+        </p:txBody>
+      </p:sp>
+      <p:sp>
+        <p:nvSpPr>
+          <p:cNvPr id="12" name="Rectangle 11"/>
           <p:cNvSpPr/>
           <p:nvPr/>
         </p:nvSpPr>
         <p:spPr>
           <a:xfrm>
-            <a:off x="4229100" y="2903220"/>
-            <a:ext cx="342900" cy="7620"/>
-          </a:xfrm>
-          <a:prstGeom prst="rect">
-            <a:avLst/>
-          </a:prstGeom>
-          <a:solidFill>
-            <a:srgbClr val="C9D2DD"/>
-          </a:solidFill>
-          <a:ln>
-            <a:noFill/>
-          </a:ln>
-          <a:effectLst/>
-        </p:spPr>
-        <p:style>
-          <a:lnRef idx="1">
-            <a:schemeClr val="accent1"/>
-          </a:lnRef>
-          <a:fillRef idx="3">
-            <a:schemeClr val="accent1"/>
-          </a:fillRef>
-          <a:effectRef idx="2">
-            <a:schemeClr val="accent1"/>
-          </a:effectRef>
-          <a:fontRef idx="minor">
-            <a:schemeClr val="lt1"/>
-          </a:fontRef>
-        </p:style>
-        <p:txBody>
-          <a:bodyPr rtlCol="0" anchor="ctr"/>
-          <a:lstStyle/>
-          <a:p>
-            <a:pPr algn="ctr"/>
-          </a:p>
-        </p:txBody>
-      </p:sp>
-      <p:sp>
-        <p:nvSpPr>
-          <p:cNvPr id="16" name="Rectangle 15"/>
-          <p:cNvSpPr/>
-          <p:nvPr/>
-        </p:nvSpPr>
-        <p:spPr>
-          <a:xfrm>
-            <a:off x="4572000" y="4069080"/>
-            <a:ext cx="1143000" cy="822960"/>
+            <a:off x="3657600" y="3680460"/>
+            <a:ext cx="990600" cy="1056132"/>
           </a:xfrm>
           <a:prstGeom prst="rect">
             <a:avLst/>
@@ -7662,14 +7484,14 @@
       </p:sp>
       <p:sp>
         <p:nvSpPr>
-          <p:cNvPr id="17" name="TextBox 16"/>
+          <p:cNvPr id="13" name="TextBox 12"/>
           <p:cNvSpPr txBox="1"/>
           <p:nvPr/>
         </p:nvSpPr>
         <p:spPr>
           <a:xfrm>
-            <a:off x="4572000" y="4069080"/>
-            <a:ext cx="1143000" cy="822960"/>
+            <a:off x="3657600" y="3680460"/>
+            <a:ext cx="990600" cy="1056132"/>
           </a:xfrm>
           <a:prstGeom prst="rect">
             <a:avLst/>
@@ -7694,78 +7516,33 @@
               </a:spcAft>
             </a:pPr>
             <a:r>
-              <a:rPr sz="1500" b="1" i="0">
+              <a:rPr sz="1300" b="1" i="0">
                 <a:solidFill>
                   <a:srgbClr val="FFFFFF"/>
                 </a:solidFill>
                 <a:latin typeface="Arial"/>
               </a:rPr>
-              <a:t>18%</a:t>
-            </a:r>
-          </a:p>
-        </p:txBody>
-      </p:sp>
-      <p:sp>
-        <p:nvSpPr>
-          <p:cNvPr id="18" name="TextBox 17"/>
-          <p:cNvSpPr txBox="1"/>
-          <p:nvPr/>
-        </p:nvSpPr>
-        <p:spPr>
-          <a:xfrm>
-            <a:off x="2286000" y="4069080"/>
-            <a:ext cx="1905000" cy="822960"/>
-          </a:xfrm>
-          <a:prstGeom prst="rect">
-            <a:avLst/>
-          </a:prstGeom>
-          <a:noFill/>
-        </p:spPr>
-        <p:txBody>
-          <a:bodyPr wrap="square" anchor="ctr" lIns="25400" rIns="25400" tIns="12700" bIns="12700">
-            <a:spAutoFit/>
-          </a:bodyPr>
-          <a:lstStyle/>
-          <a:p>
-            <a:pPr algn="r">
-              <a:lnSpc>
-                <a:spcPct val="100000"/>
-              </a:lnSpc>
-              <a:spcBef>
-                <a:spcPts val="0"/>
-              </a:spcBef>
-              <a:spcAft>
-                <a:spcPts val="400"/>
-              </a:spcAft>
-            </a:pPr>
-            <a:r>
-              <a:rPr sz="1500" b="0" i="0">
-                <a:solidFill>
-                  <a:srgbClr val="222222"/>
-                </a:solidFill>
-                <a:latin typeface="Arial"/>
-              </a:rPr>
-              <a:t>Personnel</a:t>
-            </a:r>
-          </a:p>
-        </p:txBody>
-      </p:sp>
-      <p:sp>
-        <p:nvSpPr>
-          <p:cNvPr id="19" name="Rectangle 18"/>
+              <a:t>23.1%</a:t>
+            </a:r>
+          </a:p>
+        </p:txBody>
+      </p:sp>
+      <p:sp>
+        <p:nvSpPr>
+          <p:cNvPr id="14" name="Rectangle 13"/>
           <p:cNvSpPr/>
           <p:nvPr/>
         </p:nvSpPr>
         <p:spPr>
           <a:xfrm>
-            <a:off x="4229100" y="4480560"/>
-            <a:ext cx="342900" cy="7620"/>
+            <a:off x="3657600" y="4736592"/>
+            <a:ext cx="990600" cy="909828"/>
           </a:xfrm>
           <a:prstGeom prst="rect">
             <a:avLst/>
           </a:prstGeom>
           <a:solidFill>
-            <a:srgbClr val="C9D2DD"/>
+            <a:srgbClr val="3C7DA6"/>
           </a:solidFill>
           <a:ln>
             <a:noFill/>
@@ -7796,14 +7573,59 @@
       </p:sp>
       <p:sp>
         <p:nvSpPr>
-          <p:cNvPr id="20" name="Rectangle 19"/>
+          <p:cNvPr id="15" name="TextBox 14"/>
+          <p:cNvSpPr txBox="1"/>
+          <p:nvPr/>
+        </p:nvSpPr>
+        <p:spPr>
+          <a:xfrm>
+            <a:off x="3657600" y="4736592"/>
+            <a:ext cx="990600" cy="909828"/>
+          </a:xfrm>
+          <a:prstGeom prst="rect">
+            <a:avLst/>
+          </a:prstGeom>
+          <a:noFill/>
+        </p:spPr>
+        <p:txBody>
+          <a:bodyPr wrap="square" anchor="ctr" lIns="25400" rIns="25400" tIns="12700" bIns="12700">
+            <a:spAutoFit/>
+          </a:bodyPr>
+          <a:lstStyle/>
+          <a:p>
+            <a:pPr algn="ctr">
+              <a:lnSpc>
+                <a:spcPct val="100000"/>
+              </a:lnSpc>
+              <a:spcBef>
+                <a:spcPts val="0"/>
+              </a:spcBef>
+              <a:spcAft>
+                <a:spcPts val="400"/>
+              </a:spcAft>
+            </a:pPr>
+            <a:r>
+              <a:rPr sz="1300" b="1" i="0">
+                <a:solidFill>
+                  <a:srgbClr val="FFFFFF"/>
+                </a:solidFill>
+                <a:latin typeface="Arial"/>
+              </a:rPr>
+              <a:t>19.9%</a:t>
+            </a:r>
+          </a:p>
+        </p:txBody>
+      </p:sp>
+      <p:sp>
+        <p:nvSpPr>
+          <p:cNvPr id="16" name="Rectangle 15"/>
           <p:cNvSpPr/>
           <p:nvPr/>
         </p:nvSpPr>
         <p:spPr>
           <a:xfrm>
-            <a:off x="4572000" y="4892040"/>
-            <a:ext cx="1143000" cy="274320"/>
+            <a:off x="3657600" y="5646420"/>
+            <a:ext cx="990600" cy="173736"/>
           </a:xfrm>
           <a:prstGeom prst="rect">
             <a:avLst/>
@@ -7840,14 +7662,14 @@
       </p:sp>
       <p:sp>
         <p:nvSpPr>
-          <p:cNvPr id="21" name="TextBox 20"/>
+          <p:cNvPr id="17" name="TextBox 16"/>
           <p:cNvSpPr txBox="1"/>
           <p:nvPr/>
         </p:nvSpPr>
         <p:spPr>
           <a:xfrm>
-            <a:off x="4572000" y="4892040"/>
-            <a:ext cx="1143000" cy="274320"/>
+            <a:off x="3657600" y="5646420"/>
+            <a:ext cx="990600" cy="173736"/>
           </a:xfrm>
           <a:prstGeom prst="rect">
             <a:avLst/>
@@ -7872,116 +7694,27 @@
               </a:spcAft>
             </a:pPr>
             <a:r>
-              <a:rPr sz="1500" b="1" i="0">
+              <a:rPr sz="1000" b="1" i="0">
                 <a:solidFill>
                   <a:srgbClr val="FFFFFF"/>
                 </a:solidFill>
                 <a:latin typeface="Arial"/>
               </a:rPr>
-              <a:t>6%</a:t>
-            </a:r>
-          </a:p>
-        </p:txBody>
-      </p:sp>
-      <p:sp>
-        <p:nvSpPr>
-          <p:cNvPr id="22" name="TextBox 21"/>
-          <p:cNvSpPr txBox="1"/>
-          <p:nvPr/>
-        </p:nvSpPr>
-        <p:spPr>
-          <a:xfrm>
-            <a:off x="2286000" y="4892040"/>
-            <a:ext cx="1905000" cy="274320"/>
-          </a:xfrm>
-          <a:prstGeom prst="rect">
-            <a:avLst/>
-          </a:prstGeom>
-          <a:noFill/>
-        </p:spPr>
-        <p:txBody>
-          <a:bodyPr wrap="square" anchor="ctr" lIns="25400" rIns="25400" tIns="12700" bIns="12700">
-            <a:spAutoFit/>
-          </a:bodyPr>
-          <a:lstStyle/>
-          <a:p>
-            <a:pPr algn="r">
-              <a:lnSpc>
-                <a:spcPct val="100000"/>
-              </a:lnSpc>
-              <a:spcBef>
-                <a:spcPts val="0"/>
-              </a:spcBef>
-              <a:spcAft>
-                <a:spcPts val="400"/>
-              </a:spcAft>
-            </a:pPr>
-            <a:r>
-              <a:rPr sz="1200" b="0" i="0">
-                <a:solidFill>
-                  <a:srgbClr val="222222"/>
-                </a:solidFill>
-                <a:latin typeface="Arial"/>
-              </a:rPr>
-              <a:t>Transport &amp; utilities</a:t>
-            </a:r>
-          </a:p>
-        </p:txBody>
-      </p:sp>
-      <p:sp>
-        <p:nvSpPr>
-          <p:cNvPr id="23" name="Rectangle 22"/>
+              <a:t>3.8%</a:t>
+            </a:r>
+          </a:p>
+        </p:txBody>
+      </p:sp>
+      <p:sp>
+        <p:nvSpPr>
+          <p:cNvPr id="18" name="Rectangle 17"/>
           <p:cNvSpPr/>
           <p:nvPr/>
         </p:nvSpPr>
         <p:spPr>
           <a:xfrm>
-            <a:off x="4229100" y="5029200"/>
-            <a:ext cx="342900" cy="7620"/>
-          </a:xfrm>
-          <a:prstGeom prst="rect">
-            <a:avLst/>
-          </a:prstGeom>
-          <a:solidFill>
-            <a:srgbClr val="C9D2DD"/>
-          </a:solidFill>
-          <a:ln>
-            <a:noFill/>
-          </a:ln>
-          <a:effectLst/>
-        </p:spPr>
-        <p:style>
-          <a:lnRef idx="1">
-            <a:schemeClr val="accent1"/>
-          </a:lnRef>
-          <a:fillRef idx="3">
-            <a:schemeClr val="accent1"/>
-          </a:fillRef>
-          <a:effectRef idx="2">
-            <a:schemeClr val="accent1"/>
-          </a:effectRef>
-          <a:fontRef idx="minor">
-            <a:schemeClr val="lt1"/>
-          </a:fontRef>
-        </p:style>
-        <p:txBody>
-          <a:bodyPr rtlCol="0" anchor="ctr"/>
-          <a:lstStyle/>
-          <a:p>
-            <a:pPr algn="ctr"/>
-          </a:p>
-        </p:txBody>
-      </p:sp>
-      <p:sp>
-        <p:nvSpPr>
-          <p:cNvPr id="24" name="Rectangle 23"/>
-          <p:cNvSpPr/>
-          <p:nvPr/>
-        </p:nvSpPr>
-        <p:spPr>
-          <a:xfrm>
-            <a:off x="4572000" y="5166360"/>
-            <a:ext cx="1143000" cy="137160"/>
+            <a:off x="3657600" y="5820156"/>
+            <a:ext cx="990600" cy="13716"/>
           </a:xfrm>
           <a:prstGeom prst="rect">
             <a:avLst/>
@@ -8018,110 +7751,20 @@
       </p:sp>
       <p:sp>
         <p:nvSpPr>
-          <p:cNvPr id="25" name="TextBox 24"/>
-          <p:cNvSpPr txBox="1"/>
-          <p:nvPr/>
-        </p:nvSpPr>
-        <p:spPr>
-          <a:xfrm>
-            <a:off x="4572000" y="5166360"/>
-            <a:ext cx="1143000" cy="137160"/>
-          </a:xfrm>
-          <a:prstGeom prst="rect">
-            <a:avLst/>
-          </a:prstGeom>
-          <a:noFill/>
-        </p:spPr>
-        <p:txBody>
-          <a:bodyPr wrap="square" anchor="ctr" lIns="25400" rIns="25400" tIns="12700" bIns="12700">
-            <a:spAutoFit/>
-          </a:bodyPr>
-          <a:lstStyle/>
-          <a:p>
-            <a:pPr algn="ctr">
-              <a:lnSpc>
-                <a:spcPct val="100000"/>
-              </a:lnSpc>
-              <a:spcBef>
-                <a:spcPts val="0"/>
-              </a:spcBef>
-              <a:spcAft>
-                <a:spcPts val="400"/>
-              </a:spcAft>
-            </a:pPr>
-            <a:r>
-              <a:rPr sz="1000" b="1" i="0">
-                <a:solidFill>
-                  <a:srgbClr val="222222"/>
-                </a:solidFill>
-                <a:latin typeface="Arial"/>
-              </a:rPr>
-              <a:t>3%</a:t>
-            </a:r>
-          </a:p>
-        </p:txBody>
-      </p:sp>
-      <p:sp>
-        <p:nvSpPr>
-          <p:cNvPr id="26" name="TextBox 25"/>
-          <p:cNvSpPr txBox="1"/>
-          <p:nvPr/>
-        </p:nvSpPr>
-        <p:spPr>
-          <a:xfrm>
-            <a:off x="2286000" y="5166360"/>
-            <a:ext cx="1905000" cy="137160"/>
-          </a:xfrm>
-          <a:prstGeom prst="rect">
-            <a:avLst/>
-          </a:prstGeom>
-          <a:noFill/>
-        </p:spPr>
-        <p:txBody>
-          <a:bodyPr wrap="square" anchor="ctr" lIns="25400" rIns="25400" tIns="12700" bIns="12700">
-            <a:spAutoFit/>
-          </a:bodyPr>
-          <a:lstStyle/>
-          <a:p>
-            <a:pPr algn="r">
-              <a:lnSpc>
-                <a:spcPct val="100000"/>
-              </a:lnSpc>
-              <a:spcBef>
-                <a:spcPts val="0"/>
-              </a:spcBef>
-              <a:spcAft>
-                <a:spcPts val="400"/>
-              </a:spcAft>
-            </a:pPr>
-            <a:r>
-              <a:rPr sz="1200" b="0" i="0">
-                <a:solidFill>
-                  <a:srgbClr val="222222"/>
-                </a:solidFill>
-                <a:latin typeface="Arial"/>
-              </a:rPr>
-              <a:t>Maintenance</a:t>
-            </a:r>
-          </a:p>
-        </p:txBody>
-      </p:sp>
-      <p:sp>
-        <p:nvSpPr>
-          <p:cNvPr id="27" name="Rectangle 26"/>
+          <p:cNvPr id="19" name="Rectangle 18"/>
           <p:cNvSpPr/>
           <p:nvPr/>
         </p:nvSpPr>
         <p:spPr>
           <a:xfrm>
-            <a:off x="4229100" y="5234940"/>
-            <a:ext cx="342900" cy="7620"/>
+            <a:off x="5486400" y="1257300"/>
+            <a:ext cx="990600" cy="173736"/>
           </a:xfrm>
           <a:prstGeom prst="rect">
             <a:avLst/>
           </a:prstGeom>
           <a:solidFill>
-            <a:srgbClr val="C9D2DD"/>
+            <a:srgbClr val="84BD00"/>
           </a:solidFill>
           <a:ln>
             <a:noFill/>
@@ -8152,20 +7795,65 @@
       </p:sp>
       <p:sp>
         <p:nvSpPr>
-          <p:cNvPr id="28" name="Rectangle 27"/>
+          <p:cNvPr id="20" name="TextBox 19"/>
+          <p:cNvSpPr txBox="1"/>
+          <p:nvPr/>
+        </p:nvSpPr>
+        <p:spPr>
+          <a:xfrm>
+            <a:off x="5486400" y="1257300"/>
+            <a:ext cx="990600" cy="173736"/>
+          </a:xfrm>
+          <a:prstGeom prst="rect">
+            <a:avLst/>
+          </a:prstGeom>
+          <a:noFill/>
+        </p:spPr>
+        <p:txBody>
+          <a:bodyPr wrap="square" anchor="ctr" lIns="25400" rIns="25400" tIns="12700" bIns="12700">
+            <a:spAutoFit/>
+          </a:bodyPr>
+          <a:lstStyle/>
+          <a:p>
+            <a:pPr algn="ctr">
+              <a:lnSpc>
+                <a:spcPct val="100000"/>
+              </a:lnSpc>
+              <a:spcBef>
+                <a:spcPts val="0"/>
+              </a:spcBef>
+              <a:spcAft>
+                <a:spcPts val="400"/>
+              </a:spcAft>
+            </a:pPr>
+            <a:r>
+              <a:rPr sz="1000" b="1" i="0">
+                <a:solidFill>
+                  <a:srgbClr val="222222"/>
+                </a:solidFill>
+                <a:latin typeface="Arial"/>
+              </a:rPr>
+              <a:t>3.8%</a:t>
+            </a:r>
+          </a:p>
+        </p:txBody>
+      </p:sp>
+      <p:sp>
+        <p:nvSpPr>
+          <p:cNvPr id="21" name="Rectangle 20"/>
           <p:cNvSpPr/>
           <p:nvPr/>
         </p:nvSpPr>
         <p:spPr>
           <a:xfrm>
-            <a:off x="4572000" y="5303520"/>
-            <a:ext cx="1143000" cy="502920"/>
+            <a:off x="5486400" y="1431036"/>
+            <a:ext cx="990600" cy="1755648"/>
           </a:xfrm>
           <a:prstGeom prst="rect">
             <a:avLst/>
           </a:prstGeom>
           <a:solidFill>
-            <a:srgbClr val="243746"/>
+            <a:srgbClr val="F2A100"/>
           </a:solidFill>
           <a:ln>
             <a:noFill/>
@@ -8196,14 +7884,14 @@
       </p:sp>
       <p:sp>
         <p:nvSpPr>
-          <p:cNvPr id="29" name="TextBox 28"/>
+          <p:cNvPr id="22" name="TextBox 21"/>
           <p:cNvSpPr txBox="1"/>
           <p:nvPr/>
         </p:nvSpPr>
         <p:spPr>
           <a:xfrm>
-            <a:off x="4572000" y="5303520"/>
-            <a:ext cx="1143000" cy="502920"/>
+            <a:off x="5486400" y="1431036"/>
+            <a:ext cx="990600" cy="1755648"/>
           </a:xfrm>
           <a:prstGeom prst="rect">
             <a:avLst/>
@@ -8228,78 +7916,33 @@
               </a:spcAft>
             </a:pPr>
             <a:r>
-              <a:rPr sz="1500" b="1" i="0">
-                <a:solidFill>
-                  <a:srgbClr val="FFFFFF"/>
-                </a:solidFill>
-                <a:latin typeface="Arial"/>
-              </a:rPr>
-              <a:t>11%</a:t>
-            </a:r>
-          </a:p>
-        </p:txBody>
-      </p:sp>
-      <p:sp>
-        <p:nvSpPr>
-          <p:cNvPr id="30" name="TextBox 29"/>
-          <p:cNvSpPr txBox="1"/>
-          <p:nvPr/>
-        </p:nvSpPr>
-        <p:spPr>
-          <a:xfrm>
-            <a:off x="2286000" y="5303520"/>
-            <a:ext cx="1905000" cy="502920"/>
-          </a:xfrm>
-          <a:prstGeom prst="rect">
-            <a:avLst/>
-          </a:prstGeom>
-          <a:noFill/>
-        </p:spPr>
-        <p:txBody>
-          <a:bodyPr wrap="square" anchor="ctr" lIns="25400" rIns="25400" tIns="12700" bIns="12700">
-            <a:spAutoFit/>
-          </a:bodyPr>
-          <a:lstStyle/>
-          <a:p>
-            <a:pPr algn="r">
-              <a:lnSpc>
-                <a:spcPct val="100000"/>
-              </a:lnSpc>
-              <a:spcBef>
-                <a:spcPts val="0"/>
-              </a:spcBef>
-              <a:spcAft>
-                <a:spcPts val="400"/>
-              </a:spcAft>
-            </a:pPr>
-            <a:r>
-              <a:rPr sz="1500" b="0" i="0">
+              <a:rPr sz="1300" b="1" i="0">
                 <a:solidFill>
                   <a:srgbClr val="222222"/>
                 </a:solidFill>
                 <a:latin typeface="Arial"/>
               </a:rPr>
-              <a:t>Overheads</a:t>
-            </a:r>
-          </a:p>
-        </p:txBody>
-      </p:sp>
-      <p:sp>
-        <p:nvSpPr>
-          <p:cNvPr id="31" name="Rectangle 30"/>
+              <a:t>38.4%</a:t>
+            </a:r>
+          </a:p>
+        </p:txBody>
+      </p:sp>
+      <p:sp>
+        <p:nvSpPr>
+          <p:cNvPr id="23" name="Rectangle 22"/>
           <p:cNvSpPr/>
           <p:nvPr/>
         </p:nvSpPr>
         <p:spPr>
           <a:xfrm>
-            <a:off x="4229100" y="5554980"/>
-            <a:ext cx="342900" cy="7620"/>
+            <a:off x="5486400" y="3186684"/>
+            <a:ext cx="990600" cy="1385316"/>
           </a:xfrm>
           <a:prstGeom prst="rect">
             <a:avLst/>
           </a:prstGeom>
           <a:solidFill>
-            <a:srgbClr val="C9D2DD"/>
+            <a:srgbClr val="D9531E"/>
           </a:solidFill>
           <a:ln>
             <a:noFill/>
@@ -8330,14 +7973,533 @@
       </p:sp>
       <p:sp>
         <p:nvSpPr>
-          <p:cNvPr id="32" name="TextBox 31"/>
+          <p:cNvPr id="24" name="TextBox 23"/>
           <p:cNvSpPr txBox="1"/>
           <p:nvPr/>
         </p:nvSpPr>
         <p:spPr>
           <a:xfrm>
-            <a:off x="4267200" y="5867400"/>
-            <a:ext cx="1752600" cy="182880"/>
+            <a:off x="5486400" y="3186684"/>
+            <a:ext cx="990600" cy="1385316"/>
+          </a:xfrm>
+          <a:prstGeom prst="rect">
+            <a:avLst/>
+          </a:prstGeom>
+          <a:noFill/>
+        </p:spPr>
+        <p:txBody>
+          <a:bodyPr wrap="square" anchor="ctr" lIns="25400" rIns="25400" tIns="12700" bIns="12700">
+            <a:spAutoFit/>
+          </a:bodyPr>
+          <a:lstStyle/>
+          <a:p>
+            <a:pPr algn="ctr">
+              <a:lnSpc>
+                <a:spcPct val="100000"/>
+              </a:lnSpc>
+              <a:spcBef>
+                <a:spcPts val="0"/>
+              </a:spcBef>
+              <a:spcAft>
+                <a:spcPts val="400"/>
+              </a:spcAft>
+            </a:pPr>
+            <a:r>
+              <a:rPr sz="1300" b="1" i="0">
+                <a:solidFill>
+                  <a:srgbClr val="FFFFFF"/>
+                </a:solidFill>
+                <a:latin typeface="Arial"/>
+              </a:rPr>
+              <a:t>30.3%</a:t>
+            </a:r>
+          </a:p>
+        </p:txBody>
+      </p:sp>
+      <p:sp>
+        <p:nvSpPr>
+          <p:cNvPr id="25" name="Rectangle 24"/>
+          <p:cNvSpPr/>
+          <p:nvPr/>
+        </p:nvSpPr>
+        <p:spPr>
+          <a:xfrm>
+            <a:off x="5486400" y="4572000"/>
+            <a:ext cx="990600" cy="1042416"/>
+          </a:xfrm>
+          <a:prstGeom prst="rect">
+            <a:avLst/>
+          </a:prstGeom>
+          <a:solidFill>
+            <a:srgbClr val="3C7DA6"/>
+          </a:solidFill>
+          <a:ln>
+            <a:noFill/>
+          </a:ln>
+          <a:effectLst/>
+        </p:spPr>
+        <p:style>
+          <a:lnRef idx="1">
+            <a:schemeClr val="accent1"/>
+          </a:lnRef>
+          <a:fillRef idx="3">
+            <a:schemeClr val="accent1"/>
+          </a:fillRef>
+          <a:effectRef idx="2">
+            <a:schemeClr val="accent1"/>
+          </a:effectRef>
+          <a:fontRef idx="minor">
+            <a:schemeClr val="lt1"/>
+          </a:fontRef>
+        </p:style>
+        <p:txBody>
+          <a:bodyPr rtlCol="0" anchor="ctr"/>
+          <a:lstStyle/>
+          <a:p>
+            <a:pPr algn="ctr"/>
+          </a:p>
+        </p:txBody>
+      </p:sp>
+      <p:sp>
+        <p:nvSpPr>
+          <p:cNvPr id="26" name="TextBox 25"/>
+          <p:cNvSpPr txBox="1"/>
+          <p:nvPr/>
+        </p:nvSpPr>
+        <p:spPr>
+          <a:xfrm>
+            <a:off x="5486400" y="4572000"/>
+            <a:ext cx="990600" cy="1042416"/>
+          </a:xfrm>
+          <a:prstGeom prst="rect">
+            <a:avLst/>
+          </a:prstGeom>
+          <a:noFill/>
+        </p:spPr>
+        <p:txBody>
+          <a:bodyPr wrap="square" anchor="ctr" lIns="25400" rIns="25400" tIns="12700" bIns="12700">
+            <a:spAutoFit/>
+          </a:bodyPr>
+          <a:lstStyle/>
+          <a:p>
+            <a:pPr algn="ctr">
+              <a:lnSpc>
+                <a:spcPct val="100000"/>
+              </a:lnSpc>
+              <a:spcBef>
+                <a:spcPts val="0"/>
+              </a:spcBef>
+              <a:spcAft>
+                <a:spcPts val="400"/>
+              </a:spcAft>
+            </a:pPr>
+            <a:r>
+              <a:rPr sz="1300" b="1" i="0">
+                <a:solidFill>
+                  <a:srgbClr val="FFFFFF"/>
+                </a:solidFill>
+                <a:latin typeface="Arial"/>
+              </a:rPr>
+              <a:t>22.8%</a:t>
+            </a:r>
+          </a:p>
+        </p:txBody>
+      </p:sp>
+      <p:sp>
+        <p:nvSpPr>
+          <p:cNvPr id="27" name="Rectangle 26"/>
+          <p:cNvSpPr/>
+          <p:nvPr/>
+        </p:nvSpPr>
+        <p:spPr>
+          <a:xfrm>
+            <a:off x="5486400" y="5614416"/>
+            <a:ext cx="990600" cy="192024"/>
+          </a:xfrm>
+          <a:prstGeom prst="rect">
+            <a:avLst/>
+          </a:prstGeom>
+          <a:solidFill>
+            <a:srgbClr val="8C5A2B"/>
+          </a:solidFill>
+          <a:ln>
+            <a:noFill/>
+          </a:ln>
+          <a:effectLst/>
+        </p:spPr>
+        <p:style>
+          <a:lnRef idx="1">
+            <a:schemeClr val="accent1"/>
+          </a:lnRef>
+          <a:fillRef idx="3">
+            <a:schemeClr val="accent1"/>
+          </a:fillRef>
+          <a:effectRef idx="2">
+            <a:schemeClr val="accent1"/>
+          </a:effectRef>
+          <a:fontRef idx="minor">
+            <a:schemeClr val="lt1"/>
+          </a:fontRef>
+        </p:style>
+        <p:txBody>
+          <a:bodyPr rtlCol="0" anchor="ctr"/>
+          <a:lstStyle/>
+          <a:p>
+            <a:pPr algn="ctr"/>
+          </a:p>
+        </p:txBody>
+      </p:sp>
+      <p:sp>
+        <p:nvSpPr>
+          <p:cNvPr id="28" name="TextBox 27"/>
+          <p:cNvSpPr txBox="1"/>
+          <p:nvPr/>
+        </p:nvSpPr>
+        <p:spPr>
+          <a:xfrm>
+            <a:off x="5486400" y="5614416"/>
+            <a:ext cx="990600" cy="192024"/>
+          </a:xfrm>
+          <a:prstGeom prst="rect">
+            <a:avLst/>
+          </a:prstGeom>
+          <a:noFill/>
+        </p:spPr>
+        <p:txBody>
+          <a:bodyPr wrap="square" anchor="ctr" lIns="25400" rIns="25400" tIns="12700" bIns="12700">
+            <a:spAutoFit/>
+          </a:bodyPr>
+          <a:lstStyle/>
+          <a:p>
+            <a:pPr algn="ctr">
+              <a:lnSpc>
+                <a:spcPct val="100000"/>
+              </a:lnSpc>
+              <a:spcBef>
+                <a:spcPts val="0"/>
+              </a:spcBef>
+              <a:spcAft>
+                <a:spcPts val="400"/>
+              </a:spcAft>
+            </a:pPr>
+            <a:r>
+              <a:rPr sz="1000" b="1" i="0">
+                <a:solidFill>
+                  <a:srgbClr val="FFFFFF"/>
+                </a:solidFill>
+                <a:latin typeface="Arial"/>
+              </a:rPr>
+              <a:t>4.2%</a:t>
+            </a:r>
+          </a:p>
+        </p:txBody>
+      </p:sp>
+      <p:sp>
+        <p:nvSpPr>
+          <p:cNvPr id="29" name="Rectangle 28"/>
+          <p:cNvSpPr/>
+          <p:nvPr/>
+        </p:nvSpPr>
+        <p:spPr>
+          <a:xfrm>
+            <a:off x="5486400" y="5806440"/>
+            <a:ext cx="990600" cy="22860"/>
+          </a:xfrm>
+          <a:prstGeom prst="rect">
+            <a:avLst/>
+          </a:prstGeom>
+          <a:solidFill>
+            <a:srgbClr val="BFBFBF"/>
+          </a:solidFill>
+          <a:ln>
+            <a:noFill/>
+          </a:ln>
+          <a:effectLst/>
+        </p:spPr>
+        <p:style>
+          <a:lnRef idx="1">
+            <a:schemeClr val="accent1"/>
+          </a:lnRef>
+          <a:fillRef idx="3">
+            <a:schemeClr val="accent1"/>
+          </a:fillRef>
+          <a:effectRef idx="2">
+            <a:schemeClr val="accent1"/>
+          </a:effectRef>
+          <a:fontRef idx="minor">
+            <a:schemeClr val="lt1"/>
+          </a:fontRef>
+        </p:style>
+        <p:txBody>
+          <a:bodyPr rtlCol="0" anchor="ctr"/>
+          <a:lstStyle/>
+          <a:p>
+            <a:pPr algn="ctr"/>
+          </a:p>
+        </p:txBody>
+      </p:sp>
+      <p:cxnSp>
+        <p:nvCxnSpPr>
+          <p:cNvPr id="30" name="Connector 29"/>
+          <p:cNvCxnSpPr/>
+          <p:nvPr/>
+        </p:nvCxnSpPr>
+        <p:spPr>
+          <a:xfrm>
+            <a:off x="4648200" y="1257300"/>
+            <a:ext cx="838200" cy="0"/>
+          </a:xfrm>
+          <a:prstGeom prst="line">
+            <a:avLst/>
+          </a:prstGeom>
+          <a:ln w="9525">
+            <a:solidFill>
+              <a:srgbClr val="D9DEE6"/>
+            </a:solidFill>
+          </a:ln>
+          <a:effectLst/>
+        </p:spPr>
+        <p:style>
+          <a:lnRef idx="2">
+            <a:schemeClr val="accent1"/>
+          </a:lnRef>
+          <a:fillRef idx="0">
+            <a:schemeClr val="accent1"/>
+          </a:fillRef>
+          <a:effectRef idx="1">
+            <a:schemeClr val="accent1"/>
+          </a:effectRef>
+          <a:fontRef idx="minor">
+            <a:schemeClr val="tx1"/>
+          </a:fontRef>
+        </p:style>
+      </p:cxnSp>
+      <p:cxnSp>
+        <p:nvCxnSpPr>
+          <p:cNvPr id="31" name="Connector 30"/>
+          <p:cNvCxnSpPr/>
+          <p:nvPr/>
+        </p:nvCxnSpPr>
+        <p:spPr>
+          <a:xfrm flipV="1">
+            <a:off x="4648200" y="1431036"/>
+            <a:ext cx="838200" cy="146304"/>
+          </a:xfrm>
+          <a:prstGeom prst="line">
+            <a:avLst/>
+          </a:prstGeom>
+          <a:ln w="9525">
+            <a:solidFill>
+              <a:srgbClr val="D9DEE6"/>
+            </a:solidFill>
+          </a:ln>
+          <a:effectLst/>
+        </p:spPr>
+        <p:style>
+          <a:lnRef idx="2">
+            <a:schemeClr val="accent1"/>
+          </a:lnRef>
+          <a:fillRef idx="0">
+            <a:schemeClr val="accent1"/>
+          </a:fillRef>
+          <a:effectRef idx="1">
+            <a:schemeClr val="accent1"/>
+          </a:effectRef>
+          <a:fontRef idx="minor">
+            <a:schemeClr val="tx1"/>
+          </a:fontRef>
+        </p:style>
+      </p:cxnSp>
+      <p:cxnSp>
+        <p:nvCxnSpPr>
+          <p:cNvPr id="32" name="Connector 31"/>
+          <p:cNvCxnSpPr/>
+          <p:nvPr/>
+        </p:nvCxnSpPr>
+        <p:spPr>
+          <a:xfrm flipV="1">
+            <a:off x="4648200" y="3186684"/>
+            <a:ext cx="838200" cy="493776"/>
+          </a:xfrm>
+          <a:prstGeom prst="line">
+            <a:avLst/>
+          </a:prstGeom>
+          <a:ln w="9525">
+            <a:solidFill>
+              <a:srgbClr val="D9DEE6"/>
+            </a:solidFill>
+          </a:ln>
+          <a:effectLst/>
+        </p:spPr>
+        <p:style>
+          <a:lnRef idx="2">
+            <a:schemeClr val="accent1"/>
+          </a:lnRef>
+          <a:fillRef idx="0">
+            <a:schemeClr val="accent1"/>
+          </a:fillRef>
+          <a:effectRef idx="1">
+            <a:schemeClr val="accent1"/>
+          </a:effectRef>
+          <a:fontRef idx="minor">
+            <a:schemeClr val="tx1"/>
+          </a:fontRef>
+        </p:style>
+      </p:cxnSp>
+      <p:cxnSp>
+        <p:nvCxnSpPr>
+          <p:cNvPr id="33" name="Connector 32"/>
+          <p:cNvCxnSpPr/>
+          <p:nvPr/>
+        </p:nvCxnSpPr>
+        <p:spPr>
+          <a:xfrm flipV="1">
+            <a:off x="4648200" y="4572000"/>
+            <a:ext cx="838200" cy="164592"/>
+          </a:xfrm>
+          <a:prstGeom prst="line">
+            <a:avLst/>
+          </a:prstGeom>
+          <a:ln w="9525">
+            <a:solidFill>
+              <a:srgbClr val="D9DEE6"/>
+            </a:solidFill>
+          </a:ln>
+          <a:effectLst/>
+        </p:spPr>
+        <p:style>
+          <a:lnRef idx="2">
+            <a:schemeClr val="accent1"/>
+          </a:lnRef>
+          <a:fillRef idx="0">
+            <a:schemeClr val="accent1"/>
+          </a:fillRef>
+          <a:effectRef idx="1">
+            <a:schemeClr val="accent1"/>
+          </a:effectRef>
+          <a:fontRef idx="minor">
+            <a:schemeClr val="tx1"/>
+          </a:fontRef>
+        </p:style>
+      </p:cxnSp>
+      <p:cxnSp>
+        <p:nvCxnSpPr>
+          <p:cNvPr id="34" name="Connector 33"/>
+          <p:cNvCxnSpPr/>
+          <p:nvPr/>
+        </p:nvCxnSpPr>
+        <p:spPr>
+          <a:xfrm flipV="1">
+            <a:off x="4648200" y="5614416"/>
+            <a:ext cx="838200" cy="32004"/>
+          </a:xfrm>
+          <a:prstGeom prst="line">
+            <a:avLst/>
+          </a:prstGeom>
+          <a:ln w="9525">
+            <a:solidFill>
+              <a:srgbClr val="D9DEE6"/>
+            </a:solidFill>
+          </a:ln>
+          <a:effectLst/>
+        </p:spPr>
+        <p:style>
+          <a:lnRef idx="2">
+            <a:schemeClr val="accent1"/>
+          </a:lnRef>
+          <a:fillRef idx="0">
+            <a:schemeClr val="accent1"/>
+          </a:fillRef>
+          <a:effectRef idx="1">
+            <a:schemeClr val="accent1"/>
+          </a:effectRef>
+          <a:fontRef idx="minor">
+            <a:schemeClr val="tx1"/>
+          </a:fontRef>
+        </p:style>
+      </p:cxnSp>
+      <p:cxnSp>
+        <p:nvCxnSpPr>
+          <p:cNvPr id="35" name="Connector 34"/>
+          <p:cNvCxnSpPr/>
+          <p:nvPr/>
+        </p:nvCxnSpPr>
+        <p:spPr>
+          <a:xfrm flipV="1">
+            <a:off x="4648200" y="5806440"/>
+            <a:ext cx="838200" cy="13716"/>
+          </a:xfrm>
+          <a:prstGeom prst="line">
+            <a:avLst/>
+          </a:prstGeom>
+          <a:ln w="9525">
+            <a:solidFill>
+              <a:srgbClr val="D9DEE6"/>
+            </a:solidFill>
+          </a:ln>
+          <a:effectLst/>
+        </p:spPr>
+        <p:style>
+          <a:lnRef idx="2">
+            <a:schemeClr val="accent1"/>
+          </a:lnRef>
+          <a:fillRef idx="0">
+            <a:schemeClr val="accent1"/>
+          </a:fillRef>
+          <a:effectRef idx="1">
+            <a:schemeClr val="accent1"/>
+          </a:effectRef>
+          <a:fontRef idx="minor">
+            <a:schemeClr val="tx1"/>
+          </a:fontRef>
+        </p:style>
+      </p:cxnSp>
+      <p:cxnSp>
+        <p:nvCxnSpPr>
+          <p:cNvPr id="36" name="Connector 35"/>
+          <p:cNvCxnSpPr/>
+          <p:nvPr/>
+        </p:nvCxnSpPr>
+        <p:spPr>
+          <a:xfrm flipV="1">
+            <a:off x="4648200" y="5829300"/>
+            <a:ext cx="838200" cy="4572"/>
+          </a:xfrm>
+          <a:prstGeom prst="line">
+            <a:avLst/>
+          </a:prstGeom>
+          <a:ln w="9525">
+            <a:solidFill>
+              <a:srgbClr val="D9DEE6"/>
+            </a:solidFill>
+          </a:ln>
+          <a:effectLst/>
+        </p:spPr>
+        <p:style>
+          <a:lnRef idx="2">
+            <a:schemeClr val="accent1"/>
+          </a:lnRef>
+          <a:fillRef idx="0">
+            <a:schemeClr val="accent1"/>
+          </a:fillRef>
+          <a:effectRef idx="1">
+            <a:schemeClr val="accent1"/>
+          </a:effectRef>
+          <a:fontRef idx="minor">
+            <a:schemeClr val="tx1"/>
+          </a:fontRef>
+        </p:style>
+      </p:cxnSp>
+      <p:sp>
+        <p:nvSpPr>
+          <p:cNvPr id="37" name="TextBox 36"/>
+          <p:cNvSpPr txBox="1"/>
+          <p:nvPr/>
+        </p:nvSpPr>
+        <p:spPr>
+          <a:xfrm>
+            <a:off x="3505200" y="5894832"/>
+            <a:ext cx="1295400" cy="182880"/>
           </a:xfrm>
           <a:prstGeom prst="rect">
             <a:avLst/>
@@ -8362,27 +8524,162 @@
               </a:spcAft>
             </a:pPr>
             <a:r>
-              <a:rPr sz="1300" b="1" i="0">
-                <a:solidFill>
-                  <a:srgbClr val="666666"/>
-                </a:solidFill>
-                <a:latin typeface="Arial"/>
-              </a:rPr>
-              <a:t>Cost bar</a:t>
-            </a:r>
-          </a:p>
-        </p:txBody>
-      </p:sp>
-      <p:sp>
-        <p:nvSpPr>
-          <p:cNvPr id="33" name="Rectangle 32"/>
+              <a:rPr sz="1500" b="1" i="0">
+                <a:solidFill>
+                  <a:srgbClr val="1F3A5F"/>
+                </a:solidFill>
+                <a:latin typeface="Arial"/>
+              </a:rPr>
+              <a:t>2023</a:t>
+            </a:r>
+          </a:p>
+        </p:txBody>
+      </p:sp>
+      <p:sp>
+        <p:nvSpPr>
+          <p:cNvPr id="38" name="TextBox 37"/>
+          <p:cNvSpPr txBox="1"/>
+          <p:nvPr/>
+        </p:nvSpPr>
+        <p:spPr>
+          <a:xfrm>
+            <a:off x="5334000" y="5890260"/>
+            <a:ext cx="1295400" cy="182880"/>
+          </a:xfrm>
+          <a:prstGeom prst="rect">
+            <a:avLst/>
+          </a:prstGeom>
+          <a:noFill/>
+        </p:spPr>
+        <p:txBody>
+          <a:bodyPr wrap="square" anchor="t" lIns="25400" rIns="25400" tIns="12700" bIns="12700">
+            <a:spAutoFit/>
+          </a:bodyPr>
+          <a:lstStyle/>
+          <a:p>
+            <a:pPr algn="ctr">
+              <a:lnSpc>
+                <a:spcPct val="100000"/>
+              </a:lnSpc>
+              <a:spcBef>
+                <a:spcPts val="0"/>
+              </a:spcBef>
+              <a:spcAft>
+                <a:spcPts val="400"/>
+              </a:spcAft>
+            </a:pPr>
+            <a:r>
+              <a:rPr sz="1500" b="1" i="0">
+                <a:solidFill>
+                  <a:srgbClr val="1F3A5F"/>
+                </a:solidFill>
+                <a:latin typeface="Arial"/>
+              </a:rPr>
+              <a:t>2024</a:t>
+            </a:r>
+          </a:p>
+        </p:txBody>
+      </p:sp>
+      <p:sp>
+        <p:nvSpPr>
+          <p:cNvPr id="39" name="TextBox 38"/>
+          <p:cNvSpPr txBox="1"/>
+          <p:nvPr/>
+        </p:nvSpPr>
+        <p:spPr>
+          <a:xfrm>
+            <a:off x="2667000" y="1242060"/>
+            <a:ext cx="914400" cy="167640"/>
+          </a:xfrm>
+          <a:prstGeom prst="rect">
+            <a:avLst/>
+          </a:prstGeom>
+          <a:noFill/>
+        </p:spPr>
+        <p:txBody>
+          <a:bodyPr wrap="square" anchor="t" lIns="25400" rIns="25400" tIns="12700" bIns="12700">
+            <a:spAutoFit/>
+          </a:bodyPr>
+          <a:lstStyle/>
+          <a:p>
+            <a:pPr algn="r">
+              <a:lnSpc>
+                <a:spcPct val="100000"/>
+              </a:lnSpc>
+              <a:spcBef>
+                <a:spcPts val="0"/>
+              </a:spcBef>
+              <a:spcAft>
+                <a:spcPts val="400"/>
+              </a:spcAft>
+            </a:pPr>
+            <a:r>
+              <a:rPr sz="1100" b="0" i="0">
+                <a:solidFill>
+                  <a:srgbClr val="999999"/>
+                </a:solidFill>
+                <a:latin typeface="Arial"/>
+              </a:rPr>
+              <a:t>% of value</a:t>
+            </a:r>
+          </a:p>
+        </p:txBody>
+      </p:sp>
+      <p:sp>
+        <p:nvSpPr>
+          <p:cNvPr id="40" name="TextBox 39"/>
+          <p:cNvSpPr txBox="1"/>
+          <p:nvPr/>
+        </p:nvSpPr>
+        <p:spPr>
+          <a:xfrm>
+            <a:off x="2667000" y="1379220"/>
+            <a:ext cx="914400" cy="167640"/>
+          </a:xfrm>
+          <a:prstGeom prst="rect">
+            <a:avLst/>
+          </a:prstGeom>
+          <a:noFill/>
+        </p:spPr>
+        <p:txBody>
+          <a:bodyPr wrap="square" anchor="t" lIns="25400" rIns="25400" tIns="12700" bIns="12700">
+            <a:spAutoFit/>
+          </a:bodyPr>
+          <a:lstStyle/>
+          <a:p>
+            <a:pPr algn="r">
+              <a:lnSpc>
+                <a:spcPct val="100000"/>
+              </a:lnSpc>
+              <a:spcBef>
+                <a:spcPts val="0"/>
+              </a:spcBef>
+              <a:spcAft>
+                <a:spcPts val="400"/>
+              </a:spcAft>
+            </a:pPr>
+            <a:r>
+              <a:rPr sz="1100" b="0" i="0">
+                <a:solidFill>
+                  <a:srgbClr val="999999"/>
+                </a:solidFill>
+                <a:latin typeface="Arial"/>
+              </a:rPr>
+              <a:t>of production</a:t>
+            </a:r>
+          </a:p>
+        </p:txBody>
+      </p:sp>
+      <p:sp>
+        <p:nvSpPr>
+          <p:cNvPr id="41" name="Rectangle 40"/>
           <p:cNvSpPr/>
           <p:nvPr/>
         </p:nvSpPr>
         <p:spPr>
           <a:xfrm>
-            <a:off x="7239000" y="1219200"/>
-            <a:ext cx="4572000" cy="4572000"/>
+            <a:off x="7315200" y="1447800"/>
+            <a:ext cx="4495800" cy="2286000"/>
           </a:xfrm>
           <a:prstGeom prst="rect">
             <a:avLst/>
@@ -8421,20 +8718,200 @@
       </p:sp>
       <p:sp>
         <p:nvSpPr>
-          <p:cNvPr id="34" name="Rectangle 33"/>
+          <p:cNvPr id="42" name="TextBox 41"/>
+          <p:cNvSpPr txBox="1"/>
+          <p:nvPr/>
+        </p:nvSpPr>
+        <p:spPr>
+          <a:xfrm>
+            <a:off x="7482840" y="1524000"/>
+            <a:ext cx="1981200" cy="198120"/>
+          </a:xfrm>
+          <a:prstGeom prst="rect">
+            <a:avLst/>
+          </a:prstGeom>
+          <a:noFill/>
+        </p:spPr>
+        <p:txBody>
+          <a:bodyPr wrap="square" anchor="t" lIns="25400" rIns="25400" tIns="12700" bIns="12700">
+            <a:spAutoFit/>
+          </a:bodyPr>
+          <a:lstStyle/>
+          <a:p>
+            <a:pPr algn="l">
+              <a:lnSpc>
+                <a:spcPct val="100000"/>
+              </a:lnSpc>
+              <a:spcBef>
+                <a:spcPts val="0"/>
+              </a:spcBef>
+              <a:spcAft>
+                <a:spcPts val="400"/>
+              </a:spcAft>
+            </a:pPr>
+            <a:r>
+              <a:rPr sz="1200" b="1" i="0">
+                <a:solidFill>
+                  <a:srgbClr val="666666"/>
+                </a:solidFill>
+                <a:latin typeface="Arial"/>
+              </a:rPr>
+              <a:t>Category</a:t>
+            </a:r>
+          </a:p>
+        </p:txBody>
+      </p:sp>
+      <p:sp>
+        <p:nvSpPr>
+          <p:cNvPr id="43" name="TextBox 42"/>
+          <p:cNvSpPr txBox="1"/>
+          <p:nvPr/>
+        </p:nvSpPr>
+        <p:spPr>
+          <a:xfrm>
+            <a:off x="9525000" y="1524000"/>
+            <a:ext cx="731520" cy="198120"/>
+          </a:xfrm>
+          <a:prstGeom prst="rect">
+            <a:avLst/>
+          </a:prstGeom>
+          <a:noFill/>
+        </p:spPr>
+        <p:txBody>
+          <a:bodyPr wrap="square" anchor="t" lIns="25400" rIns="25400" tIns="12700" bIns="12700">
+            <a:spAutoFit/>
+          </a:bodyPr>
+          <a:lstStyle/>
+          <a:p>
+            <a:pPr algn="ctr">
+              <a:lnSpc>
+                <a:spcPct val="100000"/>
+              </a:lnSpc>
+              <a:spcBef>
+                <a:spcPts val="0"/>
+              </a:spcBef>
+              <a:spcAft>
+                <a:spcPts val="400"/>
+              </a:spcAft>
+            </a:pPr>
+            <a:r>
+              <a:rPr sz="1200" b="1" i="0">
+                <a:solidFill>
+                  <a:srgbClr val="666666"/>
+                </a:solidFill>
+                <a:latin typeface="Arial"/>
+              </a:rPr>
+              <a:t>2023</a:t>
+            </a:r>
+          </a:p>
+        </p:txBody>
+      </p:sp>
+      <p:sp>
+        <p:nvSpPr>
+          <p:cNvPr id="44" name="TextBox 43"/>
+          <p:cNvSpPr txBox="1"/>
+          <p:nvPr/>
+        </p:nvSpPr>
+        <p:spPr>
+          <a:xfrm>
+            <a:off x="10302240" y="1524000"/>
+            <a:ext cx="731520" cy="198120"/>
+          </a:xfrm>
+          <a:prstGeom prst="rect">
+            <a:avLst/>
+          </a:prstGeom>
+          <a:noFill/>
+        </p:spPr>
+        <p:txBody>
+          <a:bodyPr wrap="square" anchor="t" lIns="25400" rIns="25400" tIns="12700" bIns="12700">
+            <a:spAutoFit/>
+          </a:bodyPr>
+          <a:lstStyle/>
+          <a:p>
+            <a:pPr algn="ctr">
+              <a:lnSpc>
+                <a:spcPct val="100000"/>
+              </a:lnSpc>
+              <a:spcBef>
+                <a:spcPts val="0"/>
+              </a:spcBef>
+              <a:spcAft>
+                <a:spcPts val="400"/>
+              </a:spcAft>
+            </a:pPr>
+            <a:r>
+              <a:rPr sz="1200" b="1" i="0">
+                <a:solidFill>
+                  <a:srgbClr val="666666"/>
+                </a:solidFill>
+                <a:latin typeface="Arial"/>
+              </a:rPr>
+              <a:t>2024</a:t>
+            </a:r>
+          </a:p>
+        </p:txBody>
+      </p:sp>
+      <p:sp>
+        <p:nvSpPr>
+          <p:cNvPr id="45" name="TextBox 44"/>
+          <p:cNvSpPr txBox="1"/>
+          <p:nvPr/>
+        </p:nvSpPr>
+        <p:spPr>
+          <a:xfrm>
+            <a:off x="11079480" y="1524000"/>
+            <a:ext cx="685800" cy="198120"/>
+          </a:xfrm>
+          <a:prstGeom prst="rect">
+            <a:avLst/>
+          </a:prstGeom>
+          <a:noFill/>
+        </p:spPr>
+        <p:txBody>
+          <a:bodyPr wrap="square" anchor="t" lIns="25400" rIns="25400" tIns="12700" bIns="12700">
+            <a:spAutoFit/>
+          </a:bodyPr>
+          <a:lstStyle/>
+          <a:p>
+            <a:pPr algn="ctr">
+              <a:lnSpc>
+                <a:spcPct val="100000"/>
+              </a:lnSpc>
+              <a:spcBef>
+                <a:spcPts val="0"/>
+              </a:spcBef>
+              <a:spcAft>
+                <a:spcPts val="400"/>
+              </a:spcAft>
+            </a:pPr>
+            <a:r>
+              <a:rPr sz="1200" b="1" i="0">
+                <a:solidFill>
+                  <a:srgbClr val="666666"/>
+                </a:solidFill>
+                <a:latin typeface="Arial"/>
+              </a:rPr>
+              <a:t>Δ pp</a:t>
+            </a:r>
+          </a:p>
+        </p:txBody>
+      </p:sp>
+      <p:sp>
+        <p:nvSpPr>
+          <p:cNvPr id="46" name="Rectangle 45"/>
           <p:cNvSpPr/>
           <p:nvPr/>
         </p:nvSpPr>
         <p:spPr>
           <a:xfrm>
-            <a:off x="7239000" y="1219200"/>
-            <a:ext cx="4572000" cy="350520"/>
+            <a:off x="7482840" y="1752600"/>
+            <a:ext cx="4282440" cy="7620"/>
           </a:xfrm>
           <a:prstGeom prst="rect">
             <a:avLst/>
           </a:prstGeom>
           <a:solidFill>
-            <a:srgbClr val="1F3A5F"/>
+            <a:srgbClr val="DFE4EA"/>
           </a:solidFill>
           <a:ln>
             <a:noFill/>
@@ -8465,14 +8942,14 @@
       </p:sp>
       <p:sp>
         <p:nvSpPr>
-          <p:cNvPr id="35" name="TextBox 34"/>
+          <p:cNvPr id="47" name="TextBox 46"/>
           <p:cNvSpPr txBox="1"/>
           <p:nvPr/>
         </p:nvSpPr>
         <p:spPr>
           <a:xfrm>
-            <a:off x="7406640" y="1219200"/>
-            <a:ext cx="4343400" cy="350520"/>
+            <a:off x="7482840" y="1859280"/>
+            <a:ext cx="2042160" cy="213360"/>
           </a:xfrm>
           <a:prstGeom prst="rect">
             <a:avLst/>
@@ -8497,27 +8974,1162 @@
               </a:spcAft>
             </a:pPr>
             <a:r>
-              <a:rPr sz="1500" b="1" i="0">
-                <a:solidFill>
-                  <a:srgbClr val="FFFFFF"/>
-                </a:solidFill>
-                <a:latin typeface="Arial"/>
-              </a:rPr>
-              <a:t>Cost structure — recap</a:t>
-            </a:r>
-          </a:p>
-        </p:txBody>
-      </p:sp>
-      <p:sp>
-        <p:nvSpPr>
-          <p:cNvPr id="36" name="TextBox 35"/>
+              <a:rPr sz="1200" b="0" i="0">
+                <a:solidFill>
+                  <a:srgbClr val="84BD00"/>
+                </a:solidFill>
+                <a:latin typeface="Arial"/>
+              </a:rPr>
+              <a:t>■ </a:t>
+            </a:r>
+            <a:r>
+              <a:rPr sz="1200" b="1" i="0">
+                <a:solidFill>
+                  <a:srgbClr val="222222"/>
+                </a:solidFill>
+                <a:latin typeface="Arial"/>
+              </a:rPr>
+              <a:t>EBITDA</a:t>
+            </a:r>
+          </a:p>
+        </p:txBody>
+      </p:sp>
+      <p:sp>
+        <p:nvSpPr>
+          <p:cNvPr id="48" name="TextBox 47"/>
           <p:cNvSpPr txBox="1"/>
           <p:nvPr/>
         </p:nvSpPr>
         <p:spPr>
           <a:xfrm>
-            <a:off x="7421880" y="1752600"/>
-            <a:ext cx="4206240" cy="3505200"/>
+            <a:off x="9525000" y="1859280"/>
+            <a:ext cx="731520" cy="213360"/>
+          </a:xfrm>
+          <a:prstGeom prst="rect">
+            <a:avLst/>
+          </a:prstGeom>
+          <a:noFill/>
+        </p:spPr>
+        <p:txBody>
+          <a:bodyPr wrap="square" anchor="ctr" lIns="25400" rIns="25400" tIns="12700" bIns="12700">
+            <a:spAutoFit/>
+          </a:bodyPr>
+          <a:lstStyle/>
+          <a:p>
+            <a:pPr algn="ctr">
+              <a:lnSpc>
+                <a:spcPct val="100000"/>
+              </a:lnSpc>
+              <a:spcBef>
+                <a:spcPts val="0"/>
+              </a:spcBef>
+              <a:spcAft>
+                <a:spcPts val="400"/>
+              </a:spcAft>
+            </a:pPr>
+            <a:r>
+              <a:rPr sz="1200" b="0" i="0">
+                <a:solidFill>
+                  <a:srgbClr val="333333"/>
+                </a:solidFill>
+                <a:latin typeface="Arial"/>
+              </a:rPr>
+              <a:t>7.0%</a:t>
+            </a:r>
+          </a:p>
+        </p:txBody>
+      </p:sp>
+      <p:sp>
+        <p:nvSpPr>
+          <p:cNvPr id="49" name="TextBox 48"/>
+          <p:cNvSpPr txBox="1"/>
+          <p:nvPr/>
+        </p:nvSpPr>
+        <p:spPr>
+          <a:xfrm>
+            <a:off x="10302240" y="1859280"/>
+            <a:ext cx="731520" cy="213360"/>
+          </a:xfrm>
+          <a:prstGeom prst="rect">
+            <a:avLst/>
+          </a:prstGeom>
+          <a:noFill/>
+        </p:spPr>
+        <p:txBody>
+          <a:bodyPr wrap="square" anchor="ctr" lIns="25400" rIns="25400" tIns="12700" bIns="12700">
+            <a:spAutoFit/>
+          </a:bodyPr>
+          <a:lstStyle/>
+          <a:p>
+            <a:pPr algn="ctr">
+              <a:lnSpc>
+                <a:spcPct val="100000"/>
+              </a:lnSpc>
+              <a:spcBef>
+                <a:spcPts val="0"/>
+              </a:spcBef>
+              <a:spcAft>
+                <a:spcPts val="400"/>
+              </a:spcAft>
+            </a:pPr>
+            <a:r>
+              <a:rPr sz="1200" b="0" i="0">
+                <a:solidFill>
+                  <a:srgbClr val="333333"/>
+                </a:solidFill>
+                <a:latin typeface="Arial"/>
+              </a:rPr>
+              <a:t>3.8%</a:t>
+            </a:r>
+          </a:p>
+        </p:txBody>
+      </p:sp>
+      <p:sp>
+        <p:nvSpPr>
+          <p:cNvPr id="50" name="TextBox 49"/>
+          <p:cNvSpPr txBox="1"/>
+          <p:nvPr/>
+        </p:nvSpPr>
+        <p:spPr>
+          <a:xfrm>
+            <a:off x="11079480" y="1859280"/>
+            <a:ext cx="685800" cy="213360"/>
+          </a:xfrm>
+          <a:prstGeom prst="rect">
+            <a:avLst/>
+          </a:prstGeom>
+          <a:noFill/>
+        </p:spPr>
+        <p:txBody>
+          <a:bodyPr wrap="square" anchor="ctr" lIns="25400" rIns="25400" tIns="12700" bIns="12700">
+            <a:spAutoFit/>
+          </a:bodyPr>
+          <a:lstStyle/>
+          <a:p>
+            <a:pPr algn="ctr">
+              <a:lnSpc>
+                <a:spcPct val="100000"/>
+              </a:lnSpc>
+              <a:spcBef>
+                <a:spcPts val="0"/>
+              </a:spcBef>
+              <a:spcAft>
+                <a:spcPts val="400"/>
+              </a:spcAft>
+            </a:pPr>
+            <a:r>
+              <a:rPr sz="1200" b="1" i="0">
+                <a:solidFill>
+                  <a:srgbClr val="C8102E"/>
+                </a:solidFill>
+                <a:latin typeface="Arial"/>
+              </a:rPr>
+              <a:t>-3.2</a:t>
+            </a:r>
+          </a:p>
+        </p:txBody>
+      </p:sp>
+      <p:sp>
+        <p:nvSpPr>
+          <p:cNvPr id="51" name="TextBox 50"/>
+          <p:cNvSpPr txBox="1"/>
+          <p:nvPr/>
+        </p:nvSpPr>
+        <p:spPr>
+          <a:xfrm>
+            <a:off x="7482840" y="2133600"/>
+            <a:ext cx="2042160" cy="213360"/>
+          </a:xfrm>
+          <a:prstGeom prst="rect">
+            <a:avLst/>
+          </a:prstGeom>
+          <a:noFill/>
+        </p:spPr>
+        <p:txBody>
+          <a:bodyPr wrap="square" anchor="ctr" lIns="25400" rIns="25400" tIns="12700" bIns="12700">
+            <a:spAutoFit/>
+          </a:bodyPr>
+          <a:lstStyle/>
+          <a:p>
+            <a:pPr algn="l">
+              <a:lnSpc>
+                <a:spcPct val="100000"/>
+              </a:lnSpc>
+              <a:spcBef>
+                <a:spcPts val="0"/>
+              </a:spcBef>
+              <a:spcAft>
+                <a:spcPts val="400"/>
+              </a:spcAft>
+            </a:pPr>
+            <a:r>
+              <a:rPr sz="1200" b="0" i="0">
+                <a:solidFill>
+                  <a:srgbClr val="F2A100"/>
+                </a:solidFill>
+                <a:latin typeface="Arial"/>
+              </a:rPr>
+              <a:t>■ </a:t>
+            </a:r>
+            <a:r>
+              <a:rPr sz="1200" b="1" i="0">
+                <a:solidFill>
+                  <a:srgbClr val="222222"/>
+                </a:solidFill>
+                <a:latin typeface="Arial"/>
+              </a:rPr>
+              <a:t>Materials</a:t>
+            </a:r>
+          </a:p>
+        </p:txBody>
+      </p:sp>
+      <p:sp>
+        <p:nvSpPr>
+          <p:cNvPr id="52" name="TextBox 51"/>
+          <p:cNvSpPr txBox="1"/>
+          <p:nvPr/>
+        </p:nvSpPr>
+        <p:spPr>
+          <a:xfrm>
+            <a:off x="9525000" y="2133600"/>
+            <a:ext cx="731520" cy="213360"/>
+          </a:xfrm>
+          <a:prstGeom prst="rect">
+            <a:avLst/>
+          </a:prstGeom>
+          <a:noFill/>
+        </p:spPr>
+        <p:txBody>
+          <a:bodyPr wrap="square" anchor="ctr" lIns="25400" rIns="25400" tIns="12700" bIns="12700">
+            <a:spAutoFit/>
+          </a:bodyPr>
+          <a:lstStyle/>
+          <a:p>
+            <a:pPr algn="ctr">
+              <a:lnSpc>
+                <a:spcPct val="100000"/>
+              </a:lnSpc>
+              <a:spcBef>
+                <a:spcPts val="0"/>
+              </a:spcBef>
+              <a:spcAft>
+                <a:spcPts val="400"/>
+              </a:spcAft>
+            </a:pPr>
+            <a:r>
+              <a:rPr sz="1200" b="0" i="0">
+                <a:solidFill>
+                  <a:srgbClr val="333333"/>
+                </a:solidFill>
+                <a:latin typeface="Arial"/>
+              </a:rPr>
+              <a:t>46.0%</a:t>
+            </a:r>
+          </a:p>
+        </p:txBody>
+      </p:sp>
+      <p:sp>
+        <p:nvSpPr>
+          <p:cNvPr id="53" name="TextBox 52"/>
+          <p:cNvSpPr txBox="1"/>
+          <p:nvPr/>
+        </p:nvSpPr>
+        <p:spPr>
+          <a:xfrm>
+            <a:off x="10302240" y="2133600"/>
+            <a:ext cx="731520" cy="213360"/>
+          </a:xfrm>
+          <a:prstGeom prst="rect">
+            <a:avLst/>
+          </a:prstGeom>
+          <a:noFill/>
+        </p:spPr>
+        <p:txBody>
+          <a:bodyPr wrap="square" anchor="ctr" lIns="25400" rIns="25400" tIns="12700" bIns="12700">
+            <a:spAutoFit/>
+          </a:bodyPr>
+          <a:lstStyle/>
+          <a:p>
+            <a:pPr algn="ctr">
+              <a:lnSpc>
+                <a:spcPct val="100000"/>
+              </a:lnSpc>
+              <a:spcBef>
+                <a:spcPts val="0"/>
+              </a:spcBef>
+              <a:spcAft>
+                <a:spcPts val="400"/>
+              </a:spcAft>
+            </a:pPr>
+            <a:r>
+              <a:rPr sz="1200" b="0" i="0">
+                <a:solidFill>
+                  <a:srgbClr val="333333"/>
+                </a:solidFill>
+                <a:latin typeface="Arial"/>
+              </a:rPr>
+              <a:t>38.4%</a:t>
+            </a:r>
+          </a:p>
+        </p:txBody>
+      </p:sp>
+      <p:sp>
+        <p:nvSpPr>
+          <p:cNvPr id="54" name="TextBox 53"/>
+          <p:cNvSpPr txBox="1"/>
+          <p:nvPr/>
+        </p:nvSpPr>
+        <p:spPr>
+          <a:xfrm>
+            <a:off x="11079480" y="2133600"/>
+            <a:ext cx="685800" cy="213360"/>
+          </a:xfrm>
+          <a:prstGeom prst="rect">
+            <a:avLst/>
+          </a:prstGeom>
+          <a:noFill/>
+        </p:spPr>
+        <p:txBody>
+          <a:bodyPr wrap="square" anchor="ctr" lIns="25400" rIns="25400" tIns="12700" bIns="12700">
+            <a:spAutoFit/>
+          </a:bodyPr>
+          <a:lstStyle/>
+          <a:p>
+            <a:pPr algn="ctr">
+              <a:lnSpc>
+                <a:spcPct val="100000"/>
+              </a:lnSpc>
+              <a:spcBef>
+                <a:spcPts val="0"/>
+              </a:spcBef>
+              <a:spcAft>
+                <a:spcPts val="400"/>
+              </a:spcAft>
+            </a:pPr>
+            <a:r>
+              <a:rPr sz="1200" b="1" i="0">
+                <a:solidFill>
+                  <a:srgbClr val="2E7D4F"/>
+                </a:solidFill>
+                <a:latin typeface="Arial"/>
+              </a:rPr>
+              <a:t>-7.6</a:t>
+            </a:r>
+          </a:p>
+        </p:txBody>
+      </p:sp>
+      <p:sp>
+        <p:nvSpPr>
+          <p:cNvPr id="55" name="TextBox 54"/>
+          <p:cNvSpPr txBox="1"/>
+          <p:nvPr/>
+        </p:nvSpPr>
+        <p:spPr>
+          <a:xfrm>
+            <a:off x="7482840" y="2407920"/>
+            <a:ext cx="2042160" cy="213360"/>
+          </a:xfrm>
+          <a:prstGeom prst="rect">
+            <a:avLst/>
+          </a:prstGeom>
+          <a:noFill/>
+        </p:spPr>
+        <p:txBody>
+          <a:bodyPr wrap="square" anchor="ctr" lIns="25400" rIns="25400" tIns="12700" bIns="12700">
+            <a:spAutoFit/>
+          </a:bodyPr>
+          <a:lstStyle/>
+          <a:p>
+            <a:pPr algn="l">
+              <a:lnSpc>
+                <a:spcPct val="100000"/>
+              </a:lnSpc>
+              <a:spcBef>
+                <a:spcPts val="0"/>
+              </a:spcBef>
+              <a:spcAft>
+                <a:spcPts val="400"/>
+              </a:spcAft>
+            </a:pPr>
+            <a:r>
+              <a:rPr sz="1200" b="0" i="0">
+                <a:solidFill>
+                  <a:srgbClr val="D9531E"/>
+                </a:solidFill>
+                <a:latin typeface="Arial"/>
+              </a:rPr>
+              <a:t>■ </a:t>
+            </a:r>
+            <a:r>
+              <a:rPr sz="1200" b="1" i="0">
+                <a:solidFill>
+                  <a:srgbClr val="222222"/>
+                </a:solidFill>
+                <a:latin typeface="Arial"/>
+              </a:rPr>
+              <a:t>Personnel</a:t>
+            </a:r>
+          </a:p>
+        </p:txBody>
+      </p:sp>
+      <p:sp>
+        <p:nvSpPr>
+          <p:cNvPr id="56" name="TextBox 55"/>
+          <p:cNvSpPr txBox="1"/>
+          <p:nvPr/>
+        </p:nvSpPr>
+        <p:spPr>
+          <a:xfrm>
+            <a:off x="9525000" y="2407920"/>
+            <a:ext cx="731520" cy="213360"/>
+          </a:xfrm>
+          <a:prstGeom prst="rect">
+            <a:avLst/>
+          </a:prstGeom>
+          <a:noFill/>
+        </p:spPr>
+        <p:txBody>
+          <a:bodyPr wrap="square" anchor="ctr" lIns="25400" rIns="25400" tIns="12700" bIns="12700">
+            <a:spAutoFit/>
+          </a:bodyPr>
+          <a:lstStyle/>
+          <a:p>
+            <a:pPr algn="ctr">
+              <a:lnSpc>
+                <a:spcPct val="100000"/>
+              </a:lnSpc>
+              <a:spcBef>
+                <a:spcPts val="0"/>
+              </a:spcBef>
+              <a:spcAft>
+                <a:spcPts val="400"/>
+              </a:spcAft>
+            </a:pPr>
+            <a:r>
+              <a:rPr sz="1200" b="0" i="0">
+                <a:solidFill>
+                  <a:srgbClr val="333333"/>
+                </a:solidFill>
+                <a:latin typeface="Arial"/>
+              </a:rPr>
+              <a:t>23.1%</a:t>
+            </a:r>
+          </a:p>
+        </p:txBody>
+      </p:sp>
+      <p:sp>
+        <p:nvSpPr>
+          <p:cNvPr id="57" name="TextBox 56"/>
+          <p:cNvSpPr txBox="1"/>
+          <p:nvPr/>
+        </p:nvSpPr>
+        <p:spPr>
+          <a:xfrm>
+            <a:off x="10302240" y="2407920"/>
+            <a:ext cx="731520" cy="213360"/>
+          </a:xfrm>
+          <a:prstGeom prst="rect">
+            <a:avLst/>
+          </a:prstGeom>
+          <a:noFill/>
+        </p:spPr>
+        <p:txBody>
+          <a:bodyPr wrap="square" anchor="ctr" lIns="25400" rIns="25400" tIns="12700" bIns="12700">
+            <a:spAutoFit/>
+          </a:bodyPr>
+          <a:lstStyle/>
+          <a:p>
+            <a:pPr algn="ctr">
+              <a:lnSpc>
+                <a:spcPct val="100000"/>
+              </a:lnSpc>
+              <a:spcBef>
+                <a:spcPts val="0"/>
+              </a:spcBef>
+              <a:spcAft>
+                <a:spcPts val="400"/>
+              </a:spcAft>
+            </a:pPr>
+            <a:r>
+              <a:rPr sz="1200" b="0" i="0">
+                <a:solidFill>
+                  <a:srgbClr val="333333"/>
+                </a:solidFill>
+                <a:latin typeface="Arial"/>
+              </a:rPr>
+              <a:t>30.3%</a:t>
+            </a:r>
+          </a:p>
+        </p:txBody>
+      </p:sp>
+      <p:sp>
+        <p:nvSpPr>
+          <p:cNvPr id="58" name="TextBox 57"/>
+          <p:cNvSpPr txBox="1"/>
+          <p:nvPr/>
+        </p:nvSpPr>
+        <p:spPr>
+          <a:xfrm>
+            <a:off x="11079480" y="2407920"/>
+            <a:ext cx="685800" cy="213360"/>
+          </a:xfrm>
+          <a:prstGeom prst="rect">
+            <a:avLst/>
+          </a:prstGeom>
+          <a:noFill/>
+        </p:spPr>
+        <p:txBody>
+          <a:bodyPr wrap="square" anchor="ctr" lIns="25400" rIns="25400" tIns="12700" bIns="12700">
+            <a:spAutoFit/>
+          </a:bodyPr>
+          <a:lstStyle/>
+          <a:p>
+            <a:pPr algn="ctr">
+              <a:lnSpc>
+                <a:spcPct val="100000"/>
+              </a:lnSpc>
+              <a:spcBef>
+                <a:spcPts val="0"/>
+              </a:spcBef>
+              <a:spcAft>
+                <a:spcPts val="400"/>
+              </a:spcAft>
+            </a:pPr>
+            <a:r>
+              <a:rPr sz="1200" b="1" i="0">
+                <a:solidFill>
+                  <a:srgbClr val="C8102E"/>
+                </a:solidFill>
+                <a:latin typeface="Arial"/>
+              </a:rPr>
+              <a:t>+7.2</a:t>
+            </a:r>
+          </a:p>
+        </p:txBody>
+      </p:sp>
+      <p:sp>
+        <p:nvSpPr>
+          <p:cNvPr id="59" name="TextBox 58"/>
+          <p:cNvSpPr txBox="1"/>
+          <p:nvPr/>
+        </p:nvSpPr>
+        <p:spPr>
+          <a:xfrm>
+            <a:off x="7482840" y="2682240"/>
+            <a:ext cx="2042160" cy="213360"/>
+          </a:xfrm>
+          <a:prstGeom prst="rect">
+            <a:avLst/>
+          </a:prstGeom>
+          <a:noFill/>
+        </p:spPr>
+        <p:txBody>
+          <a:bodyPr wrap="square" anchor="ctr" lIns="25400" rIns="25400" tIns="12700" bIns="12700">
+            <a:spAutoFit/>
+          </a:bodyPr>
+          <a:lstStyle/>
+          <a:p>
+            <a:pPr algn="l">
+              <a:lnSpc>
+                <a:spcPct val="100000"/>
+              </a:lnSpc>
+              <a:spcBef>
+                <a:spcPts val="0"/>
+              </a:spcBef>
+              <a:spcAft>
+                <a:spcPts val="400"/>
+              </a:spcAft>
+            </a:pPr>
+            <a:r>
+              <a:rPr sz="1200" b="0" i="0">
+                <a:solidFill>
+                  <a:srgbClr val="3C7DA6"/>
+                </a:solidFill>
+                <a:latin typeface="Arial"/>
+              </a:rPr>
+              <a:t>■ </a:t>
+            </a:r>
+            <a:r>
+              <a:rPr sz="1200" b="1" i="0">
+                <a:solidFill>
+                  <a:srgbClr val="222222"/>
+                </a:solidFill>
+                <a:latin typeface="Arial"/>
+              </a:rPr>
+              <a:t>Services</a:t>
+            </a:r>
+          </a:p>
+        </p:txBody>
+      </p:sp>
+      <p:sp>
+        <p:nvSpPr>
+          <p:cNvPr id="60" name="TextBox 59"/>
+          <p:cNvSpPr txBox="1"/>
+          <p:nvPr/>
+        </p:nvSpPr>
+        <p:spPr>
+          <a:xfrm>
+            <a:off x="9525000" y="2682240"/>
+            <a:ext cx="731520" cy="213360"/>
+          </a:xfrm>
+          <a:prstGeom prst="rect">
+            <a:avLst/>
+          </a:prstGeom>
+          <a:noFill/>
+        </p:spPr>
+        <p:txBody>
+          <a:bodyPr wrap="square" anchor="ctr" lIns="25400" rIns="25400" tIns="12700" bIns="12700">
+            <a:spAutoFit/>
+          </a:bodyPr>
+          <a:lstStyle/>
+          <a:p>
+            <a:pPr algn="ctr">
+              <a:lnSpc>
+                <a:spcPct val="100000"/>
+              </a:lnSpc>
+              <a:spcBef>
+                <a:spcPts val="0"/>
+              </a:spcBef>
+              <a:spcAft>
+                <a:spcPts val="400"/>
+              </a:spcAft>
+            </a:pPr>
+            <a:r>
+              <a:rPr sz="1200" b="0" i="0">
+                <a:solidFill>
+                  <a:srgbClr val="333333"/>
+                </a:solidFill>
+                <a:latin typeface="Arial"/>
+              </a:rPr>
+              <a:t>19.9%</a:t>
+            </a:r>
+          </a:p>
+        </p:txBody>
+      </p:sp>
+      <p:sp>
+        <p:nvSpPr>
+          <p:cNvPr id="61" name="TextBox 60"/>
+          <p:cNvSpPr txBox="1"/>
+          <p:nvPr/>
+        </p:nvSpPr>
+        <p:spPr>
+          <a:xfrm>
+            <a:off x="10302240" y="2682240"/>
+            <a:ext cx="731520" cy="213360"/>
+          </a:xfrm>
+          <a:prstGeom prst="rect">
+            <a:avLst/>
+          </a:prstGeom>
+          <a:noFill/>
+        </p:spPr>
+        <p:txBody>
+          <a:bodyPr wrap="square" anchor="ctr" lIns="25400" rIns="25400" tIns="12700" bIns="12700">
+            <a:spAutoFit/>
+          </a:bodyPr>
+          <a:lstStyle/>
+          <a:p>
+            <a:pPr algn="ctr">
+              <a:lnSpc>
+                <a:spcPct val="100000"/>
+              </a:lnSpc>
+              <a:spcBef>
+                <a:spcPts val="0"/>
+              </a:spcBef>
+              <a:spcAft>
+                <a:spcPts val="400"/>
+              </a:spcAft>
+            </a:pPr>
+            <a:r>
+              <a:rPr sz="1200" b="0" i="0">
+                <a:solidFill>
+                  <a:srgbClr val="333333"/>
+                </a:solidFill>
+                <a:latin typeface="Arial"/>
+              </a:rPr>
+              <a:t>22.8%</a:t>
+            </a:r>
+          </a:p>
+        </p:txBody>
+      </p:sp>
+      <p:sp>
+        <p:nvSpPr>
+          <p:cNvPr id="62" name="TextBox 61"/>
+          <p:cNvSpPr txBox="1"/>
+          <p:nvPr/>
+        </p:nvSpPr>
+        <p:spPr>
+          <a:xfrm>
+            <a:off x="11079480" y="2682240"/>
+            <a:ext cx="685800" cy="213360"/>
+          </a:xfrm>
+          <a:prstGeom prst="rect">
+            <a:avLst/>
+          </a:prstGeom>
+          <a:noFill/>
+        </p:spPr>
+        <p:txBody>
+          <a:bodyPr wrap="square" anchor="ctr" lIns="25400" rIns="25400" tIns="12700" bIns="12700">
+            <a:spAutoFit/>
+          </a:bodyPr>
+          <a:lstStyle/>
+          <a:p>
+            <a:pPr algn="ctr">
+              <a:lnSpc>
+                <a:spcPct val="100000"/>
+              </a:lnSpc>
+              <a:spcBef>
+                <a:spcPts val="0"/>
+              </a:spcBef>
+              <a:spcAft>
+                <a:spcPts val="400"/>
+              </a:spcAft>
+            </a:pPr>
+            <a:r>
+              <a:rPr sz="1200" b="1" i="0">
+                <a:solidFill>
+                  <a:srgbClr val="C8102E"/>
+                </a:solidFill>
+                <a:latin typeface="Arial"/>
+              </a:rPr>
+              <a:t>+2.9</a:t>
+            </a:r>
+          </a:p>
+        </p:txBody>
+      </p:sp>
+      <p:sp>
+        <p:nvSpPr>
+          <p:cNvPr id="63" name="TextBox 62"/>
+          <p:cNvSpPr txBox="1"/>
+          <p:nvPr/>
+        </p:nvSpPr>
+        <p:spPr>
+          <a:xfrm>
+            <a:off x="7482840" y="2956560"/>
+            <a:ext cx="2042160" cy="213360"/>
+          </a:xfrm>
+          <a:prstGeom prst="rect">
+            <a:avLst/>
+          </a:prstGeom>
+          <a:noFill/>
+        </p:spPr>
+        <p:txBody>
+          <a:bodyPr wrap="square" anchor="ctr" lIns="25400" rIns="25400" tIns="12700" bIns="12700">
+            <a:spAutoFit/>
+          </a:bodyPr>
+          <a:lstStyle/>
+          <a:p>
+            <a:pPr algn="l">
+              <a:lnSpc>
+                <a:spcPct val="100000"/>
+              </a:lnSpc>
+              <a:spcBef>
+                <a:spcPts val="0"/>
+              </a:spcBef>
+              <a:spcAft>
+                <a:spcPts val="400"/>
+              </a:spcAft>
+            </a:pPr>
+            <a:r>
+              <a:rPr sz="1200" b="0" i="0">
+                <a:solidFill>
+                  <a:srgbClr val="8C5A2B"/>
+                </a:solidFill>
+                <a:latin typeface="Arial"/>
+              </a:rPr>
+              <a:t>■ </a:t>
+            </a:r>
+            <a:r>
+              <a:rPr sz="1200" b="1" i="0">
+                <a:solidFill>
+                  <a:srgbClr val="222222"/>
+                </a:solidFill>
+                <a:latin typeface="Arial"/>
+              </a:rPr>
+              <a:t>Lease &amp; rentals</a:t>
+            </a:r>
+          </a:p>
+        </p:txBody>
+      </p:sp>
+      <p:sp>
+        <p:nvSpPr>
+          <p:cNvPr id="64" name="TextBox 63"/>
+          <p:cNvSpPr txBox="1"/>
+          <p:nvPr/>
+        </p:nvSpPr>
+        <p:spPr>
+          <a:xfrm>
+            <a:off x="9525000" y="2956560"/>
+            <a:ext cx="731520" cy="213360"/>
+          </a:xfrm>
+          <a:prstGeom prst="rect">
+            <a:avLst/>
+          </a:prstGeom>
+          <a:noFill/>
+        </p:spPr>
+        <p:txBody>
+          <a:bodyPr wrap="square" anchor="ctr" lIns="25400" rIns="25400" tIns="12700" bIns="12700">
+            <a:spAutoFit/>
+          </a:bodyPr>
+          <a:lstStyle/>
+          <a:p>
+            <a:pPr algn="ctr">
+              <a:lnSpc>
+                <a:spcPct val="100000"/>
+              </a:lnSpc>
+              <a:spcBef>
+                <a:spcPts val="0"/>
+              </a:spcBef>
+              <a:spcAft>
+                <a:spcPts val="400"/>
+              </a:spcAft>
+            </a:pPr>
+            <a:r>
+              <a:rPr sz="1200" b="0" i="0">
+                <a:solidFill>
+                  <a:srgbClr val="333333"/>
+                </a:solidFill>
+                <a:latin typeface="Arial"/>
+              </a:rPr>
+              <a:t>3.8%</a:t>
+            </a:r>
+          </a:p>
+        </p:txBody>
+      </p:sp>
+      <p:sp>
+        <p:nvSpPr>
+          <p:cNvPr id="65" name="TextBox 64"/>
+          <p:cNvSpPr txBox="1"/>
+          <p:nvPr/>
+        </p:nvSpPr>
+        <p:spPr>
+          <a:xfrm>
+            <a:off x="10302240" y="2956560"/>
+            <a:ext cx="731520" cy="213360"/>
+          </a:xfrm>
+          <a:prstGeom prst="rect">
+            <a:avLst/>
+          </a:prstGeom>
+          <a:noFill/>
+        </p:spPr>
+        <p:txBody>
+          <a:bodyPr wrap="square" anchor="ctr" lIns="25400" rIns="25400" tIns="12700" bIns="12700">
+            <a:spAutoFit/>
+          </a:bodyPr>
+          <a:lstStyle/>
+          <a:p>
+            <a:pPr algn="ctr">
+              <a:lnSpc>
+                <a:spcPct val="100000"/>
+              </a:lnSpc>
+              <a:spcBef>
+                <a:spcPts val="0"/>
+              </a:spcBef>
+              <a:spcAft>
+                <a:spcPts val="400"/>
+              </a:spcAft>
+            </a:pPr>
+            <a:r>
+              <a:rPr sz="1200" b="0" i="0">
+                <a:solidFill>
+                  <a:srgbClr val="333333"/>
+                </a:solidFill>
+                <a:latin typeface="Arial"/>
+              </a:rPr>
+              <a:t>4.2%</a:t>
+            </a:r>
+          </a:p>
+        </p:txBody>
+      </p:sp>
+      <p:sp>
+        <p:nvSpPr>
+          <p:cNvPr id="66" name="TextBox 65"/>
+          <p:cNvSpPr txBox="1"/>
+          <p:nvPr/>
+        </p:nvSpPr>
+        <p:spPr>
+          <a:xfrm>
+            <a:off x="11079480" y="2956560"/>
+            <a:ext cx="685800" cy="213360"/>
+          </a:xfrm>
+          <a:prstGeom prst="rect">
+            <a:avLst/>
+          </a:prstGeom>
+          <a:noFill/>
+        </p:spPr>
+        <p:txBody>
+          <a:bodyPr wrap="square" anchor="ctr" lIns="25400" rIns="25400" tIns="12700" bIns="12700">
+            <a:spAutoFit/>
+          </a:bodyPr>
+          <a:lstStyle/>
+          <a:p>
+            <a:pPr algn="ctr">
+              <a:lnSpc>
+                <a:spcPct val="100000"/>
+              </a:lnSpc>
+              <a:spcBef>
+                <a:spcPts val="0"/>
+              </a:spcBef>
+              <a:spcAft>
+                <a:spcPts val="400"/>
+              </a:spcAft>
+            </a:pPr>
+            <a:r>
+              <a:rPr sz="1200" b="1" i="0">
+                <a:solidFill>
+                  <a:srgbClr val="C8102E"/>
+                </a:solidFill>
+                <a:latin typeface="Arial"/>
+              </a:rPr>
+              <a:t>+0.4</a:t>
+            </a:r>
+          </a:p>
+        </p:txBody>
+      </p:sp>
+      <p:sp>
+        <p:nvSpPr>
+          <p:cNvPr id="67" name="TextBox 66"/>
+          <p:cNvSpPr txBox="1"/>
+          <p:nvPr/>
+        </p:nvSpPr>
+        <p:spPr>
+          <a:xfrm>
+            <a:off x="7482840" y="3230880"/>
+            <a:ext cx="2042160" cy="213360"/>
+          </a:xfrm>
+          <a:prstGeom prst="rect">
+            <a:avLst/>
+          </a:prstGeom>
+          <a:noFill/>
+        </p:spPr>
+        <p:txBody>
+          <a:bodyPr wrap="square" anchor="ctr" lIns="25400" rIns="25400" tIns="12700" bIns="12700">
+            <a:spAutoFit/>
+          </a:bodyPr>
+          <a:lstStyle/>
+          <a:p>
+            <a:pPr algn="l">
+              <a:lnSpc>
+                <a:spcPct val="100000"/>
+              </a:lnSpc>
+              <a:spcBef>
+                <a:spcPts val="0"/>
+              </a:spcBef>
+              <a:spcAft>
+                <a:spcPts val="400"/>
+              </a:spcAft>
+            </a:pPr>
+            <a:r>
+              <a:rPr sz="1200" b="0" i="0">
+                <a:solidFill>
+                  <a:srgbClr val="BFBFBF"/>
+                </a:solidFill>
+                <a:latin typeface="Arial"/>
+              </a:rPr>
+              <a:t>■ </a:t>
+            </a:r>
+            <a:r>
+              <a:rPr sz="1200" b="1" i="0">
+                <a:solidFill>
+                  <a:srgbClr val="222222"/>
+                </a:solidFill>
+                <a:latin typeface="Arial"/>
+              </a:rPr>
+              <a:t>Other op. costs</a:t>
+            </a:r>
+          </a:p>
+        </p:txBody>
+      </p:sp>
+      <p:sp>
+        <p:nvSpPr>
+          <p:cNvPr id="68" name="TextBox 67"/>
+          <p:cNvSpPr txBox="1"/>
+          <p:nvPr/>
+        </p:nvSpPr>
+        <p:spPr>
+          <a:xfrm>
+            <a:off x="9525000" y="3230880"/>
+            <a:ext cx="731520" cy="213360"/>
+          </a:xfrm>
+          <a:prstGeom prst="rect">
+            <a:avLst/>
+          </a:prstGeom>
+          <a:noFill/>
+        </p:spPr>
+        <p:txBody>
+          <a:bodyPr wrap="square" anchor="ctr" lIns="25400" rIns="25400" tIns="12700" bIns="12700">
+            <a:spAutoFit/>
+          </a:bodyPr>
+          <a:lstStyle/>
+          <a:p>
+            <a:pPr algn="ctr">
+              <a:lnSpc>
+                <a:spcPct val="100000"/>
+              </a:lnSpc>
+              <a:spcBef>
+                <a:spcPts val="0"/>
+              </a:spcBef>
+              <a:spcAft>
+                <a:spcPts val="400"/>
+              </a:spcAft>
+            </a:pPr>
+            <a:r>
+              <a:rPr sz="1200" b="0" i="0">
+                <a:solidFill>
+                  <a:srgbClr val="333333"/>
+                </a:solidFill>
+                <a:latin typeface="Arial"/>
+              </a:rPr>
+              <a:t>0.3%</a:t>
+            </a:r>
+          </a:p>
+        </p:txBody>
+      </p:sp>
+      <p:sp>
+        <p:nvSpPr>
+          <p:cNvPr id="69" name="TextBox 68"/>
+          <p:cNvSpPr txBox="1"/>
+          <p:nvPr/>
+        </p:nvSpPr>
+        <p:spPr>
+          <a:xfrm>
+            <a:off x="10302240" y="3230880"/>
+            <a:ext cx="731520" cy="213360"/>
+          </a:xfrm>
+          <a:prstGeom prst="rect">
+            <a:avLst/>
+          </a:prstGeom>
+          <a:noFill/>
+        </p:spPr>
+        <p:txBody>
+          <a:bodyPr wrap="square" anchor="ctr" lIns="25400" rIns="25400" tIns="12700" bIns="12700">
+            <a:spAutoFit/>
+          </a:bodyPr>
+          <a:lstStyle/>
+          <a:p>
+            <a:pPr algn="ctr">
+              <a:lnSpc>
+                <a:spcPct val="100000"/>
+              </a:lnSpc>
+              <a:spcBef>
+                <a:spcPts val="0"/>
+              </a:spcBef>
+              <a:spcAft>
+                <a:spcPts val="400"/>
+              </a:spcAft>
+            </a:pPr>
+            <a:r>
+              <a:rPr sz="1200" b="0" i="0">
+                <a:solidFill>
+                  <a:srgbClr val="333333"/>
+                </a:solidFill>
+                <a:latin typeface="Arial"/>
+              </a:rPr>
+              <a:t>0.5%</a:t>
+            </a:r>
+          </a:p>
+        </p:txBody>
+      </p:sp>
+      <p:sp>
+        <p:nvSpPr>
+          <p:cNvPr id="70" name="TextBox 69"/>
+          <p:cNvSpPr txBox="1"/>
+          <p:nvPr/>
+        </p:nvSpPr>
+        <p:spPr>
+          <a:xfrm>
+            <a:off x="11079480" y="3230880"/>
+            <a:ext cx="685800" cy="213360"/>
+          </a:xfrm>
+          <a:prstGeom prst="rect">
+            <a:avLst/>
+          </a:prstGeom>
+          <a:noFill/>
+        </p:spPr>
+        <p:txBody>
+          <a:bodyPr wrap="square" anchor="ctr" lIns="25400" rIns="25400" tIns="12700" bIns="12700">
+            <a:spAutoFit/>
+          </a:bodyPr>
+          <a:lstStyle/>
+          <a:p>
+            <a:pPr algn="ctr">
+              <a:lnSpc>
+                <a:spcPct val="100000"/>
+              </a:lnSpc>
+              <a:spcBef>
+                <a:spcPts val="0"/>
+              </a:spcBef>
+              <a:spcAft>
+                <a:spcPts val="400"/>
+              </a:spcAft>
+            </a:pPr>
+            <a:r>
+              <a:rPr sz="1200" b="1" i="0">
+                <a:solidFill>
+                  <a:srgbClr val="C8102E"/>
+                </a:solidFill>
+                <a:latin typeface="Arial"/>
+              </a:rPr>
+              <a:t>+0.2</a:t>
+            </a:r>
+          </a:p>
+        </p:txBody>
+      </p:sp>
+      <p:sp>
+        <p:nvSpPr>
+          <p:cNvPr id="71" name="Rectangle 70"/>
+          <p:cNvSpPr/>
+          <p:nvPr/>
+        </p:nvSpPr>
+        <p:spPr>
+          <a:xfrm>
+            <a:off x="7315200" y="3848100"/>
+            <a:ext cx="4495800" cy="1143000"/>
+          </a:xfrm>
+          <a:prstGeom prst="rect">
+            <a:avLst/>
+          </a:prstGeom>
+          <a:solidFill>
+            <a:srgbClr val="EEF2F7"/>
+          </a:solidFill>
+          <a:ln w="12700">
+            <a:solidFill>
+              <a:srgbClr val="CDD8E6"/>
+            </a:solidFill>
+          </a:ln>
+          <a:effectLst/>
+        </p:spPr>
+        <p:style>
+          <a:lnRef idx="1">
+            <a:schemeClr val="accent1"/>
+          </a:lnRef>
+          <a:fillRef idx="3">
+            <a:schemeClr val="accent1"/>
+          </a:fillRef>
+          <a:effectRef idx="2">
+            <a:schemeClr val="accent1"/>
+          </a:effectRef>
+          <a:fontRef idx="minor">
+            <a:schemeClr val="lt1"/>
+          </a:fontRef>
+        </p:style>
+        <p:txBody>
+          <a:bodyPr rtlCol="0" anchor="ctr"/>
+          <a:lstStyle/>
+          <a:p>
+            <a:pPr algn="ctr"/>
+          </a:p>
+        </p:txBody>
+      </p:sp>
+      <p:sp>
+        <p:nvSpPr>
+          <p:cNvPr id="72" name="TextBox 71"/>
+          <p:cNvSpPr txBox="1"/>
+          <p:nvPr/>
+        </p:nvSpPr>
+        <p:spPr>
+          <a:xfrm>
+            <a:off x="7482840" y="3939540"/>
+            <a:ext cx="4160520" cy="990600"/>
           </a:xfrm>
           <a:prstGeom prst="rect">
             <a:avLst/>
@@ -8538,280 +10150,98 @@
                 <a:spcPts val="0"/>
               </a:spcBef>
               <a:spcAft>
-                <a:spcPts val="1300"/>
-              </a:spcAft>
-            </a:pPr>
-            <a:r>
-              <a:rPr sz="1700" b="0" i="0">
-                <a:solidFill>
-                  <a:srgbClr val="84BD00"/>
-                </a:solidFill>
-                <a:latin typeface="Arial"/>
-              </a:rPr>
-              <a:t>■  </a:t>
-            </a:r>
-            <a:r>
-              <a:rPr sz="1500" b="1" i="0">
-                <a:solidFill>
-                  <a:srgbClr val="222222"/>
-                </a:solidFill>
-                <a:latin typeface="Arial"/>
-              </a:rPr>
-              <a:t>EBITDA</a:t>
-            </a:r>
-            <a:r>
-              <a:rPr sz="1500" b="0" i="0">
+                <a:spcPts val="600"/>
+              </a:spcAft>
+            </a:pPr>
+            <a:r>
+              <a:rPr sz="1400" b="1" i="0">
+                <a:solidFill>
+                  <a:srgbClr val="1F3A5F"/>
+                </a:solidFill>
+                <a:latin typeface="Arial"/>
+              </a:rPr>
+              <a:t>Fixed-cost absorption is the story: </a:t>
+            </a:r>
+            <a:r>
+              <a:rPr sz="1400" b="0" i="0">
+                <a:solidFill>
+                  <a:srgbClr val="333333"/>
+                </a:solidFill>
+                <a:latin typeface="Arial"/>
+              </a:rPr>
+              <a:t>personnel rises </a:t>
+            </a:r>
+            <a:r>
+              <a:rPr sz="1400" b="1" i="0">
+                <a:solidFill>
+                  <a:srgbClr val="333333"/>
+                </a:solidFill>
+                <a:latin typeface="Arial"/>
+              </a:rPr>
+              <a:t>+7pp</a:t>
+            </a:r>
+            <a:r>
+              <a:rPr sz="1400" b="0" i="0">
+                <a:solidFill>
+                  <a:srgbClr val="333333"/>
+                </a:solidFill>
+                <a:latin typeface="Arial"/>
+              </a:rPr>
+              <a:t> of output (stable in €, heavier on lower volume) while materials fall </a:t>
+            </a:r>
+            <a:r>
+              <a:rPr sz="1400" b="1" i="0">
+                <a:solidFill>
+                  <a:srgbClr val="333333"/>
+                </a:solidFill>
+                <a:latin typeface="Arial"/>
+              </a:rPr>
+              <a:t>-8pp</a:t>
+            </a:r>
+            <a:r>
+              <a:rPr sz="1400" b="0" i="0">
+                <a:solidFill>
+                  <a:srgbClr val="333333"/>
+                </a:solidFill>
+                <a:latin typeface="Arial"/>
+              </a:rPr>
+              <a:t> (variable) — net, EBITDA compresses from 7.0% to 3.8%.</a:t>
+            </a:r>
+          </a:p>
+          <a:p>
+            <a:pPr algn="l">
+              <a:lnSpc>
+                <a:spcPct val="100000"/>
+              </a:lnSpc>
+              <a:spcBef>
+                <a:spcPts val="0"/>
+              </a:spcBef>
+              <a:spcAft>
+                <a:spcPts val="400"/>
+              </a:spcAft>
+            </a:pPr>
+            <a:r>
+              <a:rPr sz="1200" b="0" i="1">
                 <a:solidFill>
                   <a:srgbClr val="666666"/>
                 </a:solidFill>
                 <a:latin typeface="Arial"/>
               </a:rPr>
-              <a:t>      10%</a:t>
-            </a:r>
-          </a:p>
-          <a:p>
-            <a:pPr algn="l">
-              <a:lnSpc>
-                <a:spcPct val="100000"/>
-              </a:lnSpc>
-              <a:spcBef>
-                <a:spcPts val="0"/>
-              </a:spcBef>
-              <a:spcAft>
-                <a:spcPts val="1300"/>
-              </a:spcAft>
-            </a:pPr>
-            <a:r>
-              <a:rPr sz="1700" b="0" i="0">
-                <a:solidFill>
-                  <a:srgbClr val="F2A100"/>
-                </a:solidFill>
-                <a:latin typeface="Arial"/>
-              </a:rPr>
-              <a:t>■  </a:t>
-            </a:r>
-            <a:r>
-              <a:rPr sz="1500" b="1" i="0">
-                <a:solidFill>
-                  <a:srgbClr val="222222"/>
-                </a:solidFill>
-                <a:latin typeface="Arial"/>
-              </a:rPr>
-              <a:t>Materials</a:t>
-            </a:r>
-            <a:r>
-              <a:rPr sz="1500" b="0" i="0">
-                <a:solidFill>
-                  <a:srgbClr val="666666"/>
-                </a:solidFill>
-                <a:latin typeface="Arial"/>
-              </a:rPr>
-              <a:t>      51%</a:t>
-            </a:r>
-          </a:p>
-          <a:p>
-            <a:pPr algn="l">
-              <a:lnSpc>
-                <a:spcPct val="100000"/>
-              </a:lnSpc>
-              <a:spcBef>
-                <a:spcPts val="0"/>
-              </a:spcBef>
-              <a:spcAft>
-                <a:spcPts val="1300"/>
-              </a:spcAft>
-            </a:pPr>
-            <a:r>
-              <a:rPr sz="1700" b="0" i="0">
-                <a:solidFill>
-                  <a:srgbClr val="D9531E"/>
-                </a:solidFill>
-                <a:latin typeface="Arial"/>
-              </a:rPr>
-              <a:t>■  </a:t>
-            </a:r>
-            <a:r>
-              <a:rPr sz="1500" b="1" i="0">
-                <a:solidFill>
-                  <a:srgbClr val="222222"/>
-                </a:solidFill>
-                <a:latin typeface="Arial"/>
-              </a:rPr>
-              <a:t>Personnel</a:t>
-            </a:r>
-            <a:r>
-              <a:rPr sz="1500" b="0" i="0">
-                <a:solidFill>
-                  <a:srgbClr val="666666"/>
-                </a:solidFill>
-                <a:latin typeface="Arial"/>
-              </a:rPr>
-              <a:t>      18%</a:t>
-            </a:r>
-          </a:p>
-          <a:p>
-            <a:pPr algn="l">
-              <a:lnSpc>
-                <a:spcPct val="100000"/>
-              </a:lnSpc>
-              <a:spcBef>
-                <a:spcPts val="0"/>
-              </a:spcBef>
-              <a:spcAft>
-                <a:spcPts val="1300"/>
-              </a:spcAft>
-            </a:pPr>
-            <a:r>
-              <a:rPr sz="1700" b="0" i="0">
-                <a:solidFill>
-                  <a:srgbClr val="8C5A2B"/>
-                </a:solidFill>
-                <a:latin typeface="Arial"/>
-              </a:rPr>
-              <a:t>■  </a:t>
-            </a:r>
-            <a:r>
-              <a:rPr sz="1500" b="1" i="0">
-                <a:solidFill>
-                  <a:srgbClr val="222222"/>
-                </a:solidFill>
-                <a:latin typeface="Arial"/>
-              </a:rPr>
-              <a:t>Transport &amp; utilities</a:t>
-            </a:r>
-            <a:r>
-              <a:rPr sz="1500" b="0" i="0">
-                <a:solidFill>
-                  <a:srgbClr val="666666"/>
-                </a:solidFill>
-                <a:latin typeface="Arial"/>
-              </a:rPr>
-              <a:t>      6%</a:t>
-            </a:r>
-          </a:p>
-          <a:p>
-            <a:pPr algn="l">
-              <a:lnSpc>
-                <a:spcPct val="100000"/>
-              </a:lnSpc>
-              <a:spcBef>
-                <a:spcPts val="0"/>
-              </a:spcBef>
-              <a:spcAft>
-                <a:spcPts val="1300"/>
-              </a:spcAft>
-            </a:pPr>
-            <a:r>
-              <a:rPr sz="1700" b="0" i="0">
-                <a:solidFill>
-                  <a:srgbClr val="BFBFBF"/>
-                </a:solidFill>
-                <a:latin typeface="Arial"/>
-              </a:rPr>
-              <a:t>■  </a:t>
-            </a:r>
-            <a:r>
-              <a:rPr sz="1500" b="1" i="0">
-                <a:solidFill>
-                  <a:srgbClr val="222222"/>
-                </a:solidFill>
-                <a:latin typeface="Arial"/>
-              </a:rPr>
-              <a:t>Maintenance</a:t>
-            </a:r>
-            <a:r>
-              <a:rPr sz="1500" b="0" i="0">
-                <a:solidFill>
-                  <a:srgbClr val="666666"/>
-                </a:solidFill>
-                <a:latin typeface="Arial"/>
-              </a:rPr>
-              <a:t>      3%</a:t>
-            </a:r>
-          </a:p>
-          <a:p>
-            <a:pPr algn="l">
-              <a:lnSpc>
-                <a:spcPct val="100000"/>
-              </a:lnSpc>
-              <a:spcBef>
-                <a:spcPts val="0"/>
-              </a:spcBef>
-              <a:spcAft>
-                <a:spcPts val="1300"/>
-              </a:spcAft>
-            </a:pPr>
-            <a:r>
-              <a:rPr sz="1700" b="0" i="0">
-                <a:solidFill>
-                  <a:srgbClr val="243746"/>
-                </a:solidFill>
-                <a:latin typeface="Arial"/>
-              </a:rPr>
-              <a:t>■  </a:t>
-            </a:r>
-            <a:r>
-              <a:rPr sz="1500" b="1" i="0">
-                <a:solidFill>
-                  <a:srgbClr val="222222"/>
-                </a:solidFill>
-                <a:latin typeface="Arial"/>
-              </a:rPr>
-              <a:t>Overheads</a:t>
-            </a:r>
-            <a:r>
-              <a:rPr sz="1500" b="0" i="0">
-                <a:solidFill>
-                  <a:srgbClr val="666666"/>
-                </a:solidFill>
-                <a:latin typeface="Arial"/>
-              </a:rPr>
-              <a:t>      11%</a:t>
-            </a:r>
-          </a:p>
-          <a:p>
-            <a:pPr algn="l">
-              <a:lnSpc>
-                <a:spcPct val="100000"/>
-              </a:lnSpc>
-              <a:spcBef>
-                <a:spcPts val="0"/>
-              </a:spcBef>
-              <a:spcAft>
-                <a:spcPts val="600"/>
-              </a:spcAft>
-            </a:pPr>
-            <a:r>
-              <a:rPr sz="1400" b="1" i="0">
-                <a:solidFill>
-                  <a:srgbClr val="2E7D4F"/>
-                </a:solidFill>
-                <a:latin typeface="Arial"/>
-              </a:rPr>
-              <a:t>EBITDA margin 10%</a:t>
-            </a:r>
-            <a:r>
-              <a:rPr sz="1400" b="0" i="0">
-                <a:solidFill>
-                  <a:srgbClr val="333333"/>
-                </a:solidFill>
-                <a:latin typeface="Arial"/>
-              </a:rPr>
-              <a:t>; materials are the dominant cost at 51% — the key lever on profitability.</a:t>
-            </a:r>
-          </a:p>
-        </p:txBody>
-      </p:sp>
-      <p:sp>
-        <p:nvSpPr>
-          <p:cNvPr id="37" name="TextBox 36"/>
+              <a:t>Read with the project cycle: 2024 value of production is lower as the 2023 WIP build-up unwinds.</a:t>
+            </a:r>
+          </a:p>
+        </p:txBody>
+      </p:sp>
+      <p:sp>
+        <p:nvSpPr>
+          <p:cNvPr id="73" name="TextBox 72"/>
           <p:cNvSpPr txBox="1"/>
           <p:nvPr/>
         </p:nvSpPr>
         <p:spPr>
           <a:xfrm>
-            <a:off x="381000" y="6598920"/>
-            <a:ext cx="9906000" cy="152400"/>
+            <a:off x="381000" y="6553200"/>
+            <a:ext cx="10134600" cy="228600"/>
           </a:xfrm>
           <a:prstGeom prst="rect">
             <a:avLst/>
@@ -8842,7 +10272,7 @@
                 </a:solidFill>
                 <a:latin typeface="Arial"/>
               </a:rPr>
-              <a:t>% of revenue / value of production, per the provided breakdown (sums to ~100% net of rounding).</a:t>
+              <a:t>% of value of production (€52.0m 2023 / €40.7m 2024). 2023 base inflated by WIP build-up (+€19.3m); on a revenue basis EBITDA margin was 7.2% (2023) / 3.5% (2024). Source: Coface reclassified P&amp;L.</a:t>
             </a:r>
           </a:p>
         </p:txBody>

</xml_diff>

<commit_message>
Add normalised 2-yr bar to P&L; drop value-of-production and add 2-yr aggregate to Financial chart
</commit_message>
<xml_diff>
--- a/Hennecke/pitch/HenneckeOMS_Board_Pitch_EN.pptx
+++ b/Hennecke/pitch/HenneckeOMS_Board_Pitch_EN.pptx
@@ -145,16 +145,13 @@
           </c:spPr>
           <c:cat>
             <c:strRef>
-              <c:f>Sheet1!$A$2:$A$4</c:f>
+              <c:f>Sheet1!$A$2:$A$3</c:f>
               <c:strCache>
-                <c:ptCount val="3"/>
+                <c:ptCount val="2"/>
                 <c:pt idx="0">
                   <c:v>Revenue</c:v>
                 </c:pt>
                 <c:pt idx="1">
-                  <c:v>Value of prod.</c:v>
-                </c:pt>
-                <c:pt idx="2">
                   <c:v>EBITDA</c:v>
                 </c:pt>
               </c:strCache>
@@ -162,17 +159,14 @@
           </c:cat>
           <c:val>
             <c:numRef>
-              <c:f>Sheet1!$B$2:$B$4</c:f>
+              <c:f>Sheet1!$B$2:$B$3</c:f>
               <c:numCache>
                 <c:formatCode>General</c:formatCode>
-                <c:ptCount val="3"/>
+                <c:ptCount val="2"/>
                 <c:pt idx="0">
                   <c:v>50.4</c:v>
                 </c:pt>
                 <c:pt idx="1">
-                  <c:v>52.0</c:v>
-                </c:pt>
-                <c:pt idx="2">
                   <c:v>3.6</c:v>
                 </c:pt>
               </c:numCache>
@@ -200,16 +194,13 @@
           </c:spPr>
           <c:cat>
             <c:strRef>
-              <c:f>Sheet1!$A$2:$A$4</c:f>
+              <c:f>Sheet1!$A$2:$A$3</c:f>
               <c:strCache>
-                <c:ptCount val="3"/>
+                <c:ptCount val="2"/>
                 <c:pt idx="0">
                   <c:v>Revenue</c:v>
                 </c:pt>
                 <c:pt idx="1">
-                  <c:v>Value of prod.</c:v>
-                </c:pt>
-                <c:pt idx="2">
                   <c:v>EBITDA</c:v>
                 </c:pt>
               </c:strCache>
@@ -217,18 +208,64 @@
           </c:cat>
           <c:val>
             <c:numRef>
-              <c:f>Sheet1!$C$2:$C$4</c:f>
+              <c:f>Sheet1!$C$2:$C$3</c:f>
               <c:numCache>
                 <c:formatCode>General</c:formatCode>
-                <c:ptCount val="3"/>
+                <c:ptCount val="2"/>
                 <c:pt idx="0">
                   <c:v>44.2</c:v>
                 </c:pt>
                 <c:pt idx="1">
-                  <c:v>40.7</c:v>
+                  <c:v>1.5</c:v>
                 </c:pt>
-                <c:pt idx="2">
-                  <c:v>1.5</c:v>
+              </c:numCache>
+            </c:numRef>
+          </c:val>
+        </c:ser>
+        <c:ser>
+          <c:idx val="2"/>
+          <c:order val="2"/>
+          <c:tx>
+            <c:strRef>
+              <c:f>Sheet1!$D$1</c:f>
+              <c:strCache>
+                <c:ptCount val="1"/>
+                <c:pt idx="0">
+                  <c:v>2-yr (sum)</c:v>
+                </c:pt>
+              </c:strCache>
+            </c:strRef>
+          </c:tx>
+          <c:spPr>
+            <a:solidFill>
+              <a:srgbClr val="F2C200"/>
+            </a:solidFill>
+          </c:spPr>
+          <c:cat>
+            <c:strRef>
+              <c:f>Sheet1!$A$2:$A$3</c:f>
+              <c:strCache>
+                <c:ptCount val="2"/>
+                <c:pt idx="0">
+                  <c:v>Revenue</c:v>
+                </c:pt>
+                <c:pt idx="1">
+                  <c:v>EBITDA</c:v>
+                </c:pt>
+              </c:strCache>
+            </c:strRef>
+          </c:cat>
+          <c:val>
+            <c:numRef>
+              <c:f>Sheet1!$D$2:$D$3</c:f>
+              <c:numCache>
+                <c:formatCode>General</c:formatCode>
+                <c:ptCount val="2"/>
+                <c:pt idx="0">
+                  <c:v>94.6</c:v>
+                </c:pt>
+                <c:pt idx="1">
+                  <c:v>5.2</c:v>
                 </c:pt>
               </c:numCache>
             </c:numRef>
@@ -6055,7 +6092,7 @@
         <p:spPr>
           <a:xfrm>
             <a:off x="563880" y="1066800"/>
-            <a:ext cx="3810000" cy="213360"/>
+            <a:ext cx="4572000" cy="213360"/>
           </a:xfrm>
           <a:prstGeom prst="rect">
             <a:avLst/>
@@ -6086,7 +6123,7 @@
                 </a:solidFill>
                 <a:latin typeface="Arial"/>
               </a:rPr>
-              <a:t>2023 vs 2024 (€ million)</a:t>
+              <a:t>2023 · 2024 · 2-yr aggregate (€ million)</a:t>
             </a:r>
           </a:p>
         </p:txBody>
@@ -7076,7 +7113,7 @@
                 </a:solidFill>
                 <a:latin typeface="Arial"/>
               </a:rPr>
-              <a:t>P&amp;L recap — cost structure (2023 vs 2024)</a:t>
+              <a:t>P&amp;L recap — cost structure (2023 · 2024 · normalised)</a:t>
             </a:r>
           </a:p>
         </p:txBody>
@@ -7121,7 +7158,7 @@
                 </a:solidFill>
                 <a:latin typeface="Arial"/>
               </a:rPr>
-              <a:t>Value of production split into EBITDA and cost categories · year-on-year</a:t>
+              <a:t>Summing both years nets out the project-cycle WIP swing → a normalised run-rate</a:t>
             </a:r>
           </a:p>
         </p:txBody>
@@ -7268,8 +7305,8 @@
         </p:nvSpPr>
         <p:spPr>
           <a:xfrm>
-            <a:off x="3657600" y="1257300"/>
-            <a:ext cx="990600" cy="320040"/>
+            <a:off x="3276600" y="1257300"/>
+            <a:ext cx="914400" cy="320040"/>
           </a:xfrm>
           <a:prstGeom prst="rect">
             <a:avLst/>
@@ -7312,8 +7349,8 @@
         </p:nvSpPr>
         <p:spPr>
           <a:xfrm>
-            <a:off x="3657600" y="1257300"/>
-            <a:ext cx="990600" cy="320040"/>
+            <a:off x="3276600" y="1257300"/>
+            <a:ext cx="914400" cy="320040"/>
           </a:xfrm>
           <a:prstGeom prst="rect">
             <a:avLst/>
@@ -7338,7 +7375,7 @@
               </a:spcAft>
             </a:pPr>
             <a:r>
-              <a:rPr sz="1300" b="1" i="0">
+              <a:rPr sz="1200" b="1" i="0">
                 <a:solidFill>
                   <a:srgbClr val="222222"/>
                 </a:solidFill>
@@ -7357,8 +7394,8 @@
         </p:nvSpPr>
         <p:spPr>
           <a:xfrm>
-            <a:off x="3657600" y="1577340"/>
-            <a:ext cx="990600" cy="2103120"/>
+            <a:off x="3276600" y="1577340"/>
+            <a:ext cx="914400" cy="2103120"/>
           </a:xfrm>
           <a:prstGeom prst="rect">
             <a:avLst/>
@@ -7401,8 +7438,8 @@
         </p:nvSpPr>
         <p:spPr>
           <a:xfrm>
-            <a:off x="3657600" y="1577340"/>
-            <a:ext cx="990600" cy="2103120"/>
+            <a:off x="3276600" y="1577340"/>
+            <a:ext cx="914400" cy="2103120"/>
           </a:xfrm>
           <a:prstGeom prst="rect">
             <a:avLst/>
@@ -7427,7 +7464,7 @@
               </a:spcAft>
             </a:pPr>
             <a:r>
-              <a:rPr sz="1300" b="1" i="0">
+              <a:rPr sz="1200" b="1" i="0">
                 <a:solidFill>
                   <a:srgbClr val="222222"/>
                 </a:solidFill>
@@ -7446,8 +7483,8 @@
         </p:nvSpPr>
         <p:spPr>
           <a:xfrm>
-            <a:off x="3657600" y="3680460"/>
-            <a:ext cx="990600" cy="1056132"/>
+            <a:off x="3276600" y="3680460"/>
+            <a:ext cx="914400" cy="1056132"/>
           </a:xfrm>
           <a:prstGeom prst="rect">
             <a:avLst/>
@@ -7490,8 +7527,8 @@
         </p:nvSpPr>
         <p:spPr>
           <a:xfrm>
-            <a:off x="3657600" y="3680460"/>
-            <a:ext cx="990600" cy="1056132"/>
+            <a:off x="3276600" y="3680460"/>
+            <a:ext cx="914400" cy="1056132"/>
           </a:xfrm>
           <a:prstGeom prst="rect">
             <a:avLst/>
@@ -7516,7 +7553,7 @@
               </a:spcAft>
             </a:pPr>
             <a:r>
-              <a:rPr sz="1300" b="1" i="0">
+              <a:rPr sz="1200" b="1" i="0">
                 <a:solidFill>
                   <a:srgbClr val="FFFFFF"/>
                 </a:solidFill>
@@ -7535,8 +7572,8 @@
         </p:nvSpPr>
         <p:spPr>
           <a:xfrm>
-            <a:off x="3657600" y="4736592"/>
-            <a:ext cx="990600" cy="909828"/>
+            <a:off x="3276600" y="4736592"/>
+            <a:ext cx="914400" cy="909828"/>
           </a:xfrm>
           <a:prstGeom prst="rect">
             <a:avLst/>
@@ -7579,8 +7616,8 @@
         </p:nvSpPr>
         <p:spPr>
           <a:xfrm>
-            <a:off x="3657600" y="4736592"/>
-            <a:ext cx="990600" cy="909828"/>
+            <a:off x="3276600" y="4736592"/>
+            <a:ext cx="914400" cy="909828"/>
           </a:xfrm>
           <a:prstGeom prst="rect">
             <a:avLst/>
@@ -7605,7 +7642,7 @@
               </a:spcAft>
             </a:pPr>
             <a:r>
-              <a:rPr sz="1300" b="1" i="0">
+              <a:rPr sz="1200" b="1" i="0">
                 <a:solidFill>
                   <a:srgbClr val="FFFFFF"/>
                 </a:solidFill>
@@ -7624,8 +7661,8 @@
         </p:nvSpPr>
         <p:spPr>
           <a:xfrm>
-            <a:off x="3657600" y="5646420"/>
-            <a:ext cx="990600" cy="173736"/>
+            <a:off x="3276600" y="5646420"/>
+            <a:ext cx="914400" cy="173736"/>
           </a:xfrm>
           <a:prstGeom prst="rect">
             <a:avLst/>
@@ -7668,8 +7705,8 @@
         </p:nvSpPr>
         <p:spPr>
           <a:xfrm>
-            <a:off x="3657600" y="5646420"/>
-            <a:ext cx="990600" cy="173736"/>
+            <a:off x="3276600" y="5646420"/>
+            <a:ext cx="914400" cy="173736"/>
           </a:xfrm>
           <a:prstGeom prst="rect">
             <a:avLst/>
@@ -7694,7 +7731,7 @@
               </a:spcAft>
             </a:pPr>
             <a:r>
-              <a:rPr sz="1000" b="1" i="0">
+              <a:rPr sz="900" b="1" i="0">
                 <a:solidFill>
                   <a:srgbClr val="FFFFFF"/>
                 </a:solidFill>
@@ -7713,8 +7750,8 @@
         </p:nvSpPr>
         <p:spPr>
           <a:xfrm>
-            <a:off x="3657600" y="5820156"/>
-            <a:ext cx="990600" cy="13716"/>
+            <a:off x="3276600" y="5820156"/>
+            <a:ext cx="914400" cy="13716"/>
           </a:xfrm>
           <a:prstGeom prst="rect">
             <a:avLst/>
@@ -7757,8 +7794,8 @@
         </p:nvSpPr>
         <p:spPr>
           <a:xfrm>
-            <a:off x="5486400" y="1257300"/>
-            <a:ext cx="990600" cy="173736"/>
+            <a:off x="4876800" y="1257300"/>
+            <a:ext cx="914400" cy="173736"/>
           </a:xfrm>
           <a:prstGeom prst="rect">
             <a:avLst/>
@@ -7801,8 +7838,8 @@
         </p:nvSpPr>
         <p:spPr>
           <a:xfrm>
-            <a:off x="5486400" y="1257300"/>
-            <a:ext cx="990600" cy="173736"/>
+            <a:off x="4876800" y="1257300"/>
+            <a:ext cx="914400" cy="173736"/>
           </a:xfrm>
           <a:prstGeom prst="rect">
             <a:avLst/>
@@ -7827,7 +7864,7 @@
               </a:spcAft>
             </a:pPr>
             <a:r>
-              <a:rPr sz="1000" b="1" i="0">
+              <a:rPr sz="900" b="1" i="0">
                 <a:solidFill>
                   <a:srgbClr val="222222"/>
                 </a:solidFill>
@@ -7846,8 +7883,8 @@
         </p:nvSpPr>
         <p:spPr>
           <a:xfrm>
-            <a:off x="5486400" y="1431036"/>
-            <a:ext cx="990600" cy="1755648"/>
+            <a:off x="4876800" y="1431036"/>
+            <a:ext cx="914400" cy="1755648"/>
           </a:xfrm>
           <a:prstGeom prst="rect">
             <a:avLst/>
@@ -7890,8 +7927,8 @@
         </p:nvSpPr>
         <p:spPr>
           <a:xfrm>
-            <a:off x="5486400" y="1431036"/>
-            <a:ext cx="990600" cy="1755648"/>
+            <a:off x="4876800" y="1431036"/>
+            <a:ext cx="914400" cy="1755648"/>
           </a:xfrm>
           <a:prstGeom prst="rect">
             <a:avLst/>
@@ -7916,7 +7953,7 @@
               </a:spcAft>
             </a:pPr>
             <a:r>
-              <a:rPr sz="1300" b="1" i="0">
+              <a:rPr sz="1200" b="1" i="0">
                 <a:solidFill>
                   <a:srgbClr val="222222"/>
                 </a:solidFill>
@@ -7935,8 +7972,8 @@
         </p:nvSpPr>
         <p:spPr>
           <a:xfrm>
-            <a:off x="5486400" y="3186684"/>
-            <a:ext cx="990600" cy="1385316"/>
+            <a:off x="4876800" y="3186684"/>
+            <a:ext cx="914400" cy="1385316"/>
           </a:xfrm>
           <a:prstGeom prst="rect">
             <a:avLst/>
@@ -7979,8 +8016,8 @@
         </p:nvSpPr>
         <p:spPr>
           <a:xfrm>
-            <a:off x="5486400" y="3186684"/>
-            <a:ext cx="990600" cy="1385316"/>
+            <a:off x="4876800" y="3186684"/>
+            <a:ext cx="914400" cy="1385316"/>
           </a:xfrm>
           <a:prstGeom prst="rect">
             <a:avLst/>
@@ -8005,7 +8042,7 @@
               </a:spcAft>
             </a:pPr>
             <a:r>
-              <a:rPr sz="1300" b="1" i="0">
+              <a:rPr sz="1200" b="1" i="0">
                 <a:solidFill>
                   <a:srgbClr val="FFFFFF"/>
                 </a:solidFill>
@@ -8024,8 +8061,8 @@
         </p:nvSpPr>
         <p:spPr>
           <a:xfrm>
-            <a:off x="5486400" y="4572000"/>
-            <a:ext cx="990600" cy="1042416"/>
+            <a:off x="4876800" y="4572000"/>
+            <a:ext cx="914400" cy="1042416"/>
           </a:xfrm>
           <a:prstGeom prst="rect">
             <a:avLst/>
@@ -8068,8 +8105,8 @@
         </p:nvSpPr>
         <p:spPr>
           <a:xfrm>
-            <a:off x="5486400" y="4572000"/>
-            <a:ext cx="990600" cy="1042416"/>
+            <a:off x="4876800" y="4572000"/>
+            <a:ext cx="914400" cy="1042416"/>
           </a:xfrm>
           <a:prstGeom prst="rect">
             <a:avLst/>
@@ -8094,7 +8131,7 @@
               </a:spcAft>
             </a:pPr>
             <a:r>
-              <a:rPr sz="1300" b="1" i="0">
+              <a:rPr sz="1200" b="1" i="0">
                 <a:solidFill>
                   <a:srgbClr val="FFFFFF"/>
                 </a:solidFill>
@@ -8113,8 +8150,8 @@
         </p:nvSpPr>
         <p:spPr>
           <a:xfrm>
-            <a:off x="5486400" y="5614416"/>
-            <a:ext cx="990600" cy="192024"/>
+            <a:off x="4876800" y="5614416"/>
+            <a:ext cx="914400" cy="192024"/>
           </a:xfrm>
           <a:prstGeom prst="rect">
             <a:avLst/>
@@ -8157,8 +8194,8 @@
         </p:nvSpPr>
         <p:spPr>
           <a:xfrm>
-            <a:off x="5486400" y="5614416"/>
-            <a:ext cx="990600" cy="192024"/>
+            <a:off x="4876800" y="5614416"/>
+            <a:ext cx="914400" cy="192024"/>
           </a:xfrm>
           <a:prstGeom prst="rect">
             <a:avLst/>
@@ -8183,7 +8220,7 @@
               </a:spcAft>
             </a:pPr>
             <a:r>
-              <a:rPr sz="1000" b="1" i="0">
+              <a:rPr sz="900" b="1" i="0">
                 <a:solidFill>
                   <a:srgbClr val="FFFFFF"/>
                 </a:solidFill>
@@ -8202,8 +8239,8 @@
         </p:nvSpPr>
         <p:spPr>
           <a:xfrm>
-            <a:off x="5486400" y="5806440"/>
-            <a:ext cx="990600" cy="22860"/>
+            <a:off x="4876800" y="5806440"/>
+            <a:ext cx="914400" cy="22860"/>
           </a:xfrm>
           <a:prstGeom prst="rect">
             <a:avLst/>
@@ -8238,16 +8275,505 @@
           </a:p>
         </p:txBody>
       </p:sp>
+      <p:sp>
+        <p:nvSpPr>
+          <p:cNvPr id="30" name="Rectangle 29"/>
+          <p:cNvSpPr/>
+          <p:nvPr/>
+        </p:nvSpPr>
+        <p:spPr>
+          <a:xfrm>
+            <a:off x="6477000" y="1257300"/>
+            <a:ext cx="914400" cy="256032"/>
+          </a:xfrm>
+          <a:prstGeom prst="rect">
+            <a:avLst/>
+          </a:prstGeom>
+          <a:solidFill>
+            <a:srgbClr val="84BD00"/>
+          </a:solidFill>
+          <a:ln>
+            <a:noFill/>
+          </a:ln>
+          <a:effectLst/>
+        </p:spPr>
+        <p:style>
+          <a:lnRef idx="1">
+            <a:schemeClr val="accent1"/>
+          </a:lnRef>
+          <a:fillRef idx="3">
+            <a:schemeClr val="accent1"/>
+          </a:fillRef>
+          <a:effectRef idx="2">
+            <a:schemeClr val="accent1"/>
+          </a:effectRef>
+          <a:fontRef idx="minor">
+            <a:schemeClr val="lt1"/>
+          </a:fontRef>
+        </p:style>
+        <p:txBody>
+          <a:bodyPr rtlCol="0" anchor="ctr"/>
+          <a:lstStyle/>
+          <a:p>
+            <a:pPr algn="ctr"/>
+          </a:p>
+        </p:txBody>
+      </p:sp>
+      <p:sp>
+        <p:nvSpPr>
+          <p:cNvPr id="31" name="TextBox 30"/>
+          <p:cNvSpPr txBox="1"/>
+          <p:nvPr/>
+        </p:nvSpPr>
+        <p:spPr>
+          <a:xfrm>
+            <a:off x="6477000" y="1257300"/>
+            <a:ext cx="914400" cy="256032"/>
+          </a:xfrm>
+          <a:prstGeom prst="rect">
+            <a:avLst/>
+          </a:prstGeom>
+          <a:noFill/>
+        </p:spPr>
+        <p:txBody>
+          <a:bodyPr wrap="square" anchor="ctr" lIns="25400" rIns="25400" tIns="12700" bIns="12700">
+            <a:spAutoFit/>
+          </a:bodyPr>
+          <a:lstStyle/>
+          <a:p>
+            <a:pPr algn="ctr">
+              <a:lnSpc>
+                <a:spcPct val="100000"/>
+              </a:lnSpc>
+              <a:spcBef>
+                <a:spcPts val="0"/>
+              </a:spcBef>
+              <a:spcAft>
+                <a:spcPts val="400"/>
+              </a:spcAft>
+            </a:pPr>
+            <a:r>
+              <a:rPr sz="1200" b="1" i="0">
+                <a:solidFill>
+                  <a:srgbClr val="222222"/>
+                </a:solidFill>
+                <a:latin typeface="Arial"/>
+              </a:rPr>
+              <a:t>5.6%</a:t>
+            </a:r>
+          </a:p>
+        </p:txBody>
+      </p:sp>
+      <p:sp>
+        <p:nvSpPr>
+          <p:cNvPr id="32" name="Rectangle 31"/>
+          <p:cNvSpPr/>
+          <p:nvPr/>
+        </p:nvSpPr>
+        <p:spPr>
+          <a:xfrm>
+            <a:off x="6477000" y="1513332"/>
+            <a:ext cx="914400" cy="1952244"/>
+          </a:xfrm>
+          <a:prstGeom prst="rect">
+            <a:avLst/>
+          </a:prstGeom>
+          <a:solidFill>
+            <a:srgbClr val="F2A100"/>
+          </a:solidFill>
+          <a:ln>
+            <a:noFill/>
+          </a:ln>
+          <a:effectLst/>
+        </p:spPr>
+        <p:style>
+          <a:lnRef idx="1">
+            <a:schemeClr val="accent1"/>
+          </a:lnRef>
+          <a:fillRef idx="3">
+            <a:schemeClr val="accent1"/>
+          </a:fillRef>
+          <a:effectRef idx="2">
+            <a:schemeClr val="accent1"/>
+          </a:effectRef>
+          <a:fontRef idx="minor">
+            <a:schemeClr val="lt1"/>
+          </a:fontRef>
+        </p:style>
+        <p:txBody>
+          <a:bodyPr rtlCol="0" anchor="ctr"/>
+          <a:lstStyle/>
+          <a:p>
+            <a:pPr algn="ctr"/>
+          </a:p>
+        </p:txBody>
+      </p:sp>
+      <p:sp>
+        <p:nvSpPr>
+          <p:cNvPr id="33" name="TextBox 32"/>
+          <p:cNvSpPr txBox="1"/>
+          <p:nvPr/>
+        </p:nvSpPr>
+        <p:spPr>
+          <a:xfrm>
+            <a:off x="6477000" y="1513332"/>
+            <a:ext cx="914400" cy="1952244"/>
+          </a:xfrm>
+          <a:prstGeom prst="rect">
+            <a:avLst/>
+          </a:prstGeom>
+          <a:noFill/>
+        </p:spPr>
+        <p:txBody>
+          <a:bodyPr wrap="square" anchor="ctr" lIns="25400" rIns="25400" tIns="12700" bIns="12700">
+            <a:spAutoFit/>
+          </a:bodyPr>
+          <a:lstStyle/>
+          <a:p>
+            <a:pPr algn="ctr">
+              <a:lnSpc>
+                <a:spcPct val="100000"/>
+              </a:lnSpc>
+              <a:spcBef>
+                <a:spcPts val="0"/>
+              </a:spcBef>
+              <a:spcAft>
+                <a:spcPts val="400"/>
+              </a:spcAft>
+            </a:pPr>
+            <a:r>
+              <a:rPr sz="1200" b="1" i="0">
+                <a:solidFill>
+                  <a:srgbClr val="222222"/>
+                </a:solidFill>
+                <a:latin typeface="Arial"/>
+              </a:rPr>
+              <a:t>42.7%</a:t>
+            </a:r>
+          </a:p>
+        </p:txBody>
+      </p:sp>
+      <p:sp>
+        <p:nvSpPr>
+          <p:cNvPr id="34" name="Rectangle 33"/>
+          <p:cNvSpPr/>
+          <p:nvPr/>
+        </p:nvSpPr>
+        <p:spPr>
+          <a:xfrm>
+            <a:off x="6477000" y="3465576"/>
+            <a:ext cx="914400" cy="1197864"/>
+          </a:xfrm>
+          <a:prstGeom prst="rect">
+            <a:avLst/>
+          </a:prstGeom>
+          <a:solidFill>
+            <a:srgbClr val="D9531E"/>
+          </a:solidFill>
+          <a:ln>
+            <a:noFill/>
+          </a:ln>
+          <a:effectLst/>
+        </p:spPr>
+        <p:style>
+          <a:lnRef idx="1">
+            <a:schemeClr val="accent1"/>
+          </a:lnRef>
+          <a:fillRef idx="3">
+            <a:schemeClr val="accent1"/>
+          </a:fillRef>
+          <a:effectRef idx="2">
+            <a:schemeClr val="accent1"/>
+          </a:effectRef>
+          <a:fontRef idx="minor">
+            <a:schemeClr val="lt1"/>
+          </a:fontRef>
+        </p:style>
+        <p:txBody>
+          <a:bodyPr rtlCol="0" anchor="ctr"/>
+          <a:lstStyle/>
+          <a:p>
+            <a:pPr algn="ctr"/>
+          </a:p>
+        </p:txBody>
+      </p:sp>
+      <p:sp>
+        <p:nvSpPr>
+          <p:cNvPr id="35" name="TextBox 34"/>
+          <p:cNvSpPr txBox="1"/>
+          <p:nvPr/>
+        </p:nvSpPr>
+        <p:spPr>
+          <a:xfrm>
+            <a:off x="6477000" y="3465576"/>
+            <a:ext cx="914400" cy="1197864"/>
+          </a:xfrm>
+          <a:prstGeom prst="rect">
+            <a:avLst/>
+          </a:prstGeom>
+          <a:noFill/>
+        </p:spPr>
+        <p:txBody>
+          <a:bodyPr wrap="square" anchor="ctr" lIns="25400" rIns="25400" tIns="12700" bIns="12700">
+            <a:spAutoFit/>
+          </a:bodyPr>
+          <a:lstStyle/>
+          <a:p>
+            <a:pPr algn="ctr">
+              <a:lnSpc>
+                <a:spcPct val="100000"/>
+              </a:lnSpc>
+              <a:spcBef>
+                <a:spcPts val="0"/>
+              </a:spcBef>
+              <a:spcAft>
+                <a:spcPts val="400"/>
+              </a:spcAft>
+            </a:pPr>
+            <a:r>
+              <a:rPr sz="1200" b="1" i="0">
+                <a:solidFill>
+                  <a:srgbClr val="FFFFFF"/>
+                </a:solidFill>
+                <a:latin typeface="Arial"/>
+              </a:rPr>
+              <a:t>26.2%</a:t>
+            </a:r>
+          </a:p>
+        </p:txBody>
+      </p:sp>
+      <p:sp>
+        <p:nvSpPr>
+          <p:cNvPr id="36" name="Rectangle 35"/>
+          <p:cNvSpPr/>
+          <p:nvPr/>
+        </p:nvSpPr>
+        <p:spPr>
+          <a:xfrm>
+            <a:off x="6477000" y="4663440"/>
+            <a:ext cx="914400" cy="969264"/>
+          </a:xfrm>
+          <a:prstGeom prst="rect">
+            <a:avLst/>
+          </a:prstGeom>
+          <a:solidFill>
+            <a:srgbClr val="3C7DA6"/>
+          </a:solidFill>
+          <a:ln>
+            <a:noFill/>
+          </a:ln>
+          <a:effectLst/>
+        </p:spPr>
+        <p:style>
+          <a:lnRef idx="1">
+            <a:schemeClr val="accent1"/>
+          </a:lnRef>
+          <a:fillRef idx="3">
+            <a:schemeClr val="accent1"/>
+          </a:fillRef>
+          <a:effectRef idx="2">
+            <a:schemeClr val="accent1"/>
+          </a:effectRef>
+          <a:fontRef idx="minor">
+            <a:schemeClr val="lt1"/>
+          </a:fontRef>
+        </p:style>
+        <p:txBody>
+          <a:bodyPr rtlCol="0" anchor="ctr"/>
+          <a:lstStyle/>
+          <a:p>
+            <a:pPr algn="ctr"/>
+          </a:p>
+        </p:txBody>
+      </p:sp>
+      <p:sp>
+        <p:nvSpPr>
+          <p:cNvPr id="37" name="TextBox 36"/>
+          <p:cNvSpPr txBox="1"/>
+          <p:nvPr/>
+        </p:nvSpPr>
+        <p:spPr>
+          <a:xfrm>
+            <a:off x="6477000" y="4663440"/>
+            <a:ext cx="914400" cy="969264"/>
+          </a:xfrm>
+          <a:prstGeom prst="rect">
+            <a:avLst/>
+          </a:prstGeom>
+          <a:noFill/>
+        </p:spPr>
+        <p:txBody>
+          <a:bodyPr wrap="square" anchor="ctr" lIns="25400" rIns="25400" tIns="12700" bIns="12700">
+            <a:spAutoFit/>
+          </a:bodyPr>
+          <a:lstStyle/>
+          <a:p>
+            <a:pPr algn="ctr">
+              <a:lnSpc>
+                <a:spcPct val="100000"/>
+              </a:lnSpc>
+              <a:spcBef>
+                <a:spcPts val="0"/>
+              </a:spcBef>
+              <a:spcAft>
+                <a:spcPts val="400"/>
+              </a:spcAft>
+            </a:pPr>
+            <a:r>
+              <a:rPr sz="1200" b="1" i="0">
+                <a:solidFill>
+                  <a:srgbClr val="FFFFFF"/>
+                </a:solidFill>
+                <a:latin typeface="Arial"/>
+              </a:rPr>
+              <a:t>21.2%</a:t>
+            </a:r>
+          </a:p>
+        </p:txBody>
+      </p:sp>
+      <p:sp>
+        <p:nvSpPr>
+          <p:cNvPr id="38" name="Rectangle 37"/>
+          <p:cNvSpPr/>
+          <p:nvPr/>
+        </p:nvSpPr>
+        <p:spPr>
+          <a:xfrm>
+            <a:off x="6477000" y="5632704"/>
+            <a:ext cx="914400" cy="182880"/>
+          </a:xfrm>
+          <a:prstGeom prst="rect">
+            <a:avLst/>
+          </a:prstGeom>
+          <a:solidFill>
+            <a:srgbClr val="8C5A2B"/>
+          </a:solidFill>
+          <a:ln>
+            <a:noFill/>
+          </a:ln>
+          <a:effectLst/>
+        </p:spPr>
+        <p:style>
+          <a:lnRef idx="1">
+            <a:schemeClr val="accent1"/>
+          </a:lnRef>
+          <a:fillRef idx="3">
+            <a:schemeClr val="accent1"/>
+          </a:fillRef>
+          <a:effectRef idx="2">
+            <a:schemeClr val="accent1"/>
+          </a:effectRef>
+          <a:fontRef idx="minor">
+            <a:schemeClr val="lt1"/>
+          </a:fontRef>
+        </p:style>
+        <p:txBody>
+          <a:bodyPr rtlCol="0" anchor="ctr"/>
+          <a:lstStyle/>
+          <a:p>
+            <a:pPr algn="ctr"/>
+          </a:p>
+        </p:txBody>
+      </p:sp>
+      <p:sp>
+        <p:nvSpPr>
+          <p:cNvPr id="39" name="TextBox 38"/>
+          <p:cNvSpPr txBox="1"/>
+          <p:nvPr/>
+        </p:nvSpPr>
+        <p:spPr>
+          <a:xfrm>
+            <a:off x="6477000" y="5632704"/>
+            <a:ext cx="914400" cy="182880"/>
+          </a:xfrm>
+          <a:prstGeom prst="rect">
+            <a:avLst/>
+          </a:prstGeom>
+          <a:noFill/>
+        </p:spPr>
+        <p:txBody>
+          <a:bodyPr wrap="square" anchor="ctr" lIns="25400" rIns="25400" tIns="12700" bIns="12700">
+            <a:spAutoFit/>
+          </a:bodyPr>
+          <a:lstStyle/>
+          <a:p>
+            <a:pPr algn="ctr">
+              <a:lnSpc>
+                <a:spcPct val="100000"/>
+              </a:lnSpc>
+              <a:spcBef>
+                <a:spcPts val="0"/>
+              </a:spcBef>
+              <a:spcAft>
+                <a:spcPts val="400"/>
+              </a:spcAft>
+            </a:pPr>
+            <a:r>
+              <a:rPr sz="900" b="1" i="0">
+                <a:solidFill>
+                  <a:srgbClr val="FFFFFF"/>
+                </a:solidFill>
+                <a:latin typeface="Arial"/>
+              </a:rPr>
+              <a:t>4.0%</a:t>
+            </a:r>
+          </a:p>
+        </p:txBody>
+      </p:sp>
+      <p:sp>
+        <p:nvSpPr>
+          <p:cNvPr id="40" name="Rectangle 39"/>
+          <p:cNvSpPr/>
+          <p:nvPr/>
+        </p:nvSpPr>
+        <p:spPr>
+          <a:xfrm>
+            <a:off x="6477000" y="5815584"/>
+            <a:ext cx="914400" cy="18288"/>
+          </a:xfrm>
+          <a:prstGeom prst="rect">
+            <a:avLst/>
+          </a:prstGeom>
+          <a:solidFill>
+            <a:srgbClr val="BFBFBF"/>
+          </a:solidFill>
+          <a:ln>
+            <a:noFill/>
+          </a:ln>
+          <a:effectLst/>
+        </p:spPr>
+        <p:style>
+          <a:lnRef idx="1">
+            <a:schemeClr val="accent1"/>
+          </a:lnRef>
+          <a:fillRef idx="3">
+            <a:schemeClr val="accent1"/>
+          </a:fillRef>
+          <a:effectRef idx="2">
+            <a:schemeClr val="accent1"/>
+          </a:effectRef>
+          <a:fontRef idx="minor">
+            <a:schemeClr val="lt1"/>
+          </a:fontRef>
+        </p:style>
+        <p:txBody>
+          <a:bodyPr rtlCol="0" anchor="ctr"/>
+          <a:lstStyle/>
+          <a:p>
+            <a:pPr algn="ctr"/>
+          </a:p>
+        </p:txBody>
+      </p:sp>
       <p:cxnSp>
         <p:nvCxnSpPr>
-          <p:cNvPr id="30" name="Connector 29"/>
+          <p:cNvPr id="41" name="Connector 40"/>
           <p:cNvCxnSpPr/>
           <p:nvPr/>
         </p:nvCxnSpPr>
         <p:spPr>
           <a:xfrm>
-            <a:off x="4648200" y="1257300"/>
-            <a:ext cx="838200" cy="0"/>
+            <a:off x="4191000" y="1257300"/>
+            <a:ext cx="685800" cy="0"/>
           </a:xfrm>
           <a:prstGeom prst="line">
             <a:avLst/>
@@ -8276,14 +8802,14 @@
       </p:cxnSp>
       <p:cxnSp>
         <p:nvCxnSpPr>
-          <p:cNvPr id="31" name="Connector 30"/>
+          <p:cNvPr id="42" name="Connector 41"/>
           <p:cNvCxnSpPr/>
           <p:nvPr/>
         </p:nvCxnSpPr>
         <p:spPr>
           <a:xfrm flipV="1">
-            <a:off x="4648200" y="1431036"/>
-            <a:ext cx="838200" cy="146304"/>
+            <a:off x="4191000" y="1431036"/>
+            <a:ext cx="685800" cy="146304"/>
           </a:xfrm>
           <a:prstGeom prst="line">
             <a:avLst/>
@@ -8312,14 +8838,14 @@
       </p:cxnSp>
       <p:cxnSp>
         <p:nvCxnSpPr>
-          <p:cNvPr id="32" name="Connector 31"/>
+          <p:cNvPr id="43" name="Connector 42"/>
           <p:cNvCxnSpPr/>
           <p:nvPr/>
         </p:nvCxnSpPr>
         <p:spPr>
           <a:xfrm flipV="1">
-            <a:off x="4648200" y="3186684"/>
-            <a:ext cx="838200" cy="493776"/>
+            <a:off x="4191000" y="3186684"/>
+            <a:ext cx="685800" cy="493776"/>
           </a:xfrm>
           <a:prstGeom prst="line">
             <a:avLst/>
@@ -8348,14 +8874,14 @@
       </p:cxnSp>
       <p:cxnSp>
         <p:nvCxnSpPr>
-          <p:cNvPr id="33" name="Connector 32"/>
+          <p:cNvPr id="44" name="Connector 43"/>
           <p:cNvCxnSpPr/>
           <p:nvPr/>
         </p:nvCxnSpPr>
         <p:spPr>
           <a:xfrm flipV="1">
-            <a:off x="4648200" y="4572000"/>
-            <a:ext cx="838200" cy="164592"/>
+            <a:off x="4191000" y="4572000"/>
+            <a:ext cx="685800" cy="164592"/>
           </a:xfrm>
           <a:prstGeom prst="line">
             <a:avLst/>
@@ -8384,14 +8910,14 @@
       </p:cxnSp>
       <p:cxnSp>
         <p:nvCxnSpPr>
-          <p:cNvPr id="34" name="Connector 33"/>
+          <p:cNvPr id="45" name="Connector 44"/>
           <p:cNvCxnSpPr/>
           <p:nvPr/>
         </p:nvCxnSpPr>
         <p:spPr>
           <a:xfrm flipV="1">
-            <a:off x="4648200" y="5614416"/>
-            <a:ext cx="838200" cy="32004"/>
+            <a:off x="4191000" y="5614416"/>
+            <a:ext cx="685800" cy="32004"/>
           </a:xfrm>
           <a:prstGeom prst="line">
             <a:avLst/>
@@ -8420,14 +8946,14 @@
       </p:cxnSp>
       <p:cxnSp>
         <p:nvCxnSpPr>
-          <p:cNvPr id="35" name="Connector 34"/>
+          <p:cNvPr id="46" name="Connector 45"/>
           <p:cNvCxnSpPr/>
           <p:nvPr/>
         </p:nvCxnSpPr>
         <p:spPr>
           <a:xfrm flipV="1">
-            <a:off x="4648200" y="5806440"/>
-            <a:ext cx="838200" cy="13716"/>
+            <a:off x="4191000" y="5806440"/>
+            <a:ext cx="685800" cy="13716"/>
           </a:xfrm>
           <a:prstGeom prst="line">
             <a:avLst/>
@@ -8456,14 +8982,14 @@
       </p:cxnSp>
       <p:cxnSp>
         <p:nvCxnSpPr>
-          <p:cNvPr id="36" name="Connector 35"/>
+          <p:cNvPr id="47" name="Connector 46"/>
           <p:cNvCxnSpPr/>
           <p:nvPr/>
         </p:nvCxnSpPr>
         <p:spPr>
           <a:xfrm flipV="1">
-            <a:off x="4648200" y="5829300"/>
-            <a:ext cx="838200" cy="4572"/>
+            <a:off x="4191000" y="5829300"/>
+            <a:ext cx="685800" cy="4572"/>
           </a:xfrm>
           <a:prstGeom prst="line">
             <a:avLst/>
@@ -8490,16 +9016,312 @@
           </a:fontRef>
         </p:style>
       </p:cxnSp>
-      <p:sp>
-        <p:nvSpPr>
-          <p:cNvPr id="37" name="TextBox 36"/>
+      <p:cxnSp>
+        <p:nvCxnSpPr>
+          <p:cNvPr id="48" name="Connector 47"/>
+          <p:cNvCxnSpPr/>
+          <p:nvPr/>
+        </p:nvCxnSpPr>
+        <p:spPr>
+          <a:xfrm>
+            <a:off x="5791200" y="1257300"/>
+            <a:ext cx="685800" cy="0"/>
+          </a:xfrm>
+          <a:prstGeom prst="line">
+            <a:avLst/>
+          </a:prstGeom>
+          <a:ln w="9525">
+            <a:solidFill>
+              <a:srgbClr val="D9DEE6"/>
+            </a:solidFill>
+          </a:ln>
+          <a:effectLst/>
+        </p:spPr>
+        <p:style>
+          <a:lnRef idx="2">
+            <a:schemeClr val="accent1"/>
+          </a:lnRef>
+          <a:fillRef idx="0">
+            <a:schemeClr val="accent1"/>
+          </a:fillRef>
+          <a:effectRef idx="1">
+            <a:schemeClr val="accent1"/>
+          </a:effectRef>
+          <a:fontRef idx="minor">
+            <a:schemeClr val="tx1"/>
+          </a:fontRef>
+        </p:style>
+      </p:cxnSp>
+      <p:cxnSp>
+        <p:nvCxnSpPr>
+          <p:cNvPr id="49" name="Connector 48"/>
+          <p:cNvCxnSpPr/>
+          <p:nvPr/>
+        </p:nvCxnSpPr>
+        <p:spPr>
+          <a:xfrm>
+            <a:off x="5791200" y="1431036"/>
+            <a:ext cx="685800" cy="82296"/>
+          </a:xfrm>
+          <a:prstGeom prst="line">
+            <a:avLst/>
+          </a:prstGeom>
+          <a:ln w="9525">
+            <a:solidFill>
+              <a:srgbClr val="D9DEE6"/>
+            </a:solidFill>
+          </a:ln>
+          <a:effectLst/>
+        </p:spPr>
+        <p:style>
+          <a:lnRef idx="2">
+            <a:schemeClr val="accent1"/>
+          </a:lnRef>
+          <a:fillRef idx="0">
+            <a:schemeClr val="accent1"/>
+          </a:fillRef>
+          <a:effectRef idx="1">
+            <a:schemeClr val="accent1"/>
+          </a:effectRef>
+          <a:fontRef idx="minor">
+            <a:schemeClr val="tx1"/>
+          </a:fontRef>
+        </p:style>
+      </p:cxnSp>
+      <p:cxnSp>
+        <p:nvCxnSpPr>
+          <p:cNvPr id="50" name="Connector 49"/>
+          <p:cNvCxnSpPr/>
+          <p:nvPr/>
+        </p:nvCxnSpPr>
+        <p:spPr>
+          <a:xfrm>
+            <a:off x="5791200" y="3186684"/>
+            <a:ext cx="685800" cy="278892"/>
+          </a:xfrm>
+          <a:prstGeom prst="line">
+            <a:avLst/>
+          </a:prstGeom>
+          <a:ln w="9525">
+            <a:solidFill>
+              <a:srgbClr val="D9DEE6"/>
+            </a:solidFill>
+          </a:ln>
+          <a:effectLst/>
+        </p:spPr>
+        <p:style>
+          <a:lnRef idx="2">
+            <a:schemeClr val="accent1"/>
+          </a:lnRef>
+          <a:fillRef idx="0">
+            <a:schemeClr val="accent1"/>
+          </a:fillRef>
+          <a:effectRef idx="1">
+            <a:schemeClr val="accent1"/>
+          </a:effectRef>
+          <a:fontRef idx="minor">
+            <a:schemeClr val="tx1"/>
+          </a:fontRef>
+        </p:style>
+      </p:cxnSp>
+      <p:cxnSp>
+        <p:nvCxnSpPr>
+          <p:cNvPr id="51" name="Connector 50"/>
+          <p:cNvCxnSpPr/>
+          <p:nvPr/>
+        </p:nvCxnSpPr>
+        <p:spPr>
+          <a:xfrm>
+            <a:off x="5791200" y="4572000"/>
+            <a:ext cx="685800" cy="91440"/>
+          </a:xfrm>
+          <a:prstGeom prst="line">
+            <a:avLst/>
+          </a:prstGeom>
+          <a:ln w="9525">
+            <a:solidFill>
+              <a:srgbClr val="D9DEE6"/>
+            </a:solidFill>
+          </a:ln>
+          <a:effectLst/>
+        </p:spPr>
+        <p:style>
+          <a:lnRef idx="2">
+            <a:schemeClr val="accent1"/>
+          </a:lnRef>
+          <a:fillRef idx="0">
+            <a:schemeClr val="accent1"/>
+          </a:fillRef>
+          <a:effectRef idx="1">
+            <a:schemeClr val="accent1"/>
+          </a:effectRef>
+          <a:fontRef idx="minor">
+            <a:schemeClr val="tx1"/>
+          </a:fontRef>
+        </p:style>
+      </p:cxnSp>
+      <p:cxnSp>
+        <p:nvCxnSpPr>
+          <p:cNvPr id="52" name="Connector 51"/>
+          <p:cNvCxnSpPr/>
+          <p:nvPr/>
+        </p:nvCxnSpPr>
+        <p:spPr>
+          <a:xfrm>
+            <a:off x="5791200" y="5614416"/>
+            <a:ext cx="685800" cy="18288"/>
+          </a:xfrm>
+          <a:prstGeom prst="line">
+            <a:avLst/>
+          </a:prstGeom>
+          <a:ln w="9525">
+            <a:solidFill>
+              <a:srgbClr val="D9DEE6"/>
+            </a:solidFill>
+          </a:ln>
+          <a:effectLst/>
+        </p:spPr>
+        <p:style>
+          <a:lnRef idx="2">
+            <a:schemeClr val="accent1"/>
+          </a:lnRef>
+          <a:fillRef idx="0">
+            <a:schemeClr val="accent1"/>
+          </a:fillRef>
+          <a:effectRef idx="1">
+            <a:schemeClr val="accent1"/>
+          </a:effectRef>
+          <a:fontRef idx="minor">
+            <a:schemeClr val="tx1"/>
+          </a:fontRef>
+        </p:style>
+      </p:cxnSp>
+      <p:cxnSp>
+        <p:nvCxnSpPr>
+          <p:cNvPr id="53" name="Connector 52"/>
+          <p:cNvCxnSpPr/>
+          <p:nvPr/>
+        </p:nvCxnSpPr>
+        <p:spPr>
+          <a:xfrm>
+            <a:off x="5791200" y="5806440"/>
+            <a:ext cx="685800" cy="9144"/>
+          </a:xfrm>
+          <a:prstGeom prst="line">
+            <a:avLst/>
+          </a:prstGeom>
+          <a:ln w="9525">
+            <a:solidFill>
+              <a:srgbClr val="D9DEE6"/>
+            </a:solidFill>
+          </a:ln>
+          <a:effectLst/>
+        </p:spPr>
+        <p:style>
+          <a:lnRef idx="2">
+            <a:schemeClr val="accent1"/>
+          </a:lnRef>
+          <a:fillRef idx="0">
+            <a:schemeClr val="accent1"/>
+          </a:fillRef>
+          <a:effectRef idx="1">
+            <a:schemeClr val="accent1"/>
+          </a:effectRef>
+          <a:fontRef idx="minor">
+            <a:schemeClr val="tx1"/>
+          </a:fontRef>
+        </p:style>
+      </p:cxnSp>
+      <p:cxnSp>
+        <p:nvCxnSpPr>
+          <p:cNvPr id="54" name="Connector 53"/>
+          <p:cNvCxnSpPr/>
+          <p:nvPr/>
+        </p:nvCxnSpPr>
+        <p:spPr>
+          <a:xfrm>
+            <a:off x="5791200" y="5829300"/>
+            <a:ext cx="685800" cy="4572"/>
+          </a:xfrm>
+          <a:prstGeom prst="line">
+            <a:avLst/>
+          </a:prstGeom>
+          <a:ln w="9525">
+            <a:solidFill>
+              <a:srgbClr val="D9DEE6"/>
+            </a:solidFill>
+          </a:ln>
+          <a:effectLst/>
+        </p:spPr>
+        <p:style>
+          <a:lnRef idx="2">
+            <a:schemeClr val="accent1"/>
+          </a:lnRef>
+          <a:fillRef idx="0">
+            <a:schemeClr val="accent1"/>
+          </a:fillRef>
+          <a:effectRef idx="1">
+            <a:schemeClr val="accent1"/>
+          </a:effectRef>
+          <a:fontRef idx="minor">
+            <a:schemeClr val="tx1"/>
+          </a:fontRef>
+        </p:style>
+      </p:cxnSp>
+      <p:sp>
+        <p:nvSpPr>
+          <p:cNvPr id="55" name="Rectangle 54"/>
+          <p:cNvSpPr/>
+          <p:nvPr/>
+        </p:nvSpPr>
+        <p:spPr>
+          <a:xfrm>
+            <a:off x="6111240" y="1234440"/>
+            <a:ext cx="12192" cy="4724400"/>
+          </a:xfrm>
+          <a:prstGeom prst="rect">
+            <a:avLst/>
+          </a:prstGeom>
+          <a:solidFill>
+            <a:srgbClr val="C9D2DD"/>
+          </a:solidFill>
+          <a:ln>
+            <a:noFill/>
+          </a:ln>
+          <a:effectLst/>
+        </p:spPr>
+        <p:style>
+          <a:lnRef idx="1">
+            <a:schemeClr val="accent1"/>
+          </a:lnRef>
+          <a:fillRef idx="3">
+            <a:schemeClr val="accent1"/>
+          </a:fillRef>
+          <a:effectRef idx="2">
+            <a:schemeClr val="accent1"/>
+          </a:effectRef>
+          <a:fontRef idx="minor">
+            <a:schemeClr val="lt1"/>
+          </a:fontRef>
+        </p:style>
+        <p:txBody>
+          <a:bodyPr rtlCol="0" anchor="ctr"/>
+          <a:lstStyle/>
+          <a:p>
+            <a:pPr algn="ctr"/>
+          </a:p>
+        </p:txBody>
+      </p:sp>
+      <p:sp>
+        <p:nvSpPr>
+          <p:cNvPr id="56" name="TextBox 55"/>
           <p:cNvSpPr txBox="1"/>
           <p:nvPr/>
         </p:nvSpPr>
         <p:spPr>
           <a:xfrm>
-            <a:off x="3505200" y="5894832"/>
-            <a:ext cx="1295400" cy="182880"/>
+            <a:off x="3162300" y="5894832"/>
+            <a:ext cx="1143000" cy="167640"/>
           </a:xfrm>
           <a:prstGeom prst="rect">
             <a:avLst/>
@@ -8537,14 +9359,14 @@
       </p:sp>
       <p:sp>
         <p:nvSpPr>
-          <p:cNvPr id="38" name="TextBox 37"/>
+          <p:cNvPr id="57" name="TextBox 56"/>
           <p:cNvSpPr txBox="1"/>
           <p:nvPr/>
         </p:nvSpPr>
         <p:spPr>
           <a:xfrm>
-            <a:off x="5334000" y="5890260"/>
-            <a:ext cx="1295400" cy="182880"/>
+            <a:off x="4762500" y="5894832"/>
+            <a:ext cx="1143000" cy="167640"/>
           </a:xfrm>
           <a:prstGeom prst="rect">
             <a:avLst/>
@@ -8582,14 +9404,14 @@
       </p:sp>
       <p:sp>
         <p:nvSpPr>
-          <p:cNvPr id="39" name="TextBox 38"/>
+          <p:cNvPr id="58" name="TextBox 57"/>
           <p:cNvSpPr txBox="1"/>
           <p:nvPr/>
         </p:nvSpPr>
         <p:spPr>
           <a:xfrm>
-            <a:off x="2667000" y="1242060"/>
-            <a:ext cx="914400" cy="167640"/>
+            <a:off x="6286500" y="5894832"/>
+            <a:ext cx="1295400" cy="167640"/>
           </a:xfrm>
           <a:prstGeom prst="rect">
             <a:avLst/>
@@ -8602,7 +9424,7 @@
           </a:bodyPr>
           <a:lstStyle/>
           <a:p>
-            <a:pPr algn="r">
+            <a:pPr algn="ctr">
               <a:lnSpc>
                 <a:spcPct val="100000"/>
               </a:lnSpc>
@@ -8614,27 +9436,27 @@
               </a:spcAft>
             </a:pPr>
             <a:r>
-              <a:rPr sz="1100" b="0" i="0">
-                <a:solidFill>
-                  <a:srgbClr val="999999"/>
-                </a:solidFill>
-                <a:latin typeface="Arial"/>
-              </a:rPr>
-              <a:t>% of value</a:t>
-            </a:r>
-          </a:p>
-        </p:txBody>
-      </p:sp>
-      <p:sp>
-        <p:nvSpPr>
-          <p:cNvPr id="40" name="TextBox 39"/>
+              <a:rPr sz="1500" b="1" i="0">
+                <a:solidFill>
+                  <a:srgbClr val="1F3A5F"/>
+                </a:solidFill>
+                <a:latin typeface="Arial"/>
+              </a:rPr>
+              <a:t>2-yr</a:t>
+            </a:r>
+          </a:p>
+        </p:txBody>
+      </p:sp>
+      <p:sp>
+        <p:nvSpPr>
+          <p:cNvPr id="59" name="TextBox 58"/>
           <p:cNvSpPr txBox="1"/>
           <p:nvPr/>
         </p:nvSpPr>
         <p:spPr>
           <a:xfrm>
-            <a:off x="2667000" y="1379220"/>
-            <a:ext cx="914400" cy="167640"/>
+            <a:off x="6134100" y="6062472"/>
+            <a:ext cx="1600200" cy="152400"/>
           </a:xfrm>
           <a:prstGeom prst="rect">
             <a:avLst/>
@@ -8647,6 +9469,51 @@
           </a:bodyPr>
           <a:lstStyle/>
           <a:p>
+            <a:pPr algn="ctr">
+              <a:lnSpc>
+                <a:spcPct val="100000"/>
+              </a:lnSpc>
+              <a:spcBef>
+                <a:spcPts val="0"/>
+              </a:spcBef>
+              <a:spcAft>
+                <a:spcPts val="400"/>
+              </a:spcAft>
+            </a:pPr>
+            <a:r>
+              <a:rPr sz="1100" b="0" i="0">
+                <a:solidFill>
+                  <a:srgbClr val="666666"/>
+                </a:solidFill>
+                <a:latin typeface="Arial"/>
+              </a:rPr>
+              <a:t>(normalised)</a:t>
+            </a:r>
+          </a:p>
+        </p:txBody>
+      </p:sp>
+      <p:sp>
+        <p:nvSpPr>
+          <p:cNvPr id="60" name="TextBox 59"/>
+          <p:cNvSpPr txBox="1"/>
+          <p:nvPr/>
+        </p:nvSpPr>
+        <p:spPr>
+          <a:xfrm>
+            <a:off x="2286000" y="1242060"/>
+            <a:ext cx="914400" cy="167640"/>
+          </a:xfrm>
+          <a:prstGeom prst="rect">
+            <a:avLst/>
+          </a:prstGeom>
+          <a:noFill/>
+        </p:spPr>
+        <p:txBody>
+          <a:bodyPr wrap="square" anchor="t" lIns="25400" rIns="25400" tIns="12700" bIns="12700">
+            <a:spAutoFit/>
+          </a:bodyPr>
+          <a:lstStyle/>
+          <a:p>
             <a:pPr algn="r">
               <a:lnSpc>
                 <a:spcPct val="100000"/>
@@ -8665,6 +9532,51 @@
                 </a:solidFill>
                 <a:latin typeface="Arial"/>
               </a:rPr>
+              <a:t>% of value</a:t>
+            </a:r>
+          </a:p>
+        </p:txBody>
+      </p:sp>
+      <p:sp>
+        <p:nvSpPr>
+          <p:cNvPr id="61" name="TextBox 60"/>
+          <p:cNvSpPr txBox="1"/>
+          <p:nvPr/>
+        </p:nvSpPr>
+        <p:spPr>
+          <a:xfrm>
+            <a:off x="2286000" y="1379220"/>
+            <a:ext cx="914400" cy="167640"/>
+          </a:xfrm>
+          <a:prstGeom prst="rect">
+            <a:avLst/>
+          </a:prstGeom>
+          <a:noFill/>
+        </p:spPr>
+        <p:txBody>
+          <a:bodyPr wrap="square" anchor="t" lIns="25400" rIns="25400" tIns="12700" bIns="12700">
+            <a:spAutoFit/>
+          </a:bodyPr>
+          <a:lstStyle/>
+          <a:p>
+            <a:pPr algn="r">
+              <a:lnSpc>
+                <a:spcPct val="100000"/>
+              </a:lnSpc>
+              <a:spcBef>
+                <a:spcPts val="0"/>
+              </a:spcBef>
+              <a:spcAft>
+                <a:spcPts val="400"/>
+              </a:spcAft>
+            </a:pPr>
+            <a:r>
+              <a:rPr sz="1100" b="0" i="0">
+                <a:solidFill>
+                  <a:srgbClr val="999999"/>
+                </a:solidFill>
+                <a:latin typeface="Arial"/>
+              </a:rPr>
               <a:t>of production</a:t>
             </a:r>
           </a:p>
@@ -8672,14 +9584,14 @@
       </p:sp>
       <p:sp>
         <p:nvSpPr>
-          <p:cNvPr id="41" name="Rectangle 40"/>
+          <p:cNvPr id="62" name="Rectangle 61"/>
           <p:cNvSpPr/>
           <p:nvPr/>
         </p:nvSpPr>
         <p:spPr>
           <a:xfrm>
-            <a:off x="7315200" y="1447800"/>
-            <a:ext cx="4495800" cy="2286000"/>
+            <a:off x="7696200" y="1447800"/>
+            <a:ext cx="4114800" cy="2286000"/>
           </a:xfrm>
           <a:prstGeom prst="rect">
             <a:avLst/>
@@ -8718,14 +9630,14 @@
       </p:sp>
       <p:sp>
         <p:nvSpPr>
-          <p:cNvPr id="42" name="TextBox 41"/>
+          <p:cNvPr id="63" name="TextBox 62"/>
           <p:cNvSpPr txBox="1"/>
           <p:nvPr/>
         </p:nvSpPr>
         <p:spPr>
           <a:xfrm>
-            <a:off x="7482840" y="1524000"/>
-            <a:ext cx="1981200" cy="198120"/>
+            <a:off x="7848600" y="1524000"/>
+            <a:ext cx="1676400" cy="198120"/>
           </a:xfrm>
           <a:prstGeom prst="rect">
             <a:avLst/>
@@ -8763,14 +9675,14 @@
       </p:sp>
       <p:sp>
         <p:nvSpPr>
-          <p:cNvPr id="43" name="TextBox 42"/>
+          <p:cNvPr id="64" name="TextBox 63"/>
           <p:cNvSpPr txBox="1"/>
           <p:nvPr/>
         </p:nvSpPr>
         <p:spPr>
           <a:xfrm>
-            <a:off x="9525000" y="1524000"/>
-            <a:ext cx="731520" cy="198120"/>
+            <a:off x="9563100" y="1524000"/>
+            <a:ext cx="685800" cy="198120"/>
           </a:xfrm>
           <a:prstGeom prst="rect">
             <a:avLst/>
@@ -8808,14 +9720,14 @@
       </p:sp>
       <p:sp>
         <p:nvSpPr>
-          <p:cNvPr id="44" name="TextBox 43"/>
+          <p:cNvPr id="65" name="TextBox 64"/>
           <p:cNvSpPr txBox="1"/>
           <p:nvPr/>
         </p:nvSpPr>
         <p:spPr>
           <a:xfrm>
-            <a:off x="10302240" y="1524000"/>
-            <a:ext cx="731520" cy="198120"/>
+            <a:off x="10325100" y="1524000"/>
+            <a:ext cx="685800" cy="198120"/>
           </a:xfrm>
           <a:prstGeom prst="rect">
             <a:avLst/>
@@ -8853,13 +9765,13 @@
       </p:sp>
       <p:sp>
         <p:nvSpPr>
-          <p:cNvPr id="45" name="TextBox 44"/>
+          <p:cNvPr id="66" name="TextBox 65"/>
           <p:cNvSpPr txBox="1"/>
           <p:nvPr/>
         </p:nvSpPr>
         <p:spPr>
           <a:xfrm>
-            <a:off x="11079480" y="1524000"/>
+            <a:off x="11087100" y="1524000"/>
             <a:ext cx="685800" cy="198120"/>
           </a:xfrm>
           <a:prstGeom prst="rect">
@@ -8887,25 +9799,25 @@
             <a:r>
               <a:rPr sz="1200" b="1" i="0">
                 <a:solidFill>
-                  <a:srgbClr val="666666"/>
-                </a:solidFill>
-                <a:latin typeface="Arial"/>
-              </a:rPr>
-              <a:t>Δ pp</a:t>
-            </a:r>
-          </a:p>
-        </p:txBody>
-      </p:sp>
-      <p:sp>
-        <p:nvSpPr>
-          <p:cNvPr id="46" name="Rectangle 45"/>
+                  <a:srgbClr val="1F3A5F"/>
+                </a:solidFill>
+                <a:latin typeface="Arial"/>
+              </a:rPr>
+              <a:t>2-yr</a:t>
+            </a:r>
+          </a:p>
+        </p:txBody>
+      </p:sp>
+      <p:sp>
+        <p:nvSpPr>
+          <p:cNvPr id="67" name="Rectangle 66"/>
           <p:cNvSpPr/>
           <p:nvPr/>
         </p:nvSpPr>
         <p:spPr>
           <a:xfrm>
-            <a:off x="7482840" y="1752600"/>
-            <a:ext cx="4282440" cy="7620"/>
+            <a:off x="7848600" y="1752600"/>
+            <a:ext cx="3886200" cy="7620"/>
           </a:xfrm>
           <a:prstGeom prst="rect">
             <a:avLst/>
@@ -8942,14 +9854,14 @@
       </p:sp>
       <p:sp>
         <p:nvSpPr>
-          <p:cNvPr id="47" name="TextBox 46"/>
+          <p:cNvPr id="68" name="TextBox 67"/>
           <p:cNvSpPr txBox="1"/>
           <p:nvPr/>
         </p:nvSpPr>
         <p:spPr>
           <a:xfrm>
-            <a:off x="7482840" y="1859280"/>
-            <a:ext cx="2042160" cy="213360"/>
+            <a:off x="7848600" y="1859280"/>
+            <a:ext cx="1752600" cy="213360"/>
           </a:xfrm>
           <a:prstGeom prst="rect">
             <a:avLst/>
@@ -8996,14 +9908,14 @@
       </p:sp>
       <p:sp>
         <p:nvSpPr>
-          <p:cNvPr id="48" name="TextBox 47"/>
+          <p:cNvPr id="69" name="TextBox 68"/>
           <p:cNvSpPr txBox="1"/>
           <p:nvPr/>
         </p:nvSpPr>
         <p:spPr>
           <a:xfrm>
-            <a:off x="9525000" y="1859280"/>
-            <a:ext cx="731520" cy="213360"/>
+            <a:off x="9563100" y="1859280"/>
+            <a:ext cx="685800" cy="213360"/>
           </a:xfrm>
           <a:prstGeom prst="rect">
             <a:avLst/>
@@ -9041,14 +9953,14 @@
       </p:sp>
       <p:sp>
         <p:nvSpPr>
-          <p:cNvPr id="49" name="TextBox 48"/>
+          <p:cNvPr id="70" name="TextBox 69"/>
           <p:cNvSpPr txBox="1"/>
           <p:nvPr/>
         </p:nvSpPr>
         <p:spPr>
           <a:xfrm>
-            <a:off x="10302240" y="1859280"/>
-            <a:ext cx="731520" cy="213360"/>
+            <a:off x="10325100" y="1859280"/>
+            <a:ext cx="685800" cy="213360"/>
           </a:xfrm>
           <a:prstGeom prst="rect">
             <a:avLst/>
@@ -9086,13 +9998,13 @@
       </p:sp>
       <p:sp>
         <p:nvSpPr>
-          <p:cNvPr id="50" name="TextBox 49"/>
+          <p:cNvPr id="71" name="TextBox 70"/>
           <p:cNvSpPr txBox="1"/>
           <p:nvPr/>
         </p:nvSpPr>
         <p:spPr>
           <a:xfrm>
-            <a:off x="11079480" y="1859280"/>
+            <a:off x="11087100" y="1859280"/>
             <a:ext cx="685800" cy="213360"/>
           </a:xfrm>
           <a:prstGeom prst="rect">
@@ -9120,25 +10032,25 @@
             <a:r>
               <a:rPr sz="1200" b="1" i="0">
                 <a:solidFill>
-                  <a:srgbClr val="C8102E"/>
-                </a:solidFill>
-                <a:latin typeface="Arial"/>
-              </a:rPr>
-              <a:t>-3.2</a:t>
-            </a:r>
-          </a:p>
-        </p:txBody>
-      </p:sp>
-      <p:sp>
-        <p:nvSpPr>
-          <p:cNvPr id="51" name="TextBox 50"/>
+                  <a:srgbClr val="1F3A5F"/>
+                </a:solidFill>
+                <a:latin typeface="Arial"/>
+              </a:rPr>
+              <a:t>5.6%</a:t>
+            </a:r>
+          </a:p>
+        </p:txBody>
+      </p:sp>
+      <p:sp>
+        <p:nvSpPr>
+          <p:cNvPr id="72" name="TextBox 71"/>
           <p:cNvSpPr txBox="1"/>
           <p:nvPr/>
         </p:nvSpPr>
         <p:spPr>
           <a:xfrm>
-            <a:off x="7482840" y="2133600"/>
-            <a:ext cx="2042160" cy="213360"/>
+            <a:off x="7848600" y="2133600"/>
+            <a:ext cx="1752600" cy="213360"/>
           </a:xfrm>
           <a:prstGeom prst="rect">
             <a:avLst/>
@@ -9185,14 +10097,14 @@
       </p:sp>
       <p:sp>
         <p:nvSpPr>
-          <p:cNvPr id="52" name="TextBox 51"/>
+          <p:cNvPr id="73" name="TextBox 72"/>
           <p:cNvSpPr txBox="1"/>
           <p:nvPr/>
         </p:nvSpPr>
         <p:spPr>
           <a:xfrm>
-            <a:off x="9525000" y="2133600"/>
-            <a:ext cx="731520" cy="213360"/>
+            <a:off x="9563100" y="2133600"/>
+            <a:ext cx="685800" cy="213360"/>
           </a:xfrm>
           <a:prstGeom prst="rect">
             <a:avLst/>
@@ -9230,14 +10142,14 @@
       </p:sp>
       <p:sp>
         <p:nvSpPr>
-          <p:cNvPr id="53" name="TextBox 52"/>
+          <p:cNvPr id="74" name="TextBox 73"/>
           <p:cNvSpPr txBox="1"/>
           <p:nvPr/>
         </p:nvSpPr>
         <p:spPr>
           <a:xfrm>
-            <a:off x="10302240" y="2133600"/>
-            <a:ext cx="731520" cy="213360"/>
+            <a:off x="10325100" y="2133600"/>
+            <a:ext cx="685800" cy="213360"/>
           </a:xfrm>
           <a:prstGeom prst="rect">
             <a:avLst/>
@@ -9275,13 +10187,13 @@
       </p:sp>
       <p:sp>
         <p:nvSpPr>
-          <p:cNvPr id="54" name="TextBox 53"/>
+          <p:cNvPr id="75" name="TextBox 74"/>
           <p:cNvSpPr txBox="1"/>
           <p:nvPr/>
         </p:nvSpPr>
         <p:spPr>
           <a:xfrm>
-            <a:off x="11079480" y="2133600"/>
+            <a:off x="11087100" y="2133600"/>
             <a:ext cx="685800" cy="213360"/>
           </a:xfrm>
           <a:prstGeom prst="rect">
@@ -9309,25 +10221,25 @@
             <a:r>
               <a:rPr sz="1200" b="1" i="0">
                 <a:solidFill>
-                  <a:srgbClr val="2E7D4F"/>
-                </a:solidFill>
-                <a:latin typeface="Arial"/>
-              </a:rPr>
-              <a:t>-7.6</a:t>
-            </a:r>
-          </a:p>
-        </p:txBody>
-      </p:sp>
-      <p:sp>
-        <p:nvSpPr>
-          <p:cNvPr id="55" name="TextBox 54"/>
+                  <a:srgbClr val="1F3A5F"/>
+                </a:solidFill>
+                <a:latin typeface="Arial"/>
+              </a:rPr>
+              <a:t>42.7%</a:t>
+            </a:r>
+          </a:p>
+        </p:txBody>
+      </p:sp>
+      <p:sp>
+        <p:nvSpPr>
+          <p:cNvPr id="76" name="TextBox 75"/>
           <p:cNvSpPr txBox="1"/>
           <p:nvPr/>
         </p:nvSpPr>
         <p:spPr>
           <a:xfrm>
-            <a:off x="7482840" y="2407920"/>
-            <a:ext cx="2042160" cy="213360"/>
+            <a:off x="7848600" y="2407920"/>
+            <a:ext cx="1752600" cy="213360"/>
           </a:xfrm>
           <a:prstGeom prst="rect">
             <a:avLst/>
@@ -9374,14 +10286,14 @@
       </p:sp>
       <p:sp>
         <p:nvSpPr>
-          <p:cNvPr id="56" name="TextBox 55"/>
+          <p:cNvPr id="77" name="TextBox 76"/>
           <p:cNvSpPr txBox="1"/>
           <p:nvPr/>
         </p:nvSpPr>
         <p:spPr>
           <a:xfrm>
-            <a:off x="9525000" y="2407920"/>
-            <a:ext cx="731520" cy="213360"/>
+            <a:off x="9563100" y="2407920"/>
+            <a:ext cx="685800" cy="213360"/>
           </a:xfrm>
           <a:prstGeom prst="rect">
             <a:avLst/>
@@ -9419,14 +10331,14 @@
       </p:sp>
       <p:sp>
         <p:nvSpPr>
-          <p:cNvPr id="57" name="TextBox 56"/>
+          <p:cNvPr id="78" name="TextBox 77"/>
           <p:cNvSpPr txBox="1"/>
           <p:nvPr/>
         </p:nvSpPr>
         <p:spPr>
           <a:xfrm>
-            <a:off x="10302240" y="2407920"/>
-            <a:ext cx="731520" cy="213360"/>
+            <a:off x="10325100" y="2407920"/>
+            <a:ext cx="685800" cy="213360"/>
           </a:xfrm>
           <a:prstGeom prst="rect">
             <a:avLst/>
@@ -9464,13 +10376,13 @@
       </p:sp>
       <p:sp>
         <p:nvSpPr>
-          <p:cNvPr id="58" name="TextBox 57"/>
+          <p:cNvPr id="79" name="TextBox 78"/>
           <p:cNvSpPr txBox="1"/>
           <p:nvPr/>
         </p:nvSpPr>
         <p:spPr>
           <a:xfrm>
-            <a:off x="11079480" y="2407920"/>
+            <a:off x="11087100" y="2407920"/>
             <a:ext cx="685800" cy="213360"/>
           </a:xfrm>
           <a:prstGeom prst="rect">
@@ -9498,25 +10410,25 @@
             <a:r>
               <a:rPr sz="1200" b="1" i="0">
                 <a:solidFill>
-                  <a:srgbClr val="C8102E"/>
-                </a:solidFill>
-                <a:latin typeface="Arial"/>
-              </a:rPr>
-              <a:t>+7.2</a:t>
-            </a:r>
-          </a:p>
-        </p:txBody>
-      </p:sp>
-      <p:sp>
-        <p:nvSpPr>
-          <p:cNvPr id="59" name="TextBox 58"/>
+                  <a:srgbClr val="1F3A5F"/>
+                </a:solidFill>
+                <a:latin typeface="Arial"/>
+              </a:rPr>
+              <a:t>26.2%</a:t>
+            </a:r>
+          </a:p>
+        </p:txBody>
+      </p:sp>
+      <p:sp>
+        <p:nvSpPr>
+          <p:cNvPr id="80" name="TextBox 79"/>
           <p:cNvSpPr txBox="1"/>
           <p:nvPr/>
         </p:nvSpPr>
         <p:spPr>
           <a:xfrm>
-            <a:off x="7482840" y="2682240"/>
-            <a:ext cx="2042160" cy="213360"/>
+            <a:off x="7848600" y="2682240"/>
+            <a:ext cx="1752600" cy="213360"/>
           </a:xfrm>
           <a:prstGeom prst="rect">
             <a:avLst/>
@@ -9563,14 +10475,14 @@
       </p:sp>
       <p:sp>
         <p:nvSpPr>
-          <p:cNvPr id="60" name="TextBox 59"/>
+          <p:cNvPr id="81" name="TextBox 80"/>
           <p:cNvSpPr txBox="1"/>
           <p:nvPr/>
         </p:nvSpPr>
         <p:spPr>
           <a:xfrm>
-            <a:off x="9525000" y="2682240"/>
-            <a:ext cx="731520" cy="213360"/>
+            <a:off x="9563100" y="2682240"/>
+            <a:ext cx="685800" cy="213360"/>
           </a:xfrm>
           <a:prstGeom prst="rect">
             <a:avLst/>
@@ -9608,14 +10520,14 @@
       </p:sp>
       <p:sp>
         <p:nvSpPr>
-          <p:cNvPr id="61" name="TextBox 60"/>
+          <p:cNvPr id="82" name="TextBox 81"/>
           <p:cNvSpPr txBox="1"/>
           <p:nvPr/>
         </p:nvSpPr>
         <p:spPr>
           <a:xfrm>
-            <a:off x="10302240" y="2682240"/>
-            <a:ext cx="731520" cy="213360"/>
+            <a:off x="10325100" y="2682240"/>
+            <a:ext cx="685800" cy="213360"/>
           </a:xfrm>
           <a:prstGeom prst="rect">
             <a:avLst/>
@@ -9653,13 +10565,13 @@
       </p:sp>
       <p:sp>
         <p:nvSpPr>
-          <p:cNvPr id="62" name="TextBox 61"/>
+          <p:cNvPr id="83" name="TextBox 82"/>
           <p:cNvSpPr txBox="1"/>
           <p:nvPr/>
         </p:nvSpPr>
         <p:spPr>
           <a:xfrm>
-            <a:off x="11079480" y="2682240"/>
+            <a:off x="11087100" y="2682240"/>
             <a:ext cx="685800" cy="213360"/>
           </a:xfrm>
           <a:prstGeom prst="rect">
@@ -9687,25 +10599,25 @@
             <a:r>
               <a:rPr sz="1200" b="1" i="0">
                 <a:solidFill>
-                  <a:srgbClr val="C8102E"/>
-                </a:solidFill>
-                <a:latin typeface="Arial"/>
-              </a:rPr>
-              <a:t>+2.9</a:t>
-            </a:r>
-          </a:p>
-        </p:txBody>
-      </p:sp>
-      <p:sp>
-        <p:nvSpPr>
-          <p:cNvPr id="63" name="TextBox 62"/>
+                  <a:srgbClr val="1F3A5F"/>
+                </a:solidFill>
+                <a:latin typeface="Arial"/>
+              </a:rPr>
+              <a:t>21.2%</a:t>
+            </a:r>
+          </a:p>
+        </p:txBody>
+      </p:sp>
+      <p:sp>
+        <p:nvSpPr>
+          <p:cNvPr id="84" name="TextBox 83"/>
           <p:cNvSpPr txBox="1"/>
           <p:nvPr/>
         </p:nvSpPr>
         <p:spPr>
           <a:xfrm>
-            <a:off x="7482840" y="2956560"/>
-            <a:ext cx="2042160" cy="213360"/>
+            <a:off x="7848600" y="2956560"/>
+            <a:ext cx="1752600" cy="213360"/>
           </a:xfrm>
           <a:prstGeom prst="rect">
             <a:avLst/>
@@ -9752,14 +10664,14 @@
       </p:sp>
       <p:sp>
         <p:nvSpPr>
-          <p:cNvPr id="64" name="TextBox 63"/>
+          <p:cNvPr id="85" name="TextBox 84"/>
           <p:cNvSpPr txBox="1"/>
           <p:nvPr/>
         </p:nvSpPr>
         <p:spPr>
           <a:xfrm>
-            <a:off x="9525000" y="2956560"/>
-            <a:ext cx="731520" cy="213360"/>
+            <a:off x="9563100" y="2956560"/>
+            <a:ext cx="685800" cy="213360"/>
           </a:xfrm>
           <a:prstGeom prst="rect">
             <a:avLst/>
@@ -9797,14 +10709,14 @@
       </p:sp>
       <p:sp>
         <p:nvSpPr>
-          <p:cNvPr id="65" name="TextBox 64"/>
+          <p:cNvPr id="86" name="TextBox 85"/>
           <p:cNvSpPr txBox="1"/>
           <p:nvPr/>
         </p:nvSpPr>
         <p:spPr>
           <a:xfrm>
-            <a:off x="10302240" y="2956560"/>
-            <a:ext cx="731520" cy="213360"/>
+            <a:off x="10325100" y="2956560"/>
+            <a:ext cx="685800" cy="213360"/>
           </a:xfrm>
           <a:prstGeom prst="rect">
             <a:avLst/>
@@ -9842,13 +10754,13 @@
       </p:sp>
       <p:sp>
         <p:nvSpPr>
-          <p:cNvPr id="66" name="TextBox 65"/>
+          <p:cNvPr id="87" name="TextBox 86"/>
           <p:cNvSpPr txBox="1"/>
           <p:nvPr/>
         </p:nvSpPr>
         <p:spPr>
           <a:xfrm>
-            <a:off x="11079480" y="2956560"/>
+            <a:off x="11087100" y="2956560"/>
             <a:ext cx="685800" cy="213360"/>
           </a:xfrm>
           <a:prstGeom prst="rect">
@@ -9876,25 +10788,25 @@
             <a:r>
               <a:rPr sz="1200" b="1" i="0">
                 <a:solidFill>
-                  <a:srgbClr val="C8102E"/>
-                </a:solidFill>
-                <a:latin typeface="Arial"/>
-              </a:rPr>
-              <a:t>+0.4</a:t>
-            </a:r>
-          </a:p>
-        </p:txBody>
-      </p:sp>
-      <p:sp>
-        <p:nvSpPr>
-          <p:cNvPr id="67" name="TextBox 66"/>
+                  <a:srgbClr val="1F3A5F"/>
+                </a:solidFill>
+                <a:latin typeface="Arial"/>
+              </a:rPr>
+              <a:t>4.0%</a:t>
+            </a:r>
+          </a:p>
+        </p:txBody>
+      </p:sp>
+      <p:sp>
+        <p:nvSpPr>
+          <p:cNvPr id="88" name="TextBox 87"/>
           <p:cNvSpPr txBox="1"/>
           <p:nvPr/>
         </p:nvSpPr>
         <p:spPr>
           <a:xfrm>
-            <a:off x="7482840" y="3230880"/>
-            <a:ext cx="2042160" cy="213360"/>
+            <a:off x="7848600" y="3230880"/>
+            <a:ext cx="1752600" cy="213360"/>
           </a:xfrm>
           <a:prstGeom prst="rect">
             <a:avLst/>
@@ -9941,14 +10853,14 @@
       </p:sp>
       <p:sp>
         <p:nvSpPr>
-          <p:cNvPr id="68" name="TextBox 67"/>
+          <p:cNvPr id="89" name="TextBox 88"/>
           <p:cNvSpPr txBox="1"/>
           <p:nvPr/>
         </p:nvSpPr>
         <p:spPr>
           <a:xfrm>
-            <a:off x="9525000" y="3230880"/>
-            <a:ext cx="731520" cy="213360"/>
+            <a:off x="9563100" y="3230880"/>
+            <a:ext cx="685800" cy="213360"/>
           </a:xfrm>
           <a:prstGeom prst="rect">
             <a:avLst/>
@@ -9986,14 +10898,14 @@
       </p:sp>
       <p:sp>
         <p:nvSpPr>
-          <p:cNvPr id="69" name="TextBox 68"/>
+          <p:cNvPr id="90" name="TextBox 89"/>
           <p:cNvSpPr txBox="1"/>
           <p:nvPr/>
         </p:nvSpPr>
         <p:spPr>
           <a:xfrm>
-            <a:off x="10302240" y="3230880"/>
-            <a:ext cx="731520" cy="213360"/>
+            <a:off x="10325100" y="3230880"/>
+            <a:ext cx="685800" cy="213360"/>
           </a:xfrm>
           <a:prstGeom prst="rect">
             <a:avLst/>
@@ -10031,13 +10943,13 @@
       </p:sp>
       <p:sp>
         <p:nvSpPr>
-          <p:cNvPr id="70" name="TextBox 69"/>
+          <p:cNvPr id="91" name="TextBox 90"/>
           <p:cNvSpPr txBox="1"/>
           <p:nvPr/>
         </p:nvSpPr>
         <p:spPr>
           <a:xfrm>
-            <a:off x="11079480" y="3230880"/>
+            <a:off x="11087100" y="3230880"/>
             <a:ext cx="685800" cy="213360"/>
           </a:xfrm>
           <a:prstGeom prst="rect">
@@ -10065,25 +10977,25 @@
             <a:r>
               <a:rPr sz="1200" b="1" i="0">
                 <a:solidFill>
-                  <a:srgbClr val="C8102E"/>
-                </a:solidFill>
-                <a:latin typeface="Arial"/>
-              </a:rPr>
-              <a:t>+0.2</a:t>
-            </a:r>
-          </a:p>
-        </p:txBody>
-      </p:sp>
-      <p:sp>
-        <p:nvSpPr>
-          <p:cNvPr id="71" name="Rectangle 70"/>
+                  <a:srgbClr val="1F3A5F"/>
+                </a:solidFill>
+                <a:latin typeface="Arial"/>
+              </a:rPr>
+              <a:t>0.4%</a:t>
+            </a:r>
+          </a:p>
+        </p:txBody>
+      </p:sp>
+      <p:sp>
+        <p:nvSpPr>
+          <p:cNvPr id="92" name="Rectangle 91"/>
           <p:cNvSpPr/>
           <p:nvPr/>
         </p:nvSpPr>
         <p:spPr>
           <a:xfrm>
-            <a:off x="7315200" y="3848100"/>
-            <a:ext cx="4495800" cy="1143000"/>
+            <a:off x="7696200" y="3848100"/>
+            <a:ext cx="4114800" cy="1143000"/>
           </a:xfrm>
           <a:prstGeom prst="rect">
             <a:avLst/>
@@ -10122,14 +11034,14 @@
       </p:sp>
       <p:sp>
         <p:nvSpPr>
-          <p:cNvPr id="72" name="TextBox 71"/>
+          <p:cNvPr id="93" name="TextBox 92"/>
           <p:cNvSpPr txBox="1"/>
           <p:nvPr/>
         </p:nvSpPr>
         <p:spPr>
           <a:xfrm>
-            <a:off x="7482840" y="3939540"/>
-            <a:ext cx="4160520" cy="990600"/>
+            <a:off x="7863840" y="3924300"/>
+            <a:ext cx="3779520" cy="1005840"/>
           </a:xfrm>
           <a:prstGeom prst="rect">
             <a:avLst/>
@@ -10160,7 +11072,7 @@
                 </a:solidFill>
                 <a:latin typeface="Arial"/>
               </a:rPr>
-              <a:t>Fixed-cost absorption is the story: </a:t>
+              <a:t>Normalising the cycle: </a:t>
             </a:r>
             <a:r>
               <a:rPr sz="1400" b="0" i="0">
@@ -10169,7 +11081,7 @@
                 </a:solidFill>
                 <a:latin typeface="Arial"/>
               </a:rPr>
-              <a:t>personnel rises </a:t>
+              <a:t>aggregating 2023+2024 nets out the WIP swing, giving a run-rate EBITDA of </a:t>
             </a:r>
             <a:r>
               <a:rPr sz="1400" b="1" i="0">
@@ -10178,7 +11090,7 @@
                 </a:solidFill>
                 <a:latin typeface="Arial"/>
               </a:rPr>
-              <a:t>+7pp</a:t>
+              <a:t>~5.6% of value of production</a:t>
             </a:r>
             <a:r>
               <a:rPr sz="1400" b="0" i="0">
@@ -10187,25 +11099,7 @@
                 </a:solidFill>
                 <a:latin typeface="Arial"/>
               </a:rPr>
-              <a:t> of output (stable in €, heavier on lower volume) while materials fall </a:t>
-            </a:r>
-            <a:r>
-              <a:rPr sz="1400" b="1" i="0">
-                <a:solidFill>
-                  <a:srgbClr val="333333"/>
-                </a:solidFill>
-                <a:latin typeface="Arial"/>
-              </a:rPr>
-              <a:t>-8pp</a:t>
-            </a:r>
-            <a:r>
-              <a:rPr sz="1400" b="0" i="0">
-                <a:solidFill>
-                  <a:srgbClr val="333333"/>
-                </a:solidFill>
-                <a:latin typeface="Arial"/>
-              </a:rPr>
-              <a:t> (variable) — net, EBITDA compresses from 7.0% to 3.8%.</a:t>
+              <a:t> (~5.5% of revenue) — a fairer valuation base than either single year.</a:t>
             </a:r>
           </a:p>
           <a:p>
@@ -10227,14 +11121,14 @@
                 </a:solidFill>
                 <a:latin typeface="Arial"/>
               </a:rPr>
-              <a:t>Read with the project cycle: 2024 value of production is lower as the 2023 WIP build-up unwinds.</a:t>
-            </a:r>
-          </a:p>
-        </p:txBody>
-      </p:sp>
-      <p:sp>
-        <p:nvSpPr>
-          <p:cNvPr id="73" name="TextBox 72"/>
+              <a:t>Single years are distorted by project timing: 7.0% (2023, WIP build-up) vs 3.8% (2024, WIP unwind).</a:t>
+            </a:r>
+          </a:p>
+        </p:txBody>
+      </p:sp>
+      <p:sp>
+        <p:nvSpPr>
+          <p:cNvPr id="94" name="TextBox 93"/>
           <p:cNvSpPr txBox="1"/>
           <p:nvPr/>
         </p:nvSpPr>
@@ -10272,7 +11166,7 @@
                 </a:solidFill>
                 <a:latin typeface="Arial"/>
               </a:rPr>
-              <a:t>% of value of production (€52.0m 2023 / €40.7m 2024). 2023 base inflated by WIP build-up (+€19.3m); on a revenue basis EBITDA margin was 7.2% (2023) / 3.5% (2024). Source: Coface reclassified P&amp;L.</a:t>
+              <a:t>2-yr = 2023+2024 aggregated (value of production €92.7m), neutralising the project-cycle WIP swing. % of value of production; may not sum to 100 due to rounding. Source: Coface reclassified P&amp;L.</a:t>
             </a:r>
           </a:p>
         </p:txBody>

</xml_diff>

<commit_message>
Use 2-yr annual average (not sum) for normalised views on P&L and Financial charts
</commit_message>
<xml_diff>
--- a/Hennecke/pitch/HenneckeOMS_Board_Pitch_EN.pptx
+++ b/Hennecke/pitch/HenneckeOMS_Board_Pitch_EN.pptx
@@ -231,7 +231,7 @@
               <c:strCache>
                 <c:ptCount val="1"/>
                 <c:pt idx="0">
-                  <c:v>2-yr (sum)</c:v>
+                  <c:v>2-yr avg</c:v>
                 </c:pt>
               </c:strCache>
             </c:strRef>
@@ -262,10 +262,10 @@
                 <c:formatCode>General</c:formatCode>
                 <c:ptCount val="2"/>
                 <c:pt idx="0">
-                  <c:v>94.6</c:v>
+                  <c:v>47.3</c:v>
                 </c:pt>
                 <c:pt idx="1">
-                  <c:v>5.2</c:v>
+                  <c:v>2.6</c:v>
                 </c:pt>
               </c:numCache>
             </c:numRef>
@@ -6123,7 +6123,7 @@
                 </a:solidFill>
                 <a:latin typeface="Arial"/>
               </a:rPr>
-              <a:t>2023 · 2024 · 2-yr aggregate (€ million)</a:t>
+              <a:t>2023 · 2024 · 2-yr average (€ million)</a:t>
             </a:r>
           </a:p>
         </p:txBody>
@@ -7158,7 +7158,7 @@
                 </a:solidFill>
                 <a:latin typeface="Arial"/>
               </a:rPr>
-              <a:t>Summing both years nets out the project-cycle WIP swing → a normalised run-rate</a:t>
+              <a:t>Averaging both years nets out the project-cycle WIP swing → a normalised run-rate</a:t>
             </a:r>
           </a:p>
         </p:txBody>
@@ -11081,7 +11081,7 @@
                 </a:solidFill>
                 <a:latin typeface="Arial"/>
               </a:rPr>
-              <a:t>aggregating 2023+2024 nets out the WIP swing, giving a run-rate EBITDA of </a:t>
+              <a:t>averaging 2023+2024 nets out the WIP swing, giving a run-rate EBITDA of </a:t>
             </a:r>
             <a:r>
               <a:rPr sz="1400" b="1" i="0">
@@ -11166,7 +11166,7 @@
                 </a:solidFill>
                 <a:latin typeface="Arial"/>
               </a:rPr>
-              <a:t>2-yr = 2023+2024 aggregated (value of production €92.7m), neutralising the project-cycle WIP swing. % of value of production; may not sum to 100 due to rounding. Source: Coface reclassified P&amp;L.</a:t>
+              <a:t>2-yr = annual average of 2023+2024 (value of production €46.3m), neutralising the project-cycle WIP swing. % of value of production; may not sum to 100 due to rounding. Source: Coface reclassified P&amp;L.</a:t>
             </a:r>
           </a:p>
         </p:txBody>

</xml_diff>

<commit_message>
Add EBITDA margin readout (incl. normalised 2-yr) to Financial chart
</commit_message>
<xml_diff>
--- a/Hennecke/pitch/HenneckeOMS_Board_Pitch_EN.pptx
+++ b/Hennecke/pitch/HenneckeOMS_Board_Pitch_EN.pptx
@@ -6226,13 +6226,22 @@
               </a:spcAft>
             </a:pPr>
             <a:r>
-              <a:rPr sz="1600" b="1" i="0">
+              <a:rPr sz="1600" b="0" i="0">
                 <a:solidFill>
                   <a:srgbClr val="C8102E"/>
                 </a:solidFill>
                 <a:latin typeface="Arial"/>
               </a:rPr>
-              <a:t>EBITDA margin: 7.2% → 3.5%</a:t>
+              <a:t>EBITDA margin: 7.2% (2023) → 3.5% (2024)</a:t>
+            </a:r>
+            <a:r>
+              <a:rPr sz="1600" b="0" i="0">
+                <a:solidFill>
+                  <a:srgbClr val="2E7D4F"/>
+                </a:solidFill>
+                <a:latin typeface="Arial"/>
+              </a:rPr>
+              <a:t>  ·  ~5.5% normalised (2-yr avg)</a:t>
             </a:r>
           </a:p>
           <a:p>

</xml_diff>